<commit_message>
docs: add creator motivation to demo deck
</commit_message>
<xml_diff>
--- a/outputs/vertex-palace-build-week-demo.pptx
+++ b/outputs/vertex-palace-build-week-demo.pptx
@@ -2,20 +2,20 @@
 <file path=ppt/presentation.xml><?xml version="1.0" encoding="utf-8"?>
 <p:presentation xmlns:p="http://schemas.openxmlformats.org/presentationml/2006/main">
   <p:sldMasterIdLst>
-    <p:sldMasterId xmlns:r="http://schemas.openxmlformats.org/officeDocument/2006/relationships" id="2147483648" r:id="R912c9a5baca9456e"/>
+    <p:sldMasterId xmlns:r="http://schemas.openxmlformats.org/officeDocument/2006/relationships" id="2147483648" r:id="Ree44bf9335644666"/>
   </p:sldMasterIdLst>
   <p:notesMasterIdLst>
-    <p:notesMasterId xmlns:r="http://schemas.openxmlformats.org/officeDocument/2006/relationships" r:id="R9823172bfb3b4dd3"/>
+    <p:notesMasterId xmlns:r="http://schemas.openxmlformats.org/officeDocument/2006/relationships" r:id="Rc98aa339755b45d2"/>
   </p:notesMasterIdLst>
   <p:sldIdLst>
-    <p:sldId xmlns:r="http://schemas.openxmlformats.org/officeDocument/2006/relationships" id="256" r:id="R7a6a1aad2d4b4843"/>
-    <p:sldId xmlns:r="http://schemas.openxmlformats.org/officeDocument/2006/relationships" id="257" r:id="R005125e0c92040e5"/>
-    <p:sldId xmlns:r="http://schemas.openxmlformats.org/officeDocument/2006/relationships" id="258" r:id="Re2c08d55d21d49b6"/>
-    <p:sldId xmlns:r="http://schemas.openxmlformats.org/officeDocument/2006/relationships" id="259" r:id="Ra9b4943a0e0546b9"/>
-    <p:sldId xmlns:r="http://schemas.openxmlformats.org/officeDocument/2006/relationships" id="260" r:id="R07cebb8b9a344ec9"/>
-    <p:sldId xmlns:r="http://schemas.openxmlformats.org/officeDocument/2006/relationships" id="261" r:id="R3a3ac93bbf0b439b"/>
-    <p:sldId xmlns:r="http://schemas.openxmlformats.org/officeDocument/2006/relationships" id="262" r:id="Ra50b6d9c070e45ae"/>
-    <p:sldId xmlns:r="http://schemas.openxmlformats.org/officeDocument/2006/relationships" id="263" r:id="R8bdfaaf9d0b4401f"/>
+    <p:sldId xmlns:r="http://schemas.openxmlformats.org/officeDocument/2006/relationships" id="256" r:id="R131d1e2aa3984a09"/>
+    <p:sldId xmlns:r="http://schemas.openxmlformats.org/officeDocument/2006/relationships" id="257" r:id="R0e224fd3b0ea4cd5"/>
+    <p:sldId xmlns:r="http://schemas.openxmlformats.org/officeDocument/2006/relationships" id="258" r:id="R1b859cddd684407b"/>
+    <p:sldId xmlns:r="http://schemas.openxmlformats.org/officeDocument/2006/relationships" id="259" r:id="Rc5188e4aadc34b76"/>
+    <p:sldId xmlns:r="http://schemas.openxmlformats.org/officeDocument/2006/relationships" id="260" r:id="R02eaf360ec414d5e"/>
+    <p:sldId xmlns:r="http://schemas.openxmlformats.org/officeDocument/2006/relationships" id="261" r:id="R8d53dc85e8714916"/>
+    <p:sldId xmlns:r="http://schemas.openxmlformats.org/officeDocument/2006/relationships" id="262" r:id="R56009698a3ed4950"/>
+    <p:sldId xmlns:r="http://schemas.openxmlformats.org/officeDocument/2006/relationships" id="263" r:id="Rd7b6dbc3d9d34784"/>
   </p:sldIdLst>
   <p:sldSz cx="12192000" cy="6858000"/>
   <p:notesSz cx="6858000" cy="9144000"/>
@@ -619,12 +619,12 @@
           <a:lstStyle xmlns:a="http://schemas.openxmlformats.org/drawingml/2006/main"/>
           <a:p xmlns:a="http://schemas.openxmlformats.org/drawingml/2006/main">
             <a:r>
-              <a:t>Explain the problem in plain language. Large repositories make the agent search widely, reread context, and forget earlier decisions or deployment pitfalls.</a:t>
-            </a:r>
-          </a:p>
-          <a:p xmlns:a="http://schemas.openxmlformats.org/drawingml/2006/main">
-            <a:r>
-              <a:t>Do not claim that all broad inspection is waste. The point is that the agent needs a task-specific entry path.</a:t>
+              <a:t>Speak in the first person. Vertex Palace began with a recurring problem in my own large projects: a single issue could take more than an hour, while token usage climbed as the agent rediscovered files, relationships, and earlier decisions.</a:t>
+            </a:r>
+          </a:p>
+          <a:p xmlns:a="http://schemas.openxmlformats.org/drawingml/2006/main">
+            <a:r>
+              <a:t>This was the point where I stopped treating the context cost as an inconvenience and decided to build a task-specific entry path. Do not present this personal experience as a universal benchmark result.</a:t>
             </a:r>
           </a:p>
         </p:txBody>
@@ -694,7 +694,12 @@
           <a:lstStyle xmlns:a="http://schemas.openxmlformats.org/drawingml/2006/main"/>
           <a:p xmlns:a="http://schemas.openxmlformats.org/drawingml/2006/main">
             <a:r>
-              <a:t>Walk left to right: index the repository structure, select an adaptive mode, pack only primary and supporting context, execute the task, then preserve relevant decisions and pitfalls.</a:t>
+              <a:t>The inspiration came from the human memory-palace technique: assign knowledge to places, then follow a route to retrieve it. Vertex Palace maps repository domains to floors, features to rooms, and files and symbols to smaller storage layers.</a:t>
+            </a:r>
+          </a:p>
+          <a:p xmlns:a="http://schemas.openxmlformats.org/drawingml/2006/main">
+            <a:r>
+              <a:t>Walk left to right: index the repository structure, select an adaptive mode, pack only primary and supporting context, execute the task, then preserve relevant decisions and pitfalls at the entrance for the next task.</a:t>
             </a:r>
           </a:p>
           <a:p xmlns:a="http://schemas.openxmlformats.org/drawingml/2006/main">
@@ -1147,7 +1152,7 @@
   </p:cSld>
   <p:clrMap bg1="lt1" tx1="dk1" bg2="lt2" tx2="dk2" accent1="accent1" accent2="accent2" accent3="accent3" accent4="accent4" accent5="accent5" accent6="accent6" hlink="hlink" folHlink="folHlink"/>
   <p:sldLayoutIdLst>
-    <p:sldLayoutId xmlns:r="http://schemas.openxmlformats.org/officeDocument/2006/relationships" id="2147483649" r:id="R08ab4793d8b949a7"/>
+    <p:sldLayoutId xmlns:r="http://schemas.openxmlformats.org/officeDocument/2006/relationships" id="2147483649" r:id="R0902ee43faeb40ea"/>
   </p:sldLayoutIdLst>
   <p:txStyles>
     <p:titleStyle>
@@ -2039,7 +2044,7 @@
           <p:cNvPr id="7" name="s1-eyebrow">
             <a:extLst xmlns:a="http://schemas.openxmlformats.org/drawingml/2006/main">
               <a:ext uri="{FF2B5EF4-FFF2-40B4-BE49-F238E27FC236}">
-                <a16:creationId xmlns:a16="http://schemas.microsoft.com/office/drawing/2014/main" id="{03938B8F-9401-4D99-9F04-3FF351557AAA}"/>
+                <a16:creationId xmlns:a16="http://schemas.microsoft.com/office/drawing/2014/main" id="{C9BAD10D-D100-46F6-B29C-35EEBEA7F4C4}"/>
               </a:ext>
             </a:extLst>
           </p:cNvPr>
@@ -2084,7 +2089,7 @@
           <p:cNvPr id="2" name="s1-title">
             <a:extLst xmlns:a="http://schemas.openxmlformats.org/drawingml/2006/main">
               <a:ext uri="{FF2B5EF4-FFF2-40B4-BE49-F238E27FC236}">
-                <a16:creationId xmlns:a16="http://schemas.microsoft.com/office/drawing/2014/main" id="{C6964373-B123-4D5B-B8BB-4C65FFD92FB3}"/>
+                <a16:creationId xmlns:a16="http://schemas.microsoft.com/office/drawing/2014/main" id="{65668104-24CF-4A09-85F4-456208D4F40A}"/>
               </a:ext>
             </a:extLst>
           </p:cNvPr>
@@ -2152,7 +2157,7 @@
           <p:cNvPr id="4" name="s1-subtitle">
             <a:extLst xmlns:a="http://schemas.openxmlformats.org/drawingml/2006/main">
               <a:ext uri="{FF2B5EF4-FFF2-40B4-BE49-F238E27FC236}">
-                <a16:creationId xmlns:a16="http://schemas.microsoft.com/office/drawing/2014/main" id="{9EAD236D-6F0A-46A1-B2C2-6C427BDEE33C}"/>
+                <a16:creationId xmlns:a16="http://schemas.microsoft.com/office/drawing/2014/main" id="{307ADBE3-367C-427C-B41C-28D8304A314B}"/>
               </a:ext>
             </a:extLst>
           </p:cNvPr>
@@ -2197,7 +2202,7 @@
           <p:cNvPr id="5" name="s1-version">
             <a:extLst xmlns:a="http://schemas.openxmlformats.org/drawingml/2006/main">
               <a:ext uri="{FF2B5EF4-FFF2-40B4-BE49-F238E27FC236}">
-                <a16:creationId xmlns:a16="http://schemas.microsoft.com/office/drawing/2014/main" id="{BBB4C90D-B0D0-4D3A-9845-A25193521DDE}"/>
+                <a16:creationId xmlns:a16="http://schemas.microsoft.com/office/drawing/2014/main" id="{70875ACA-49B9-43F0-A67F-7BD6D6DAA45D}"/>
               </a:ext>
             </a:extLst>
           </p:cNvPr>
@@ -2246,7 +2251,7 @@
           <p:nvPr/>
         </p:nvPicPr>
         <p:blipFill>
-          <a:blip xmlns:r="http://schemas.openxmlformats.org/officeDocument/2006/relationships" xmlns:a="http://schemas.openxmlformats.org/drawingml/2006/main" r:embed="R45b29ed6f1c84063"/>
+          <a:blip xmlns:r="http://schemas.openxmlformats.org/officeDocument/2006/relationships" xmlns:a="http://schemas.openxmlformats.org/drawingml/2006/main" r:embed="Rac4445891b354050"/>
           <a:stretch xmlns:a="http://schemas.openxmlformats.org/drawingml/2006/main"/>
         </p:blipFill>
         <p:spPr>
@@ -2262,7 +2267,7 @@
     </p:spTree>
     <p:extLst>
       <p:ext uri="{BB962C8B-B14F-4D97-AF65-F5344CB8AC3E}">
-        <p14:creationId xmlns:p14="http://schemas.microsoft.com/office/powerpoint/2010/main" val="212124495"/>
+        <p14:creationId xmlns:p14="http://schemas.microsoft.com/office/powerpoint/2010/main" val="1199054850"/>
       </p:ext>
     </p:extLst>
   </p:cSld>
@@ -2293,7 +2298,7 @@
           <p:cNvPr id="33" name="s2-title">
             <a:extLst xmlns:a="http://schemas.openxmlformats.org/drawingml/2006/main">
               <a:ext uri="{FF2B5EF4-FFF2-40B4-BE49-F238E27FC236}">
-                <a16:creationId xmlns:a16="http://schemas.microsoft.com/office/drawing/2014/main" id="{BB77534F-F9AA-4132-910A-DB96851312C1}"/>
+                <a16:creationId xmlns:a16="http://schemas.microsoft.com/office/drawing/2014/main" id="{652C5319-8479-4A01-A996-AF2A32B16EDE}"/>
               </a:ext>
             </a:extLst>
           </p:cNvPr>
@@ -2328,7 +2333,7 @@
               </a:defRPr>
             </a:pPr>
             <a:r>
-              <a:t>A repository is structured. Agent context often is not.</a:t>
+              <a:t>As my projects grew, one issue could take over an hour.</a:t>
             </a:r>
           </a:p>
         </p:txBody>
@@ -2338,7 +2343,7 @@
           <p:cNvPr id="2" name="s2-subtitle">
             <a:extLst xmlns:a="http://schemas.openxmlformats.org/drawingml/2006/main">
               <a:ext uri="{FF2B5EF4-FFF2-40B4-BE49-F238E27FC236}">
-                <a16:creationId xmlns:a16="http://schemas.microsoft.com/office/drawing/2014/main" id="{8F755787-EACB-4CD2-85B9-539CBAE09396}"/>
+                <a16:creationId xmlns:a16="http://schemas.microsoft.com/office/drawing/2014/main" id="{F23EEC23-A893-47E9-81E0-363EA7CCE6D6}"/>
               </a:ext>
             </a:extLst>
           </p:cNvPr>
@@ -2350,7 +2355,7 @@
         <p:spPr>
           <a:xfrm xmlns:a="http://schemas.openxmlformats.org/drawingml/2006/main">
             <a:off x="400050" y="1066800"/>
-            <a:ext cx="7715250" cy="381000"/>
+            <a:ext cx="11391900" cy="381000"/>
           </a:xfrm>
           <a:prstGeom xmlns:a="http://schemas.openxmlformats.org/drawingml/2006/main" prst="rect">
             <a:avLst/>
@@ -2373,7 +2378,7 @@
               </a:defRPr>
             </a:pPr>
             <a:r>
-              <a:t>Without a route, the agent repeatedly fans out across files and history.</a:t>
+              <a:t>Token use became just as unreasonable as the agent repeatedly rediscovered the same repository.</a:t>
             </a:r>
           </a:p>
         </p:txBody>
@@ -2493,7 +2498,7 @@
           <p:cNvPr id="8" name="s2-agent">
             <a:extLst xmlns:a="http://schemas.openxmlformats.org/drawingml/2006/main">
               <a:ext uri="{FF2B5EF4-FFF2-40B4-BE49-F238E27FC236}">
-                <a16:creationId xmlns:a16="http://schemas.microsoft.com/office/drawing/2014/main" id="{84A070B6-0251-4CDA-8F0D-ABE6A4ACF9AD}"/>
+                <a16:creationId xmlns:a16="http://schemas.microsoft.com/office/drawing/2014/main" id="{952457D8-E0AD-42F1-B51A-87BF700BB257}"/>
               </a:ext>
             </a:extLst>
           </p:cNvPr>
@@ -2526,7 +2531,7 @@
           <p:cNvPr id="9" name="s2-agent-label">
             <a:extLst xmlns:a="http://schemas.openxmlformats.org/drawingml/2006/main">
               <a:ext uri="{FF2B5EF4-FFF2-40B4-BE49-F238E27FC236}">
-                <a16:creationId xmlns:a16="http://schemas.microsoft.com/office/drawing/2014/main" id="{6CF39E17-8373-440C-B2F0-D6AE2D150E4F}"/>
+                <a16:creationId xmlns:a16="http://schemas.microsoft.com/office/drawing/2014/main" id="{F77C85EF-E588-4129-9299-BCA943D51270}"/>
               </a:ext>
             </a:extLst>
           </p:cNvPr>
@@ -2571,7 +2576,7 @@
           <p:cNvPr id="10" name="s2-file-a">
             <a:extLst xmlns:a="http://schemas.openxmlformats.org/drawingml/2006/main">
               <a:ext uri="{FF2B5EF4-FFF2-40B4-BE49-F238E27FC236}">
-                <a16:creationId xmlns:a16="http://schemas.microsoft.com/office/drawing/2014/main" id="{474F3837-C022-4015-BDF4-6426BB161B32}"/>
+                <a16:creationId xmlns:a16="http://schemas.microsoft.com/office/drawing/2014/main" id="{E25DE2F3-5816-465E-B5D8-85F5EA5B7B04}"/>
               </a:ext>
             </a:extLst>
           </p:cNvPr>
@@ -2604,7 +2609,7 @@
           <p:cNvPr id="11" name="s2-file-b">
             <a:extLst xmlns:a="http://schemas.openxmlformats.org/drawingml/2006/main">
               <a:ext uri="{FF2B5EF4-FFF2-40B4-BE49-F238E27FC236}">
-                <a16:creationId xmlns:a16="http://schemas.microsoft.com/office/drawing/2014/main" id="{1F9D2184-C282-423E-ADA8-41ACF4852C06}"/>
+                <a16:creationId xmlns:a16="http://schemas.microsoft.com/office/drawing/2014/main" id="{BDB7543C-1AF2-4437-B019-E3AE12963C32}"/>
               </a:ext>
             </a:extLst>
           </p:cNvPr>
@@ -2637,7 +2642,7 @@
           <p:cNvPr id="12" name="s2-file-c">
             <a:extLst xmlns:a="http://schemas.openxmlformats.org/drawingml/2006/main">
               <a:ext uri="{FF2B5EF4-FFF2-40B4-BE49-F238E27FC236}">
-                <a16:creationId xmlns:a16="http://schemas.microsoft.com/office/drawing/2014/main" id="{B1B70562-D81A-4886-87E8-A3D80BA646BC}"/>
+                <a16:creationId xmlns:a16="http://schemas.microsoft.com/office/drawing/2014/main" id="{CE506F9F-AC1C-4B4A-95B1-350D04A85CF9}"/>
               </a:ext>
             </a:extLst>
           </p:cNvPr>
@@ -2670,7 +2675,7 @@
           <p:cNvPr id="13" name="s2-file-d">
             <a:extLst xmlns:a="http://schemas.openxmlformats.org/drawingml/2006/main">
               <a:ext uri="{FF2B5EF4-FFF2-40B4-BE49-F238E27FC236}">
-                <a16:creationId xmlns:a16="http://schemas.microsoft.com/office/drawing/2014/main" id="{7592179F-30DA-4397-A78C-CA17A2F6BC34}"/>
+                <a16:creationId xmlns:a16="http://schemas.microsoft.com/office/drawing/2014/main" id="{D645ECDD-670D-4934-B048-87EAB7D19EB8}"/>
               </a:ext>
             </a:extLst>
           </p:cNvPr>
@@ -2703,7 +2708,7 @@
           <p:cNvPr id="14" name="s2-file-e">
             <a:extLst xmlns:a="http://schemas.openxmlformats.org/drawingml/2006/main">
               <a:ext uri="{FF2B5EF4-FFF2-40B4-BE49-F238E27FC236}">
-                <a16:creationId xmlns:a16="http://schemas.microsoft.com/office/drawing/2014/main" id="{DBBF86A9-80E5-4593-A0FB-378DE345A095}"/>
+                <a16:creationId xmlns:a16="http://schemas.microsoft.com/office/drawing/2014/main" id="{AB99B7B3-9C63-4FBF-9470-48EFF288786B}"/>
               </a:ext>
             </a:extLst>
           </p:cNvPr>
@@ -2736,7 +2741,7 @@
           <p:cNvPr id="15" name="s2-file-a-label">
             <a:extLst xmlns:a="http://schemas.openxmlformats.org/drawingml/2006/main">
               <a:ext uri="{FF2B5EF4-FFF2-40B4-BE49-F238E27FC236}">
-                <a16:creationId xmlns:a16="http://schemas.microsoft.com/office/drawing/2014/main" id="{52C289BA-ED16-45F6-BAEC-209AF30A9194}"/>
+                <a16:creationId xmlns:a16="http://schemas.microsoft.com/office/drawing/2014/main" id="{009650EF-6DC2-4FD3-8230-57AEC17762E7}"/>
               </a:ext>
             </a:extLst>
           </p:cNvPr>
@@ -2781,7 +2786,7 @@
           <p:cNvPr id="16" name="s2-file-b-label">
             <a:extLst xmlns:a="http://schemas.openxmlformats.org/drawingml/2006/main">
               <a:ext uri="{FF2B5EF4-FFF2-40B4-BE49-F238E27FC236}">
-                <a16:creationId xmlns:a16="http://schemas.microsoft.com/office/drawing/2014/main" id="{371A28E6-3656-4CE0-9306-575838710869}"/>
+                <a16:creationId xmlns:a16="http://schemas.microsoft.com/office/drawing/2014/main" id="{206287A0-0D71-417D-9323-BD356B9E1F30}"/>
               </a:ext>
             </a:extLst>
           </p:cNvPr>
@@ -2826,7 +2831,7 @@
           <p:cNvPr id="17" name="s2-file-c-label">
             <a:extLst xmlns:a="http://schemas.openxmlformats.org/drawingml/2006/main">
               <a:ext uri="{FF2B5EF4-FFF2-40B4-BE49-F238E27FC236}">
-                <a16:creationId xmlns:a16="http://schemas.microsoft.com/office/drawing/2014/main" id="{4D232135-AA59-4957-83E7-00A6160E59DD}"/>
+                <a16:creationId xmlns:a16="http://schemas.microsoft.com/office/drawing/2014/main" id="{9EFF31B8-0D5E-4438-9973-3F302892D7E7}"/>
               </a:ext>
             </a:extLst>
           </p:cNvPr>
@@ -2871,7 +2876,7 @@
           <p:cNvPr id="18" name="s2-file-d-label">
             <a:extLst xmlns:a="http://schemas.openxmlformats.org/drawingml/2006/main">
               <a:ext uri="{FF2B5EF4-FFF2-40B4-BE49-F238E27FC236}">
-                <a16:creationId xmlns:a16="http://schemas.microsoft.com/office/drawing/2014/main" id="{E0A6DB81-F61D-4F8B-B007-73371BA7B74A}"/>
+                <a16:creationId xmlns:a16="http://schemas.microsoft.com/office/drawing/2014/main" id="{CD0096AC-2AFE-4B0A-B4A5-7F28E314F0CF}"/>
               </a:ext>
             </a:extLst>
           </p:cNvPr>
@@ -2916,7 +2921,7 @@
           <p:cNvPr id="19" name="s2-file-e-label">
             <a:extLst xmlns:a="http://schemas.openxmlformats.org/drawingml/2006/main">
               <a:ext uri="{FF2B5EF4-FFF2-40B4-BE49-F238E27FC236}">
-                <a16:creationId xmlns:a16="http://schemas.microsoft.com/office/drawing/2014/main" id="{907BF0B7-D9A2-4176-824C-04AD2E5B0E6C}"/>
+                <a16:creationId xmlns:a16="http://schemas.microsoft.com/office/drawing/2014/main" id="{D1A04DEF-CED8-482C-80F0-603EDB5572BD}"/>
               </a:ext>
             </a:extLst>
           </p:cNvPr>
@@ -2961,7 +2966,7 @@
           <p:cNvPr id="20" name="s2-n1">
             <a:extLst xmlns:a="http://schemas.openxmlformats.org/drawingml/2006/main">
               <a:ext uri="{FF2B5EF4-FFF2-40B4-BE49-F238E27FC236}">
-                <a16:creationId xmlns:a16="http://schemas.microsoft.com/office/drawing/2014/main" id="{F2A33600-DC10-43DA-9051-472E5629BEDE}"/>
+                <a16:creationId xmlns:a16="http://schemas.microsoft.com/office/drawing/2014/main" id="{54B0AA2E-152C-4877-86BD-E4A7AC425BED}"/>
               </a:ext>
             </a:extLst>
           </p:cNvPr>
@@ -2994,7 +2999,7 @@
           <p:cNvPr id="21" name="s2-n1-label">
             <a:extLst xmlns:a="http://schemas.openxmlformats.org/drawingml/2006/main">
               <a:ext uri="{FF2B5EF4-FFF2-40B4-BE49-F238E27FC236}">
-                <a16:creationId xmlns:a16="http://schemas.microsoft.com/office/drawing/2014/main" id="{D0E9395D-C7D9-4376-B7B3-59C4D49DEFB0}"/>
+                <a16:creationId xmlns:a16="http://schemas.microsoft.com/office/drawing/2014/main" id="{A4F29DD1-F602-43E6-903F-81710190A760}"/>
               </a:ext>
             </a:extLst>
           </p:cNvPr>
@@ -3039,7 +3044,7 @@
           <p:cNvPr id="22" name="s2-p1">
             <a:extLst xmlns:a="http://schemas.openxmlformats.org/drawingml/2006/main">
               <a:ext uri="{FF2B5EF4-FFF2-40B4-BE49-F238E27FC236}">
-                <a16:creationId xmlns:a16="http://schemas.microsoft.com/office/drawing/2014/main" id="{7DEC690F-18E6-4923-8BA3-3279E863381C}"/>
+                <a16:creationId xmlns:a16="http://schemas.microsoft.com/office/drawing/2014/main" id="{25298350-FBC0-4CA0-9F3C-39230D5BC29D}"/>
               </a:ext>
             </a:extLst>
           </p:cNvPr>
@@ -3084,7 +3089,7 @@
           <p:cNvPr id="23" name="s2-n2">
             <a:extLst xmlns:a="http://schemas.openxmlformats.org/drawingml/2006/main">
               <a:ext uri="{FF2B5EF4-FFF2-40B4-BE49-F238E27FC236}">
-                <a16:creationId xmlns:a16="http://schemas.microsoft.com/office/drawing/2014/main" id="{BEF91318-4C46-42D8-B543-666201F7ECF5}"/>
+                <a16:creationId xmlns:a16="http://schemas.microsoft.com/office/drawing/2014/main" id="{E6531A41-12DF-4413-9622-33CCCB7DD2B3}"/>
               </a:ext>
             </a:extLst>
           </p:cNvPr>
@@ -3117,7 +3122,7 @@
           <p:cNvPr id="24" name="s2-n2-label">
             <a:extLst xmlns:a="http://schemas.openxmlformats.org/drawingml/2006/main">
               <a:ext uri="{FF2B5EF4-FFF2-40B4-BE49-F238E27FC236}">
-                <a16:creationId xmlns:a16="http://schemas.microsoft.com/office/drawing/2014/main" id="{AD7C54C5-F54F-4405-A9EF-3A9C34F3641C}"/>
+                <a16:creationId xmlns:a16="http://schemas.microsoft.com/office/drawing/2014/main" id="{6234723A-5B6E-4197-83AA-5C04AAEB4714}"/>
               </a:ext>
             </a:extLst>
           </p:cNvPr>
@@ -3162,7 +3167,7 @@
           <p:cNvPr id="25" name="s2-p2">
             <a:extLst xmlns:a="http://schemas.openxmlformats.org/drawingml/2006/main">
               <a:ext uri="{FF2B5EF4-FFF2-40B4-BE49-F238E27FC236}">
-                <a16:creationId xmlns:a16="http://schemas.microsoft.com/office/drawing/2014/main" id="{CEE263DF-BE37-4EC7-B255-167F415251B0}"/>
+                <a16:creationId xmlns:a16="http://schemas.microsoft.com/office/drawing/2014/main" id="{729C3FF9-5232-45C7-B73F-F6FA4121E56B}"/>
               </a:ext>
             </a:extLst>
           </p:cNvPr>
@@ -3207,7 +3212,7 @@
           <p:cNvPr id="26" name="s2-n3">
             <a:extLst xmlns:a="http://schemas.openxmlformats.org/drawingml/2006/main">
               <a:ext uri="{FF2B5EF4-FFF2-40B4-BE49-F238E27FC236}">
-                <a16:creationId xmlns:a16="http://schemas.microsoft.com/office/drawing/2014/main" id="{98BCC457-4F97-45AA-AABD-4803AB7D686F}"/>
+                <a16:creationId xmlns:a16="http://schemas.microsoft.com/office/drawing/2014/main" id="{1AFAC487-D452-4854-BFE1-52FA51238224}"/>
               </a:ext>
             </a:extLst>
           </p:cNvPr>
@@ -3240,7 +3245,7 @@
           <p:cNvPr id="27" name="s2-n3-label">
             <a:extLst xmlns:a="http://schemas.openxmlformats.org/drawingml/2006/main">
               <a:ext uri="{FF2B5EF4-FFF2-40B4-BE49-F238E27FC236}">
-                <a16:creationId xmlns:a16="http://schemas.microsoft.com/office/drawing/2014/main" id="{7D86C3A0-F65E-4CCE-97AC-9083B16CC46F}"/>
+                <a16:creationId xmlns:a16="http://schemas.microsoft.com/office/drawing/2014/main" id="{00FB4118-EAB5-4692-BCCC-3EFEFD754756}"/>
               </a:ext>
             </a:extLst>
           </p:cNvPr>
@@ -3285,7 +3290,7 @@
           <p:cNvPr id="28" name="s2-p3">
             <a:extLst xmlns:a="http://schemas.openxmlformats.org/drawingml/2006/main">
               <a:ext uri="{FF2B5EF4-FFF2-40B4-BE49-F238E27FC236}">
-                <a16:creationId xmlns:a16="http://schemas.microsoft.com/office/drawing/2014/main" id="{43A3EFAC-692A-48E2-85F5-A4D49CB34D65}"/>
+                <a16:creationId xmlns:a16="http://schemas.microsoft.com/office/drawing/2014/main" id="{529BF1A9-8EFB-498C-B00F-9DDB260AB287}"/>
               </a:ext>
             </a:extLst>
           </p:cNvPr>
@@ -3330,7 +3335,7 @@
           <p:cNvPr id="29" name="s2-takeaway">
             <a:extLst xmlns:a="http://schemas.openxmlformats.org/drawingml/2006/main">
               <a:ext uri="{FF2B5EF4-FFF2-40B4-BE49-F238E27FC236}">
-                <a16:creationId xmlns:a16="http://schemas.microsoft.com/office/drawing/2014/main" id="{5A1579B9-D99E-44DA-B6F1-56B71FB7E614}"/>
+                <a16:creationId xmlns:a16="http://schemas.microsoft.com/office/drawing/2014/main" id="{D0ACB8BD-EE21-4326-B986-8FC8AC8317B6}"/>
               </a:ext>
             </a:extLst>
           </p:cNvPr>
@@ -3365,7 +3370,7 @@
               </a:defRPr>
             </a:pPr>
             <a:r>
-              <a:t>The cost is not only tokens. It is attention spent proving what is irrelevant.</a:t>
+              <a:t>That frustration became the reason I built Vertex Palace.</a:t>
             </a:r>
           </a:p>
         </p:txBody>
@@ -3397,7 +3402,7 @@
           <p:cNvPr id="31" name="footer-source-2">
             <a:extLst xmlns:a="http://schemas.openxmlformats.org/drawingml/2006/main">
               <a:ext uri="{FF2B5EF4-FFF2-40B4-BE49-F238E27FC236}">
-                <a16:creationId xmlns:a16="http://schemas.microsoft.com/office/drawing/2014/main" id="{38D4D3A4-4CC7-429F-B22D-8A41006163BF}"/>
+                <a16:creationId xmlns:a16="http://schemas.microsoft.com/office/drawing/2014/main" id="{F5D6DA4A-4F56-493A-9566-C2D522D6727C}"/>
               </a:ext>
             </a:extLst>
           </p:cNvPr>
@@ -3442,7 +3447,7 @@
           <p:cNvPr id="32" name="footer-number-2">
             <a:extLst xmlns:a="http://schemas.openxmlformats.org/drawingml/2006/main">
               <a:ext uri="{FF2B5EF4-FFF2-40B4-BE49-F238E27FC236}">
-                <a16:creationId xmlns:a16="http://schemas.microsoft.com/office/drawing/2014/main" id="{A9292CFD-30D4-4A57-A124-44445084F5A0}"/>
+                <a16:creationId xmlns:a16="http://schemas.microsoft.com/office/drawing/2014/main" id="{57A1E16F-B221-4BC2-9FD6-36B9A9BC135D}"/>
               </a:ext>
             </a:extLst>
           </p:cNvPr>
@@ -3485,7 +3490,7 @@
     </p:spTree>
     <p:extLst>
       <p:ext uri="{BB962C8B-B14F-4D97-AF65-F5344CB8AC3E}">
-        <p14:creationId xmlns:p14="http://schemas.microsoft.com/office/powerpoint/2010/main" val="426176209"/>
+        <p14:creationId xmlns:p14="http://schemas.microsoft.com/office/powerpoint/2010/main" val="1232146288"/>
       </p:ext>
     </p:extLst>
   </p:cSld>
@@ -3516,7 +3521,7 @@
           <p:cNvPr id="29" name="s3-title">
             <a:extLst xmlns:a="http://schemas.openxmlformats.org/drawingml/2006/main">
               <a:ext uri="{FF2B5EF4-FFF2-40B4-BE49-F238E27FC236}">
-                <a16:creationId xmlns:a16="http://schemas.microsoft.com/office/drawing/2014/main" id="{2D75350B-04D8-4216-9B8C-093B9D682A10}"/>
+                <a16:creationId xmlns:a16="http://schemas.microsoft.com/office/drawing/2014/main" id="{D92F9CBF-9B75-48D7-9978-568567EF54DC}"/>
               </a:ext>
             </a:extLst>
           </p:cNvPr>
@@ -3551,7 +3556,7 @@
               </a:defRPr>
             </a:pPr>
             <a:r>
-              <a:t>One request becomes a bounded, explainable route.</a:t>
+              <a:t>A human memory palace became a map for code.</a:t>
             </a:r>
           </a:p>
         </p:txBody>
@@ -3561,7 +3566,7 @@
           <p:cNvPr id="2" name="s3-subtitle">
             <a:extLst xmlns:a="http://schemas.openxmlformats.org/drawingml/2006/main">
               <a:ext uri="{FF2B5EF4-FFF2-40B4-BE49-F238E27FC236}">
-                <a16:creationId xmlns:a16="http://schemas.microsoft.com/office/drawing/2014/main" id="{1226F62E-28D2-4DB2-9108-54E65698DA59}"/>
+                <a16:creationId xmlns:a16="http://schemas.microsoft.com/office/drawing/2014/main" id="{5C55AC4E-DEDD-46CF-9F11-0449E0E187CD}"/>
               </a:ext>
             </a:extLst>
           </p:cNvPr>
@@ -3573,7 +3578,7 @@
         <p:spPr>
           <a:xfrm xmlns:a="http://schemas.openxmlformats.org/drawingml/2006/main">
             <a:off x="400050" y="1066800"/>
-            <a:ext cx="9239250" cy="381000"/>
+            <a:ext cx="11391900" cy="381000"/>
           </a:xfrm>
           <a:prstGeom xmlns:a="http://schemas.openxmlformats.org/drawingml/2006/main" prst="rect">
             <a:avLst/>
@@ -3596,7 +3601,7 @@
               </a:defRPr>
             </a:pPr>
             <a:r>
-              <a:t>Vertex Palace combines structural indexing, adaptive context, and scoped project memory.</a:t>
+              <a:t>Floors organize domains. Rooms hold features. Routes retrieve context. Pitfalls wait at the entrance.</a:t>
             </a:r>
           </a:p>
         </p:txBody>
@@ -3716,7 +3721,7 @@
           <p:cNvPr id="8" name="s3-repo">
             <a:extLst xmlns:a="http://schemas.openxmlformats.org/drawingml/2006/main">
               <a:ext uri="{FF2B5EF4-FFF2-40B4-BE49-F238E27FC236}">
-                <a16:creationId xmlns:a16="http://schemas.microsoft.com/office/drawing/2014/main" id="{7C3EAB46-D15D-486F-95F6-15FD0941BFE7}"/>
+                <a16:creationId xmlns:a16="http://schemas.microsoft.com/office/drawing/2014/main" id="{2D2EF53F-31C5-4978-ABAA-D68449E00DA8}"/>
               </a:ext>
             </a:extLst>
           </p:cNvPr>
@@ -3751,7 +3756,7 @@
           <p:cNvPr id="9" name="s3-index">
             <a:extLst xmlns:a="http://schemas.openxmlformats.org/drawingml/2006/main">
               <a:ext uri="{FF2B5EF4-FFF2-40B4-BE49-F238E27FC236}">
-                <a16:creationId xmlns:a16="http://schemas.microsoft.com/office/drawing/2014/main" id="{02AF8924-9907-4398-B154-EA9EE1C017E5}"/>
+                <a16:creationId xmlns:a16="http://schemas.microsoft.com/office/drawing/2014/main" id="{1A9AA8D4-1388-42DB-93F7-1519B29C9353}"/>
               </a:ext>
             </a:extLst>
           </p:cNvPr>
@@ -3786,7 +3791,7 @@
           <p:cNvPr id="10" name="s3-mode">
             <a:extLst xmlns:a="http://schemas.openxmlformats.org/drawingml/2006/main">
               <a:ext uri="{FF2B5EF4-FFF2-40B4-BE49-F238E27FC236}">
-                <a16:creationId xmlns:a16="http://schemas.microsoft.com/office/drawing/2014/main" id="{FB9C79DB-8FF6-482C-828B-6293C2AB3B56}"/>
+                <a16:creationId xmlns:a16="http://schemas.microsoft.com/office/drawing/2014/main" id="{0A5361B6-FE8E-4CF3-8B46-BF5CA1F4F179}"/>
               </a:ext>
             </a:extLst>
           </p:cNvPr>
@@ -3821,7 +3826,7 @@
           <p:cNvPr id="11" name="s3-pack">
             <a:extLst xmlns:a="http://schemas.openxmlformats.org/drawingml/2006/main">
               <a:ext uri="{FF2B5EF4-FFF2-40B4-BE49-F238E27FC236}">
-                <a16:creationId xmlns:a16="http://schemas.microsoft.com/office/drawing/2014/main" id="{C42356E4-92A2-46D3-A225-04ED582CAEFE}"/>
+                <a16:creationId xmlns:a16="http://schemas.microsoft.com/office/drawing/2014/main" id="{2A5089C0-ED1A-46E9-AD71-7A84B1788F77}"/>
               </a:ext>
             </a:extLst>
           </p:cNvPr>
@@ -3856,7 +3861,7 @@
           <p:cNvPr id="12" name="s3-task">
             <a:extLst xmlns:a="http://schemas.openxmlformats.org/drawingml/2006/main">
               <a:ext uri="{FF2B5EF4-FFF2-40B4-BE49-F238E27FC236}">
-                <a16:creationId xmlns:a16="http://schemas.microsoft.com/office/drawing/2014/main" id="{649CB1A1-49D3-4EF0-8BCC-4787FF0A78D9}"/>
+                <a16:creationId xmlns:a16="http://schemas.microsoft.com/office/drawing/2014/main" id="{3372EEC0-BB6A-42B0-94B0-B4A2F814F491}"/>
               </a:ext>
             </a:extLst>
           </p:cNvPr>
@@ -3891,7 +3896,7 @@
           <p:cNvPr id="13" name="s3-repo-label">
             <a:extLst xmlns:a="http://schemas.openxmlformats.org/drawingml/2006/main">
               <a:ext uri="{FF2B5EF4-FFF2-40B4-BE49-F238E27FC236}">
-                <a16:creationId xmlns:a16="http://schemas.microsoft.com/office/drawing/2014/main" id="{629BDD9B-C459-4F17-885F-3893511AA8AA}"/>
+                <a16:creationId xmlns:a16="http://schemas.microsoft.com/office/drawing/2014/main" id="{C3D2DF5B-EFC5-494F-A605-521DDE9E1A4B}"/>
               </a:ext>
             </a:extLst>
           </p:cNvPr>
@@ -3936,7 +3941,7 @@
           <p:cNvPr id="14" name="s3-repo-main">
             <a:extLst xmlns:a="http://schemas.openxmlformats.org/drawingml/2006/main">
               <a:ext uri="{FF2B5EF4-FFF2-40B4-BE49-F238E27FC236}">
-                <a16:creationId xmlns:a16="http://schemas.microsoft.com/office/drawing/2014/main" id="{F033DB1B-F1F2-448C-877B-0F0F331BE849}"/>
+                <a16:creationId xmlns:a16="http://schemas.microsoft.com/office/drawing/2014/main" id="{D08BBECF-F87F-404F-B7C6-EFAF4ECC6D17}"/>
               </a:ext>
             </a:extLst>
           </p:cNvPr>
@@ -3981,7 +3986,7 @@
           <p:cNvPr id="15" name="s3-index-label">
             <a:extLst xmlns:a="http://schemas.openxmlformats.org/drawingml/2006/main">
               <a:ext uri="{FF2B5EF4-FFF2-40B4-BE49-F238E27FC236}">
-                <a16:creationId xmlns:a16="http://schemas.microsoft.com/office/drawing/2014/main" id="{A4607E84-91D3-4340-960C-4926E2528823}"/>
+                <a16:creationId xmlns:a16="http://schemas.microsoft.com/office/drawing/2014/main" id="{9CEE3B39-E5AB-43E8-9410-409B433E192D}"/>
               </a:ext>
             </a:extLst>
           </p:cNvPr>
@@ -4026,7 +4031,7 @@
           <p:cNvPr id="16" name="s3-index-main">
             <a:extLst xmlns:a="http://schemas.openxmlformats.org/drawingml/2006/main">
               <a:ext uri="{FF2B5EF4-FFF2-40B4-BE49-F238E27FC236}">
-                <a16:creationId xmlns:a16="http://schemas.microsoft.com/office/drawing/2014/main" id="{94FF517D-11BF-4F2A-94D9-69BB28568F3B}"/>
+                <a16:creationId xmlns:a16="http://schemas.microsoft.com/office/drawing/2014/main" id="{5DE3F261-5714-4F5B-9ED1-5FD182A2F133}"/>
               </a:ext>
             </a:extLst>
           </p:cNvPr>
@@ -4071,7 +4076,7 @@
           <p:cNvPr id="17" name="s3-mode-label">
             <a:extLst xmlns:a="http://schemas.openxmlformats.org/drawingml/2006/main">
               <a:ext uri="{FF2B5EF4-FFF2-40B4-BE49-F238E27FC236}">
-                <a16:creationId xmlns:a16="http://schemas.microsoft.com/office/drawing/2014/main" id="{507034A9-0FE3-4EB2-8138-FB6AFAE351AD}"/>
+                <a16:creationId xmlns:a16="http://schemas.microsoft.com/office/drawing/2014/main" id="{4139FC64-999A-45F7-8770-136EAE227679}"/>
               </a:ext>
             </a:extLst>
           </p:cNvPr>
@@ -4116,7 +4121,7 @@
           <p:cNvPr id="18" name="s3-mode-main">
             <a:extLst xmlns:a="http://schemas.openxmlformats.org/drawingml/2006/main">
               <a:ext uri="{FF2B5EF4-FFF2-40B4-BE49-F238E27FC236}">
-                <a16:creationId xmlns:a16="http://schemas.microsoft.com/office/drawing/2014/main" id="{1B42CB96-CBE5-4028-BA7B-C3C98098F835}"/>
+                <a16:creationId xmlns:a16="http://schemas.microsoft.com/office/drawing/2014/main" id="{39C7742F-62C2-4E76-AC74-8C9448293D94}"/>
               </a:ext>
             </a:extLst>
           </p:cNvPr>
@@ -4161,7 +4166,7 @@
           <p:cNvPr id="19" name="s3-pack-label">
             <a:extLst xmlns:a="http://schemas.openxmlformats.org/drawingml/2006/main">
               <a:ext uri="{FF2B5EF4-FFF2-40B4-BE49-F238E27FC236}">
-                <a16:creationId xmlns:a16="http://schemas.microsoft.com/office/drawing/2014/main" id="{B7529E3F-6E85-4FCA-ACE0-1C675F05DE08}"/>
+                <a16:creationId xmlns:a16="http://schemas.microsoft.com/office/drawing/2014/main" id="{2B5D58DB-5CFC-45B3-9422-23C1CC531681}"/>
               </a:ext>
             </a:extLst>
           </p:cNvPr>
@@ -4206,7 +4211,7 @@
           <p:cNvPr id="20" name="s3-pack-main">
             <a:extLst xmlns:a="http://schemas.openxmlformats.org/drawingml/2006/main">
               <a:ext uri="{FF2B5EF4-FFF2-40B4-BE49-F238E27FC236}">
-                <a16:creationId xmlns:a16="http://schemas.microsoft.com/office/drawing/2014/main" id="{DB4DA38F-68CD-41B2-89BF-1C641C1CDF74}"/>
+                <a16:creationId xmlns:a16="http://schemas.microsoft.com/office/drawing/2014/main" id="{4E32E37A-1023-4D21-B597-282845AFFF57}"/>
               </a:ext>
             </a:extLst>
           </p:cNvPr>
@@ -4251,7 +4256,7 @@
           <p:cNvPr id="21" name="s3-task-label">
             <a:extLst xmlns:a="http://schemas.openxmlformats.org/drawingml/2006/main">
               <a:ext uri="{FF2B5EF4-FFF2-40B4-BE49-F238E27FC236}">
-                <a16:creationId xmlns:a16="http://schemas.microsoft.com/office/drawing/2014/main" id="{98D605FC-4211-4229-B6BF-CFDE55854D9F}"/>
+                <a16:creationId xmlns:a16="http://schemas.microsoft.com/office/drawing/2014/main" id="{C8F5B856-286B-4FF9-A925-B6A5417AB582}"/>
               </a:ext>
             </a:extLst>
           </p:cNvPr>
@@ -4296,7 +4301,7 @@
           <p:cNvPr id="22" name="s3-task-main">
             <a:extLst xmlns:a="http://schemas.openxmlformats.org/drawingml/2006/main">
               <a:ext uri="{FF2B5EF4-FFF2-40B4-BE49-F238E27FC236}">
-                <a16:creationId xmlns:a16="http://schemas.microsoft.com/office/drawing/2014/main" id="{DDEC3D53-8E69-489E-9286-FEEB770D9D45}"/>
+                <a16:creationId xmlns:a16="http://schemas.microsoft.com/office/drawing/2014/main" id="{695CFAC2-62EC-417E-B040-37E950FD429C}"/>
               </a:ext>
             </a:extLst>
           </p:cNvPr>
@@ -4341,7 +4346,7 @@
           <p:cNvPr id="23" name="s3-memory">
             <a:extLst xmlns:a="http://schemas.openxmlformats.org/drawingml/2006/main">
               <a:ext uri="{FF2B5EF4-FFF2-40B4-BE49-F238E27FC236}">
-                <a16:creationId xmlns:a16="http://schemas.microsoft.com/office/drawing/2014/main" id="{50F66902-D3D4-4D63-8A19-E9992C972D6A}"/>
+                <a16:creationId xmlns:a16="http://schemas.microsoft.com/office/drawing/2014/main" id="{66EF50F3-8ABC-450E-B25B-A7FDB7B839F9}"/>
               </a:ext>
             </a:extLst>
           </p:cNvPr>
@@ -4376,7 +4381,7 @@
           <p:cNvPr id="24" name="s3-memory-label">
             <a:extLst xmlns:a="http://schemas.openxmlformats.org/drawingml/2006/main">
               <a:ext uri="{FF2B5EF4-FFF2-40B4-BE49-F238E27FC236}">
-                <a16:creationId xmlns:a16="http://schemas.microsoft.com/office/drawing/2014/main" id="{F97EAA58-99D6-4058-86A5-1567651A6159}"/>
+                <a16:creationId xmlns:a16="http://schemas.microsoft.com/office/drawing/2014/main" id="{11CDE2CB-061F-4DA6-8B4C-B074F0F745CA}"/>
               </a:ext>
             </a:extLst>
           </p:cNvPr>
@@ -4421,7 +4426,7 @@
           <p:cNvPr id="25" name="s3-memory-main">
             <a:extLst xmlns:a="http://schemas.openxmlformats.org/drawingml/2006/main">
               <a:ext uri="{FF2B5EF4-FFF2-40B4-BE49-F238E27FC236}">
-                <a16:creationId xmlns:a16="http://schemas.microsoft.com/office/drawing/2014/main" id="{13687926-CB40-4FDA-9BDC-31A7E973E204}"/>
+                <a16:creationId xmlns:a16="http://schemas.microsoft.com/office/drawing/2014/main" id="{8CA8B7A1-668E-4D96-9618-9520F20C402F}"/>
               </a:ext>
             </a:extLst>
           </p:cNvPr>
@@ -4489,7 +4494,7 @@
           <p:cNvPr id="27" name="footer-source-3">
             <a:extLst xmlns:a="http://schemas.openxmlformats.org/drawingml/2006/main">
               <a:ext uri="{FF2B5EF4-FFF2-40B4-BE49-F238E27FC236}">
-                <a16:creationId xmlns:a16="http://schemas.microsoft.com/office/drawing/2014/main" id="{C8B0C1CF-FEC0-4645-8F8B-566956B0D8EB}"/>
+                <a16:creationId xmlns:a16="http://schemas.microsoft.com/office/drawing/2014/main" id="{B62A79BE-149B-4286-8522-827B65ED8C76}"/>
               </a:ext>
             </a:extLst>
           </p:cNvPr>
@@ -4534,7 +4539,7 @@
           <p:cNvPr id="28" name="footer-number-3">
             <a:extLst xmlns:a="http://schemas.openxmlformats.org/drawingml/2006/main">
               <a:ext uri="{FF2B5EF4-FFF2-40B4-BE49-F238E27FC236}">
-                <a16:creationId xmlns:a16="http://schemas.microsoft.com/office/drawing/2014/main" id="{6B3080F1-48BB-4099-83DF-D16867730071}"/>
+                <a16:creationId xmlns:a16="http://schemas.microsoft.com/office/drawing/2014/main" id="{FDCCC621-878A-40B5-AD45-DFE111C01B65}"/>
               </a:ext>
             </a:extLst>
           </p:cNvPr>
@@ -4577,7 +4582,7 @@
     </p:spTree>
     <p:extLst>
       <p:ext uri="{BB962C8B-B14F-4D97-AF65-F5344CB8AC3E}">
-        <p14:creationId xmlns:p14="http://schemas.microsoft.com/office/powerpoint/2010/main" val="1450612614"/>
+        <p14:creationId xmlns:p14="http://schemas.microsoft.com/office/powerpoint/2010/main" val="1625512413"/>
       </p:ext>
     </p:extLst>
   </p:cSld>
@@ -4608,7 +4613,7 @@
           <p:cNvPr id="26" name="s4-title">
             <a:extLst xmlns:a="http://schemas.openxmlformats.org/drawingml/2006/main">
               <a:ext uri="{FF2B5EF4-FFF2-40B4-BE49-F238E27FC236}">
-                <a16:creationId xmlns:a16="http://schemas.microsoft.com/office/drawing/2014/main" id="{8B8C0188-82E7-4AD9-A8F9-2AF9DC6FF329}"/>
+                <a16:creationId xmlns:a16="http://schemas.microsoft.com/office/drawing/2014/main" id="{74BDA43C-BFDB-43EC-AF4C-0DCE8F9B7618}"/>
               </a:ext>
             </a:extLst>
           </p:cNvPr>
@@ -4653,7 +4658,7 @@
           <p:cNvPr id="2" name="s4-subtitle">
             <a:extLst xmlns:a="http://schemas.openxmlformats.org/drawingml/2006/main">
               <a:ext uri="{FF2B5EF4-FFF2-40B4-BE49-F238E27FC236}">
-                <a16:creationId xmlns:a16="http://schemas.microsoft.com/office/drawing/2014/main" id="{1FA8C591-B717-41F7-85EC-E7BF1EE2E6F2}"/>
+                <a16:creationId xmlns:a16="http://schemas.microsoft.com/office/drawing/2014/main" id="{7418B20B-4660-4729-B812-1C8E72866175}"/>
               </a:ext>
             </a:extLst>
           </p:cNvPr>
@@ -4698,7 +4703,7 @@
           <p:cNvPr id="3" name="s4-terminal">
             <a:extLst xmlns:a="http://schemas.openxmlformats.org/drawingml/2006/main">
               <a:ext uri="{FF2B5EF4-FFF2-40B4-BE49-F238E27FC236}">
-                <a16:creationId xmlns:a16="http://schemas.microsoft.com/office/drawing/2014/main" id="{50E2F904-C757-4D4D-8C5A-813F5AFF1B9E}"/>
+                <a16:creationId xmlns:a16="http://schemas.microsoft.com/office/drawing/2014/main" id="{AEA1B5C2-FBA6-40FD-9AFF-73B8BDE69E5F}"/>
               </a:ext>
             </a:extLst>
           </p:cNvPr>
@@ -4755,7 +4760,7 @@
           <p:cNvPr id="5" name="s4-dot1">
             <a:extLst xmlns:a="http://schemas.openxmlformats.org/drawingml/2006/main">
               <a:ext uri="{FF2B5EF4-FFF2-40B4-BE49-F238E27FC236}">
-                <a16:creationId xmlns:a16="http://schemas.microsoft.com/office/drawing/2014/main" id="{3BB6B074-9212-4971-8044-C5F95D62015E}"/>
+                <a16:creationId xmlns:a16="http://schemas.microsoft.com/office/drawing/2014/main" id="{B2DDEE5B-8847-4D78-9FC8-C3CA87313A5B}"/>
               </a:ext>
             </a:extLst>
           </p:cNvPr>
@@ -4788,7 +4793,7 @@
           <p:cNvPr id="6" name="s4-dot2">
             <a:extLst xmlns:a="http://schemas.openxmlformats.org/drawingml/2006/main">
               <a:ext uri="{FF2B5EF4-FFF2-40B4-BE49-F238E27FC236}">
-                <a16:creationId xmlns:a16="http://schemas.microsoft.com/office/drawing/2014/main" id="{2661CE75-B472-451B-8E7B-F049BE48FF84}"/>
+                <a16:creationId xmlns:a16="http://schemas.microsoft.com/office/drawing/2014/main" id="{A4120322-37E7-4602-806E-41D8EFFB6BD2}"/>
               </a:ext>
             </a:extLst>
           </p:cNvPr>
@@ -4821,7 +4826,7 @@
           <p:cNvPr id="7" name="s4-dot3">
             <a:extLst xmlns:a="http://schemas.openxmlformats.org/drawingml/2006/main">
               <a:ext uri="{FF2B5EF4-FFF2-40B4-BE49-F238E27FC236}">
-                <a16:creationId xmlns:a16="http://schemas.microsoft.com/office/drawing/2014/main" id="{9D0B8205-7F1B-4057-B6AB-13000945E104}"/>
+                <a16:creationId xmlns:a16="http://schemas.microsoft.com/office/drawing/2014/main" id="{FBB6EC7D-42BA-4247-A36C-6FBFEB459E22}"/>
               </a:ext>
             </a:extLst>
           </p:cNvPr>
@@ -4854,7 +4859,7 @@
           <p:cNvPr id="8" name="s4-command-label">
             <a:extLst xmlns:a="http://schemas.openxmlformats.org/drawingml/2006/main">
               <a:ext uri="{FF2B5EF4-FFF2-40B4-BE49-F238E27FC236}">
-                <a16:creationId xmlns:a16="http://schemas.microsoft.com/office/drawing/2014/main" id="{3C980936-3782-4BFF-B638-ED8BD2340ED5}"/>
+                <a16:creationId xmlns:a16="http://schemas.microsoft.com/office/drawing/2014/main" id="{BA374669-918A-48C4-AB7E-F32EE3FA9198}"/>
               </a:ext>
             </a:extLst>
           </p:cNvPr>
@@ -4899,7 +4904,7 @@
           <p:cNvPr id="9" name="s4-command">
             <a:extLst xmlns:a="http://schemas.openxmlformats.org/drawingml/2006/main">
               <a:ext uri="{FF2B5EF4-FFF2-40B4-BE49-F238E27FC236}">
-                <a16:creationId xmlns:a16="http://schemas.microsoft.com/office/drawing/2014/main" id="{D72A38F0-99A7-447E-AB26-6DA7891488A2}"/>
+                <a16:creationId xmlns:a16="http://schemas.microsoft.com/office/drawing/2014/main" id="{9BE86474-632D-43EA-9C9E-89468A5B90E7}"/>
               </a:ext>
             </a:extLst>
           </p:cNvPr>
@@ -4948,7 +4953,7 @@
           <p:cNvPr id="10" name="s4-command-note">
             <a:extLst xmlns:a="http://schemas.openxmlformats.org/drawingml/2006/main">
               <a:ext uri="{FF2B5EF4-FFF2-40B4-BE49-F238E27FC236}">
-                <a16:creationId xmlns:a16="http://schemas.microsoft.com/office/drawing/2014/main" id="{A0B12E46-67A6-4916-A68D-FBA2DED2D2E4}"/>
+                <a16:creationId xmlns:a16="http://schemas.microsoft.com/office/drawing/2014/main" id="{27D11303-38FE-411A-B586-4587331DBDAD}"/>
               </a:ext>
             </a:extLst>
           </p:cNvPr>
@@ -4993,7 +4998,7 @@
           <p:cNvPr id="11" name="s4-output-label">
             <a:extLst xmlns:a="http://schemas.openxmlformats.org/drawingml/2006/main">
               <a:ext uri="{FF2B5EF4-FFF2-40B4-BE49-F238E27FC236}">
-                <a16:creationId xmlns:a16="http://schemas.microsoft.com/office/drawing/2014/main" id="{F4C0B86C-2BAE-4FFB-9698-DDCDA48253AB}"/>
+                <a16:creationId xmlns:a16="http://schemas.microsoft.com/office/drawing/2014/main" id="{F06940CE-1C30-47DD-9F3F-634D6640923D}"/>
               </a:ext>
             </a:extLst>
           </p:cNvPr>
@@ -5038,7 +5043,7 @@
           <p:cNvPr id="12" name="s4-o1a">
             <a:extLst xmlns:a="http://schemas.openxmlformats.org/drawingml/2006/main">
               <a:ext uri="{FF2B5EF4-FFF2-40B4-BE49-F238E27FC236}">
-                <a16:creationId xmlns:a16="http://schemas.microsoft.com/office/drawing/2014/main" id="{324D1561-13E1-4C09-9662-F2EB996BF9C0}"/>
+                <a16:creationId xmlns:a16="http://schemas.microsoft.com/office/drawing/2014/main" id="{E954E9FD-4ABC-49A8-98B8-7CB739A7867E}"/>
               </a:ext>
             </a:extLst>
           </p:cNvPr>
@@ -5083,7 +5088,7 @@
           <p:cNvPr id="13" name="s4-o1b">
             <a:extLst xmlns:a="http://schemas.openxmlformats.org/drawingml/2006/main">
               <a:ext uri="{FF2B5EF4-FFF2-40B4-BE49-F238E27FC236}">
-                <a16:creationId xmlns:a16="http://schemas.microsoft.com/office/drawing/2014/main" id="{A6699324-BD9F-4517-A068-53C0A8C998E4}"/>
+                <a16:creationId xmlns:a16="http://schemas.microsoft.com/office/drawing/2014/main" id="{FF81212A-580A-4793-B355-F7016ECC6B47}"/>
               </a:ext>
             </a:extLst>
           </p:cNvPr>
@@ -5128,7 +5133,7 @@
           <p:cNvPr id="14" name="s4-o2a">
             <a:extLst xmlns:a="http://schemas.openxmlformats.org/drawingml/2006/main">
               <a:ext uri="{FF2B5EF4-FFF2-40B4-BE49-F238E27FC236}">
-                <a16:creationId xmlns:a16="http://schemas.microsoft.com/office/drawing/2014/main" id="{D20F5E0C-41B9-418B-A01E-4A2414082F23}"/>
+                <a16:creationId xmlns:a16="http://schemas.microsoft.com/office/drawing/2014/main" id="{8124CF30-039C-43EF-9CE1-B1D7F6E73F59}"/>
               </a:ext>
             </a:extLst>
           </p:cNvPr>
@@ -5173,7 +5178,7 @@
           <p:cNvPr id="15" name="s4-o2b">
             <a:extLst xmlns:a="http://schemas.openxmlformats.org/drawingml/2006/main">
               <a:ext uri="{FF2B5EF4-FFF2-40B4-BE49-F238E27FC236}">
-                <a16:creationId xmlns:a16="http://schemas.microsoft.com/office/drawing/2014/main" id="{1426ECC5-6A3B-4BDE-A9B5-B121BBC26F9B}"/>
+                <a16:creationId xmlns:a16="http://schemas.microsoft.com/office/drawing/2014/main" id="{445EFAC5-8441-473A-805E-6255B05A93F1}"/>
               </a:ext>
             </a:extLst>
           </p:cNvPr>
@@ -5218,7 +5223,7 @@
           <p:cNvPr id="16" name="s4-o3a">
             <a:extLst xmlns:a="http://schemas.openxmlformats.org/drawingml/2006/main">
               <a:ext uri="{FF2B5EF4-FFF2-40B4-BE49-F238E27FC236}">
-                <a16:creationId xmlns:a16="http://schemas.microsoft.com/office/drawing/2014/main" id="{332D7B6D-D5F3-466C-B8EE-79F700C3C114}"/>
+                <a16:creationId xmlns:a16="http://schemas.microsoft.com/office/drawing/2014/main" id="{FE8313A0-DBD2-4D3C-8432-DB6839E176A8}"/>
               </a:ext>
             </a:extLst>
           </p:cNvPr>
@@ -5263,7 +5268,7 @@
           <p:cNvPr id="17" name="s4-o3b">
             <a:extLst xmlns:a="http://schemas.openxmlformats.org/drawingml/2006/main">
               <a:ext uri="{FF2B5EF4-FFF2-40B4-BE49-F238E27FC236}">
-                <a16:creationId xmlns:a16="http://schemas.microsoft.com/office/drawing/2014/main" id="{2B450276-144B-4529-BC74-0F240292E476}"/>
+                <a16:creationId xmlns:a16="http://schemas.microsoft.com/office/drawing/2014/main" id="{78569779-1F75-4CD9-992E-3A04F7664A3B}"/>
               </a:ext>
             </a:extLst>
           </p:cNvPr>
@@ -5308,7 +5313,7 @@
           <p:cNvPr id="18" name="s4-o4a">
             <a:extLst xmlns:a="http://schemas.openxmlformats.org/drawingml/2006/main">
               <a:ext uri="{FF2B5EF4-FFF2-40B4-BE49-F238E27FC236}">
-                <a16:creationId xmlns:a16="http://schemas.microsoft.com/office/drawing/2014/main" id="{95C9CF3D-AE33-46F7-9075-558E5C1931EF}"/>
+                <a16:creationId xmlns:a16="http://schemas.microsoft.com/office/drawing/2014/main" id="{5A134E6B-A5C0-4DDD-9529-0892C1365D9B}"/>
               </a:ext>
             </a:extLst>
           </p:cNvPr>
@@ -5353,7 +5358,7 @@
           <p:cNvPr id="19" name="s4-o4b">
             <a:extLst xmlns:a="http://schemas.openxmlformats.org/drawingml/2006/main">
               <a:ext uri="{FF2B5EF4-FFF2-40B4-BE49-F238E27FC236}">
-                <a16:creationId xmlns:a16="http://schemas.microsoft.com/office/drawing/2014/main" id="{B870409A-D6B6-449E-8CF3-8DC3EEDC2A64}"/>
+                <a16:creationId xmlns:a16="http://schemas.microsoft.com/office/drawing/2014/main" id="{2DB88EB1-A797-4AEA-A6DA-91C3A2A6E5C2}"/>
               </a:ext>
             </a:extLst>
           </p:cNvPr>
@@ -5399,7 +5404,7 @@
           <p:cNvPr id="20" name="s4-o5a">
             <a:extLst xmlns:a="http://schemas.openxmlformats.org/drawingml/2006/main">
               <a:ext uri="{FF2B5EF4-FFF2-40B4-BE49-F238E27FC236}">
-                <a16:creationId xmlns:a16="http://schemas.microsoft.com/office/drawing/2014/main" id="{43329430-1FCE-4D17-A8BA-F1DC2393205A}"/>
+                <a16:creationId xmlns:a16="http://schemas.microsoft.com/office/drawing/2014/main" id="{490F1FE3-EB67-4C8C-A5E6-170C395824C6}"/>
               </a:ext>
             </a:extLst>
           </p:cNvPr>
@@ -5444,7 +5449,7 @@
           <p:cNvPr id="21" name="s4-o5b">
             <a:extLst xmlns:a="http://schemas.openxmlformats.org/drawingml/2006/main">
               <a:ext uri="{FF2B5EF4-FFF2-40B4-BE49-F238E27FC236}">
-                <a16:creationId xmlns:a16="http://schemas.microsoft.com/office/drawing/2014/main" id="{7DEE24E1-44BE-4E9B-A7E1-8486054A2593}"/>
+                <a16:creationId xmlns:a16="http://schemas.microsoft.com/office/drawing/2014/main" id="{8C85233A-30D2-4019-B87A-045BB9910A17}"/>
               </a:ext>
             </a:extLst>
           </p:cNvPr>
@@ -5489,7 +5494,7 @@
           <p:cNvPr id="22" name="s4-output-note">
             <a:extLst xmlns:a="http://schemas.openxmlformats.org/drawingml/2006/main">
               <a:ext uri="{FF2B5EF4-FFF2-40B4-BE49-F238E27FC236}">
-                <a16:creationId xmlns:a16="http://schemas.microsoft.com/office/drawing/2014/main" id="{9C6435BD-35FD-4B9C-ABC6-FDA92B96F7C7}"/>
+                <a16:creationId xmlns:a16="http://schemas.microsoft.com/office/drawing/2014/main" id="{F75EC3B4-5808-4810-8BF0-3B8BECDCD7AB}"/>
               </a:ext>
             </a:extLst>
           </p:cNvPr>
@@ -5556,7 +5561,7 @@
           <p:cNvPr id="24" name="footer-source-4">
             <a:extLst xmlns:a="http://schemas.openxmlformats.org/drawingml/2006/main">
               <a:ext uri="{FF2B5EF4-FFF2-40B4-BE49-F238E27FC236}">
-                <a16:creationId xmlns:a16="http://schemas.microsoft.com/office/drawing/2014/main" id="{1F87CA40-A6D8-47BE-96E7-EBC389D929D7}"/>
+                <a16:creationId xmlns:a16="http://schemas.microsoft.com/office/drawing/2014/main" id="{0F0D8938-A89A-4493-9D6F-C0E839966556}"/>
               </a:ext>
             </a:extLst>
           </p:cNvPr>
@@ -5601,7 +5606,7 @@
           <p:cNvPr id="25" name="footer-number-4">
             <a:extLst xmlns:a="http://schemas.openxmlformats.org/drawingml/2006/main">
               <a:ext uri="{FF2B5EF4-FFF2-40B4-BE49-F238E27FC236}">
-                <a16:creationId xmlns:a16="http://schemas.microsoft.com/office/drawing/2014/main" id="{AF4523AB-8F25-4B90-9938-025B3FEE879F}"/>
+                <a16:creationId xmlns:a16="http://schemas.microsoft.com/office/drawing/2014/main" id="{54A5B34E-C247-47E2-A958-1B925C4003D4}"/>
               </a:ext>
             </a:extLst>
           </p:cNvPr>
@@ -5644,7 +5649,7 @@
     </p:spTree>
     <p:extLst>
       <p:ext uri="{BB962C8B-B14F-4D97-AF65-F5344CB8AC3E}">
-        <p14:creationId xmlns:p14="http://schemas.microsoft.com/office/powerpoint/2010/main" val="803423681"/>
+        <p14:creationId xmlns:p14="http://schemas.microsoft.com/office/powerpoint/2010/main" val="1252619973"/>
       </p:ext>
     </p:extLst>
   </p:cSld>
@@ -5675,7 +5680,7 @@
           <p:cNvPr id="17" name="s5-title">
             <a:extLst xmlns:a="http://schemas.openxmlformats.org/drawingml/2006/main">
               <a:ext uri="{FF2B5EF4-FFF2-40B4-BE49-F238E27FC236}">
-                <a16:creationId xmlns:a16="http://schemas.microsoft.com/office/drawing/2014/main" id="{76E52DD2-A0C9-4656-92A8-F4E0988AFABE}"/>
+                <a16:creationId xmlns:a16="http://schemas.microsoft.com/office/drawing/2014/main" id="{D35F4426-6DDA-41A9-A765-9D36A49EDA8D}"/>
               </a:ext>
             </a:extLst>
           </p:cNvPr>
@@ -5720,7 +5725,7 @@
           <p:cNvPr id="2" name="s5-subtitle">
             <a:extLst xmlns:a="http://schemas.openxmlformats.org/drawingml/2006/main">
               <a:ext uri="{FF2B5EF4-FFF2-40B4-BE49-F238E27FC236}">
-                <a16:creationId xmlns:a16="http://schemas.microsoft.com/office/drawing/2014/main" id="{1813B990-C9CA-4746-A818-EA77B804CF2C}"/>
+                <a16:creationId xmlns:a16="http://schemas.microsoft.com/office/drawing/2014/main" id="{5B81A1D7-33A5-403F-940A-AB9321BE373B}"/>
               </a:ext>
             </a:extLst>
           </p:cNvPr>
@@ -5765,7 +5770,7 @@
           <p:cNvPr id="3" name="s5-chart-label-pack">
             <a:extLst xmlns:a="http://schemas.openxmlformats.org/drawingml/2006/main">
               <a:ext uri="{FF2B5EF4-FFF2-40B4-BE49-F238E27FC236}">
-                <a16:creationId xmlns:a16="http://schemas.microsoft.com/office/drawing/2014/main" id="{C46B7979-995C-429D-986F-01DF6996E13D}"/>
+                <a16:creationId xmlns:a16="http://schemas.microsoft.com/office/drawing/2014/main" id="{15374AF6-392A-40A3-A784-6090F6E8572D}"/>
               </a:ext>
             </a:extLst>
           </p:cNvPr>
@@ -5810,7 +5815,7 @@
           <p:cNvPr id="4" name="s5-chart-label-repo">
             <a:extLst xmlns:a="http://schemas.openxmlformats.org/drawingml/2006/main">
               <a:ext uri="{FF2B5EF4-FFF2-40B4-BE49-F238E27FC236}">
-                <a16:creationId xmlns:a16="http://schemas.microsoft.com/office/drawing/2014/main" id="{31052C75-8E41-4E01-BE28-706892D54C78}"/>
+                <a16:creationId xmlns:a16="http://schemas.microsoft.com/office/drawing/2014/main" id="{857CE099-7D3C-4806-9B0E-A935E09ACE42}"/>
               </a:ext>
             </a:extLst>
           </p:cNvPr>
@@ -5855,7 +5860,7 @@
           <p:cNvPr id="5" name="s5-stat1">
             <a:extLst xmlns:a="http://schemas.openxmlformats.org/drawingml/2006/main">
               <a:ext uri="{FF2B5EF4-FFF2-40B4-BE49-F238E27FC236}">
-                <a16:creationId xmlns:a16="http://schemas.microsoft.com/office/drawing/2014/main" id="{A1CA9DEA-A48C-43E1-86DA-83F491DD7513}"/>
+                <a16:creationId xmlns:a16="http://schemas.microsoft.com/office/drawing/2014/main" id="{510BE700-F9C1-4618-8AB5-E0F514AB8467}"/>
               </a:ext>
             </a:extLst>
           </p:cNvPr>
@@ -5900,7 +5905,7 @@
           <p:cNvPr id="6" name="s5-stat1-label">
             <a:extLst xmlns:a="http://schemas.openxmlformats.org/drawingml/2006/main">
               <a:ext uri="{FF2B5EF4-FFF2-40B4-BE49-F238E27FC236}">
-                <a16:creationId xmlns:a16="http://schemas.microsoft.com/office/drawing/2014/main" id="{16203803-29F8-4903-B4BF-00FA3911468F}"/>
+                <a16:creationId xmlns:a16="http://schemas.microsoft.com/office/drawing/2014/main" id="{3C9856A0-5542-4072-8570-5336FE307974}"/>
               </a:ext>
             </a:extLst>
           </p:cNvPr>
@@ -5967,7 +5972,7 @@
           <p:cNvPr id="8" name="s5-stat2">
             <a:extLst xmlns:a="http://schemas.openxmlformats.org/drawingml/2006/main">
               <a:ext uri="{FF2B5EF4-FFF2-40B4-BE49-F238E27FC236}">
-                <a16:creationId xmlns:a16="http://schemas.microsoft.com/office/drawing/2014/main" id="{D285DE64-11D9-4B58-8AB8-73FD0AD3FC35}"/>
+                <a16:creationId xmlns:a16="http://schemas.microsoft.com/office/drawing/2014/main" id="{C3969D29-751F-465A-8D81-0ED66641AD20}"/>
               </a:ext>
             </a:extLst>
           </p:cNvPr>
@@ -6012,7 +6017,7 @@
           <p:cNvPr id="9" name="s5-stat2-label">
             <a:extLst xmlns:a="http://schemas.openxmlformats.org/drawingml/2006/main">
               <a:ext uri="{FF2B5EF4-FFF2-40B4-BE49-F238E27FC236}">
-                <a16:creationId xmlns:a16="http://schemas.microsoft.com/office/drawing/2014/main" id="{B7E363B3-08A2-4447-B692-2D6F110F7FDC}"/>
+                <a16:creationId xmlns:a16="http://schemas.microsoft.com/office/drawing/2014/main" id="{8E5BB0A4-1645-4780-A8D1-3316715CF8C6}"/>
               </a:ext>
             </a:extLst>
           </p:cNvPr>
@@ -6057,7 +6062,7 @@
           <p:cNvPr id="10" name="s5-stat3">
             <a:extLst xmlns:a="http://schemas.openxmlformats.org/drawingml/2006/main">
               <a:ext uri="{FF2B5EF4-FFF2-40B4-BE49-F238E27FC236}">
-                <a16:creationId xmlns:a16="http://schemas.microsoft.com/office/drawing/2014/main" id="{1752231E-611E-445E-B4E1-A54C54B4FDD2}"/>
+                <a16:creationId xmlns:a16="http://schemas.microsoft.com/office/drawing/2014/main" id="{41EAC7CB-18E0-40B8-83CB-EEC902F5B11A}"/>
               </a:ext>
             </a:extLst>
           </p:cNvPr>
@@ -6102,7 +6107,7 @@
           <p:cNvPr id="11" name="s5-stat3-label">
             <a:extLst xmlns:a="http://schemas.openxmlformats.org/drawingml/2006/main">
               <a:ext uri="{FF2B5EF4-FFF2-40B4-BE49-F238E27FC236}">
-                <a16:creationId xmlns:a16="http://schemas.microsoft.com/office/drawing/2014/main" id="{0C9C64DF-9217-4490-AEA7-3A139C87F7EB}"/>
+                <a16:creationId xmlns:a16="http://schemas.microsoft.com/office/drawing/2014/main" id="{8CACC0FA-D6CD-49C4-BC77-1D7FC51BF615}"/>
               </a:ext>
             </a:extLst>
           </p:cNvPr>
@@ -6147,7 +6152,7 @@
           <p:cNvPr id="12" name="s5-explain">
             <a:extLst xmlns:a="http://schemas.openxmlformats.org/drawingml/2006/main">
               <a:ext uri="{FF2B5EF4-FFF2-40B4-BE49-F238E27FC236}">
-                <a16:creationId xmlns:a16="http://schemas.microsoft.com/office/drawing/2014/main" id="{F8E691CA-7234-488D-A4C4-C29DCCBF7B4C}"/>
+                <a16:creationId xmlns:a16="http://schemas.microsoft.com/office/drawing/2014/main" id="{E537750A-8D2D-4833-B7C1-CC328B600570}"/>
               </a:ext>
             </a:extLst>
           </p:cNvPr>
@@ -6214,7 +6219,7 @@
           <p:cNvPr id="14" name="footer-source-5">
             <a:extLst xmlns:a="http://schemas.openxmlformats.org/drawingml/2006/main">
               <a:ext uri="{FF2B5EF4-FFF2-40B4-BE49-F238E27FC236}">
-                <a16:creationId xmlns:a16="http://schemas.microsoft.com/office/drawing/2014/main" id="{08D00938-8CE1-4AB6-8B56-5D412A04CF25}"/>
+                <a16:creationId xmlns:a16="http://schemas.microsoft.com/office/drawing/2014/main" id="{9D323E44-8B38-4A30-8173-39057CAE28E7}"/>
               </a:ext>
             </a:extLst>
           </p:cNvPr>
@@ -6259,7 +6264,7 @@
           <p:cNvPr id="15" name="footer-number-5">
             <a:extLst xmlns:a="http://schemas.openxmlformats.org/drawingml/2006/main">
               <a:ext uri="{FF2B5EF4-FFF2-40B4-BE49-F238E27FC236}">
-                <a16:creationId xmlns:a16="http://schemas.microsoft.com/office/drawing/2014/main" id="{831FFF51-2794-4601-9CD6-B9594BFFCE95}"/>
+                <a16:creationId xmlns:a16="http://schemas.microsoft.com/office/drawing/2014/main" id="{C6D0FAFD-AA84-47FE-9BF1-D56BC4FE3AE5}"/>
               </a:ext>
             </a:extLst>
           </p:cNvPr>
@@ -6311,14 +6316,14 @@
         </p:xfrm>
         <a:graphic xmlns:a="http://schemas.openxmlformats.org/drawingml/2006/main">
           <a:graphicData uri="http://schemas.openxmlformats.org/drawingml/2006/chart">
-            <c:chart xmlns:r="http://schemas.openxmlformats.org/officeDocument/2006/relationships" xmlns:c="http://schemas.openxmlformats.org/drawingml/2006/chart" r:id="R2d0c0a3a26044da2"/>
+            <c:chart xmlns:r="http://schemas.openxmlformats.org/officeDocument/2006/relationships" xmlns:c="http://schemas.openxmlformats.org/drawingml/2006/chart" r:id="Re4e83c61b9544540"/>
           </a:graphicData>
         </a:graphic>
       </p:graphicFrame>
     </p:spTree>
     <p:extLst>
       <p:ext uri="{BB962C8B-B14F-4D97-AF65-F5344CB8AC3E}">
-        <p14:creationId xmlns:p14="http://schemas.microsoft.com/office/powerpoint/2010/main" val="1814809642"/>
+        <p14:creationId xmlns:p14="http://schemas.microsoft.com/office/powerpoint/2010/main" val="1396701938"/>
       </p:ext>
     </p:extLst>
   </p:cSld>
@@ -6349,7 +6354,7 @@
           <p:cNvPr id="16" name="s6-title">
             <a:extLst xmlns:a="http://schemas.openxmlformats.org/drawingml/2006/main">
               <a:ext uri="{FF2B5EF4-FFF2-40B4-BE49-F238E27FC236}">
-                <a16:creationId xmlns:a16="http://schemas.microsoft.com/office/drawing/2014/main" id="{ED7ACF8D-9A97-45E7-BDB0-415D135B78FF}"/>
+                <a16:creationId xmlns:a16="http://schemas.microsoft.com/office/drawing/2014/main" id="{ACF77855-613B-41FD-8957-492B422DE8AC}"/>
               </a:ext>
             </a:extLst>
           </p:cNvPr>
@@ -6394,7 +6399,7 @@
           <p:cNvPr id="2" name="s6-subtitle">
             <a:extLst xmlns:a="http://schemas.openxmlformats.org/drawingml/2006/main">
               <a:ext uri="{FF2B5EF4-FFF2-40B4-BE49-F238E27FC236}">
-                <a16:creationId xmlns:a16="http://schemas.microsoft.com/office/drawing/2014/main" id="{B7FE93F4-B421-4AFD-9983-A482F00FD6FB}"/>
+                <a16:creationId xmlns:a16="http://schemas.microsoft.com/office/drawing/2014/main" id="{E1CC9539-625A-42A9-B9E8-9D351A509BA6}"/>
               </a:ext>
             </a:extLst>
           </p:cNvPr>
@@ -6439,7 +6444,7 @@
           <p:cNvPr id="3" name="s6-chart-label-control">
             <a:extLst xmlns:a="http://schemas.openxmlformats.org/drawingml/2006/main">
               <a:ext uri="{FF2B5EF4-FFF2-40B4-BE49-F238E27FC236}">
-                <a16:creationId xmlns:a16="http://schemas.microsoft.com/office/drawing/2014/main" id="{A11A4637-B098-48E0-B7A1-B6C40639F480}"/>
+                <a16:creationId xmlns:a16="http://schemas.microsoft.com/office/drawing/2014/main" id="{81658054-77FC-4B26-8910-8A2193215FB4}"/>
               </a:ext>
             </a:extLst>
           </p:cNvPr>
@@ -6484,7 +6489,7 @@
           <p:cNvPr id="4" name="s6-chart-label-full">
             <a:extLst xmlns:a="http://schemas.openxmlformats.org/drawingml/2006/main">
               <a:ext uri="{FF2B5EF4-FFF2-40B4-BE49-F238E27FC236}">
-                <a16:creationId xmlns:a16="http://schemas.microsoft.com/office/drawing/2014/main" id="{8DCE5DD6-341D-4FD8-917B-7765B1C7DC04}"/>
+                <a16:creationId xmlns:a16="http://schemas.microsoft.com/office/drawing/2014/main" id="{3ADDE3A8-8517-4EB9-AF42-D813F0E84717}"/>
               </a:ext>
             </a:extLst>
           </p:cNvPr>
@@ -6529,7 +6534,7 @@
           <p:cNvPr id="5" name="s6-stat">
             <a:extLst xmlns:a="http://schemas.openxmlformats.org/drawingml/2006/main">
               <a:ext uri="{FF2B5EF4-FFF2-40B4-BE49-F238E27FC236}">
-                <a16:creationId xmlns:a16="http://schemas.microsoft.com/office/drawing/2014/main" id="{FC7C3E79-4475-43F4-A73F-7034EF71464D}"/>
+                <a16:creationId xmlns:a16="http://schemas.microsoft.com/office/drawing/2014/main" id="{CDE68CE2-9F33-41A7-A9C6-C5F02DEA669A}"/>
               </a:ext>
             </a:extLst>
           </p:cNvPr>
@@ -6574,7 +6579,7 @@
           <p:cNvPr id="6" name="s6-stat-label">
             <a:extLst xmlns:a="http://schemas.openxmlformats.org/drawingml/2006/main">
               <a:ext uri="{FF2B5EF4-FFF2-40B4-BE49-F238E27FC236}">
-                <a16:creationId xmlns:a16="http://schemas.microsoft.com/office/drawing/2014/main" id="{18A100F7-F96A-4D8D-8182-EE38E8FBFAA3}"/>
+                <a16:creationId xmlns:a16="http://schemas.microsoft.com/office/drawing/2014/main" id="{D817698C-7A3D-4405-9872-DF3F6885F2F9}"/>
               </a:ext>
             </a:extLst>
           </p:cNvPr>
@@ -6642,7 +6647,7 @@
           <p:cNvPr id="8" name="s6-supported">
             <a:extLst xmlns:a="http://schemas.openxmlformats.org/drawingml/2006/main">
               <a:ext uri="{FF2B5EF4-FFF2-40B4-BE49-F238E27FC236}">
-                <a16:creationId xmlns:a16="http://schemas.microsoft.com/office/drawing/2014/main" id="{4340F155-C1CF-4163-8363-A89633A9EE77}"/>
+                <a16:creationId xmlns:a16="http://schemas.microsoft.com/office/drawing/2014/main" id="{FE922A09-0B03-404E-91F1-E10E30097F27}"/>
               </a:ext>
             </a:extLst>
           </p:cNvPr>
@@ -6687,7 +6692,7 @@
           <p:cNvPr id="9" name="s6-supported-body">
             <a:extLst xmlns:a="http://schemas.openxmlformats.org/drawingml/2006/main">
               <a:ext uri="{FF2B5EF4-FFF2-40B4-BE49-F238E27FC236}">
-                <a16:creationId xmlns:a16="http://schemas.microsoft.com/office/drawing/2014/main" id="{6D69E72D-8FA2-40AC-9262-45689A4997C4}"/>
+                <a16:creationId xmlns:a16="http://schemas.microsoft.com/office/drawing/2014/main" id="{3C177898-B0AF-4F83-89E4-C792BEEC6441}"/>
               </a:ext>
             </a:extLst>
           </p:cNvPr>
@@ -6732,7 +6737,7 @@
           <p:cNvPr id="10" name="s6-unsupported">
             <a:extLst xmlns:a="http://schemas.openxmlformats.org/drawingml/2006/main">
               <a:ext uri="{FF2B5EF4-FFF2-40B4-BE49-F238E27FC236}">
-                <a16:creationId xmlns:a16="http://schemas.microsoft.com/office/drawing/2014/main" id="{C6EDFF66-B66F-47BB-A6B1-0D0453AD3F0D}"/>
+                <a16:creationId xmlns:a16="http://schemas.microsoft.com/office/drawing/2014/main" id="{18324A18-340B-4EAB-BE12-C928503E5BE2}"/>
               </a:ext>
             </a:extLst>
           </p:cNvPr>
@@ -6777,7 +6782,7 @@
           <p:cNvPr id="11" name="s6-unsupported-body">
             <a:extLst xmlns:a="http://schemas.openxmlformats.org/drawingml/2006/main">
               <a:ext uri="{FF2B5EF4-FFF2-40B4-BE49-F238E27FC236}">
-                <a16:creationId xmlns:a16="http://schemas.microsoft.com/office/drawing/2014/main" id="{A7CCA6D1-0FBB-4D8F-8ACA-3EE5F10DCC94}"/>
+                <a16:creationId xmlns:a16="http://schemas.microsoft.com/office/drawing/2014/main" id="{AD856CD7-9EE2-48D0-A902-79E56003B16D}"/>
               </a:ext>
             </a:extLst>
           </p:cNvPr>
@@ -6844,7 +6849,7 @@
           <p:cNvPr id="13" name="footer-source-6">
             <a:extLst xmlns:a="http://schemas.openxmlformats.org/drawingml/2006/main">
               <a:ext uri="{FF2B5EF4-FFF2-40B4-BE49-F238E27FC236}">
-                <a16:creationId xmlns:a16="http://schemas.microsoft.com/office/drawing/2014/main" id="{A8B15FB6-0A23-400E-9FED-EEF02DB1B7D8}"/>
+                <a16:creationId xmlns:a16="http://schemas.microsoft.com/office/drawing/2014/main" id="{A1B22078-607D-47F4-86C5-E3A17323700A}"/>
               </a:ext>
             </a:extLst>
           </p:cNvPr>
@@ -6889,7 +6894,7 @@
           <p:cNvPr id="14" name="footer-number-6">
             <a:extLst xmlns:a="http://schemas.openxmlformats.org/drawingml/2006/main">
               <a:ext uri="{FF2B5EF4-FFF2-40B4-BE49-F238E27FC236}">
-                <a16:creationId xmlns:a16="http://schemas.microsoft.com/office/drawing/2014/main" id="{70529FC6-A27F-493F-976F-403BB738AA00}"/>
+                <a16:creationId xmlns:a16="http://schemas.microsoft.com/office/drawing/2014/main" id="{592928E7-D616-4B17-9567-2EEE4D8564A4}"/>
               </a:ext>
             </a:extLst>
           </p:cNvPr>
@@ -6941,14 +6946,14 @@
         </p:xfrm>
         <a:graphic xmlns:a="http://schemas.openxmlformats.org/drawingml/2006/main">
           <a:graphicData uri="http://schemas.openxmlformats.org/drawingml/2006/chart">
-            <c:chart xmlns:r="http://schemas.openxmlformats.org/officeDocument/2006/relationships" xmlns:c="http://schemas.openxmlformats.org/drawingml/2006/chart" r:id="Ra7c4e6c0cbe94e69"/>
+            <c:chart xmlns:r="http://schemas.openxmlformats.org/officeDocument/2006/relationships" xmlns:c="http://schemas.openxmlformats.org/drawingml/2006/chart" r:id="R8d5fdcea74d24596"/>
           </a:graphicData>
         </a:graphic>
       </p:graphicFrame>
     </p:spTree>
     <p:extLst>
       <p:ext uri="{BB962C8B-B14F-4D97-AF65-F5344CB8AC3E}">
-        <p14:creationId xmlns:p14="http://schemas.microsoft.com/office/powerpoint/2010/main" val="1611279686"/>
+        <p14:creationId xmlns:p14="http://schemas.microsoft.com/office/powerpoint/2010/main" val="333664532"/>
       </p:ext>
     </p:extLst>
   </p:cSld>
@@ -6979,7 +6984,7 @@
           <p:cNvPr id="26" name="s7-title">
             <a:extLst xmlns:a="http://schemas.openxmlformats.org/drawingml/2006/main">
               <a:ext uri="{FF2B5EF4-FFF2-40B4-BE49-F238E27FC236}">
-                <a16:creationId xmlns:a16="http://schemas.microsoft.com/office/drawing/2014/main" id="{03B7C1E8-467A-4FB7-A335-9F11C2D1A29A}"/>
+                <a16:creationId xmlns:a16="http://schemas.microsoft.com/office/drawing/2014/main" id="{27FC7876-5211-4706-9520-259EF0DA52B1}"/>
               </a:ext>
             </a:extLst>
           </p:cNvPr>
@@ -7024,7 +7029,7 @@
           <p:cNvPr id="2" name="s7-subtitle">
             <a:extLst xmlns:a="http://schemas.openxmlformats.org/drawingml/2006/main">
               <a:ext uri="{FF2B5EF4-FFF2-40B4-BE49-F238E27FC236}">
-                <a16:creationId xmlns:a16="http://schemas.microsoft.com/office/drawing/2014/main" id="{D83508C6-579F-489E-B53E-F6ABE4E9D241}"/>
+                <a16:creationId xmlns:a16="http://schemas.microsoft.com/office/drawing/2014/main" id="{FDC73038-17AD-412F-BFB6-FC86DBDA35B1}"/>
               </a:ext>
             </a:extLst>
           </p:cNvPr>
@@ -7157,7 +7162,7 @@
           <p:cNvPr id="7" name="s7-card1">
             <a:extLst xmlns:a="http://schemas.openxmlformats.org/drawingml/2006/main">
               <a:ext uri="{FF2B5EF4-FFF2-40B4-BE49-F238E27FC236}">
-                <a16:creationId xmlns:a16="http://schemas.microsoft.com/office/drawing/2014/main" id="{21247143-F275-40E1-99F2-48BB27D62FA8}"/>
+                <a16:creationId xmlns:a16="http://schemas.microsoft.com/office/drawing/2014/main" id="{80B10633-CC49-4528-951B-FAC4295D2A7E}"/>
               </a:ext>
             </a:extLst>
           </p:cNvPr>
@@ -7192,7 +7197,7 @@
           <p:cNvPr id="8" name="s7-card2">
             <a:extLst xmlns:a="http://schemas.openxmlformats.org/drawingml/2006/main">
               <a:ext uri="{FF2B5EF4-FFF2-40B4-BE49-F238E27FC236}">
-                <a16:creationId xmlns:a16="http://schemas.microsoft.com/office/drawing/2014/main" id="{CB5EB1B5-9F0B-4526-9413-2F7E507F356A}"/>
+                <a16:creationId xmlns:a16="http://schemas.microsoft.com/office/drawing/2014/main" id="{BB708C9D-ADCA-4DAD-B976-2ED33C172687}"/>
               </a:ext>
             </a:extLst>
           </p:cNvPr>
@@ -7227,7 +7232,7 @@
           <p:cNvPr id="9" name="s7-card3">
             <a:extLst xmlns:a="http://schemas.openxmlformats.org/drawingml/2006/main">
               <a:ext uri="{FF2B5EF4-FFF2-40B4-BE49-F238E27FC236}">
-                <a16:creationId xmlns:a16="http://schemas.microsoft.com/office/drawing/2014/main" id="{3F3C764D-703D-4E0B-93B9-F192494D106C}"/>
+                <a16:creationId xmlns:a16="http://schemas.microsoft.com/office/drawing/2014/main" id="{1D3EBFCE-B074-4FE8-A1C1-38BFECEC9269}"/>
               </a:ext>
             </a:extLst>
           </p:cNvPr>
@@ -7262,7 +7267,7 @@
           <p:cNvPr id="10" name="s7-dot1">
             <a:extLst xmlns:a="http://schemas.openxmlformats.org/drawingml/2006/main">
               <a:ext uri="{FF2B5EF4-FFF2-40B4-BE49-F238E27FC236}">
-                <a16:creationId xmlns:a16="http://schemas.microsoft.com/office/drawing/2014/main" id="{112E9A34-9440-4627-A59B-03B488D71122}"/>
+                <a16:creationId xmlns:a16="http://schemas.microsoft.com/office/drawing/2014/main" id="{D39059FC-DD61-41DB-9F5C-D940E87DADE9}"/>
               </a:ext>
             </a:extLst>
           </p:cNvPr>
@@ -7295,7 +7300,7 @@
           <p:cNvPr id="11" name="s7-dot2">
             <a:extLst xmlns:a="http://schemas.openxmlformats.org/drawingml/2006/main">
               <a:ext uri="{FF2B5EF4-FFF2-40B4-BE49-F238E27FC236}">
-                <a16:creationId xmlns:a16="http://schemas.microsoft.com/office/drawing/2014/main" id="{8FD38703-4F01-4ED0-AFFA-3AC5BFE4275A}"/>
+                <a16:creationId xmlns:a16="http://schemas.microsoft.com/office/drawing/2014/main" id="{6B251CA2-EDBD-4997-B4C7-A2333B4646A3}"/>
               </a:ext>
             </a:extLst>
           </p:cNvPr>
@@ -7328,7 +7333,7 @@
           <p:cNvPr id="12" name="s7-dot3">
             <a:extLst xmlns:a="http://schemas.openxmlformats.org/drawingml/2006/main">
               <a:ext uri="{FF2B5EF4-FFF2-40B4-BE49-F238E27FC236}">
-                <a16:creationId xmlns:a16="http://schemas.microsoft.com/office/drawing/2014/main" id="{378290FE-912F-4B2C-8282-C5EF63A6B354}"/>
+                <a16:creationId xmlns:a16="http://schemas.microsoft.com/office/drawing/2014/main" id="{40ABDC04-DA54-4AA2-A42E-FFA11751101E}"/>
               </a:ext>
             </a:extLst>
           </p:cNvPr>
@@ -7361,7 +7366,7 @@
           <p:cNvPr id="13" name="s7-k1">
             <a:extLst xmlns:a="http://schemas.openxmlformats.org/drawingml/2006/main">
               <a:ext uri="{FF2B5EF4-FFF2-40B4-BE49-F238E27FC236}">
-                <a16:creationId xmlns:a16="http://schemas.microsoft.com/office/drawing/2014/main" id="{A8C7007A-C652-4111-A9DC-22DCC2C92161}"/>
+                <a16:creationId xmlns:a16="http://schemas.microsoft.com/office/drawing/2014/main" id="{A80966A8-8666-43C8-B9C8-416F1C1B3994}"/>
               </a:ext>
             </a:extLst>
           </p:cNvPr>
@@ -7406,7 +7411,7 @@
           <p:cNvPr id="14" name="s7-b1">
             <a:extLst xmlns:a="http://schemas.openxmlformats.org/drawingml/2006/main">
               <a:ext uri="{FF2B5EF4-FFF2-40B4-BE49-F238E27FC236}">
-                <a16:creationId xmlns:a16="http://schemas.microsoft.com/office/drawing/2014/main" id="{6F20B9D8-A2F4-43A8-8A11-C5CC861DE2C1}"/>
+                <a16:creationId xmlns:a16="http://schemas.microsoft.com/office/drawing/2014/main" id="{EC746CCD-3B0C-4E8E-A60F-20FB8D55F3EC}"/>
               </a:ext>
             </a:extLst>
           </p:cNvPr>
@@ -7451,7 +7456,7 @@
           <p:cNvPr id="15" name="s7-v1">
             <a:extLst xmlns:a="http://schemas.openxmlformats.org/drawingml/2006/main">
               <a:ext uri="{FF2B5EF4-FFF2-40B4-BE49-F238E27FC236}">
-                <a16:creationId xmlns:a16="http://schemas.microsoft.com/office/drawing/2014/main" id="{4AEFE631-5819-4709-9C27-488199A72531}"/>
+                <a16:creationId xmlns:a16="http://schemas.microsoft.com/office/drawing/2014/main" id="{31733DC4-9C55-49BC-BC79-25517120BD9A}"/>
               </a:ext>
             </a:extLst>
           </p:cNvPr>
@@ -7496,7 +7501,7 @@
           <p:cNvPr id="16" name="s7-k2">
             <a:extLst xmlns:a="http://schemas.openxmlformats.org/drawingml/2006/main">
               <a:ext uri="{FF2B5EF4-FFF2-40B4-BE49-F238E27FC236}">
-                <a16:creationId xmlns:a16="http://schemas.microsoft.com/office/drawing/2014/main" id="{EA586754-56B6-4F53-B736-7F69C31EF9B4}"/>
+                <a16:creationId xmlns:a16="http://schemas.microsoft.com/office/drawing/2014/main" id="{0B325EC1-46EC-40BD-9791-635E24C4B102}"/>
               </a:ext>
             </a:extLst>
           </p:cNvPr>
@@ -7541,7 +7546,7 @@
           <p:cNvPr id="17" name="s7-b2">
             <a:extLst xmlns:a="http://schemas.openxmlformats.org/drawingml/2006/main">
               <a:ext uri="{FF2B5EF4-FFF2-40B4-BE49-F238E27FC236}">
-                <a16:creationId xmlns:a16="http://schemas.microsoft.com/office/drawing/2014/main" id="{B5112A16-7B65-4B5A-A067-AE5F1109D378}"/>
+                <a16:creationId xmlns:a16="http://schemas.microsoft.com/office/drawing/2014/main" id="{D008F08F-E162-455C-A1D4-1C984901159C}"/>
               </a:ext>
             </a:extLst>
           </p:cNvPr>
@@ -7586,7 +7591,7 @@
           <p:cNvPr id="18" name="s7-v2">
             <a:extLst xmlns:a="http://schemas.openxmlformats.org/drawingml/2006/main">
               <a:ext uri="{FF2B5EF4-FFF2-40B4-BE49-F238E27FC236}">
-                <a16:creationId xmlns:a16="http://schemas.microsoft.com/office/drawing/2014/main" id="{F60FAED7-DF7A-43D0-9915-EF8647B401C1}"/>
+                <a16:creationId xmlns:a16="http://schemas.microsoft.com/office/drawing/2014/main" id="{69E6F07F-7221-4FA9-9EA4-6296F4F83CBC}"/>
               </a:ext>
             </a:extLst>
           </p:cNvPr>
@@ -7631,7 +7636,7 @@
           <p:cNvPr id="19" name="s7-k3">
             <a:extLst xmlns:a="http://schemas.openxmlformats.org/drawingml/2006/main">
               <a:ext uri="{FF2B5EF4-FFF2-40B4-BE49-F238E27FC236}">
-                <a16:creationId xmlns:a16="http://schemas.microsoft.com/office/drawing/2014/main" id="{B0CFCDA9-FB2D-4DB7-9E19-64C1BEE6FFF9}"/>
+                <a16:creationId xmlns:a16="http://schemas.microsoft.com/office/drawing/2014/main" id="{98A41F99-3E19-4ED7-A94E-5CC6CFD5160C}"/>
               </a:ext>
             </a:extLst>
           </p:cNvPr>
@@ -7676,7 +7681,7 @@
           <p:cNvPr id="20" name="s7-b3">
             <a:extLst xmlns:a="http://schemas.openxmlformats.org/drawingml/2006/main">
               <a:ext uri="{FF2B5EF4-FFF2-40B4-BE49-F238E27FC236}">
-                <a16:creationId xmlns:a16="http://schemas.microsoft.com/office/drawing/2014/main" id="{673231AC-28AD-4369-9015-55410F3F6493}"/>
+                <a16:creationId xmlns:a16="http://schemas.microsoft.com/office/drawing/2014/main" id="{69BEFD4D-B40C-4EB6-B114-6450069E145D}"/>
               </a:ext>
             </a:extLst>
           </p:cNvPr>
@@ -7721,7 +7726,7 @@
           <p:cNvPr id="21" name="s7-v3">
             <a:extLst xmlns:a="http://schemas.openxmlformats.org/drawingml/2006/main">
               <a:ext uri="{FF2B5EF4-FFF2-40B4-BE49-F238E27FC236}">
-                <a16:creationId xmlns:a16="http://schemas.microsoft.com/office/drawing/2014/main" id="{7B717499-FEEA-4A74-A9C3-D052F59437CB}"/>
+                <a16:creationId xmlns:a16="http://schemas.microsoft.com/office/drawing/2014/main" id="{A792DA74-DA87-40C2-AD7A-AF4972DA80D6}"/>
               </a:ext>
             </a:extLst>
           </p:cNvPr>
@@ -7766,7 +7771,7 @@
           <p:cNvPr id="22" name="s7-human">
             <a:extLst xmlns:a="http://schemas.openxmlformats.org/drawingml/2006/main">
               <a:ext uri="{FF2B5EF4-FFF2-40B4-BE49-F238E27FC236}">
-                <a16:creationId xmlns:a16="http://schemas.microsoft.com/office/drawing/2014/main" id="{8AA98AF3-2A0E-4641-8F12-FD23DD71C233}"/>
+                <a16:creationId xmlns:a16="http://schemas.microsoft.com/office/drawing/2014/main" id="{A39BF957-E6BC-4853-AE03-0D7466923FDF}"/>
               </a:ext>
             </a:extLst>
           </p:cNvPr>
@@ -7833,7 +7838,7 @@
           <p:cNvPr id="24" name="footer-source-7">
             <a:extLst xmlns:a="http://schemas.openxmlformats.org/drawingml/2006/main">
               <a:ext uri="{FF2B5EF4-FFF2-40B4-BE49-F238E27FC236}">
-                <a16:creationId xmlns:a16="http://schemas.microsoft.com/office/drawing/2014/main" id="{D9C37DDF-E9FF-4A42-982F-DC1FA15E1C50}"/>
+                <a16:creationId xmlns:a16="http://schemas.microsoft.com/office/drawing/2014/main" id="{F3490E14-E7CD-4B1B-8F16-4FBBF4AA0D29}"/>
               </a:ext>
             </a:extLst>
           </p:cNvPr>
@@ -7878,7 +7883,7 @@
           <p:cNvPr id="25" name="footer-number-7">
             <a:extLst xmlns:a="http://schemas.openxmlformats.org/drawingml/2006/main">
               <a:ext uri="{FF2B5EF4-FFF2-40B4-BE49-F238E27FC236}">
-                <a16:creationId xmlns:a16="http://schemas.microsoft.com/office/drawing/2014/main" id="{F62FBA15-FEF3-4D4C-9098-D55086DFA0A1}"/>
+                <a16:creationId xmlns:a16="http://schemas.microsoft.com/office/drawing/2014/main" id="{1508B504-CD81-4E39-A825-38D6D6C9B325}"/>
               </a:ext>
             </a:extLst>
           </p:cNvPr>
@@ -7921,7 +7926,7 @@
     </p:spTree>
     <p:extLst>
       <p:ext uri="{BB962C8B-B14F-4D97-AF65-F5344CB8AC3E}">
-        <p14:creationId xmlns:p14="http://schemas.microsoft.com/office/powerpoint/2010/main" val="336452656"/>
+        <p14:creationId xmlns:p14="http://schemas.microsoft.com/office/powerpoint/2010/main" val="283734944"/>
       </p:ext>
     </p:extLst>
   </p:cSld>
@@ -7952,7 +7957,7 @@
           <p:cNvPr id="19" name="s8-eyebrow">
             <a:extLst xmlns:a="http://schemas.openxmlformats.org/drawingml/2006/main">
               <a:ext uri="{FF2B5EF4-FFF2-40B4-BE49-F238E27FC236}">
-                <a16:creationId xmlns:a16="http://schemas.microsoft.com/office/drawing/2014/main" id="{A1164D58-772E-4CC7-8977-6C367666CBF6}"/>
+                <a16:creationId xmlns:a16="http://schemas.microsoft.com/office/drawing/2014/main" id="{E65E9B11-4AAA-4A35-9E53-B9898B75F6CB}"/>
               </a:ext>
             </a:extLst>
           </p:cNvPr>
@@ -7997,7 +8002,7 @@
           <p:cNvPr id="2" name="s8-title">
             <a:extLst xmlns:a="http://schemas.openxmlformats.org/drawingml/2006/main">
               <a:ext uri="{FF2B5EF4-FFF2-40B4-BE49-F238E27FC236}">
-                <a16:creationId xmlns:a16="http://schemas.microsoft.com/office/drawing/2014/main" id="{4F225D14-19EF-4F7A-B8E4-DE0E650AC216}"/>
+                <a16:creationId xmlns:a16="http://schemas.microsoft.com/office/drawing/2014/main" id="{25BCDD51-7836-4F24-87C2-AC7EEF0EA503}"/>
               </a:ext>
             </a:extLst>
           </p:cNvPr>
@@ -8066,7 +8071,7 @@
           <p:cNvPr id="4" name="s8-close">
             <a:extLst xmlns:a="http://schemas.openxmlformats.org/drawingml/2006/main">
               <a:ext uri="{FF2B5EF4-FFF2-40B4-BE49-F238E27FC236}">
-                <a16:creationId xmlns:a16="http://schemas.microsoft.com/office/drawing/2014/main" id="{25881C26-2EDC-4629-9175-8B03FB5A6229}"/>
+                <a16:creationId xmlns:a16="http://schemas.microsoft.com/office/drawing/2014/main" id="{3DA98D3F-6812-446D-A866-C0E86E67A4A2}"/>
               </a:ext>
             </a:extLst>
           </p:cNvPr>
@@ -8111,7 +8116,7 @@
           <p:cNvPr id="5" name="s8-command-box">
             <a:extLst xmlns:a="http://schemas.openxmlformats.org/drawingml/2006/main">
               <a:ext uri="{FF2B5EF4-FFF2-40B4-BE49-F238E27FC236}">
-                <a16:creationId xmlns:a16="http://schemas.microsoft.com/office/drawing/2014/main" id="{102B6943-1C89-4322-9BA2-38DBF95E81B0}"/>
+                <a16:creationId xmlns:a16="http://schemas.microsoft.com/office/drawing/2014/main" id="{6F30E500-4C89-414A-8B10-A80AA3A3B02C}"/>
               </a:ext>
             </a:extLst>
           </p:cNvPr>
@@ -8146,7 +8151,7 @@
           <p:cNvPr id="6" name="s8-command">
             <a:extLst xmlns:a="http://schemas.openxmlformats.org/drawingml/2006/main">
               <a:ext uri="{FF2B5EF4-FFF2-40B4-BE49-F238E27FC236}">
-                <a16:creationId xmlns:a16="http://schemas.microsoft.com/office/drawing/2014/main" id="{C41EA649-6BD4-46B8-B8BA-712C81298B90}"/>
+                <a16:creationId xmlns:a16="http://schemas.microsoft.com/office/drawing/2014/main" id="{54E3D959-D7D2-4F52-BF13-7DD089E98585}"/>
               </a:ext>
             </a:extLst>
           </p:cNvPr>
@@ -8192,7 +8197,7 @@
           <p:cNvPr id="7" name="s8-github">
             <a:extLst xmlns:a="http://schemas.openxmlformats.org/drawingml/2006/main">
               <a:ext uri="{FF2B5EF4-FFF2-40B4-BE49-F238E27FC236}">
-                <a16:creationId xmlns:a16="http://schemas.microsoft.com/office/drawing/2014/main" id="{EFDA97DB-97DE-4762-9F6F-46060F900E91}"/>
+                <a16:creationId xmlns:a16="http://schemas.microsoft.com/office/drawing/2014/main" id="{9D581FBD-7225-4AA5-84C1-813C8E3EF574}"/>
               </a:ext>
             </a:extLst>
           </p:cNvPr>
@@ -8237,7 +8242,7 @@
           <p:cNvPr id="8" name="s8-npm">
             <a:extLst xmlns:a="http://schemas.openxmlformats.org/drawingml/2006/main">
               <a:ext uri="{FF2B5EF4-FFF2-40B4-BE49-F238E27FC236}">
-                <a16:creationId xmlns:a16="http://schemas.microsoft.com/office/drawing/2014/main" id="{AE89145D-5F3B-41F7-BEBC-48C64F93BFA5}"/>
+                <a16:creationId xmlns:a16="http://schemas.microsoft.com/office/drawing/2014/main" id="{D060CE72-FBE5-4677-9DC7-211735AAB2DF}"/>
               </a:ext>
             </a:extLst>
           </p:cNvPr>
@@ -8282,7 +8287,7 @@
           <p:cNvPr id="9" name="s8-d1">
             <a:extLst xmlns:a="http://schemas.openxmlformats.org/drawingml/2006/main">
               <a:ext uri="{FF2B5EF4-FFF2-40B4-BE49-F238E27FC236}">
-                <a16:creationId xmlns:a16="http://schemas.microsoft.com/office/drawing/2014/main" id="{9B81D749-F4F4-42CF-BEB4-1E5C0BC1EF18}"/>
+                <a16:creationId xmlns:a16="http://schemas.microsoft.com/office/drawing/2014/main" id="{D46123D2-78D2-404D-BE78-BE31FD1B5357}"/>
               </a:ext>
             </a:extLst>
           </p:cNvPr>
@@ -8315,7 +8320,7 @@
           <p:cNvPr id="10" name="s8-l1">
             <a:extLst xmlns:a="http://schemas.openxmlformats.org/drawingml/2006/main">
               <a:ext uri="{FF2B5EF4-FFF2-40B4-BE49-F238E27FC236}">
-                <a16:creationId xmlns:a16="http://schemas.microsoft.com/office/drawing/2014/main" id="{1BF375C9-5B3C-4D25-9E28-FD7DA4205BB9}"/>
+                <a16:creationId xmlns:a16="http://schemas.microsoft.com/office/drawing/2014/main" id="{6CD18A7C-A265-44FB-B991-E39D4459B52C}"/>
               </a:ext>
             </a:extLst>
           </p:cNvPr>
@@ -8360,7 +8365,7 @@
           <p:cNvPr id="11" name="s8-d2">
             <a:extLst xmlns:a="http://schemas.openxmlformats.org/drawingml/2006/main">
               <a:ext uri="{FF2B5EF4-FFF2-40B4-BE49-F238E27FC236}">
-                <a16:creationId xmlns:a16="http://schemas.microsoft.com/office/drawing/2014/main" id="{DE39F716-AE9E-4450-9296-35AD08AE228F}"/>
+                <a16:creationId xmlns:a16="http://schemas.microsoft.com/office/drawing/2014/main" id="{246562C9-B70A-42CB-B2DC-7DBED1CD1E97}"/>
               </a:ext>
             </a:extLst>
           </p:cNvPr>
@@ -8393,7 +8398,7 @@
           <p:cNvPr id="12" name="s8-l2">
             <a:extLst xmlns:a="http://schemas.openxmlformats.org/drawingml/2006/main">
               <a:ext uri="{FF2B5EF4-FFF2-40B4-BE49-F238E27FC236}">
-                <a16:creationId xmlns:a16="http://schemas.microsoft.com/office/drawing/2014/main" id="{BF547D23-5F61-4104-96C8-55A0136CECAD}"/>
+                <a16:creationId xmlns:a16="http://schemas.microsoft.com/office/drawing/2014/main" id="{FE49A203-DE64-47A4-8F4C-9228D59E082B}"/>
               </a:ext>
             </a:extLst>
           </p:cNvPr>
@@ -8438,7 +8443,7 @@
           <p:cNvPr id="13" name="s8-d3">
             <a:extLst xmlns:a="http://schemas.openxmlformats.org/drawingml/2006/main">
               <a:ext uri="{FF2B5EF4-FFF2-40B4-BE49-F238E27FC236}">
-                <a16:creationId xmlns:a16="http://schemas.microsoft.com/office/drawing/2014/main" id="{302B440F-0A6E-4F63-AC28-93B3711DA66D}"/>
+                <a16:creationId xmlns:a16="http://schemas.microsoft.com/office/drawing/2014/main" id="{FC0ED1D1-CC2C-48B0-93E0-8B658E3B9333}"/>
               </a:ext>
             </a:extLst>
           </p:cNvPr>
@@ -8471,7 +8476,7 @@
           <p:cNvPr id="14" name="s8-l3">
             <a:extLst xmlns:a="http://schemas.openxmlformats.org/drawingml/2006/main">
               <a:ext uri="{FF2B5EF4-FFF2-40B4-BE49-F238E27FC236}">
-                <a16:creationId xmlns:a16="http://schemas.microsoft.com/office/drawing/2014/main" id="{89866269-C75F-424B-987A-91225CE0E954}"/>
+                <a16:creationId xmlns:a16="http://schemas.microsoft.com/office/drawing/2014/main" id="{2919F2EF-2478-48DE-9EDB-92828A09622C}"/>
               </a:ext>
             </a:extLst>
           </p:cNvPr>
@@ -8516,7 +8521,7 @@
           <p:cNvPr id="15" name="s8-platforms">
             <a:extLst xmlns:a="http://schemas.openxmlformats.org/drawingml/2006/main">
               <a:ext uri="{FF2B5EF4-FFF2-40B4-BE49-F238E27FC236}">
-                <a16:creationId xmlns:a16="http://schemas.microsoft.com/office/drawing/2014/main" id="{5590FA77-B0AB-48F3-A33F-B318B423844D}"/>
+                <a16:creationId xmlns:a16="http://schemas.microsoft.com/office/drawing/2014/main" id="{2E5456D7-0A3C-4095-B1DE-CBD341D50F21}"/>
               </a:ext>
             </a:extLst>
           </p:cNvPr>
@@ -8583,7 +8588,7 @@
           <p:cNvPr id="17" name="footer-source-8">
             <a:extLst xmlns:a="http://schemas.openxmlformats.org/drawingml/2006/main">
               <a:ext uri="{FF2B5EF4-FFF2-40B4-BE49-F238E27FC236}">
-                <a16:creationId xmlns:a16="http://schemas.microsoft.com/office/drawing/2014/main" id="{CC04D024-2E07-4A39-9EDE-3CBF7679D31A}"/>
+                <a16:creationId xmlns:a16="http://schemas.microsoft.com/office/drawing/2014/main" id="{763819D6-142E-4027-9992-42159980982E}"/>
               </a:ext>
             </a:extLst>
           </p:cNvPr>
@@ -8628,7 +8633,7 @@
           <p:cNvPr id="18" name="footer-number-8">
             <a:extLst xmlns:a="http://schemas.openxmlformats.org/drawingml/2006/main">
               <a:ext uri="{FF2B5EF4-FFF2-40B4-BE49-F238E27FC236}">
-                <a16:creationId xmlns:a16="http://schemas.microsoft.com/office/drawing/2014/main" id="{0F932832-8320-4E80-9359-862E281E750C}"/>
+                <a16:creationId xmlns:a16="http://schemas.microsoft.com/office/drawing/2014/main" id="{6529AE35-2D0E-403F-B31D-7FD915E3586B}"/>
               </a:ext>
             </a:extLst>
           </p:cNvPr>
@@ -8671,7 +8676,7 @@
     </p:spTree>
     <p:extLst>
       <p:ext uri="{BB962C8B-B14F-4D97-AF65-F5344CB8AC3E}">
-        <p14:creationId xmlns:p14="http://schemas.microsoft.com/office/powerpoint/2010/main" val="736178879"/>
+        <p14:creationId xmlns:p14="http://schemas.microsoft.com/office/powerpoint/2010/main" val="2134665719"/>
       </p:ext>
     </p:extLst>
   </p:cSld>

</xml_diff>

<commit_message>
docs: clarify 2D-to-3D design inspiration
</commit_message>
<xml_diff>
--- a/outputs/vertex-palace-build-week-demo.pptx
+++ b/outputs/vertex-palace-build-week-demo.pptx
@@ -2,20 +2,20 @@
 <file path=ppt/presentation.xml><?xml version="1.0" encoding="utf-8"?>
 <p:presentation xmlns:p="http://schemas.openxmlformats.org/presentationml/2006/main">
   <p:sldMasterIdLst>
-    <p:sldMasterId xmlns:r="http://schemas.openxmlformats.org/officeDocument/2006/relationships" id="2147483648" r:id="Ree44bf9335644666"/>
+    <p:sldMasterId xmlns:r="http://schemas.openxmlformats.org/officeDocument/2006/relationships" id="2147483648" r:id="R2abdefaf395e490e"/>
   </p:sldMasterIdLst>
   <p:notesMasterIdLst>
-    <p:notesMasterId xmlns:r="http://schemas.openxmlformats.org/officeDocument/2006/relationships" r:id="Rc98aa339755b45d2"/>
+    <p:notesMasterId xmlns:r="http://schemas.openxmlformats.org/officeDocument/2006/relationships" r:id="Rc34b74eb9f5142bc"/>
   </p:notesMasterIdLst>
   <p:sldIdLst>
-    <p:sldId xmlns:r="http://schemas.openxmlformats.org/officeDocument/2006/relationships" id="256" r:id="R131d1e2aa3984a09"/>
-    <p:sldId xmlns:r="http://schemas.openxmlformats.org/officeDocument/2006/relationships" id="257" r:id="R0e224fd3b0ea4cd5"/>
-    <p:sldId xmlns:r="http://schemas.openxmlformats.org/officeDocument/2006/relationships" id="258" r:id="R1b859cddd684407b"/>
-    <p:sldId xmlns:r="http://schemas.openxmlformats.org/officeDocument/2006/relationships" id="259" r:id="Rc5188e4aadc34b76"/>
-    <p:sldId xmlns:r="http://schemas.openxmlformats.org/officeDocument/2006/relationships" id="260" r:id="R02eaf360ec414d5e"/>
-    <p:sldId xmlns:r="http://schemas.openxmlformats.org/officeDocument/2006/relationships" id="261" r:id="R8d53dc85e8714916"/>
-    <p:sldId xmlns:r="http://schemas.openxmlformats.org/officeDocument/2006/relationships" id="262" r:id="R56009698a3ed4950"/>
-    <p:sldId xmlns:r="http://schemas.openxmlformats.org/officeDocument/2006/relationships" id="263" r:id="Rd7b6dbc3d9d34784"/>
+    <p:sldId xmlns:r="http://schemas.openxmlformats.org/officeDocument/2006/relationships" id="256" r:id="R39f7a98369034cca"/>
+    <p:sldId xmlns:r="http://schemas.openxmlformats.org/officeDocument/2006/relationships" id="257" r:id="R8b76a65345ab4a79"/>
+    <p:sldId xmlns:r="http://schemas.openxmlformats.org/officeDocument/2006/relationships" id="258" r:id="R4a9d51c5d6d2426f"/>
+    <p:sldId xmlns:r="http://schemas.openxmlformats.org/officeDocument/2006/relationships" id="259" r:id="R9d509893f2314f34"/>
+    <p:sldId xmlns:r="http://schemas.openxmlformats.org/officeDocument/2006/relationships" id="260" r:id="Ree36d4941d4348ac"/>
+    <p:sldId xmlns:r="http://schemas.openxmlformats.org/officeDocument/2006/relationships" id="261" r:id="R46364cad20e14537"/>
+    <p:sldId xmlns:r="http://schemas.openxmlformats.org/officeDocument/2006/relationships" id="262" r:id="R954f177c827342ca"/>
+    <p:sldId xmlns:r="http://schemas.openxmlformats.org/officeDocument/2006/relationships" id="263" r:id="R88ca8e012d334404"/>
   </p:sldIdLst>
   <p:sldSz cx="12192000" cy="6858000"/>
   <p:notesSz cx="6858000" cy="9144000"/>
@@ -694,7 +694,12 @@
           <a:lstStyle xmlns:a="http://schemas.openxmlformats.org/drawingml/2006/main"/>
           <a:p xmlns:a="http://schemas.openxmlformats.org/drawingml/2006/main">
             <a:r>
-              <a:t>The inspiration came from the human memory-palace technique: assign knowledge to places, then follow a route to retrieve it. Vertex Palace maps repository domains to floors, features to rooms, and files and symbols to smaller storage layers.</a:t>
+              <a:t>The original idea began with a spatial question: could a flat, two-dimensional repository tree become a three-dimensional place? A building became the natural model, with domains as floors, features as rooms, and files and symbols as cabinets and drawers.</a:t>
+            </a:r>
+          </a:p>
+          <a:p xmlns:a="http://schemas.openxmlformats.org/drawingml/2006/main">
+            <a:r>
+              <a:t>The connection to the human memory-palace technique came next. Once the repository had places, a task could follow a route through them and relevant past mistakes could wait at the entrance.</a:t>
             </a:r>
           </a:p>
           <a:p xmlns:a="http://schemas.openxmlformats.org/drawingml/2006/main">
@@ -1152,7 +1157,7 @@
   </p:cSld>
   <p:clrMap bg1="lt1" tx1="dk1" bg2="lt2" tx2="dk2" accent1="accent1" accent2="accent2" accent3="accent3" accent4="accent4" accent5="accent5" accent6="accent6" hlink="hlink" folHlink="folHlink"/>
   <p:sldLayoutIdLst>
-    <p:sldLayoutId xmlns:r="http://schemas.openxmlformats.org/officeDocument/2006/relationships" id="2147483649" r:id="R0902ee43faeb40ea"/>
+    <p:sldLayoutId xmlns:r="http://schemas.openxmlformats.org/officeDocument/2006/relationships" id="2147483649" r:id="Rfeaf7f294e654a66"/>
   </p:sldLayoutIdLst>
   <p:txStyles>
     <p:titleStyle>
@@ -2044,7 +2049,7 @@
           <p:cNvPr id="7" name="s1-eyebrow">
             <a:extLst xmlns:a="http://schemas.openxmlformats.org/drawingml/2006/main">
               <a:ext uri="{FF2B5EF4-FFF2-40B4-BE49-F238E27FC236}">
-                <a16:creationId xmlns:a16="http://schemas.microsoft.com/office/drawing/2014/main" id="{C9BAD10D-D100-46F6-B29C-35EEBEA7F4C4}"/>
+                <a16:creationId xmlns:a16="http://schemas.microsoft.com/office/drawing/2014/main" id="{B7B1FA98-806C-40C5-A554-1071E0862DBB}"/>
               </a:ext>
             </a:extLst>
           </p:cNvPr>
@@ -2089,7 +2094,7 @@
           <p:cNvPr id="2" name="s1-title">
             <a:extLst xmlns:a="http://schemas.openxmlformats.org/drawingml/2006/main">
               <a:ext uri="{FF2B5EF4-FFF2-40B4-BE49-F238E27FC236}">
-                <a16:creationId xmlns:a16="http://schemas.microsoft.com/office/drawing/2014/main" id="{65668104-24CF-4A09-85F4-456208D4F40A}"/>
+                <a16:creationId xmlns:a16="http://schemas.microsoft.com/office/drawing/2014/main" id="{C1889C3F-BF41-4D7C-8A0A-ED3374146D69}"/>
               </a:ext>
             </a:extLst>
           </p:cNvPr>
@@ -2157,7 +2162,7 @@
           <p:cNvPr id="4" name="s1-subtitle">
             <a:extLst xmlns:a="http://schemas.openxmlformats.org/drawingml/2006/main">
               <a:ext uri="{FF2B5EF4-FFF2-40B4-BE49-F238E27FC236}">
-                <a16:creationId xmlns:a16="http://schemas.microsoft.com/office/drawing/2014/main" id="{307ADBE3-367C-427C-B41C-28D8304A314B}"/>
+                <a16:creationId xmlns:a16="http://schemas.microsoft.com/office/drawing/2014/main" id="{4669666D-118B-4D03-ACA6-8F67931BCE11}"/>
               </a:ext>
             </a:extLst>
           </p:cNvPr>
@@ -2202,7 +2207,7 @@
           <p:cNvPr id="5" name="s1-version">
             <a:extLst xmlns:a="http://schemas.openxmlformats.org/drawingml/2006/main">
               <a:ext uri="{FF2B5EF4-FFF2-40B4-BE49-F238E27FC236}">
-                <a16:creationId xmlns:a16="http://schemas.microsoft.com/office/drawing/2014/main" id="{70875ACA-49B9-43F0-A67F-7BD6D6DAA45D}"/>
+                <a16:creationId xmlns:a16="http://schemas.microsoft.com/office/drawing/2014/main" id="{6DDE248A-DE7A-44C3-BBD9-7FC9B0CEB408}"/>
               </a:ext>
             </a:extLst>
           </p:cNvPr>
@@ -2251,7 +2256,7 @@
           <p:nvPr/>
         </p:nvPicPr>
         <p:blipFill>
-          <a:blip xmlns:r="http://schemas.openxmlformats.org/officeDocument/2006/relationships" xmlns:a="http://schemas.openxmlformats.org/drawingml/2006/main" r:embed="Rac4445891b354050"/>
+          <a:blip xmlns:r="http://schemas.openxmlformats.org/officeDocument/2006/relationships" xmlns:a="http://schemas.openxmlformats.org/drawingml/2006/main" r:embed="Rb0f2c6423231481c"/>
           <a:stretch xmlns:a="http://schemas.openxmlformats.org/drawingml/2006/main"/>
         </p:blipFill>
         <p:spPr>
@@ -2267,7 +2272,7 @@
     </p:spTree>
     <p:extLst>
       <p:ext uri="{BB962C8B-B14F-4D97-AF65-F5344CB8AC3E}">
-        <p14:creationId xmlns:p14="http://schemas.microsoft.com/office/powerpoint/2010/main" val="1199054850"/>
+        <p14:creationId xmlns:p14="http://schemas.microsoft.com/office/powerpoint/2010/main" val="1270227419"/>
       </p:ext>
     </p:extLst>
   </p:cSld>
@@ -2298,7 +2303,7 @@
           <p:cNvPr id="33" name="s2-title">
             <a:extLst xmlns:a="http://schemas.openxmlformats.org/drawingml/2006/main">
               <a:ext uri="{FF2B5EF4-FFF2-40B4-BE49-F238E27FC236}">
-                <a16:creationId xmlns:a16="http://schemas.microsoft.com/office/drawing/2014/main" id="{652C5319-8479-4A01-A996-AF2A32B16EDE}"/>
+                <a16:creationId xmlns:a16="http://schemas.microsoft.com/office/drawing/2014/main" id="{C5FC4020-68D7-4811-ADE7-A817D4BC3B36}"/>
               </a:ext>
             </a:extLst>
           </p:cNvPr>
@@ -2343,7 +2348,7 @@
           <p:cNvPr id="2" name="s2-subtitle">
             <a:extLst xmlns:a="http://schemas.openxmlformats.org/drawingml/2006/main">
               <a:ext uri="{FF2B5EF4-FFF2-40B4-BE49-F238E27FC236}">
-                <a16:creationId xmlns:a16="http://schemas.microsoft.com/office/drawing/2014/main" id="{F23EEC23-A893-47E9-81E0-363EA7CCE6D6}"/>
+                <a16:creationId xmlns:a16="http://schemas.microsoft.com/office/drawing/2014/main" id="{4940A15F-891F-4344-A13A-B1C339B0A557}"/>
               </a:ext>
             </a:extLst>
           </p:cNvPr>
@@ -2498,7 +2503,7 @@
           <p:cNvPr id="8" name="s2-agent">
             <a:extLst xmlns:a="http://schemas.openxmlformats.org/drawingml/2006/main">
               <a:ext uri="{FF2B5EF4-FFF2-40B4-BE49-F238E27FC236}">
-                <a16:creationId xmlns:a16="http://schemas.microsoft.com/office/drawing/2014/main" id="{952457D8-E0AD-42F1-B51A-87BF700BB257}"/>
+                <a16:creationId xmlns:a16="http://schemas.microsoft.com/office/drawing/2014/main" id="{A01F559D-912B-4B3C-965D-04A0BBECBFA2}"/>
               </a:ext>
             </a:extLst>
           </p:cNvPr>
@@ -2531,7 +2536,7 @@
           <p:cNvPr id="9" name="s2-agent-label">
             <a:extLst xmlns:a="http://schemas.openxmlformats.org/drawingml/2006/main">
               <a:ext uri="{FF2B5EF4-FFF2-40B4-BE49-F238E27FC236}">
-                <a16:creationId xmlns:a16="http://schemas.microsoft.com/office/drawing/2014/main" id="{F77C85EF-E588-4129-9299-BCA943D51270}"/>
+                <a16:creationId xmlns:a16="http://schemas.microsoft.com/office/drawing/2014/main" id="{A44C0778-51D2-4D50-9E6C-D44F690E9A45}"/>
               </a:ext>
             </a:extLst>
           </p:cNvPr>
@@ -2576,7 +2581,7 @@
           <p:cNvPr id="10" name="s2-file-a">
             <a:extLst xmlns:a="http://schemas.openxmlformats.org/drawingml/2006/main">
               <a:ext uri="{FF2B5EF4-FFF2-40B4-BE49-F238E27FC236}">
-                <a16:creationId xmlns:a16="http://schemas.microsoft.com/office/drawing/2014/main" id="{E25DE2F3-5816-465E-B5D8-85F5EA5B7B04}"/>
+                <a16:creationId xmlns:a16="http://schemas.microsoft.com/office/drawing/2014/main" id="{7DD03FA1-A93C-481A-A316-AB9D11260DBC}"/>
               </a:ext>
             </a:extLst>
           </p:cNvPr>
@@ -2609,7 +2614,7 @@
           <p:cNvPr id="11" name="s2-file-b">
             <a:extLst xmlns:a="http://schemas.openxmlformats.org/drawingml/2006/main">
               <a:ext uri="{FF2B5EF4-FFF2-40B4-BE49-F238E27FC236}">
-                <a16:creationId xmlns:a16="http://schemas.microsoft.com/office/drawing/2014/main" id="{BDB7543C-1AF2-4437-B019-E3AE12963C32}"/>
+                <a16:creationId xmlns:a16="http://schemas.microsoft.com/office/drawing/2014/main" id="{200592A9-79DC-475F-981B-0164FB535A27}"/>
               </a:ext>
             </a:extLst>
           </p:cNvPr>
@@ -2642,7 +2647,7 @@
           <p:cNvPr id="12" name="s2-file-c">
             <a:extLst xmlns:a="http://schemas.openxmlformats.org/drawingml/2006/main">
               <a:ext uri="{FF2B5EF4-FFF2-40B4-BE49-F238E27FC236}">
-                <a16:creationId xmlns:a16="http://schemas.microsoft.com/office/drawing/2014/main" id="{CE506F9F-AC1C-4B4A-95B1-350D04A85CF9}"/>
+                <a16:creationId xmlns:a16="http://schemas.microsoft.com/office/drawing/2014/main" id="{F024A584-4103-45D1-8D3E-DEF1CB2EFDB7}"/>
               </a:ext>
             </a:extLst>
           </p:cNvPr>
@@ -2675,7 +2680,7 @@
           <p:cNvPr id="13" name="s2-file-d">
             <a:extLst xmlns:a="http://schemas.openxmlformats.org/drawingml/2006/main">
               <a:ext uri="{FF2B5EF4-FFF2-40B4-BE49-F238E27FC236}">
-                <a16:creationId xmlns:a16="http://schemas.microsoft.com/office/drawing/2014/main" id="{D645ECDD-670D-4934-B048-87EAB7D19EB8}"/>
+                <a16:creationId xmlns:a16="http://schemas.microsoft.com/office/drawing/2014/main" id="{8DDC61FB-59DB-4BE7-BF2A-2316C278718D}"/>
               </a:ext>
             </a:extLst>
           </p:cNvPr>
@@ -2708,7 +2713,7 @@
           <p:cNvPr id="14" name="s2-file-e">
             <a:extLst xmlns:a="http://schemas.openxmlformats.org/drawingml/2006/main">
               <a:ext uri="{FF2B5EF4-FFF2-40B4-BE49-F238E27FC236}">
-                <a16:creationId xmlns:a16="http://schemas.microsoft.com/office/drawing/2014/main" id="{AB99B7B3-9C63-4FBF-9470-48EFF288786B}"/>
+                <a16:creationId xmlns:a16="http://schemas.microsoft.com/office/drawing/2014/main" id="{B33BFD1E-4A8B-4F32-AB43-EB36FA455BA0}"/>
               </a:ext>
             </a:extLst>
           </p:cNvPr>
@@ -2741,7 +2746,7 @@
           <p:cNvPr id="15" name="s2-file-a-label">
             <a:extLst xmlns:a="http://schemas.openxmlformats.org/drawingml/2006/main">
               <a:ext uri="{FF2B5EF4-FFF2-40B4-BE49-F238E27FC236}">
-                <a16:creationId xmlns:a16="http://schemas.microsoft.com/office/drawing/2014/main" id="{009650EF-6DC2-4FD3-8230-57AEC17762E7}"/>
+                <a16:creationId xmlns:a16="http://schemas.microsoft.com/office/drawing/2014/main" id="{32BF2F3A-D65D-4DF4-A83D-4A0FB33B9AB6}"/>
               </a:ext>
             </a:extLst>
           </p:cNvPr>
@@ -2786,7 +2791,7 @@
           <p:cNvPr id="16" name="s2-file-b-label">
             <a:extLst xmlns:a="http://schemas.openxmlformats.org/drawingml/2006/main">
               <a:ext uri="{FF2B5EF4-FFF2-40B4-BE49-F238E27FC236}">
-                <a16:creationId xmlns:a16="http://schemas.microsoft.com/office/drawing/2014/main" id="{206287A0-0D71-417D-9323-BD356B9E1F30}"/>
+                <a16:creationId xmlns:a16="http://schemas.microsoft.com/office/drawing/2014/main" id="{4587D486-932F-4FB6-B402-137073E34186}"/>
               </a:ext>
             </a:extLst>
           </p:cNvPr>
@@ -2831,7 +2836,7 @@
           <p:cNvPr id="17" name="s2-file-c-label">
             <a:extLst xmlns:a="http://schemas.openxmlformats.org/drawingml/2006/main">
               <a:ext uri="{FF2B5EF4-FFF2-40B4-BE49-F238E27FC236}">
-                <a16:creationId xmlns:a16="http://schemas.microsoft.com/office/drawing/2014/main" id="{9EFF31B8-0D5E-4438-9973-3F302892D7E7}"/>
+                <a16:creationId xmlns:a16="http://schemas.microsoft.com/office/drawing/2014/main" id="{56E77D73-AFAD-438B-9DA9-99357F7C4419}"/>
               </a:ext>
             </a:extLst>
           </p:cNvPr>
@@ -2876,7 +2881,7 @@
           <p:cNvPr id="18" name="s2-file-d-label">
             <a:extLst xmlns:a="http://schemas.openxmlformats.org/drawingml/2006/main">
               <a:ext uri="{FF2B5EF4-FFF2-40B4-BE49-F238E27FC236}">
-                <a16:creationId xmlns:a16="http://schemas.microsoft.com/office/drawing/2014/main" id="{CD0096AC-2AFE-4B0A-B4A5-7F28E314F0CF}"/>
+                <a16:creationId xmlns:a16="http://schemas.microsoft.com/office/drawing/2014/main" id="{F306541C-8593-40AC-A877-CC3DE563777C}"/>
               </a:ext>
             </a:extLst>
           </p:cNvPr>
@@ -2921,7 +2926,7 @@
           <p:cNvPr id="19" name="s2-file-e-label">
             <a:extLst xmlns:a="http://schemas.openxmlformats.org/drawingml/2006/main">
               <a:ext uri="{FF2B5EF4-FFF2-40B4-BE49-F238E27FC236}">
-                <a16:creationId xmlns:a16="http://schemas.microsoft.com/office/drawing/2014/main" id="{D1A04DEF-CED8-482C-80F0-603EDB5572BD}"/>
+                <a16:creationId xmlns:a16="http://schemas.microsoft.com/office/drawing/2014/main" id="{8D3B657F-C97B-47DA-AE05-3EB3F1CD849F}"/>
               </a:ext>
             </a:extLst>
           </p:cNvPr>
@@ -2966,7 +2971,7 @@
           <p:cNvPr id="20" name="s2-n1">
             <a:extLst xmlns:a="http://schemas.openxmlformats.org/drawingml/2006/main">
               <a:ext uri="{FF2B5EF4-FFF2-40B4-BE49-F238E27FC236}">
-                <a16:creationId xmlns:a16="http://schemas.microsoft.com/office/drawing/2014/main" id="{54B0AA2E-152C-4877-86BD-E4A7AC425BED}"/>
+                <a16:creationId xmlns:a16="http://schemas.microsoft.com/office/drawing/2014/main" id="{D8FEB7E8-7602-4187-B600-F0EA3B74AE52}"/>
               </a:ext>
             </a:extLst>
           </p:cNvPr>
@@ -2999,7 +3004,7 @@
           <p:cNvPr id="21" name="s2-n1-label">
             <a:extLst xmlns:a="http://schemas.openxmlformats.org/drawingml/2006/main">
               <a:ext uri="{FF2B5EF4-FFF2-40B4-BE49-F238E27FC236}">
-                <a16:creationId xmlns:a16="http://schemas.microsoft.com/office/drawing/2014/main" id="{A4F29DD1-F602-43E6-903F-81710190A760}"/>
+                <a16:creationId xmlns:a16="http://schemas.microsoft.com/office/drawing/2014/main" id="{62768408-9234-4E1A-86BD-3089003B8B33}"/>
               </a:ext>
             </a:extLst>
           </p:cNvPr>
@@ -3044,7 +3049,7 @@
           <p:cNvPr id="22" name="s2-p1">
             <a:extLst xmlns:a="http://schemas.openxmlformats.org/drawingml/2006/main">
               <a:ext uri="{FF2B5EF4-FFF2-40B4-BE49-F238E27FC236}">
-                <a16:creationId xmlns:a16="http://schemas.microsoft.com/office/drawing/2014/main" id="{25298350-FBC0-4CA0-9F3C-39230D5BC29D}"/>
+                <a16:creationId xmlns:a16="http://schemas.microsoft.com/office/drawing/2014/main" id="{F5162042-A516-4172-987A-DEC9A5623A64}"/>
               </a:ext>
             </a:extLst>
           </p:cNvPr>
@@ -3089,7 +3094,7 @@
           <p:cNvPr id="23" name="s2-n2">
             <a:extLst xmlns:a="http://schemas.openxmlformats.org/drawingml/2006/main">
               <a:ext uri="{FF2B5EF4-FFF2-40B4-BE49-F238E27FC236}">
-                <a16:creationId xmlns:a16="http://schemas.microsoft.com/office/drawing/2014/main" id="{E6531A41-12DF-4413-9622-33CCCB7DD2B3}"/>
+                <a16:creationId xmlns:a16="http://schemas.microsoft.com/office/drawing/2014/main" id="{B4BD2993-05F2-4960-93EC-545FE3A79B48}"/>
               </a:ext>
             </a:extLst>
           </p:cNvPr>
@@ -3122,7 +3127,7 @@
           <p:cNvPr id="24" name="s2-n2-label">
             <a:extLst xmlns:a="http://schemas.openxmlformats.org/drawingml/2006/main">
               <a:ext uri="{FF2B5EF4-FFF2-40B4-BE49-F238E27FC236}">
-                <a16:creationId xmlns:a16="http://schemas.microsoft.com/office/drawing/2014/main" id="{6234723A-5B6E-4197-83AA-5C04AAEB4714}"/>
+                <a16:creationId xmlns:a16="http://schemas.microsoft.com/office/drawing/2014/main" id="{758B1B5C-4A3A-4E43-9223-B0F64104B272}"/>
               </a:ext>
             </a:extLst>
           </p:cNvPr>
@@ -3167,7 +3172,7 @@
           <p:cNvPr id="25" name="s2-p2">
             <a:extLst xmlns:a="http://schemas.openxmlformats.org/drawingml/2006/main">
               <a:ext uri="{FF2B5EF4-FFF2-40B4-BE49-F238E27FC236}">
-                <a16:creationId xmlns:a16="http://schemas.microsoft.com/office/drawing/2014/main" id="{729C3FF9-5232-45C7-B73F-F6FA4121E56B}"/>
+                <a16:creationId xmlns:a16="http://schemas.microsoft.com/office/drawing/2014/main" id="{216F0699-0303-427C-A104-396B5BFAEB4D}"/>
               </a:ext>
             </a:extLst>
           </p:cNvPr>
@@ -3212,7 +3217,7 @@
           <p:cNvPr id="26" name="s2-n3">
             <a:extLst xmlns:a="http://schemas.openxmlformats.org/drawingml/2006/main">
               <a:ext uri="{FF2B5EF4-FFF2-40B4-BE49-F238E27FC236}">
-                <a16:creationId xmlns:a16="http://schemas.microsoft.com/office/drawing/2014/main" id="{1AFAC487-D452-4854-BFE1-52FA51238224}"/>
+                <a16:creationId xmlns:a16="http://schemas.microsoft.com/office/drawing/2014/main" id="{953A21F2-A6AD-4166-9B57-9F79639EE525}"/>
               </a:ext>
             </a:extLst>
           </p:cNvPr>
@@ -3245,7 +3250,7 @@
           <p:cNvPr id="27" name="s2-n3-label">
             <a:extLst xmlns:a="http://schemas.openxmlformats.org/drawingml/2006/main">
               <a:ext uri="{FF2B5EF4-FFF2-40B4-BE49-F238E27FC236}">
-                <a16:creationId xmlns:a16="http://schemas.microsoft.com/office/drawing/2014/main" id="{00FB4118-EAB5-4692-BCCC-3EFEFD754756}"/>
+                <a16:creationId xmlns:a16="http://schemas.microsoft.com/office/drawing/2014/main" id="{67E3757C-7BC9-473D-BD3D-0A16007A14C9}"/>
               </a:ext>
             </a:extLst>
           </p:cNvPr>
@@ -3290,7 +3295,7 @@
           <p:cNvPr id="28" name="s2-p3">
             <a:extLst xmlns:a="http://schemas.openxmlformats.org/drawingml/2006/main">
               <a:ext uri="{FF2B5EF4-FFF2-40B4-BE49-F238E27FC236}">
-                <a16:creationId xmlns:a16="http://schemas.microsoft.com/office/drawing/2014/main" id="{529BF1A9-8EFB-498C-B00F-9DDB260AB287}"/>
+                <a16:creationId xmlns:a16="http://schemas.microsoft.com/office/drawing/2014/main" id="{769800D5-994F-4BB1-AD39-635972011F2D}"/>
               </a:ext>
             </a:extLst>
           </p:cNvPr>
@@ -3335,7 +3340,7 @@
           <p:cNvPr id="29" name="s2-takeaway">
             <a:extLst xmlns:a="http://schemas.openxmlformats.org/drawingml/2006/main">
               <a:ext uri="{FF2B5EF4-FFF2-40B4-BE49-F238E27FC236}">
-                <a16:creationId xmlns:a16="http://schemas.microsoft.com/office/drawing/2014/main" id="{D0ACB8BD-EE21-4326-B986-8FC8AC8317B6}"/>
+                <a16:creationId xmlns:a16="http://schemas.microsoft.com/office/drawing/2014/main" id="{F96DB957-1493-4D0D-8297-7670DA2B63B2}"/>
               </a:ext>
             </a:extLst>
           </p:cNvPr>
@@ -3402,7 +3407,7 @@
           <p:cNvPr id="31" name="footer-source-2">
             <a:extLst xmlns:a="http://schemas.openxmlformats.org/drawingml/2006/main">
               <a:ext uri="{FF2B5EF4-FFF2-40B4-BE49-F238E27FC236}">
-                <a16:creationId xmlns:a16="http://schemas.microsoft.com/office/drawing/2014/main" id="{F5D6DA4A-4F56-493A-9566-C2D522D6727C}"/>
+                <a16:creationId xmlns:a16="http://schemas.microsoft.com/office/drawing/2014/main" id="{73CFBAD0-5848-46F1-AA68-4BF1E8A140F0}"/>
               </a:ext>
             </a:extLst>
           </p:cNvPr>
@@ -3447,7 +3452,7 @@
           <p:cNvPr id="32" name="footer-number-2">
             <a:extLst xmlns:a="http://schemas.openxmlformats.org/drawingml/2006/main">
               <a:ext uri="{FF2B5EF4-FFF2-40B4-BE49-F238E27FC236}">
-                <a16:creationId xmlns:a16="http://schemas.microsoft.com/office/drawing/2014/main" id="{57A1E16F-B221-4BC2-9FD6-36B9A9BC135D}"/>
+                <a16:creationId xmlns:a16="http://schemas.microsoft.com/office/drawing/2014/main" id="{C40432CF-26AF-4DE0-B190-F8AE9AB03723}"/>
               </a:ext>
             </a:extLst>
           </p:cNvPr>
@@ -3490,7 +3495,7 @@
     </p:spTree>
     <p:extLst>
       <p:ext uri="{BB962C8B-B14F-4D97-AF65-F5344CB8AC3E}">
-        <p14:creationId xmlns:p14="http://schemas.microsoft.com/office/powerpoint/2010/main" val="1232146288"/>
+        <p14:creationId xmlns:p14="http://schemas.microsoft.com/office/powerpoint/2010/main" val="1442236352"/>
       </p:ext>
     </p:extLst>
   </p:cSld>
@@ -3521,7 +3526,7 @@
           <p:cNvPr id="29" name="s3-title">
             <a:extLst xmlns:a="http://schemas.openxmlformats.org/drawingml/2006/main">
               <a:ext uri="{FF2B5EF4-FFF2-40B4-BE49-F238E27FC236}">
-                <a16:creationId xmlns:a16="http://schemas.microsoft.com/office/drawing/2014/main" id="{D92F9CBF-9B75-48D7-9978-568567EF54DC}"/>
+                <a16:creationId xmlns:a16="http://schemas.microsoft.com/office/drawing/2014/main" id="{E27733F7-45C4-4741-BECA-AB6F8949F354}"/>
               </a:ext>
             </a:extLst>
           </p:cNvPr>
@@ -3556,7 +3561,7 @@
               </a:defRPr>
             </a:pPr>
             <a:r>
-              <a:t>A human memory palace became a map for code.</a:t>
+              <a:t>I wanted to turn a 2D repository into a 3D building.</a:t>
             </a:r>
           </a:p>
         </p:txBody>
@@ -3566,7 +3571,7 @@
           <p:cNvPr id="2" name="s3-subtitle">
             <a:extLst xmlns:a="http://schemas.openxmlformats.org/drawingml/2006/main">
               <a:ext uri="{FF2B5EF4-FFF2-40B4-BE49-F238E27FC236}">
-                <a16:creationId xmlns:a16="http://schemas.microsoft.com/office/drawing/2014/main" id="{5C55AC4E-DEDD-46CF-9F11-0449E0E187CD}"/>
+                <a16:creationId xmlns:a16="http://schemas.microsoft.com/office/drawing/2014/main" id="{D8B89513-F66C-4268-806F-44E2DF33041A}"/>
               </a:ext>
             </a:extLst>
           </p:cNvPr>
@@ -3601,7 +3606,7 @@
               </a:defRPr>
             </a:pPr>
             <a:r>
-              <a:t>Floors organize domains. Rooms hold features. Routes retrieve context. Pitfalls wait at the entrance.</a:t>
+              <a:t>Domains became floors. Features became rooms. Files and symbols became cabinets and drawers.</a:t>
             </a:r>
           </a:p>
         </p:txBody>
@@ -3721,7 +3726,7 @@
           <p:cNvPr id="8" name="s3-repo">
             <a:extLst xmlns:a="http://schemas.openxmlformats.org/drawingml/2006/main">
               <a:ext uri="{FF2B5EF4-FFF2-40B4-BE49-F238E27FC236}">
-                <a16:creationId xmlns:a16="http://schemas.microsoft.com/office/drawing/2014/main" id="{2D2EF53F-31C5-4978-ABAA-D68449E00DA8}"/>
+                <a16:creationId xmlns:a16="http://schemas.microsoft.com/office/drawing/2014/main" id="{F84B093C-FEA3-4914-8E41-2D9A530BAA25}"/>
               </a:ext>
             </a:extLst>
           </p:cNvPr>
@@ -3756,7 +3761,7 @@
           <p:cNvPr id="9" name="s3-index">
             <a:extLst xmlns:a="http://schemas.openxmlformats.org/drawingml/2006/main">
               <a:ext uri="{FF2B5EF4-FFF2-40B4-BE49-F238E27FC236}">
-                <a16:creationId xmlns:a16="http://schemas.microsoft.com/office/drawing/2014/main" id="{1A9AA8D4-1388-42DB-93F7-1519B29C9353}"/>
+                <a16:creationId xmlns:a16="http://schemas.microsoft.com/office/drawing/2014/main" id="{89846913-9258-41E6-A885-56F6F473227D}"/>
               </a:ext>
             </a:extLst>
           </p:cNvPr>
@@ -3791,7 +3796,7 @@
           <p:cNvPr id="10" name="s3-mode">
             <a:extLst xmlns:a="http://schemas.openxmlformats.org/drawingml/2006/main">
               <a:ext uri="{FF2B5EF4-FFF2-40B4-BE49-F238E27FC236}">
-                <a16:creationId xmlns:a16="http://schemas.microsoft.com/office/drawing/2014/main" id="{0A5361B6-FE8E-4CF3-8B46-BF5CA1F4F179}"/>
+                <a16:creationId xmlns:a16="http://schemas.microsoft.com/office/drawing/2014/main" id="{C55F47EA-5C65-456D-B485-4D330B21B66C}"/>
               </a:ext>
             </a:extLst>
           </p:cNvPr>
@@ -3826,7 +3831,7 @@
           <p:cNvPr id="11" name="s3-pack">
             <a:extLst xmlns:a="http://schemas.openxmlformats.org/drawingml/2006/main">
               <a:ext uri="{FF2B5EF4-FFF2-40B4-BE49-F238E27FC236}">
-                <a16:creationId xmlns:a16="http://schemas.microsoft.com/office/drawing/2014/main" id="{2A5089C0-ED1A-46E9-AD71-7A84B1788F77}"/>
+                <a16:creationId xmlns:a16="http://schemas.microsoft.com/office/drawing/2014/main" id="{253B49D7-D4B8-44CF-8038-1EC8F11B9418}"/>
               </a:ext>
             </a:extLst>
           </p:cNvPr>
@@ -3861,7 +3866,7 @@
           <p:cNvPr id="12" name="s3-task">
             <a:extLst xmlns:a="http://schemas.openxmlformats.org/drawingml/2006/main">
               <a:ext uri="{FF2B5EF4-FFF2-40B4-BE49-F238E27FC236}">
-                <a16:creationId xmlns:a16="http://schemas.microsoft.com/office/drawing/2014/main" id="{3372EEC0-BB6A-42B0-94B0-B4A2F814F491}"/>
+                <a16:creationId xmlns:a16="http://schemas.microsoft.com/office/drawing/2014/main" id="{8D16ACD7-C8C3-4977-8C92-5CC73FFE564B}"/>
               </a:ext>
             </a:extLst>
           </p:cNvPr>
@@ -3896,19 +3901,19 @@
           <p:cNvPr id="13" name="s3-repo-label">
             <a:extLst xmlns:a="http://schemas.openxmlformats.org/drawingml/2006/main">
               <a:ext uri="{FF2B5EF4-FFF2-40B4-BE49-F238E27FC236}">
-                <a16:creationId xmlns:a16="http://schemas.microsoft.com/office/drawing/2014/main" id="{C3D2DF5B-EFC5-494F-A605-521DDE9E1A4B}"/>
-              </a:ext>
-            </a:extLst>
-          </p:cNvPr>
-          <p:cNvSpPr>
-            <a:spLocks xmlns:a="http://schemas.openxmlformats.org/drawingml/2006/main" noGrp="1"/>
-          </p:cNvSpPr>
-          <p:nvPr/>
-        </p:nvSpPr>
-        <p:spPr>
-          <a:xfrm xmlns:a="http://schemas.openxmlformats.org/drawingml/2006/main">
-            <a:off x="752475" y="2447925"/>
-            <a:ext cx="1295400" cy="285750"/>
+                <a16:creationId xmlns:a16="http://schemas.microsoft.com/office/drawing/2014/main" id="{DE66DED8-C4E0-495F-9EA6-E16BAEC49390}"/>
+              </a:ext>
+            </a:extLst>
+          </p:cNvPr>
+          <p:cNvSpPr>
+            <a:spLocks xmlns:a="http://schemas.openxmlformats.org/drawingml/2006/main" noGrp="1"/>
+          </p:cNvSpPr>
+          <p:nvPr/>
+        </p:nvSpPr>
+        <p:spPr>
+          <a:xfrm xmlns:a="http://schemas.openxmlformats.org/drawingml/2006/main">
+            <a:off x="666750" y="2447925"/>
+            <a:ext cx="1466850" cy="285750"/>
           </a:xfrm>
           <a:prstGeom xmlns:a="http://schemas.openxmlformats.org/drawingml/2006/main" prst="rect">
             <a:avLst/>
@@ -3921,7 +3926,7 @@
           <a:lstStyle xmlns:a="http://schemas.openxmlformats.org/drawingml/2006/main"/>
           <a:p xmlns:a="http://schemas.openxmlformats.org/drawingml/2006/main">
             <a:pPr algn="ctr">
-              <a:defRPr sz="1275" b="1">
+              <a:defRPr sz="1200" b="1">
                 <a:solidFill>
                   <a:srgbClr val="526071"/>
                 </a:solidFill>
@@ -3931,7 +3936,7 @@
               </a:defRPr>
             </a:pPr>
             <a:r>
-              <a:t>REPOSITORY</a:t>
+              <a:t>2D REPOSITORY</a:t>
             </a:r>
           </a:p>
         </p:txBody>
@@ -3941,7 +3946,7 @@
           <p:cNvPr id="14" name="s3-repo-main">
             <a:extLst xmlns:a="http://schemas.openxmlformats.org/drawingml/2006/main">
               <a:ext uri="{FF2B5EF4-FFF2-40B4-BE49-F238E27FC236}">
-                <a16:creationId xmlns:a16="http://schemas.microsoft.com/office/drawing/2014/main" id="{D08BBECF-F87F-404F-B7C6-EFAF4ECC6D17}"/>
+                <a16:creationId xmlns:a16="http://schemas.microsoft.com/office/drawing/2014/main" id="{68158F59-AA4A-4B63-BB04-EEB6328FF700}"/>
               </a:ext>
             </a:extLst>
           </p:cNvPr>
@@ -3986,7 +3991,7 @@
           <p:cNvPr id="15" name="s3-index-label">
             <a:extLst xmlns:a="http://schemas.openxmlformats.org/drawingml/2006/main">
               <a:ext uri="{FF2B5EF4-FFF2-40B4-BE49-F238E27FC236}">
-                <a16:creationId xmlns:a16="http://schemas.microsoft.com/office/drawing/2014/main" id="{9CEE3B39-E5AB-43E8-9410-409B433E192D}"/>
+                <a16:creationId xmlns:a16="http://schemas.microsoft.com/office/drawing/2014/main" id="{61C61F4D-AB50-4C8A-A245-D365FFB10584}"/>
               </a:ext>
             </a:extLst>
           </p:cNvPr>
@@ -4021,7 +4026,7 @@
               </a:defRPr>
             </a:pPr>
             <a:r>
-              <a:t>INDEX</a:t>
+              <a:t>3D MAP</a:t>
             </a:r>
           </a:p>
         </p:txBody>
@@ -4031,7 +4036,7 @@
           <p:cNvPr id="16" name="s3-index-main">
             <a:extLst xmlns:a="http://schemas.openxmlformats.org/drawingml/2006/main">
               <a:ext uri="{FF2B5EF4-FFF2-40B4-BE49-F238E27FC236}">
-                <a16:creationId xmlns:a16="http://schemas.microsoft.com/office/drawing/2014/main" id="{5DE3F261-5714-4F5B-9ED1-5FD182A2F133}"/>
+                <a16:creationId xmlns:a16="http://schemas.microsoft.com/office/drawing/2014/main" id="{80ED80A2-8106-4FBE-B141-772AB77F4A5D}"/>
               </a:ext>
             </a:extLst>
           </p:cNvPr>
@@ -4066,7 +4071,7 @@
               </a:defRPr>
             </a:pPr>
             <a:r>
-              <a:t>Rooms + edges</a:t>
+              <a:t>Floors + rooms</a:t>
             </a:r>
           </a:p>
         </p:txBody>
@@ -4076,7 +4081,7 @@
           <p:cNvPr id="17" name="s3-mode-label">
             <a:extLst xmlns:a="http://schemas.openxmlformats.org/drawingml/2006/main">
               <a:ext uri="{FF2B5EF4-FFF2-40B4-BE49-F238E27FC236}">
-                <a16:creationId xmlns:a16="http://schemas.microsoft.com/office/drawing/2014/main" id="{4139FC64-999A-45F7-8770-136EAE227679}"/>
+                <a16:creationId xmlns:a16="http://schemas.microsoft.com/office/drawing/2014/main" id="{50EC9758-2A1F-4CCC-AFCC-3FE14473EB71}"/>
               </a:ext>
             </a:extLst>
           </p:cNvPr>
@@ -4121,7 +4126,7 @@
           <p:cNvPr id="18" name="s3-mode-main">
             <a:extLst xmlns:a="http://schemas.openxmlformats.org/drawingml/2006/main">
               <a:ext uri="{FF2B5EF4-FFF2-40B4-BE49-F238E27FC236}">
-                <a16:creationId xmlns:a16="http://schemas.microsoft.com/office/drawing/2014/main" id="{39C7742F-62C2-4E76-AC74-8C9448293D94}"/>
+                <a16:creationId xmlns:a16="http://schemas.microsoft.com/office/drawing/2014/main" id="{1141A154-71D2-4D75-BBBC-811FF386FA02}"/>
               </a:ext>
             </a:extLst>
           </p:cNvPr>
@@ -4166,7 +4171,7 @@
           <p:cNvPr id="19" name="s3-pack-label">
             <a:extLst xmlns:a="http://schemas.openxmlformats.org/drawingml/2006/main">
               <a:ext uri="{FF2B5EF4-FFF2-40B4-BE49-F238E27FC236}">
-                <a16:creationId xmlns:a16="http://schemas.microsoft.com/office/drawing/2014/main" id="{2B5D58DB-5CFC-45B3-9422-23C1CC531681}"/>
+                <a16:creationId xmlns:a16="http://schemas.microsoft.com/office/drawing/2014/main" id="{CC3A3F32-7EEA-4FEA-ABB0-35FC9A1F0B23}"/>
               </a:ext>
             </a:extLst>
           </p:cNvPr>
@@ -4211,7 +4216,7 @@
           <p:cNvPr id="20" name="s3-pack-main">
             <a:extLst xmlns:a="http://schemas.openxmlformats.org/drawingml/2006/main">
               <a:ext uri="{FF2B5EF4-FFF2-40B4-BE49-F238E27FC236}">
-                <a16:creationId xmlns:a16="http://schemas.microsoft.com/office/drawing/2014/main" id="{4E32E37A-1023-4D21-B597-282845AFFF57}"/>
+                <a16:creationId xmlns:a16="http://schemas.microsoft.com/office/drawing/2014/main" id="{514BDFEB-EBD4-4270-A5E1-9EC8CDB44BAB}"/>
               </a:ext>
             </a:extLst>
           </p:cNvPr>
@@ -4256,7 +4261,7 @@
           <p:cNvPr id="21" name="s3-task-label">
             <a:extLst xmlns:a="http://schemas.openxmlformats.org/drawingml/2006/main">
               <a:ext uri="{FF2B5EF4-FFF2-40B4-BE49-F238E27FC236}">
-                <a16:creationId xmlns:a16="http://schemas.microsoft.com/office/drawing/2014/main" id="{C8F5B856-286B-4FF9-A925-B6A5417AB582}"/>
+                <a16:creationId xmlns:a16="http://schemas.microsoft.com/office/drawing/2014/main" id="{9BA4AB6D-90C4-4A8D-B33E-DF0776097333}"/>
               </a:ext>
             </a:extLst>
           </p:cNvPr>
@@ -4301,7 +4306,7 @@
           <p:cNvPr id="22" name="s3-task-main">
             <a:extLst xmlns:a="http://schemas.openxmlformats.org/drawingml/2006/main">
               <a:ext uri="{FF2B5EF4-FFF2-40B4-BE49-F238E27FC236}">
-                <a16:creationId xmlns:a16="http://schemas.microsoft.com/office/drawing/2014/main" id="{695CFAC2-62EC-417E-B040-37E950FD429C}"/>
+                <a16:creationId xmlns:a16="http://schemas.microsoft.com/office/drawing/2014/main" id="{ACB93DFB-A28F-45E4-A94B-BAB1B6B6DD2E}"/>
               </a:ext>
             </a:extLst>
           </p:cNvPr>
@@ -4346,7 +4351,7 @@
           <p:cNvPr id="23" name="s3-memory">
             <a:extLst xmlns:a="http://schemas.openxmlformats.org/drawingml/2006/main">
               <a:ext uri="{FF2B5EF4-FFF2-40B4-BE49-F238E27FC236}">
-                <a16:creationId xmlns:a16="http://schemas.microsoft.com/office/drawing/2014/main" id="{66EF50F3-8ABC-450E-B25B-A7FDB7B839F9}"/>
+                <a16:creationId xmlns:a16="http://schemas.microsoft.com/office/drawing/2014/main" id="{22661A92-B252-4608-BE68-42477823B58A}"/>
               </a:ext>
             </a:extLst>
           </p:cNvPr>
@@ -4381,7 +4386,7 @@
           <p:cNvPr id="24" name="s3-memory-label">
             <a:extLst xmlns:a="http://schemas.openxmlformats.org/drawingml/2006/main">
               <a:ext uri="{FF2B5EF4-FFF2-40B4-BE49-F238E27FC236}">
-                <a16:creationId xmlns:a16="http://schemas.microsoft.com/office/drawing/2014/main" id="{11CDE2CB-061F-4DA6-8B4C-B074F0F745CA}"/>
+                <a16:creationId xmlns:a16="http://schemas.microsoft.com/office/drawing/2014/main" id="{38A2F781-4E22-45E9-A836-99B70AAF960C}"/>
               </a:ext>
             </a:extLst>
           </p:cNvPr>
@@ -4426,7 +4431,7 @@
           <p:cNvPr id="25" name="s3-memory-main">
             <a:extLst xmlns:a="http://schemas.openxmlformats.org/drawingml/2006/main">
               <a:ext uri="{FF2B5EF4-FFF2-40B4-BE49-F238E27FC236}">
-                <a16:creationId xmlns:a16="http://schemas.microsoft.com/office/drawing/2014/main" id="{8CA8B7A1-668E-4D96-9618-9520F20C402F}"/>
+                <a16:creationId xmlns:a16="http://schemas.microsoft.com/office/drawing/2014/main" id="{9176910D-FF8F-47BD-9D19-D6FF55856235}"/>
               </a:ext>
             </a:extLst>
           </p:cNvPr>
@@ -4494,7 +4499,7 @@
           <p:cNvPr id="27" name="footer-source-3">
             <a:extLst xmlns:a="http://schemas.openxmlformats.org/drawingml/2006/main">
               <a:ext uri="{FF2B5EF4-FFF2-40B4-BE49-F238E27FC236}">
-                <a16:creationId xmlns:a16="http://schemas.microsoft.com/office/drawing/2014/main" id="{B62A79BE-149B-4286-8522-827B65ED8C76}"/>
+                <a16:creationId xmlns:a16="http://schemas.microsoft.com/office/drawing/2014/main" id="{D36EEE0C-5739-45FB-998D-4F61E564678D}"/>
               </a:ext>
             </a:extLst>
           </p:cNvPr>
@@ -4539,7 +4544,7 @@
           <p:cNvPr id="28" name="footer-number-3">
             <a:extLst xmlns:a="http://schemas.openxmlformats.org/drawingml/2006/main">
               <a:ext uri="{FF2B5EF4-FFF2-40B4-BE49-F238E27FC236}">
-                <a16:creationId xmlns:a16="http://schemas.microsoft.com/office/drawing/2014/main" id="{FDCCC621-878A-40B5-AD45-DFE111C01B65}"/>
+                <a16:creationId xmlns:a16="http://schemas.microsoft.com/office/drawing/2014/main" id="{FF2E9AEF-FEBB-42E0-B537-B71C9B502CB6}"/>
               </a:ext>
             </a:extLst>
           </p:cNvPr>
@@ -4582,7 +4587,7 @@
     </p:spTree>
     <p:extLst>
       <p:ext uri="{BB962C8B-B14F-4D97-AF65-F5344CB8AC3E}">
-        <p14:creationId xmlns:p14="http://schemas.microsoft.com/office/powerpoint/2010/main" val="1625512413"/>
+        <p14:creationId xmlns:p14="http://schemas.microsoft.com/office/powerpoint/2010/main" val="1758424556"/>
       </p:ext>
     </p:extLst>
   </p:cSld>
@@ -4613,7 +4618,7 @@
           <p:cNvPr id="26" name="s4-title">
             <a:extLst xmlns:a="http://schemas.openxmlformats.org/drawingml/2006/main">
               <a:ext uri="{FF2B5EF4-FFF2-40B4-BE49-F238E27FC236}">
-                <a16:creationId xmlns:a16="http://schemas.microsoft.com/office/drawing/2014/main" id="{74BDA43C-BFDB-43EC-AF4C-0DCE8F9B7618}"/>
+                <a16:creationId xmlns:a16="http://schemas.microsoft.com/office/drawing/2014/main" id="{ECA5D961-2EE9-4A5E-B81F-8A9688892170}"/>
               </a:ext>
             </a:extLst>
           </p:cNvPr>
@@ -4658,7 +4663,7 @@
           <p:cNvPr id="2" name="s4-subtitle">
             <a:extLst xmlns:a="http://schemas.openxmlformats.org/drawingml/2006/main">
               <a:ext uri="{FF2B5EF4-FFF2-40B4-BE49-F238E27FC236}">
-                <a16:creationId xmlns:a16="http://schemas.microsoft.com/office/drawing/2014/main" id="{7418B20B-4660-4729-B812-1C8E72866175}"/>
+                <a16:creationId xmlns:a16="http://schemas.microsoft.com/office/drawing/2014/main" id="{321E7CAC-0FC2-46A7-9274-8A907B2D1403}"/>
               </a:ext>
             </a:extLst>
           </p:cNvPr>
@@ -4703,7 +4708,7 @@
           <p:cNvPr id="3" name="s4-terminal">
             <a:extLst xmlns:a="http://schemas.openxmlformats.org/drawingml/2006/main">
               <a:ext uri="{FF2B5EF4-FFF2-40B4-BE49-F238E27FC236}">
-                <a16:creationId xmlns:a16="http://schemas.microsoft.com/office/drawing/2014/main" id="{AEA1B5C2-FBA6-40FD-9AFF-73B8BDE69E5F}"/>
+                <a16:creationId xmlns:a16="http://schemas.microsoft.com/office/drawing/2014/main" id="{DFE91957-DDAD-4185-BD6E-A67F17BD252D}"/>
               </a:ext>
             </a:extLst>
           </p:cNvPr>
@@ -4760,7 +4765,7 @@
           <p:cNvPr id="5" name="s4-dot1">
             <a:extLst xmlns:a="http://schemas.openxmlformats.org/drawingml/2006/main">
               <a:ext uri="{FF2B5EF4-FFF2-40B4-BE49-F238E27FC236}">
-                <a16:creationId xmlns:a16="http://schemas.microsoft.com/office/drawing/2014/main" id="{B2DDEE5B-8847-4D78-9FC8-C3CA87313A5B}"/>
+                <a16:creationId xmlns:a16="http://schemas.microsoft.com/office/drawing/2014/main" id="{DCF94B8F-E198-417E-90D2-D57B6656DB45}"/>
               </a:ext>
             </a:extLst>
           </p:cNvPr>
@@ -4793,7 +4798,7 @@
           <p:cNvPr id="6" name="s4-dot2">
             <a:extLst xmlns:a="http://schemas.openxmlformats.org/drawingml/2006/main">
               <a:ext uri="{FF2B5EF4-FFF2-40B4-BE49-F238E27FC236}">
-                <a16:creationId xmlns:a16="http://schemas.microsoft.com/office/drawing/2014/main" id="{A4120322-37E7-4602-806E-41D8EFFB6BD2}"/>
+                <a16:creationId xmlns:a16="http://schemas.microsoft.com/office/drawing/2014/main" id="{580B3C56-7D5F-472B-BC43-74DBD9CC4587}"/>
               </a:ext>
             </a:extLst>
           </p:cNvPr>
@@ -4826,7 +4831,7 @@
           <p:cNvPr id="7" name="s4-dot3">
             <a:extLst xmlns:a="http://schemas.openxmlformats.org/drawingml/2006/main">
               <a:ext uri="{FF2B5EF4-FFF2-40B4-BE49-F238E27FC236}">
-                <a16:creationId xmlns:a16="http://schemas.microsoft.com/office/drawing/2014/main" id="{FBB6EC7D-42BA-4247-A36C-6FBFEB459E22}"/>
+                <a16:creationId xmlns:a16="http://schemas.microsoft.com/office/drawing/2014/main" id="{94D12B48-C7BB-495D-87D3-42E1E09F494D}"/>
               </a:ext>
             </a:extLst>
           </p:cNvPr>
@@ -4859,7 +4864,7 @@
           <p:cNvPr id="8" name="s4-command-label">
             <a:extLst xmlns:a="http://schemas.openxmlformats.org/drawingml/2006/main">
               <a:ext uri="{FF2B5EF4-FFF2-40B4-BE49-F238E27FC236}">
-                <a16:creationId xmlns:a16="http://schemas.microsoft.com/office/drawing/2014/main" id="{BA374669-918A-48C4-AB7E-F32EE3FA9198}"/>
+                <a16:creationId xmlns:a16="http://schemas.microsoft.com/office/drawing/2014/main" id="{6BFAD678-1E01-48C1-9FEB-A1066E6262DA}"/>
               </a:ext>
             </a:extLst>
           </p:cNvPr>
@@ -4904,7 +4909,7 @@
           <p:cNvPr id="9" name="s4-command">
             <a:extLst xmlns:a="http://schemas.openxmlformats.org/drawingml/2006/main">
               <a:ext uri="{FF2B5EF4-FFF2-40B4-BE49-F238E27FC236}">
-                <a16:creationId xmlns:a16="http://schemas.microsoft.com/office/drawing/2014/main" id="{9BE86474-632D-43EA-9C9E-89468A5B90E7}"/>
+                <a16:creationId xmlns:a16="http://schemas.microsoft.com/office/drawing/2014/main" id="{BC067BAD-F1B8-430C-A94A-24FD66FB9623}"/>
               </a:ext>
             </a:extLst>
           </p:cNvPr>
@@ -4953,7 +4958,7 @@
           <p:cNvPr id="10" name="s4-command-note">
             <a:extLst xmlns:a="http://schemas.openxmlformats.org/drawingml/2006/main">
               <a:ext uri="{FF2B5EF4-FFF2-40B4-BE49-F238E27FC236}">
-                <a16:creationId xmlns:a16="http://schemas.microsoft.com/office/drawing/2014/main" id="{27D11303-38FE-411A-B586-4587331DBDAD}"/>
+                <a16:creationId xmlns:a16="http://schemas.microsoft.com/office/drawing/2014/main" id="{B2E2F647-B92F-471E-BE3A-2804F7CE3BA4}"/>
               </a:ext>
             </a:extLst>
           </p:cNvPr>
@@ -4998,7 +5003,7 @@
           <p:cNvPr id="11" name="s4-output-label">
             <a:extLst xmlns:a="http://schemas.openxmlformats.org/drawingml/2006/main">
               <a:ext uri="{FF2B5EF4-FFF2-40B4-BE49-F238E27FC236}">
-                <a16:creationId xmlns:a16="http://schemas.microsoft.com/office/drawing/2014/main" id="{F06940CE-1C30-47DD-9F3F-634D6640923D}"/>
+                <a16:creationId xmlns:a16="http://schemas.microsoft.com/office/drawing/2014/main" id="{B5358BA2-183D-49E8-89FC-E121568F0B55}"/>
               </a:ext>
             </a:extLst>
           </p:cNvPr>
@@ -5043,7 +5048,7 @@
           <p:cNvPr id="12" name="s4-o1a">
             <a:extLst xmlns:a="http://schemas.openxmlformats.org/drawingml/2006/main">
               <a:ext uri="{FF2B5EF4-FFF2-40B4-BE49-F238E27FC236}">
-                <a16:creationId xmlns:a16="http://schemas.microsoft.com/office/drawing/2014/main" id="{E954E9FD-4ABC-49A8-98B8-7CB739A7867E}"/>
+                <a16:creationId xmlns:a16="http://schemas.microsoft.com/office/drawing/2014/main" id="{3F3A315A-A832-4508-B97E-057AC5D7B79D}"/>
               </a:ext>
             </a:extLst>
           </p:cNvPr>
@@ -5088,7 +5093,7 @@
           <p:cNvPr id="13" name="s4-o1b">
             <a:extLst xmlns:a="http://schemas.openxmlformats.org/drawingml/2006/main">
               <a:ext uri="{FF2B5EF4-FFF2-40B4-BE49-F238E27FC236}">
-                <a16:creationId xmlns:a16="http://schemas.microsoft.com/office/drawing/2014/main" id="{FF81212A-580A-4793-B355-F7016ECC6B47}"/>
+                <a16:creationId xmlns:a16="http://schemas.microsoft.com/office/drawing/2014/main" id="{415326A1-EA95-438B-A5A9-078EB0DF7A70}"/>
               </a:ext>
             </a:extLst>
           </p:cNvPr>
@@ -5133,7 +5138,7 @@
           <p:cNvPr id="14" name="s4-o2a">
             <a:extLst xmlns:a="http://schemas.openxmlformats.org/drawingml/2006/main">
               <a:ext uri="{FF2B5EF4-FFF2-40B4-BE49-F238E27FC236}">
-                <a16:creationId xmlns:a16="http://schemas.microsoft.com/office/drawing/2014/main" id="{8124CF30-039C-43EF-9CE1-B1D7F6E73F59}"/>
+                <a16:creationId xmlns:a16="http://schemas.microsoft.com/office/drawing/2014/main" id="{C150D3AC-C6E0-4280-AB80-17F3590A3FA9}"/>
               </a:ext>
             </a:extLst>
           </p:cNvPr>
@@ -5178,7 +5183,7 @@
           <p:cNvPr id="15" name="s4-o2b">
             <a:extLst xmlns:a="http://schemas.openxmlformats.org/drawingml/2006/main">
               <a:ext uri="{FF2B5EF4-FFF2-40B4-BE49-F238E27FC236}">
-                <a16:creationId xmlns:a16="http://schemas.microsoft.com/office/drawing/2014/main" id="{445EFAC5-8441-473A-805E-6255B05A93F1}"/>
+                <a16:creationId xmlns:a16="http://schemas.microsoft.com/office/drawing/2014/main" id="{9D684430-950D-41C8-A2D1-D44F19D82E41}"/>
               </a:ext>
             </a:extLst>
           </p:cNvPr>
@@ -5223,7 +5228,7 @@
           <p:cNvPr id="16" name="s4-o3a">
             <a:extLst xmlns:a="http://schemas.openxmlformats.org/drawingml/2006/main">
               <a:ext uri="{FF2B5EF4-FFF2-40B4-BE49-F238E27FC236}">
-                <a16:creationId xmlns:a16="http://schemas.microsoft.com/office/drawing/2014/main" id="{FE8313A0-DBD2-4D3C-8432-DB6839E176A8}"/>
+                <a16:creationId xmlns:a16="http://schemas.microsoft.com/office/drawing/2014/main" id="{7C63FBB0-FD02-4013-A128-D24B97FAA85B}"/>
               </a:ext>
             </a:extLst>
           </p:cNvPr>
@@ -5268,7 +5273,7 @@
           <p:cNvPr id="17" name="s4-o3b">
             <a:extLst xmlns:a="http://schemas.openxmlformats.org/drawingml/2006/main">
               <a:ext uri="{FF2B5EF4-FFF2-40B4-BE49-F238E27FC236}">
-                <a16:creationId xmlns:a16="http://schemas.microsoft.com/office/drawing/2014/main" id="{78569779-1F75-4CD9-992E-3A04F7664A3B}"/>
+                <a16:creationId xmlns:a16="http://schemas.microsoft.com/office/drawing/2014/main" id="{174A7B0C-D948-4F71-9367-164A398FB2B9}"/>
               </a:ext>
             </a:extLst>
           </p:cNvPr>
@@ -5313,7 +5318,7 @@
           <p:cNvPr id="18" name="s4-o4a">
             <a:extLst xmlns:a="http://schemas.openxmlformats.org/drawingml/2006/main">
               <a:ext uri="{FF2B5EF4-FFF2-40B4-BE49-F238E27FC236}">
-                <a16:creationId xmlns:a16="http://schemas.microsoft.com/office/drawing/2014/main" id="{5A134E6B-A5C0-4DDD-9529-0892C1365D9B}"/>
+                <a16:creationId xmlns:a16="http://schemas.microsoft.com/office/drawing/2014/main" id="{6AE3775C-738C-413E-9136-2502F8B11B51}"/>
               </a:ext>
             </a:extLst>
           </p:cNvPr>
@@ -5358,7 +5363,7 @@
           <p:cNvPr id="19" name="s4-o4b">
             <a:extLst xmlns:a="http://schemas.openxmlformats.org/drawingml/2006/main">
               <a:ext uri="{FF2B5EF4-FFF2-40B4-BE49-F238E27FC236}">
-                <a16:creationId xmlns:a16="http://schemas.microsoft.com/office/drawing/2014/main" id="{2DB88EB1-A797-4AEA-A6DA-91C3A2A6E5C2}"/>
+                <a16:creationId xmlns:a16="http://schemas.microsoft.com/office/drawing/2014/main" id="{75695E33-5176-479E-B4B9-FE1001AA7B83}"/>
               </a:ext>
             </a:extLst>
           </p:cNvPr>
@@ -5404,7 +5409,7 @@
           <p:cNvPr id="20" name="s4-o5a">
             <a:extLst xmlns:a="http://schemas.openxmlformats.org/drawingml/2006/main">
               <a:ext uri="{FF2B5EF4-FFF2-40B4-BE49-F238E27FC236}">
-                <a16:creationId xmlns:a16="http://schemas.microsoft.com/office/drawing/2014/main" id="{490F1FE3-EB67-4C8C-A5E6-170C395824C6}"/>
+                <a16:creationId xmlns:a16="http://schemas.microsoft.com/office/drawing/2014/main" id="{70530514-10EB-4369-BE2E-6D6ABE0C273F}"/>
               </a:ext>
             </a:extLst>
           </p:cNvPr>
@@ -5449,7 +5454,7 @@
           <p:cNvPr id="21" name="s4-o5b">
             <a:extLst xmlns:a="http://schemas.openxmlformats.org/drawingml/2006/main">
               <a:ext uri="{FF2B5EF4-FFF2-40B4-BE49-F238E27FC236}">
-                <a16:creationId xmlns:a16="http://schemas.microsoft.com/office/drawing/2014/main" id="{8C85233A-30D2-4019-B87A-045BB9910A17}"/>
+                <a16:creationId xmlns:a16="http://schemas.microsoft.com/office/drawing/2014/main" id="{1AB4CD06-0FF7-4127-BC5B-79E885B2C3AB}"/>
               </a:ext>
             </a:extLst>
           </p:cNvPr>
@@ -5494,7 +5499,7 @@
           <p:cNvPr id="22" name="s4-output-note">
             <a:extLst xmlns:a="http://schemas.openxmlformats.org/drawingml/2006/main">
               <a:ext uri="{FF2B5EF4-FFF2-40B4-BE49-F238E27FC236}">
-                <a16:creationId xmlns:a16="http://schemas.microsoft.com/office/drawing/2014/main" id="{F75EC3B4-5808-4810-8BF0-3B8BECDCD7AB}"/>
+                <a16:creationId xmlns:a16="http://schemas.microsoft.com/office/drawing/2014/main" id="{1FAC71B4-C94A-4FBA-94A6-E7E5C2E3C991}"/>
               </a:ext>
             </a:extLst>
           </p:cNvPr>
@@ -5561,7 +5566,7 @@
           <p:cNvPr id="24" name="footer-source-4">
             <a:extLst xmlns:a="http://schemas.openxmlformats.org/drawingml/2006/main">
               <a:ext uri="{FF2B5EF4-FFF2-40B4-BE49-F238E27FC236}">
-                <a16:creationId xmlns:a16="http://schemas.microsoft.com/office/drawing/2014/main" id="{0F0D8938-A89A-4493-9D6F-C0E839966556}"/>
+                <a16:creationId xmlns:a16="http://schemas.microsoft.com/office/drawing/2014/main" id="{F63D8B2C-3A87-4263-9A45-5C444E223E8A}"/>
               </a:ext>
             </a:extLst>
           </p:cNvPr>
@@ -5606,7 +5611,7 @@
           <p:cNvPr id="25" name="footer-number-4">
             <a:extLst xmlns:a="http://schemas.openxmlformats.org/drawingml/2006/main">
               <a:ext uri="{FF2B5EF4-FFF2-40B4-BE49-F238E27FC236}">
-                <a16:creationId xmlns:a16="http://schemas.microsoft.com/office/drawing/2014/main" id="{54A5B34E-C247-47E2-A958-1B925C4003D4}"/>
+                <a16:creationId xmlns:a16="http://schemas.microsoft.com/office/drawing/2014/main" id="{A9B14503-75BC-4257-BC86-E0D03F6C9783}"/>
               </a:ext>
             </a:extLst>
           </p:cNvPr>
@@ -5649,7 +5654,7 @@
     </p:spTree>
     <p:extLst>
       <p:ext uri="{BB962C8B-B14F-4D97-AF65-F5344CB8AC3E}">
-        <p14:creationId xmlns:p14="http://schemas.microsoft.com/office/powerpoint/2010/main" val="1252619973"/>
+        <p14:creationId xmlns:p14="http://schemas.microsoft.com/office/powerpoint/2010/main" val="611825970"/>
       </p:ext>
     </p:extLst>
   </p:cSld>
@@ -5680,7 +5685,7 @@
           <p:cNvPr id="17" name="s5-title">
             <a:extLst xmlns:a="http://schemas.openxmlformats.org/drawingml/2006/main">
               <a:ext uri="{FF2B5EF4-FFF2-40B4-BE49-F238E27FC236}">
-                <a16:creationId xmlns:a16="http://schemas.microsoft.com/office/drawing/2014/main" id="{D35F4426-6DDA-41A9-A765-9D36A49EDA8D}"/>
+                <a16:creationId xmlns:a16="http://schemas.microsoft.com/office/drawing/2014/main" id="{9960B5BD-357D-46AC-9292-A4FEF9254D35}"/>
               </a:ext>
             </a:extLst>
           </p:cNvPr>
@@ -5725,7 +5730,7 @@
           <p:cNvPr id="2" name="s5-subtitle">
             <a:extLst xmlns:a="http://schemas.openxmlformats.org/drawingml/2006/main">
               <a:ext uri="{FF2B5EF4-FFF2-40B4-BE49-F238E27FC236}">
-                <a16:creationId xmlns:a16="http://schemas.microsoft.com/office/drawing/2014/main" id="{5B81A1D7-33A5-403F-940A-AB9321BE373B}"/>
+                <a16:creationId xmlns:a16="http://schemas.microsoft.com/office/drawing/2014/main" id="{D4B1788C-1D9B-40A2-9F2B-5E4B3A8449E8}"/>
               </a:ext>
             </a:extLst>
           </p:cNvPr>
@@ -5770,7 +5775,7 @@
           <p:cNvPr id="3" name="s5-chart-label-pack">
             <a:extLst xmlns:a="http://schemas.openxmlformats.org/drawingml/2006/main">
               <a:ext uri="{FF2B5EF4-FFF2-40B4-BE49-F238E27FC236}">
-                <a16:creationId xmlns:a16="http://schemas.microsoft.com/office/drawing/2014/main" id="{15374AF6-392A-40A3-A784-6090F6E8572D}"/>
+                <a16:creationId xmlns:a16="http://schemas.microsoft.com/office/drawing/2014/main" id="{B302D2F5-7B48-496C-8A30-671D8C512E83}"/>
               </a:ext>
             </a:extLst>
           </p:cNvPr>
@@ -5815,7 +5820,7 @@
           <p:cNvPr id="4" name="s5-chart-label-repo">
             <a:extLst xmlns:a="http://schemas.openxmlformats.org/drawingml/2006/main">
               <a:ext uri="{FF2B5EF4-FFF2-40B4-BE49-F238E27FC236}">
-                <a16:creationId xmlns:a16="http://schemas.microsoft.com/office/drawing/2014/main" id="{857CE099-7D3C-4806-9B0E-A935E09ACE42}"/>
+                <a16:creationId xmlns:a16="http://schemas.microsoft.com/office/drawing/2014/main" id="{0873D7B7-95FB-41E8-A9FF-10CD59A40501}"/>
               </a:ext>
             </a:extLst>
           </p:cNvPr>
@@ -5860,7 +5865,7 @@
           <p:cNvPr id="5" name="s5-stat1">
             <a:extLst xmlns:a="http://schemas.openxmlformats.org/drawingml/2006/main">
               <a:ext uri="{FF2B5EF4-FFF2-40B4-BE49-F238E27FC236}">
-                <a16:creationId xmlns:a16="http://schemas.microsoft.com/office/drawing/2014/main" id="{510BE700-F9C1-4618-8AB5-E0F514AB8467}"/>
+                <a16:creationId xmlns:a16="http://schemas.microsoft.com/office/drawing/2014/main" id="{CFABFDA4-1947-4A45-9087-E5CA71C23EE6}"/>
               </a:ext>
             </a:extLst>
           </p:cNvPr>
@@ -5905,7 +5910,7 @@
           <p:cNvPr id="6" name="s5-stat1-label">
             <a:extLst xmlns:a="http://schemas.openxmlformats.org/drawingml/2006/main">
               <a:ext uri="{FF2B5EF4-FFF2-40B4-BE49-F238E27FC236}">
-                <a16:creationId xmlns:a16="http://schemas.microsoft.com/office/drawing/2014/main" id="{3C9856A0-5542-4072-8570-5336FE307974}"/>
+                <a16:creationId xmlns:a16="http://schemas.microsoft.com/office/drawing/2014/main" id="{89784536-19BF-4B39-9A6C-DB166297047B}"/>
               </a:ext>
             </a:extLst>
           </p:cNvPr>
@@ -5972,7 +5977,7 @@
           <p:cNvPr id="8" name="s5-stat2">
             <a:extLst xmlns:a="http://schemas.openxmlformats.org/drawingml/2006/main">
               <a:ext uri="{FF2B5EF4-FFF2-40B4-BE49-F238E27FC236}">
-                <a16:creationId xmlns:a16="http://schemas.microsoft.com/office/drawing/2014/main" id="{C3969D29-751F-465A-8D81-0ED66641AD20}"/>
+                <a16:creationId xmlns:a16="http://schemas.microsoft.com/office/drawing/2014/main" id="{6BF0995E-B27D-412A-85ED-C7385FE383EC}"/>
               </a:ext>
             </a:extLst>
           </p:cNvPr>
@@ -6017,7 +6022,7 @@
           <p:cNvPr id="9" name="s5-stat2-label">
             <a:extLst xmlns:a="http://schemas.openxmlformats.org/drawingml/2006/main">
               <a:ext uri="{FF2B5EF4-FFF2-40B4-BE49-F238E27FC236}">
-                <a16:creationId xmlns:a16="http://schemas.microsoft.com/office/drawing/2014/main" id="{8E5BB0A4-1645-4780-A8D1-3316715CF8C6}"/>
+                <a16:creationId xmlns:a16="http://schemas.microsoft.com/office/drawing/2014/main" id="{CDBE5ED7-B628-4456-A1F8-6E0A939C27CF}"/>
               </a:ext>
             </a:extLst>
           </p:cNvPr>
@@ -6062,7 +6067,7 @@
           <p:cNvPr id="10" name="s5-stat3">
             <a:extLst xmlns:a="http://schemas.openxmlformats.org/drawingml/2006/main">
               <a:ext uri="{FF2B5EF4-FFF2-40B4-BE49-F238E27FC236}">
-                <a16:creationId xmlns:a16="http://schemas.microsoft.com/office/drawing/2014/main" id="{41EAC7CB-18E0-40B8-83CB-EEC902F5B11A}"/>
+                <a16:creationId xmlns:a16="http://schemas.microsoft.com/office/drawing/2014/main" id="{B89465DC-908F-48F5-A652-8F0C3FF59B25}"/>
               </a:ext>
             </a:extLst>
           </p:cNvPr>
@@ -6107,7 +6112,7 @@
           <p:cNvPr id="11" name="s5-stat3-label">
             <a:extLst xmlns:a="http://schemas.openxmlformats.org/drawingml/2006/main">
               <a:ext uri="{FF2B5EF4-FFF2-40B4-BE49-F238E27FC236}">
-                <a16:creationId xmlns:a16="http://schemas.microsoft.com/office/drawing/2014/main" id="{8CACC0FA-D6CD-49C4-BC77-1D7FC51BF615}"/>
+                <a16:creationId xmlns:a16="http://schemas.microsoft.com/office/drawing/2014/main" id="{D387EA68-54E2-41A5-98F2-1033EC89CDD9}"/>
               </a:ext>
             </a:extLst>
           </p:cNvPr>
@@ -6152,7 +6157,7 @@
           <p:cNvPr id="12" name="s5-explain">
             <a:extLst xmlns:a="http://schemas.openxmlformats.org/drawingml/2006/main">
               <a:ext uri="{FF2B5EF4-FFF2-40B4-BE49-F238E27FC236}">
-                <a16:creationId xmlns:a16="http://schemas.microsoft.com/office/drawing/2014/main" id="{E537750A-8D2D-4833-B7C1-CC328B600570}"/>
+                <a16:creationId xmlns:a16="http://schemas.microsoft.com/office/drawing/2014/main" id="{DF8A17DB-F518-4892-B58A-892C81ACE86D}"/>
               </a:ext>
             </a:extLst>
           </p:cNvPr>
@@ -6219,7 +6224,7 @@
           <p:cNvPr id="14" name="footer-source-5">
             <a:extLst xmlns:a="http://schemas.openxmlformats.org/drawingml/2006/main">
               <a:ext uri="{FF2B5EF4-FFF2-40B4-BE49-F238E27FC236}">
-                <a16:creationId xmlns:a16="http://schemas.microsoft.com/office/drawing/2014/main" id="{9D323E44-8B38-4A30-8173-39057CAE28E7}"/>
+                <a16:creationId xmlns:a16="http://schemas.microsoft.com/office/drawing/2014/main" id="{1381C75E-9B0D-4D19-8364-9EFF93B73F6F}"/>
               </a:ext>
             </a:extLst>
           </p:cNvPr>
@@ -6264,7 +6269,7 @@
           <p:cNvPr id="15" name="footer-number-5">
             <a:extLst xmlns:a="http://schemas.openxmlformats.org/drawingml/2006/main">
               <a:ext uri="{FF2B5EF4-FFF2-40B4-BE49-F238E27FC236}">
-                <a16:creationId xmlns:a16="http://schemas.microsoft.com/office/drawing/2014/main" id="{C6D0FAFD-AA84-47FE-9BF1-D56BC4FE3AE5}"/>
+                <a16:creationId xmlns:a16="http://schemas.microsoft.com/office/drawing/2014/main" id="{98F320C5-9CE7-40CA-9357-4765D3222782}"/>
               </a:ext>
             </a:extLst>
           </p:cNvPr>
@@ -6316,14 +6321,14 @@
         </p:xfrm>
         <a:graphic xmlns:a="http://schemas.openxmlformats.org/drawingml/2006/main">
           <a:graphicData uri="http://schemas.openxmlformats.org/drawingml/2006/chart">
-            <c:chart xmlns:r="http://schemas.openxmlformats.org/officeDocument/2006/relationships" xmlns:c="http://schemas.openxmlformats.org/drawingml/2006/chart" r:id="Re4e83c61b9544540"/>
+            <c:chart xmlns:r="http://schemas.openxmlformats.org/officeDocument/2006/relationships" xmlns:c="http://schemas.openxmlformats.org/drawingml/2006/chart" r:id="R47ea2b50f6794f4e"/>
           </a:graphicData>
         </a:graphic>
       </p:graphicFrame>
     </p:spTree>
     <p:extLst>
       <p:ext uri="{BB962C8B-B14F-4D97-AF65-F5344CB8AC3E}">
-        <p14:creationId xmlns:p14="http://schemas.microsoft.com/office/powerpoint/2010/main" val="1396701938"/>
+        <p14:creationId xmlns:p14="http://schemas.microsoft.com/office/powerpoint/2010/main" val="1800457806"/>
       </p:ext>
     </p:extLst>
   </p:cSld>
@@ -6354,7 +6359,7 @@
           <p:cNvPr id="16" name="s6-title">
             <a:extLst xmlns:a="http://schemas.openxmlformats.org/drawingml/2006/main">
               <a:ext uri="{FF2B5EF4-FFF2-40B4-BE49-F238E27FC236}">
-                <a16:creationId xmlns:a16="http://schemas.microsoft.com/office/drawing/2014/main" id="{ACF77855-613B-41FD-8957-492B422DE8AC}"/>
+                <a16:creationId xmlns:a16="http://schemas.microsoft.com/office/drawing/2014/main" id="{0C2D433A-0A5F-4750-A545-B4BBADD062D5}"/>
               </a:ext>
             </a:extLst>
           </p:cNvPr>
@@ -6399,7 +6404,7 @@
           <p:cNvPr id="2" name="s6-subtitle">
             <a:extLst xmlns:a="http://schemas.openxmlformats.org/drawingml/2006/main">
               <a:ext uri="{FF2B5EF4-FFF2-40B4-BE49-F238E27FC236}">
-                <a16:creationId xmlns:a16="http://schemas.microsoft.com/office/drawing/2014/main" id="{E1CC9539-625A-42A9-B9E8-9D351A509BA6}"/>
+                <a16:creationId xmlns:a16="http://schemas.microsoft.com/office/drawing/2014/main" id="{EE4BFD3C-F413-4E75-8CA7-AEE80452EA2C}"/>
               </a:ext>
             </a:extLst>
           </p:cNvPr>
@@ -6444,7 +6449,7 @@
           <p:cNvPr id="3" name="s6-chart-label-control">
             <a:extLst xmlns:a="http://schemas.openxmlformats.org/drawingml/2006/main">
               <a:ext uri="{FF2B5EF4-FFF2-40B4-BE49-F238E27FC236}">
-                <a16:creationId xmlns:a16="http://schemas.microsoft.com/office/drawing/2014/main" id="{81658054-77FC-4B26-8910-8A2193215FB4}"/>
+                <a16:creationId xmlns:a16="http://schemas.microsoft.com/office/drawing/2014/main" id="{5466175F-C1E1-40DE-ACAC-C3FCC407F2AD}"/>
               </a:ext>
             </a:extLst>
           </p:cNvPr>
@@ -6489,7 +6494,7 @@
           <p:cNvPr id="4" name="s6-chart-label-full">
             <a:extLst xmlns:a="http://schemas.openxmlformats.org/drawingml/2006/main">
               <a:ext uri="{FF2B5EF4-FFF2-40B4-BE49-F238E27FC236}">
-                <a16:creationId xmlns:a16="http://schemas.microsoft.com/office/drawing/2014/main" id="{3ADDE3A8-8517-4EB9-AF42-D813F0E84717}"/>
+                <a16:creationId xmlns:a16="http://schemas.microsoft.com/office/drawing/2014/main" id="{DED135FB-2FD2-4960-98DF-81D70C0B7343}"/>
               </a:ext>
             </a:extLst>
           </p:cNvPr>
@@ -6534,7 +6539,7 @@
           <p:cNvPr id="5" name="s6-stat">
             <a:extLst xmlns:a="http://schemas.openxmlformats.org/drawingml/2006/main">
               <a:ext uri="{FF2B5EF4-FFF2-40B4-BE49-F238E27FC236}">
-                <a16:creationId xmlns:a16="http://schemas.microsoft.com/office/drawing/2014/main" id="{CDE68CE2-9F33-41A7-A9C6-C5F02DEA669A}"/>
+                <a16:creationId xmlns:a16="http://schemas.microsoft.com/office/drawing/2014/main" id="{768D07AB-4D1A-474B-95EF-569164FA9146}"/>
               </a:ext>
             </a:extLst>
           </p:cNvPr>
@@ -6579,7 +6584,7 @@
           <p:cNvPr id="6" name="s6-stat-label">
             <a:extLst xmlns:a="http://schemas.openxmlformats.org/drawingml/2006/main">
               <a:ext uri="{FF2B5EF4-FFF2-40B4-BE49-F238E27FC236}">
-                <a16:creationId xmlns:a16="http://schemas.microsoft.com/office/drawing/2014/main" id="{D817698C-7A3D-4405-9872-DF3F6885F2F9}"/>
+                <a16:creationId xmlns:a16="http://schemas.microsoft.com/office/drawing/2014/main" id="{CA80A2BD-C7B1-4FC9-ACE0-97F54DB43668}"/>
               </a:ext>
             </a:extLst>
           </p:cNvPr>
@@ -6647,7 +6652,7 @@
           <p:cNvPr id="8" name="s6-supported">
             <a:extLst xmlns:a="http://schemas.openxmlformats.org/drawingml/2006/main">
               <a:ext uri="{FF2B5EF4-FFF2-40B4-BE49-F238E27FC236}">
-                <a16:creationId xmlns:a16="http://schemas.microsoft.com/office/drawing/2014/main" id="{FE922A09-0B03-404E-91F1-E10E30097F27}"/>
+                <a16:creationId xmlns:a16="http://schemas.microsoft.com/office/drawing/2014/main" id="{D0A0DAFF-993E-4627-AFDA-3E7F1ED72EBE}"/>
               </a:ext>
             </a:extLst>
           </p:cNvPr>
@@ -6692,7 +6697,7 @@
           <p:cNvPr id="9" name="s6-supported-body">
             <a:extLst xmlns:a="http://schemas.openxmlformats.org/drawingml/2006/main">
               <a:ext uri="{FF2B5EF4-FFF2-40B4-BE49-F238E27FC236}">
-                <a16:creationId xmlns:a16="http://schemas.microsoft.com/office/drawing/2014/main" id="{3C177898-B0AF-4F83-89E4-C792BEEC6441}"/>
+                <a16:creationId xmlns:a16="http://schemas.microsoft.com/office/drawing/2014/main" id="{70FABB36-C603-47F5-B3B7-CC579B84336D}"/>
               </a:ext>
             </a:extLst>
           </p:cNvPr>
@@ -6737,7 +6742,7 @@
           <p:cNvPr id="10" name="s6-unsupported">
             <a:extLst xmlns:a="http://schemas.openxmlformats.org/drawingml/2006/main">
               <a:ext uri="{FF2B5EF4-FFF2-40B4-BE49-F238E27FC236}">
-                <a16:creationId xmlns:a16="http://schemas.microsoft.com/office/drawing/2014/main" id="{18324A18-340B-4EAB-BE12-C928503E5BE2}"/>
+                <a16:creationId xmlns:a16="http://schemas.microsoft.com/office/drawing/2014/main" id="{657E45F9-7E83-44B6-8BB0-27AE799FE80E}"/>
               </a:ext>
             </a:extLst>
           </p:cNvPr>
@@ -6782,7 +6787,7 @@
           <p:cNvPr id="11" name="s6-unsupported-body">
             <a:extLst xmlns:a="http://schemas.openxmlformats.org/drawingml/2006/main">
               <a:ext uri="{FF2B5EF4-FFF2-40B4-BE49-F238E27FC236}">
-                <a16:creationId xmlns:a16="http://schemas.microsoft.com/office/drawing/2014/main" id="{AD856CD7-9EE2-48D0-A902-79E56003B16D}"/>
+                <a16:creationId xmlns:a16="http://schemas.microsoft.com/office/drawing/2014/main" id="{3197535D-34AD-4118-A1DC-E0D9BB3954A3}"/>
               </a:ext>
             </a:extLst>
           </p:cNvPr>
@@ -6849,7 +6854,7 @@
           <p:cNvPr id="13" name="footer-source-6">
             <a:extLst xmlns:a="http://schemas.openxmlformats.org/drawingml/2006/main">
               <a:ext uri="{FF2B5EF4-FFF2-40B4-BE49-F238E27FC236}">
-                <a16:creationId xmlns:a16="http://schemas.microsoft.com/office/drawing/2014/main" id="{A1B22078-607D-47F4-86C5-E3A17323700A}"/>
+                <a16:creationId xmlns:a16="http://schemas.microsoft.com/office/drawing/2014/main" id="{73332EA1-1677-4881-8B67-C3684940470E}"/>
               </a:ext>
             </a:extLst>
           </p:cNvPr>
@@ -6894,7 +6899,7 @@
           <p:cNvPr id="14" name="footer-number-6">
             <a:extLst xmlns:a="http://schemas.openxmlformats.org/drawingml/2006/main">
               <a:ext uri="{FF2B5EF4-FFF2-40B4-BE49-F238E27FC236}">
-                <a16:creationId xmlns:a16="http://schemas.microsoft.com/office/drawing/2014/main" id="{592928E7-D616-4B17-9567-2EEE4D8564A4}"/>
+                <a16:creationId xmlns:a16="http://schemas.microsoft.com/office/drawing/2014/main" id="{6F2BDA4C-3ED2-43E4-8C63-9F21706169EE}"/>
               </a:ext>
             </a:extLst>
           </p:cNvPr>
@@ -6946,14 +6951,14 @@
         </p:xfrm>
         <a:graphic xmlns:a="http://schemas.openxmlformats.org/drawingml/2006/main">
           <a:graphicData uri="http://schemas.openxmlformats.org/drawingml/2006/chart">
-            <c:chart xmlns:r="http://schemas.openxmlformats.org/officeDocument/2006/relationships" xmlns:c="http://schemas.openxmlformats.org/drawingml/2006/chart" r:id="R8d5fdcea74d24596"/>
+            <c:chart xmlns:r="http://schemas.openxmlformats.org/officeDocument/2006/relationships" xmlns:c="http://schemas.openxmlformats.org/drawingml/2006/chart" r:id="R15084b7a54204e72"/>
           </a:graphicData>
         </a:graphic>
       </p:graphicFrame>
     </p:spTree>
     <p:extLst>
       <p:ext uri="{BB962C8B-B14F-4D97-AF65-F5344CB8AC3E}">
-        <p14:creationId xmlns:p14="http://schemas.microsoft.com/office/powerpoint/2010/main" val="333664532"/>
+        <p14:creationId xmlns:p14="http://schemas.microsoft.com/office/powerpoint/2010/main" val="2035459435"/>
       </p:ext>
     </p:extLst>
   </p:cSld>
@@ -6984,7 +6989,7 @@
           <p:cNvPr id="26" name="s7-title">
             <a:extLst xmlns:a="http://schemas.openxmlformats.org/drawingml/2006/main">
               <a:ext uri="{FF2B5EF4-FFF2-40B4-BE49-F238E27FC236}">
-                <a16:creationId xmlns:a16="http://schemas.microsoft.com/office/drawing/2014/main" id="{27FC7876-5211-4706-9520-259EF0DA52B1}"/>
+                <a16:creationId xmlns:a16="http://schemas.microsoft.com/office/drawing/2014/main" id="{62307740-79C4-45E5-B354-B214B79B46E9}"/>
               </a:ext>
             </a:extLst>
           </p:cNvPr>
@@ -7029,7 +7034,7 @@
           <p:cNvPr id="2" name="s7-subtitle">
             <a:extLst xmlns:a="http://schemas.openxmlformats.org/drawingml/2006/main">
               <a:ext uri="{FF2B5EF4-FFF2-40B4-BE49-F238E27FC236}">
-                <a16:creationId xmlns:a16="http://schemas.microsoft.com/office/drawing/2014/main" id="{FDC73038-17AD-412F-BFB6-FC86DBDA35B1}"/>
+                <a16:creationId xmlns:a16="http://schemas.microsoft.com/office/drawing/2014/main" id="{6BC49522-2AF5-485D-A1E4-5D5DC0DB3369}"/>
               </a:ext>
             </a:extLst>
           </p:cNvPr>
@@ -7162,7 +7167,7 @@
           <p:cNvPr id="7" name="s7-card1">
             <a:extLst xmlns:a="http://schemas.openxmlformats.org/drawingml/2006/main">
               <a:ext uri="{FF2B5EF4-FFF2-40B4-BE49-F238E27FC236}">
-                <a16:creationId xmlns:a16="http://schemas.microsoft.com/office/drawing/2014/main" id="{80B10633-CC49-4528-951B-FAC4295D2A7E}"/>
+                <a16:creationId xmlns:a16="http://schemas.microsoft.com/office/drawing/2014/main" id="{7D7C20F4-85BD-450E-B486-4D4FF9169430}"/>
               </a:ext>
             </a:extLst>
           </p:cNvPr>
@@ -7197,7 +7202,7 @@
           <p:cNvPr id="8" name="s7-card2">
             <a:extLst xmlns:a="http://schemas.openxmlformats.org/drawingml/2006/main">
               <a:ext uri="{FF2B5EF4-FFF2-40B4-BE49-F238E27FC236}">
-                <a16:creationId xmlns:a16="http://schemas.microsoft.com/office/drawing/2014/main" id="{BB708C9D-ADCA-4DAD-B976-2ED33C172687}"/>
+                <a16:creationId xmlns:a16="http://schemas.microsoft.com/office/drawing/2014/main" id="{1CF1ADA0-1C81-4FFC-8E1D-A5B7BFE53FBA}"/>
               </a:ext>
             </a:extLst>
           </p:cNvPr>
@@ -7232,7 +7237,7 @@
           <p:cNvPr id="9" name="s7-card3">
             <a:extLst xmlns:a="http://schemas.openxmlformats.org/drawingml/2006/main">
               <a:ext uri="{FF2B5EF4-FFF2-40B4-BE49-F238E27FC236}">
-                <a16:creationId xmlns:a16="http://schemas.microsoft.com/office/drawing/2014/main" id="{1D3EBFCE-B074-4FE8-A1C1-38BFECEC9269}"/>
+                <a16:creationId xmlns:a16="http://schemas.microsoft.com/office/drawing/2014/main" id="{EC2E9828-528B-4CC5-ABDA-345FCA599887}"/>
               </a:ext>
             </a:extLst>
           </p:cNvPr>
@@ -7267,7 +7272,7 @@
           <p:cNvPr id="10" name="s7-dot1">
             <a:extLst xmlns:a="http://schemas.openxmlformats.org/drawingml/2006/main">
               <a:ext uri="{FF2B5EF4-FFF2-40B4-BE49-F238E27FC236}">
-                <a16:creationId xmlns:a16="http://schemas.microsoft.com/office/drawing/2014/main" id="{D39059FC-DD61-41DB-9F5C-D940E87DADE9}"/>
+                <a16:creationId xmlns:a16="http://schemas.microsoft.com/office/drawing/2014/main" id="{DB69A42A-1C50-434E-8916-B18955905E3E}"/>
               </a:ext>
             </a:extLst>
           </p:cNvPr>
@@ -7300,7 +7305,7 @@
           <p:cNvPr id="11" name="s7-dot2">
             <a:extLst xmlns:a="http://schemas.openxmlformats.org/drawingml/2006/main">
               <a:ext uri="{FF2B5EF4-FFF2-40B4-BE49-F238E27FC236}">
-                <a16:creationId xmlns:a16="http://schemas.microsoft.com/office/drawing/2014/main" id="{6B251CA2-EDBD-4997-B4C7-A2333B4646A3}"/>
+                <a16:creationId xmlns:a16="http://schemas.microsoft.com/office/drawing/2014/main" id="{099A993C-DB73-478B-8AA3-5359D13359B6}"/>
               </a:ext>
             </a:extLst>
           </p:cNvPr>
@@ -7333,7 +7338,7 @@
           <p:cNvPr id="12" name="s7-dot3">
             <a:extLst xmlns:a="http://schemas.openxmlformats.org/drawingml/2006/main">
               <a:ext uri="{FF2B5EF4-FFF2-40B4-BE49-F238E27FC236}">
-                <a16:creationId xmlns:a16="http://schemas.microsoft.com/office/drawing/2014/main" id="{40ABDC04-DA54-4AA2-A42E-FFA11751101E}"/>
+                <a16:creationId xmlns:a16="http://schemas.microsoft.com/office/drawing/2014/main" id="{0FF17C76-E67E-40BD-8193-C19D1F53174F}"/>
               </a:ext>
             </a:extLst>
           </p:cNvPr>
@@ -7366,7 +7371,7 @@
           <p:cNvPr id="13" name="s7-k1">
             <a:extLst xmlns:a="http://schemas.openxmlformats.org/drawingml/2006/main">
               <a:ext uri="{FF2B5EF4-FFF2-40B4-BE49-F238E27FC236}">
-                <a16:creationId xmlns:a16="http://schemas.microsoft.com/office/drawing/2014/main" id="{A80966A8-8666-43C8-B9C8-416F1C1B3994}"/>
+                <a16:creationId xmlns:a16="http://schemas.microsoft.com/office/drawing/2014/main" id="{E003B36B-D895-4A69-AF86-E865C0F65527}"/>
               </a:ext>
             </a:extLst>
           </p:cNvPr>
@@ -7411,7 +7416,7 @@
           <p:cNvPr id="14" name="s7-b1">
             <a:extLst xmlns:a="http://schemas.openxmlformats.org/drawingml/2006/main">
               <a:ext uri="{FF2B5EF4-FFF2-40B4-BE49-F238E27FC236}">
-                <a16:creationId xmlns:a16="http://schemas.microsoft.com/office/drawing/2014/main" id="{EC746CCD-3B0C-4E8E-A60F-20FB8D55F3EC}"/>
+                <a16:creationId xmlns:a16="http://schemas.microsoft.com/office/drawing/2014/main" id="{1F0365B3-BFDD-4DC1-BCFC-1F3FB89260A1}"/>
               </a:ext>
             </a:extLst>
           </p:cNvPr>
@@ -7456,7 +7461,7 @@
           <p:cNvPr id="15" name="s7-v1">
             <a:extLst xmlns:a="http://schemas.openxmlformats.org/drawingml/2006/main">
               <a:ext uri="{FF2B5EF4-FFF2-40B4-BE49-F238E27FC236}">
-                <a16:creationId xmlns:a16="http://schemas.microsoft.com/office/drawing/2014/main" id="{31733DC4-9C55-49BC-BC79-25517120BD9A}"/>
+                <a16:creationId xmlns:a16="http://schemas.microsoft.com/office/drawing/2014/main" id="{FBE9EF65-4136-486E-BE12-E0468B1EF79D}"/>
               </a:ext>
             </a:extLst>
           </p:cNvPr>
@@ -7501,7 +7506,7 @@
           <p:cNvPr id="16" name="s7-k2">
             <a:extLst xmlns:a="http://schemas.openxmlformats.org/drawingml/2006/main">
               <a:ext uri="{FF2B5EF4-FFF2-40B4-BE49-F238E27FC236}">
-                <a16:creationId xmlns:a16="http://schemas.microsoft.com/office/drawing/2014/main" id="{0B325EC1-46EC-40BD-9791-635E24C4B102}"/>
+                <a16:creationId xmlns:a16="http://schemas.microsoft.com/office/drawing/2014/main" id="{20E20B9E-D1DD-4ECD-AE19-C63C11984AD3}"/>
               </a:ext>
             </a:extLst>
           </p:cNvPr>
@@ -7546,7 +7551,7 @@
           <p:cNvPr id="17" name="s7-b2">
             <a:extLst xmlns:a="http://schemas.openxmlformats.org/drawingml/2006/main">
               <a:ext uri="{FF2B5EF4-FFF2-40B4-BE49-F238E27FC236}">
-                <a16:creationId xmlns:a16="http://schemas.microsoft.com/office/drawing/2014/main" id="{D008F08F-E162-455C-A1D4-1C984901159C}"/>
+                <a16:creationId xmlns:a16="http://schemas.microsoft.com/office/drawing/2014/main" id="{576DBC82-DCA6-4348-9207-B83374DA9CAB}"/>
               </a:ext>
             </a:extLst>
           </p:cNvPr>
@@ -7591,7 +7596,7 @@
           <p:cNvPr id="18" name="s7-v2">
             <a:extLst xmlns:a="http://schemas.openxmlformats.org/drawingml/2006/main">
               <a:ext uri="{FF2B5EF4-FFF2-40B4-BE49-F238E27FC236}">
-                <a16:creationId xmlns:a16="http://schemas.microsoft.com/office/drawing/2014/main" id="{69E6F07F-7221-4FA9-9EA4-6296F4F83CBC}"/>
+                <a16:creationId xmlns:a16="http://schemas.microsoft.com/office/drawing/2014/main" id="{66E86001-6B3D-40E3-9828-1C9CF27D291F}"/>
               </a:ext>
             </a:extLst>
           </p:cNvPr>
@@ -7636,7 +7641,7 @@
           <p:cNvPr id="19" name="s7-k3">
             <a:extLst xmlns:a="http://schemas.openxmlformats.org/drawingml/2006/main">
               <a:ext uri="{FF2B5EF4-FFF2-40B4-BE49-F238E27FC236}">
-                <a16:creationId xmlns:a16="http://schemas.microsoft.com/office/drawing/2014/main" id="{98A41F99-3E19-4ED7-A94E-5CC6CFD5160C}"/>
+                <a16:creationId xmlns:a16="http://schemas.microsoft.com/office/drawing/2014/main" id="{8F05AB0E-788D-4EED-9BAB-B94073A87D10}"/>
               </a:ext>
             </a:extLst>
           </p:cNvPr>
@@ -7681,7 +7686,7 @@
           <p:cNvPr id="20" name="s7-b3">
             <a:extLst xmlns:a="http://schemas.openxmlformats.org/drawingml/2006/main">
               <a:ext uri="{FF2B5EF4-FFF2-40B4-BE49-F238E27FC236}">
-                <a16:creationId xmlns:a16="http://schemas.microsoft.com/office/drawing/2014/main" id="{69BEFD4D-B40C-4EB6-B114-6450069E145D}"/>
+                <a16:creationId xmlns:a16="http://schemas.microsoft.com/office/drawing/2014/main" id="{605B9B9E-C4D1-4650-AFB3-77F2F043CF61}"/>
               </a:ext>
             </a:extLst>
           </p:cNvPr>
@@ -7726,7 +7731,7 @@
           <p:cNvPr id="21" name="s7-v3">
             <a:extLst xmlns:a="http://schemas.openxmlformats.org/drawingml/2006/main">
               <a:ext uri="{FF2B5EF4-FFF2-40B4-BE49-F238E27FC236}">
-                <a16:creationId xmlns:a16="http://schemas.microsoft.com/office/drawing/2014/main" id="{A792DA74-DA87-40C2-AD7A-AF4972DA80D6}"/>
+                <a16:creationId xmlns:a16="http://schemas.microsoft.com/office/drawing/2014/main" id="{D63B3F2D-1A06-4909-9C0E-B0D6FFAAFEE5}"/>
               </a:ext>
             </a:extLst>
           </p:cNvPr>
@@ -7771,7 +7776,7 @@
           <p:cNvPr id="22" name="s7-human">
             <a:extLst xmlns:a="http://schemas.openxmlformats.org/drawingml/2006/main">
               <a:ext uri="{FF2B5EF4-FFF2-40B4-BE49-F238E27FC236}">
-                <a16:creationId xmlns:a16="http://schemas.microsoft.com/office/drawing/2014/main" id="{A39BF957-E6BC-4853-AE03-0D7466923FDF}"/>
+                <a16:creationId xmlns:a16="http://schemas.microsoft.com/office/drawing/2014/main" id="{F3EC9779-C014-4A0D-8FD0-E6E2FABEBCA6}"/>
               </a:ext>
             </a:extLst>
           </p:cNvPr>
@@ -7838,7 +7843,7 @@
           <p:cNvPr id="24" name="footer-source-7">
             <a:extLst xmlns:a="http://schemas.openxmlformats.org/drawingml/2006/main">
               <a:ext uri="{FF2B5EF4-FFF2-40B4-BE49-F238E27FC236}">
-                <a16:creationId xmlns:a16="http://schemas.microsoft.com/office/drawing/2014/main" id="{F3490E14-E7CD-4B1B-8F16-4FBBF4AA0D29}"/>
+                <a16:creationId xmlns:a16="http://schemas.microsoft.com/office/drawing/2014/main" id="{DB55EB28-2BFD-4C16-8A1D-162669AB4496}"/>
               </a:ext>
             </a:extLst>
           </p:cNvPr>
@@ -7883,7 +7888,7 @@
           <p:cNvPr id="25" name="footer-number-7">
             <a:extLst xmlns:a="http://schemas.openxmlformats.org/drawingml/2006/main">
               <a:ext uri="{FF2B5EF4-FFF2-40B4-BE49-F238E27FC236}">
-                <a16:creationId xmlns:a16="http://schemas.microsoft.com/office/drawing/2014/main" id="{1508B504-CD81-4E39-A825-38D6D6C9B325}"/>
+                <a16:creationId xmlns:a16="http://schemas.microsoft.com/office/drawing/2014/main" id="{FEC4E551-9CD6-4DCF-A25E-83D7096000EB}"/>
               </a:ext>
             </a:extLst>
           </p:cNvPr>
@@ -7926,7 +7931,7 @@
     </p:spTree>
     <p:extLst>
       <p:ext uri="{BB962C8B-B14F-4D97-AF65-F5344CB8AC3E}">
-        <p14:creationId xmlns:p14="http://schemas.microsoft.com/office/powerpoint/2010/main" val="283734944"/>
+        <p14:creationId xmlns:p14="http://schemas.microsoft.com/office/powerpoint/2010/main" val="2144432346"/>
       </p:ext>
     </p:extLst>
   </p:cSld>
@@ -7957,7 +7962,7 @@
           <p:cNvPr id="19" name="s8-eyebrow">
             <a:extLst xmlns:a="http://schemas.openxmlformats.org/drawingml/2006/main">
               <a:ext uri="{FF2B5EF4-FFF2-40B4-BE49-F238E27FC236}">
-                <a16:creationId xmlns:a16="http://schemas.microsoft.com/office/drawing/2014/main" id="{E65E9B11-4AAA-4A35-9E53-B9898B75F6CB}"/>
+                <a16:creationId xmlns:a16="http://schemas.microsoft.com/office/drawing/2014/main" id="{D7A16CD0-B306-4ACB-AE6E-0629C612EE67}"/>
               </a:ext>
             </a:extLst>
           </p:cNvPr>
@@ -8002,7 +8007,7 @@
           <p:cNvPr id="2" name="s8-title">
             <a:extLst xmlns:a="http://schemas.openxmlformats.org/drawingml/2006/main">
               <a:ext uri="{FF2B5EF4-FFF2-40B4-BE49-F238E27FC236}">
-                <a16:creationId xmlns:a16="http://schemas.microsoft.com/office/drawing/2014/main" id="{25BCDD51-7836-4F24-87C2-AC7EEF0EA503}"/>
+                <a16:creationId xmlns:a16="http://schemas.microsoft.com/office/drawing/2014/main" id="{ABBA4495-E05B-46A6-B02F-D61846528968}"/>
               </a:ext>
             </a:extLst>
           </p:cNvPr>
@@ -8071,7 +8076,7 @@
           <p:cNvPr id="4" name="s8-close">
             <a:extLst xmlns:a="http://schemas.openxmlformats.org/drawingml/2006/main">
               <a:ext uri="{FF2B5EF4-FFF2-40B4-BE49-F238E27FC236}">
-                <a16:creationId xmlns:a16="http://schemas.microsoft.com/office/drawing/2014/main" id="{3DA98D3F-6812-446D-A866-C0E86E67A4A2}"/>
+                <a16:creationId xmlns:a16="http://schemas.microsoft.com/office/drawing/2014/main" id="{74B32A34-E346-4563-8FB7-E78BCEB67710}"/>
               </a:ext>
             </a:extLst>
           </p:cNvPr>
@@ -8116,7 +8121,7 @@
           <p:cNvPr id="5" name="s8-command-box">
             <a:extLst xmlns:a="http://schemas.openxmlformats.org/drawingml/2006/main">
               <a:ext uri="{FF2B5EF4-FFF2-40B4-BE49-F238E27FC236}">
-                <a16:creationId xmlns:a16="http://schemas.microsoft.com/office/drawing/2014/main" id="{6F30E500-4C89-414A-8B10-A80AA3A3B02C}"/>
+                <a16:creationId xmlns:a16="http://schemas.microsoft.com/office/drawing/2014/main" id="{8939BC3B-C64F-4496-8C4E-469BA1F49407}"/>
               </a:ext>
             </a:extLst>
           </p:cNvPr>
@@ -8151,7 +8156,7 @@
           <p:cNvPr id="6" name="s8-command">
             <a:extLst xmlns:a="http://schemas.openxmlformats.org/drawingml/2006/main">
               <a:ext uri="{FF2B5EF4-FFF2-40B4-BE49-F238E27FC236}">
-                <a16:creationId xmlns:a16="http://schemas.microsoft.com/office/drawing/2014/main" id="{54E3D959-D7D2-4F52-BF13-7DD089E98585}"/>
+                <a16:creationId xmlns:a16="http://schemas.microsoft.com/office/drawing/2014/main" id="{2741DBFD-99D2-4EEA-867E-7CC67701E272}"/>
               </a:ext>
             </a:extLst>
           </p:cNvPr>
@@ -8197,7 +8202,7 @@
           <p:cNvPr id="7" name="s8-github">
             <a:extLst xmlns:a="http://schemas.openxmlformats.org/drawingml/2006/main">
               <a:ext uri="{FF2B5EF4-FFF2-40B4-BE49-F238E27FC236}">
-                <a16:creationId xmlns:a16="http://schemas.microsoft.com/office/drawing/2014/main" id="{9D581FBD-7225-4AA5-84C1-813C8E3EF574}"/>
+                <a16:creationId xmlns:a16="http://schemas.microsoft.com/office/drawing/2014/main" id="{BFE149C0-BDB7-4F64-AD11-15F053E4D2CF}"/>
               </a:ext>
             </a:extLst>
           </p:cNvPr>
@@ -8242,7 +8247,7 @@
           <p:cNvPr id="8" name="s8-npm">
             <a:extLst xmlns:a="http://schemas.openxmlformats.org/drawingml/2006/main">
               <a:ext uri="{FF2B5EF4-FFF2-40B4-BE49-F238E27FC236}">
-                <a16:creationId xmlns:a16="http://schemas.microsoft.com/office/drawing/2014/main" id="{D060CE72-FBE5-4677-9DC7-211735AAB2DF}"/>
+                <a16:creationId xmlns:a16="http://schemas.microsoft.com/office/drawing/2014/main" id="{F7F6D1C7-5851-4975-90C6-4D666912BA74}"/>
               </a:ext>
             </a:extLst>
           </p:cNvPr>
@@ -8287,7 +8292,7 @@
           <p:cNvPr id="9" name="s8-d1">
             <a:extLst xmlns:a="http://schemas.openxmlformats.org/drawingml/2006/main">
               <a:ext uri="{FF2B5EF4-FFF2-40B4-BE49-F238E27FC236}">
-                <a16:creationId xmlns:a16="http://schemas.microsoft.com/office/drawing/2014/main" id="{D46123D2-78D2-404D-BE78-BE31FD1B5357}"/>
+                <a16:creationId xmlns:a16="http://schemas.microsoft.com/office/drawing/2014/main" id="{91DDB8B8-A07A-4FC4-8CAD-37D30C3B7F67}"/>
               </a:ext>
             </a:extLst>
           </p:cNvPr>
@@ -8320,7 +8325,7 @@
           <p:cNvPr id="10" name="s8-l1">
             <a:extLst xmlns:a="http://schemas.openxmlformats.org/drawingml/2006/main">
               <a:ext uri="{FF2B5EF4-FFF2-40B4-BE49-F238E27FC236}">
-                <a16:creationId xmlns:a16="http://schemas.microsoft.com/office/drawing/2014/main" id="{6CD18A7C-A265-44FB-B991-E39D4459B52C}"/>
+                <a16:creationId xmlns:a16="http://schemas.microsoft.com/office/drawing/2014/main" id="{C4805384-80DD-439A-9F3B-748EBDBA746A}"/>
               </a:ext>
             </a:extLst>
           </p:cNvPr>
@@ -8365,7 +8370,7 @@
           <p:cNvPr id="11" name="s8-d2">
             <a:extLst xmlns:a="http://schemas.openxmlformats.org/drawingml/2006/main">
               <a:ext uri="{FF2B5EF4-FFF2-40B4-BE49-F238E27FC236}">
-                <a16:creationId xmlns:a16="http://schemas.microsoft.com/office/drawing/2014/main" id="{246562C9-B70A-42CB-B2DC-7DBED1CD1E97}"/>
+                <a16:creationId xmlns:a16="http://schemas.microsoft.com/office/drawing/2014/main" id="{7A57D747-4406-4A9B-899E-213958211E91}"/>
               </a:ext>
             </a:extLst>
           </p:cNvPr>
@@ -8398,7 +8403,7 @@
           <p:cNvPr id="12" name="s8-l2">
             <a:extLst xmlns:a="http://schemas.openxmlformats.org/drawingml/2006/main">
               <a:ext uri="{FF2B5EF4-FFF2-40B4-BE49-F238E27FC236}">
-                <a16:creationId xmlns:a16="http://schemas.microsoft.com/office/drawing/2014/main" id="{FE49A203-DE64-47A4-8F4C-9228D59E082B}"/>
+                <a16:creationId xmlns:a16="http://schemas.microsoft.com/office/drawing/2014/main" id="{6C2106C5-A204-4920-8066-806344907E14}"/>
               </a:ext>
             </a:extLst>
           </p:cNvPr>
@@ -8443,7 +8448,7 @@
           <p:cNvPr id="13" name="s8-d3">
             <a:extLst xmlns:a="http://schemas.openxmlformats.org/drawingml/2006/main">
               <a:ext uri="{FF2B5EF4-FFF2-40B4-BE49-F238E27FC236}">
-                <a16:creationId xmlns:a16="http://schemas.microsoft.com/office/drawing/2014/main" id="{FC0ED1D1-CC2C-48B0-93E0-8B658E3B9333}"/>
+                <a16:creationId xmlns:a16="http://schemas.microsoft.com/office/drawing/2014/main" id="{EA0B3F80-C9A0-4924-A30A-361F11D6AEDE}"/>
               </a:ext>
             </a:extLst>
           </p:cNvPr>
@@ -8476,7 +8481,7 @@
           <p:cNvPr id="14" name="s8-l3">
             <a:extLst xmlns:a="http://schemas.openxmlformats.org/drawingml/2006/main">
               <a:ext uri="{FF2B5EF4-FFF2-40B4-BE49-F238E27FC236}">
-                <a16:creationId xmlns:a16="http://schemas.microsoft.com/office/drawing/2014/main" id="{2919F2EF-2478-48DE-9EDB-92828A09622C}"/>
+                <a16:creationId xmlns:a16="http://schemas.microsoft.com/office/drawing/2014/main" id="{7EEF8C95-F7D6-4C9C-A2C6-AAD268664D3C}"/>
               </a:ext>
             </a:extLst>
           </p:cNvPr>
@@ -8521,7 +8526,7 @@
           <p:cNvPr id="15" name="s8-platforms">
             <a:extLst xmlns:a="http://schemas.openxmlformats.org/drawingml/2006/main">
               <a:ext uri="{FF2B5EF4-FFF2-40B4-BE49-F238E27FC236}">
-                <a16:creationId xmlns:a16="http://schemas.microsoft.com/office/drawing/2014/main" id="{2E5456D7-0A3C-4095-B1DE-CBD341D50F21}"/>
+                <a16:creationId xmlns:a16="http://schemas.microsoft.com/office/drawing/2014/main" id="{7DAD2529-C304-4C68-A7AE-81A7C31E709B}"/>
               </a:ext>
             </a:extLst>
           </p:cNvPr>
@@ -8588,7 +8593,7 @@
           <p:cNvPr id="17" name="footer-source-8">
             <a:extLst xmlns:a="http://schemas.openxmlformats.org/drawingml/2006/main">
               <a:ext uri="{FF2B5EF4-FFF2-40B4-BE49-F238E27FC236}">
-                <a16:creationId xmlns:a16="http://schemas.microsoft.com/office/drawing/2014/main" id="{763819D6-142E-4027-9992-42159980982E}"/>
+                <a16:creationId xmlns:a16="http://schemas.microsoft.com/office/drawing/2014/main" id="{7B79A44B-BBE1-49AD-98B9-18B5D3499FCF}"/>
               </a:ext>
             </a:extLst>
           </p:cNvPr>
@@ -8633,7 +8638,7 @@
           <p:cNvPr id="18" name="footer-number-8">
             <a:extLst xmlns:a="http://schemas.openxmlformats.org/drawingml/2006/main">
               <a:ext uri="{FF2B5EF4-FFF2-40B4-BE49-F238E27FC236}">
-                <a16:creationId xmlns:a16="http://schemas.microsoft.com/office/drawing/2014/main" id="{6529AE35-2D0E-403F-B31D-7FD915E3586B}"/>
+                <a16:creationId xmlns:a16="http://schemas.microsoft.com/office/drawing/2014/main" id="{06D2C7E8-428D-49E7-BE60-DD3EECA2C140}"/>
               </a:ext>
             </a:extLst>
           </p:cNvPr>
@@ -8676,7 +8681,7 @@
     </p:spTree>
     <p:extLst>
       <p:ext uri="{BB962C8B-B14F-4D97-AF65-F5344CB8AC3E}">
-        <p14:creationId xmlns:p14="http://schemas.microsoft.com/office/powerpoint/2010/main" val="2134665719"/>
+        <p14:creationId xmlns:p14="http://schemas.microsoft.com/office/powerpoint/2010/main" val="1784538584"/>
       </p:ext>
     </p:extLst>
   </p:cSld>

</xml_diff>

<commit_message>
docs: define spatial coordinate model
</commit_message>
<xml_diff>
--- a/outputs/vertex-palace-build-week-demo.pptx
+++ b/outputs/vertex-palace-build-week-demo.pptx
@@ -2,20 +2,20 @@
 <file path=ppt/presentation.xml><?xml version="1.0" encoding="utf-8"?>
 <p:presentation xmlns:p="http://schemas.openxmlformats.org/presentationml/2006/main">
   <p:sldMasterIdLst>
-    <p:sldMasterId xmlns:r="http://schemas.openxmlformats.org/officeDocument/2006/relationships" id="2147483648" r:id="R2abdefaf395e490e"/>
+    <p:sldMasterId xmlns:r="http://schemas.openxmlformats.org/officeDocument/2006/relationships" id="2147483648" r:id="R3f463e87c024421e"/>
   </p:sldMasterIdLst>
   <p:notesMasterIdLst>
-    <p:notesMasterId xmlns:r="http://schemas.openxmlformats.org/officeDocument/2006/relationships" r:id="Rc34b74eb9f5142bc"/>
+    <p:notesMasterId xmlns:r="http://schemas.openxmlformats.org/officeDocument/2006/relationships" r:id="R4de69a31150e49a2"/>
   </p:notesMasterIdLst>
   <p:sldIdLst>
-    <p:sldId xmlns:r="http://schemas.openxmlformats.org/officeDocument/2006/relationships" id="256" r:id="R39f7a98369034cca"/>
-    <p:sldId xmlns:r="http://schemas.openxmlformats.org/officeDocument/2006/relationships" id="257" r:id="R8b76a65345ab4a79"/>
-    <p:sldId xmlns:r="http://schemas.openxmlformats.org/officeDocument/2006/relationships" id="258" r:id="R4a9d51c5d6d2426f"/>
-    <p:sldId xmlns:r="http://schemas.openxmlformats.org/officeDocument/2006/relationships" id="259" r:id="R9d509893f2314f34"/>
-    <p:sldId xmlns:r="http://schemas.openxmlformats.org/officeDocument/2006/relationships" id="260" r:id="Ree36d4941d4348ac"/>
-    <p:sldId xmlns:r="http://schemas.openxmlformats.org/officeDocument/2006/relationships" id="261" r:id="R46364cad20e14537"/>
-    <p:sldId xmlns:r="http://schemas.openxmlformats.org/officeDocument/2006/relationships" id="262" r:id="R954f177c827342ca"/>
-    <p:sldId xmlns:r="http://schemas.openxmlformats.org/officeDocument/2006/relationships" id="263" r:id="R88ca8e012d334404"/>
+    <p:sldId xmlns:r="http://schemas.openxmlformats.org/officeDocument/2006/relationships" id="256" r:id="R7f3627edb4d242b2"/>
+    <p:sldId xmlns:r="http://schemas.openxmlformats.org/officeDocument/2006/relationships" id="257" r:id="R5f826e2058554739"/>
+    <p:sldId xmlns:r="http://schemas.openxmlformats.org/officeDocument/2006/relationships" id="258" r:id="R2e5e818dfe134e6c"/>
+    <p:sldId xmlns:r="http://schemas.openxmlformats.org/officeDocument/2006/relationships" id="259" r:id="R0a6761302045405c"/>
+    <p:sldId xmlns:r="http://schemas.openxmlformats.org/officeDocument/2006/relationships" id="260" r:id="Rbe7db10c67f042cf"/>
+    <p:sldId xmlns:r="http://schemas.openxmlformats.org/officeDocument/2006/relationships" id="261" r:id="R52708aea921d4872"/>
+    <p:sldId xmlns:r="http://schemas.openxmlformats.org/officeDocument/2006/relationships" id="262" r:id="Refedc8ec5cb14507"/>
+    <p:sldId xmlns:r="http://schemas.openxmlformats.org/officeDocument/2006/relationships" id="263" r:id="Raec27861df8a4f93"/>
   </p:sldIdLst>
   <p:sldSz cx="12192000" cy="6858000"/>
   <p:notesSz cx="6858000" cy="9144000"/>
@@ -694,22 +694,22 @@
           <a:lstStyle xmlns:a="http://schemas.openxmlformats.org/drawingml/2006/main"/>
           <a:p xmlns:a="http://schemas.openxmlformats.org/drawingml/2006/main">
             <a:r>
-              <a:t>The original idea began with a spatial question: could a flat, two-dimensional repository tree become a three-dimensional place? A building became the natural model, with domains as floors, features as rooms, and files and symbols as cabinets and drawers.</a:t>
-            </a:r>
-          </a:p>
-          <a:p xmlns:a="http://schemas.openxmlformats.org/drawingml/2006/main">
-            <a:r>
-              <a:t>The connection to the human memory-palace technique came next. Once the repository had places, a task could follow a route through them and relevant past mistakes could wait at the entrance.</a:t>
-            </a:r>
-          </a:p>
-          <a:p xmlns:a="http://schemas.openxmlformats.org/drawingml/2006/main">
-            <a:r>
-              <a:t>Walk left to right: index the repository structure, select an adaptive mode, pack only primary and supporting context, execute the task, then preserve relevant decisions and pitfalls at the entrance for the next task.</a:t>
-            </a:r>
-          </a:p>
-          <a:p xmlns:a="http://schemas.openxmlformats.org/drawingml/2006/main">
-            <a:r>
-              <a:t>Emphasize that current code and tests outrank memory. The memory layer is a guardrail, not a source of truth.</a:t>
+              <a:t>The 2D-to-3D idea only becomes useful when each axis has a stable meaning. X is the horizontal functional area or module, such as auth, checkout, or blog.</a:t>
+            </a:r>
+          </a:p>
+          <a:p xmlns:a="http://schemas.openxmlformats.org/drawingml/2006/main">
+            <a:r>
+              <a:t>Y is the vertical architectural floor, such as interface, implementation, data, verification, or runtime. Z is inspection depth: room overview, file cabinet, symbol drawer, then the smallest useful snippet.</a:t>
+            </a:r>
+          </a:p>
+          <a:p xmlns:a="http://schemas.openxmlformats.org/drawingml/2006/main">
+            <a:r>
+              <a:t>For example, checkout / implementation / shippingQuote() is one address. A task route is a path between addresses; memory, evidence, confidence, and the Pitfall Board attach to places instead of becoming extra axes.</a:t>
+            </a:r>
+          </a:p>
+          <a:p xmlns:a="http://schemas.openxmlformats.org/drawingml/2006/main">
+            <a:r>
+              <a:t>This keeps the building stable as the repository changes. Current code and tests still outrank remembered guidance.</a:t>
             </a:r>
           </a:p>
         </p:txBody>
@@ -1157,7 +1157,7 @@
   </p:cSld>
   <p:clrMap bg1="lt1" tx1="dk1" bg2="lt2" tx2="dk2" accent1="accent1" accent2="accent2" accent3="accent3" accent4="accent4" accent5="accent5" accent6="accent6" hlink="hlink" folHlink="folHlink"/>
   <p:sldLayoutIdLst>
-    <p:sldLayoutId xmlns:r="http://schemas.openxmlformats.org/officeDocument/2006/relationships" id="2147483649" r:id="Rfeaf7f294e654a66"/>
+    <p:sldLayoutId xmlns:r="http://schemas.openxmlformats.org/officeDocument/2006/relationships" id="2147483649" r:id="R4cfe5f496f634ff8"/>
   </p:sldLayoutIdLst>
   <p:txStyles>
     <p:titleStyle>
@@ -2049,7 +2049,7 @@
           <p:cNvPr id="7" name="s1-eyebrow">
             <a:extLst xmlns:a="http://schemas.openxmlformats.org/drawingml/2006/main">
               <a:ext uri="{FF2B5EF4-FFF2-40B4-BE49-F238E27FC236}">
-                <a16:creationId xmlns:a16="http://schemas.microsoft.com/office/drawing/2014/main" id="{B7B1FA98-806C-40C5-A554-1071E0862DBB}"/>
+                <a16:creationId xmlns:a16="http://schemas.microsoft.com/office/drawing/2014/main" id="{BA4A2A4C-2C67-46E2-9EBA-7D4F37C0A397}"/>
               </a:ext>
             </a:extLst>
           </p:cNvPr>
@@ -2094,7 +2094,7 @@
           <p:cNvPr id="2" name="s1-title">
             <a:extLst xmlns:a="http://schemas.openxmlformats.org/drawingml/2006/main">
               <a:ext uri="{FF2B5EF4-FFF2-40B4-BE49-F238E27FC236}">
-                <a16:creationId xmlns:a16="http://schemas.microsoft.com/office/drawing/2014/main" id="{C1889C3F-BF41-4D7C-8A0A-ED3374146D69}"/>
+                <a16:creationId xmlns:a16="http://schemas.microsoft.com/office/drawing/2014/main" id="{FDE79580-A097-46F0-9627-A59A4B319954}"/>
               </a:ext>
             </a:extLst>
           </p:cNvPr>
@@ -2162,7 +2162,7 @@
           <p:cNvPr id="4" name="s1-subtitle">
             <a:extLst xmlns:a="http://schemas.openxmlformats.org/drawingml/2006/main">
               <a:ext uri="{FF2B5EF4-FFF2-40B4-BE49-F238E27FC236}">
-                <a16:creationId xmlns:a16="http://schemas.microsoft.com/office/drawing/2014/main" id="{4669666D-118B-4D03-ACA6-8F67931BCE11}"/>
+                <a16:creationId xmlns:a16="http://schemas.microsoft.com/office/drawing/2014/main" id="{614FD7A3-576F-4740-A719-5CC5B0ADFAB7}"/>
               </a:ext>
             </a:extLst>
           </p:cNvPr>
@@ -2207,7 +2207,7 @@
           <p:cNvPr id="5" name="s1-version">
             <a:extLst xmlns:a="http://schemas.openxmlformats.org/drawingml/2006/main">
               <a:ext uri="{FF2B5EF4-FFF2-40B4-BE49-F238E27FC236}">
-                <a16:creationId xmlns:a16="http://schemas.microsoft.com/office/drawing/2014/main" id="{6DDE248A-DE7A-44C3-BBD9-7FC9B0CEB408}"/>
+                <a16:creationId xmlns:a16="http://schemas.microsoft.com/office/drawing/2014/main" id="{3525B2D3-BA2F-4189-9DEA-8150F4D72115}"/>
               </a:ext>
             </a:extLst>
           </p:cNvPr>
@@ -2256,7 +2256,7 @@
           <p:nvPr/>
         </p:nvPicPr>
         <p:blipFill>
-          <a:blip xmlns:r="http://schemas.openxmlformats.org/officeDocument/2006/relationships" xmlns:a="http://schemas.openxmlformats.org/drawingml/2006/main" r:embed="Rb0f2c6423231481c"/>
+          <a:blip xmlns:r="http://schemas.openxmlformats.org/officeDocument/2006/relationships" xmlns:a="http://schemas.openxmlformats.org/drawingml/2006/main" r:embed="R79c1d2b0254f4d99"/>
           <a:stretch xmlns:a="http://schemas.openxmlformats.org/drawingml/2006/main"/>
         </p:blipFill>
         <p:spPr>
@@ -2272,7 +2272,7 @@
     </p:spTree>
     <p:extLst>
       <p:ext uri="{BB962C8B-B14F-4D97-AF65-F5344CB8AC3E}">
-        <p14:creationId xmlns:p14="http://schemas.microsoft.com/office/powerpoint/2010/main" val="1270227419"/>
+        <p14:creationId xmlns:p14="http://schemas.microsoft.com/office/powerpoint/2010/main" val="1340954457"/>
       </p:ext>
     </p:extLst>
   </p:cSld>
@@ -2303,7 +2303,7 @@
           <p:cNvPr id="33" name="s2-title">
             <a:extLst xmlns:a="http://schemas.openxmlformats.org/drawingml/2006/main">
               <a:ext uri="{FF2B5EF4-FFF2-40B4-BE49-F238E27FC236}">
-                <a16:creationId xmlns:a16="http://schemas.microsoft.com/office/drawing/2014/main" id="{C5FC4020-68D7-4811-ADE7-A817D4BC3B36}"/>
+                <a16:creationId xmlns:a16="http://schemas.microsoft.com/office/drawing/2014/main" id="{CE01E587-EA77-4DCF-BC45-15C0EDA23EAE}"/>
               </a:ext>
             </a:extLst>
           </p:cNvPr>
@@ -2348,7 +2348,7 @@
           <p:cNvPr id="2" name="s2-subtitle">
             <a:extLst xmlns:a="http://schemas.openxmlformats.org/drawingml/2006/main">
               <a:ext uri="{FF2B5EF4-FFF2-40B4-BE49-F238E27FC236}">
-                <a16:creationId xmlns:a16="http://schemas.microsoft.com/office/drawing/2014/main" id="{4940A15F-891F-4344-A13A-B1C339B0A557}"/>
+                <a16:creationId xmlns:a16="http://schemas.microsoft.com/office/drawing/2014/main" id="{37763A1F-21DD-4ED8-95FE-6CC5595977BB}"/>
               </a:ext>
             </a:extLst>
           </p:cNvPr>
@@ -2503,7 +2503,7 @@
           <p:cNvPr id="8" name="s2-agent">
             <a:extLst xmlns:a="http://schemas.openxmlformats.org/drawingml/2006/main">
               <a:ext uri="{FF2B5EF4-FFF2-40B4-BE49-F238E27FC236}">
-                <a16:creationId xmlns:a16="http://schemas.microsoft.com/office/drawing/2014/main" id="{A01F559D-912B-4B3C-965D-04A0BBECBFA2}"/>
+                <a16:creationId xmlns:a16="http://schemas.microsoft.com/office/drawing/2014/main" id="{B54C204E-3868-469B-A58F-530A830304FA}"/>
               </a:ext>
             </a:extLst>
           </p:cNvPr>
@@ -2536,7 +2536,7 @@
           <p:cNvPr id="9" name="s2-agent-label">
             <a:extLst xmlns:a="http://schemas.openxmlformats.org/drawingml/2006/main">
               <a:ext uri="{FF2B5EF4-FFF2-40B4-BE49-F238E27FC236}">
-                <a16:creationId xmlns:a16="http://schemas.microsoft.com/office/drawing/2014/main" id="{A44C0778-51D2-4D50-9E6C-D44F690E9A45}"/>
+                <a16:creationId xmlns:a16="http://schemas.microsoft.com/office/drawing/2014/main" id="{E5F4D873-882C-4DE3-9A01-D8A63F219B61}"/>
               </a:ext>
             </a:extLst>
           </p:cNvPr>
@@ -2581,7 +2581,7 @@
           <p:cNvPr id="10" name="s2-file-a">
             <a:extLst xmlns:a="http://schemas.openxmlformats.org/drawingml/2006/main">
               <a:ext uri="{FF2B5EF4-FFF2-40B4-BE49-F238E27FC236}">
-                <a16:creationId xmlns:a16="http://schemas.microsoft.com/office/drawing/2014/main" id="{7DD03FA1-A93C-481A-A316-AB9D11260DBC}"/>
+                <a16:creationId xmlns:a16="http://schemas.microsoft.com/office/drawing/2014/main" id="{EDFB5032-CC38-4425-BC7B-0A93AF329F55}"/>
               </a:ext>
             </a:extLst>
           </p:cNvPr>
@@ -2614,7 +2614,7 @@
           <p:cNvPr id="11" name="s2-file-b">
             <a:extLst xmlns:a="http://schemas.openxmlformats.org/drawingml/2006/main">
               <a:ext uri="{FF2B5EF4-FFF2-40B4-BE49-F238E27FC236}">
-                <a16:creationId xmlns:a16="http://schemas.microsoft.com/office/drawing/2014/main" id="{200592A9-79DC-475F-981B-0164FB535A27}"/>
+                <a16:creationId xmlns:a16="http://schemas.microsoft.com/office/drawing/2014/main" id="{5D8AA49E-5348-43A7-99D4-0F6E7DDB6D18}"/>
               </a:ext>
             </a:extLst>
           </p:cNvPr>
@@ -2647,7 +2647,7 @@
           <p:cNvPr id="12" name="s2-file-c">
             <a:extLst xmlns:a="http://schemas.openxmlformats.org/drawingml/2006/main">
               <a:ext uri="{FF2B5EF4-FFF2-40B4-BE49-F238E27FC236}">
-                <a16:creationId xmlns:a16="http://schemas.microsoft.com/office/drawing/2014/main" id="{F024A584-4103-45D1-8D3E-DEF1CB2EFDB7}"/>
+                <a16:creationId xmlns:a16="http://schemas.microsoft.com/office/drawing/2014/main" id="{955CDD8F-920A-4F86-BBDF-8CB217B1AA6A}"/>
               </a:ext>
             </a:extLst>
           </p:cNvPr>
@@ -2680,7 +2680,7 @@
           <p:cNvPr id="13" name="s2-file-d">
             <a:extLst xmlns:a="http://schemas.openxmlformats.org/drawingml/2006/main">
               <a:ext uri="{FF2B5EF4-FFF2-40B4-BE49-F238E27FC236}">
-                <a16:creationId xmlns:a16="http://schemas.microsoft.com/office/drawing/2014/main" id="{8DDC61FB-59DB-4BE7-BF2A-2316C278718D}"/>
+                <a16:creationId xmlns:a16="http://schemas.microsoft.com/office/drawing/2014/main" id="{E4712813-2BEF-4B2B-BC37-68C0A6981F41}"/>
               </a:ext>
             </a:extLst>
           </p:cNvPr>
@@ -2713,7 +2713,7 @@
           <p:cNvPr id="14" name="s2-file-e">
             <a:extLst xmlns:a="http://schemas.openxmlformats.org/drawingml/2006/main">
               <a:ext uri="{FF2B5EF4-FFF2-40B4-BE49-F238E27FC236}">
-                <a16:creationId xmlns:a16="http://schemas.microsoft.com/office/drawing/2014/main" id="{B33BFD1E-4A8B-4F32-AB43-EB36FA455BA0}"/>
+                <a16:creationId xmlns:a16="http://schemas.microsoft.com/office/drawing/2014/main" id="{BFEB7E66-1CF9-4FDB-9968-95CC281021B8}"/>
               </a:ext>
             </a:extLst>
           </p:cNvPr>
@@ -2746,7 +2746,7 @@
           <p:cNvPr id="15" name="s2-file-a-label">
             <a:extLst xmlns:a="http://schemas.openxmlformats.org/drawingml/2006/main">
               <a:ext uri="{FF2B5EF4-FFF2-40B4-BE49-F238E27FC236}">
-                <a16:creationId xmlns:a16="http://schemas.microsoft.com/office/drawing/2014/main" id="{32BF2F3A-D65D-4DF4-A83D-4A0FB33B9AB6}"/>
+                <a16:creationId xmlns:a16="http://schemas.microsoft.com/office/drawing/2014/main" id="{752A3A93-5DB7-4D8A-85EB-2F85B4A37338}"/>
               </a:ext>
             </a:extLst>
           </p:cNvPr>
@@ -2791,7 +2791,7 @@
           <p:cNvPr id="16" name="s2-file-b-label">
             <a:extLst xmlns:a="http://schemas.openxmlformats.org/drawingml/2006/main">
               <a:ext uri="{FF2B5EF4-FFF2-40B4-BE49-F238E27FC236}">
-                <a16:creationId xmlns:a16="http://schemas.microsoft.com/office/drawing/2014/main" id="{4587D486-932F-4FB6-B402-137073E34186}"/>
+                <a16:creationId xmlns:a16="http://schemas.microsoft.com/office/drawing/2014/main" id="{83476026-6F86-4310-81AD-0EB70161AB73}"/>
               </a:ext>
             </a:extLst>
           </p:cNvPr>
@@ -2836,7 +2836,7 @@
           <p:cNvPr id="17" name="s2-file-c-label">
             <a:extLst xmlns:a="http://schemas.openxmlformats.org/drawingml/2006/main">
               <a:ext uri="{FF2B5EF4-FFF2-40B4-BE49-F238E27FC236}">
-                <a16:creationId xmlns:a16="http://schemas.microsoft.com/office/drawing/2014/main" id="{56E77D73-AFAD-438B-9DA9-99357F7C4419}"/>
+                <a16:creationId xmlns:a16="http://schemas.microsoft.com/office/drawing/2014/main" id="{2D5D81C8-3062-4C2F-8F52-07141AFB48DE}"/>
               </a:ext>
             </a:extLst>
           </p:cNvPr>
@@ -2881,7 +2881,7 @@
           <p:cNvPr id="18" name="s2-file-d-label">
             <a:extLst xmlns:a="http://schemas.openxmlformats.org/drawingml/2006/main">
               <a:ext uri="{FF2B5EF4-FFF2-40B4-BE49-F238E27FC236}">
-                <a16:creationId xmlns:a16="http://schemas.microsoft.com/office/drawing/2014/main" id="{F306541C-8593-40AC-A877-CC3DE563777C}"/>
+                <a16:creationId xmlns:a16="http://schemas.microsoft.com/office/drawing/2014/main" id="{688B4AE7-6A7D-433F-8FBC-CCC60779B83D}"/>
               </a:ext>
             </a:extLst>
           </p:cNvPr>
@@ -2926,7 +2926,7 @@
           <p:cNvPr id="19" name="s2-file-e-label">
             <a:extLst xmlns:a="http://schemas.openxmlformats.org/drawingml/2006/main">
               <a:ext uri="{FF2B5EF4-FFF2-40B4-BE49-F238E27FC236}">
-                <a16:creationId xmlns:a16="http://schemas.microsoft.com/office/drawing/2014/main" id="{8D3B657F-C97B-47DA-AE05-3EB3F1CD849F}"/>
+                <a16:creationId xmlns:a16="http://schemas.microsoft.com/office/drawing/2014/main" id="{B8123406-4926-4A2B-8900-6518003D50B3}"/>
               </a:ext>
             </a:extLst>
           </p:cNvPr>
@@ -2971,7 +2971,7 @@
           <p:cNvPr id="20" name="s2-n1">
             <a:extLst xmlns:a="http://schemas.openxmlformats.org/drawingml/2006/main">
               <a:ext uri="{FF2B5EF4-FFF2-40B4-BE49-F238E27FC236}">
-                <a16:creationId xmlns:a16="http://schemas.microsoft.com/office/drawing/2014/main" id="{D8FEB7E8-7602-4187-B600-F0EA3B74AE52}"/>
+                <a16:creationId xmlns:a16="http://schemas.microsoft.com/office/drawing/2014/main" id="{CF21291D-1275-49CA-B125-C708D0B07357}"/>
               </a:ext>
             </a:extLst>
           </p:cNvPr>
@@ -3004,7 +3004,7 @@
           <p:cNvPr id="21" name="s2-n1-label">
             <a:extLst xmlns:a="http://schemas.openxmlformats.org/drawingml/2006/main">
               <a:ext uri="{FF2B5EF4-FFF2-40B4-BE49-F238E27FC236}">
-                <a16:creationId xmlns:a16="http://schemas.microsoft.com/office/drawing/2014/main" id="{62768408-9234-4E1A-86BD-3089003B8B33}"/>
+                <a16:creationId xmlns:a16="http://schemas.microsoft.com/office/drawing/2014/main" id="{50212A83-479A-4F6A-902A-5B2215B7A5A7}"/>
               </a:ext>
             </a:extLst>
           </p:cNvPr>
@@ -3049,7 +3049,7 @@
           <p:cNvPr id="22" name="s2-p1">
             <a:extLst xmlns:a="http://schemas.openxmlformats.org/drawingml/2006/main">
               <a:ext uri="{FF2B5EF4-FFF2-40B4-BE49-F238E27FC236}">
-                <a16:creationId xmlns:a16="http://schemas.microsoft.com/office/drawing/2014/main" id="{F5162042-A516-4172-987A-DEC9A5623A64}"/>
+                <a16:creationId xmlns:a16="http://schemas.microsoft.com/office/drawing/2014/main" id="{8947F4D5-7B54-4AFB-B6A8-CD20E237802C}"/>
               </a:ext>
             </a:extLst>
           </p:cNvPr>
@@ -3094,7 +3094,7 @@
           <p:cNvPr id="23" name="s2-n2">
             <a:extLst xmlns:a="http://schemas.openxmlformats.org/drawingml/2006/main">
               <a:ext uri="{FF2B5EF4-FFF2-40B4-BE49-F238E27FC236}">
-                <a16:creationId xmlns:a16="http://schemas.microsoft.com/office/drawing/2014/main" id="{B4BD2993-05F2-4960-93EC-545FE3A79B48}"/>
+                <a16:creationId xmlns:a16="http://schemas.microsoft.com/office/drawing/2014/main" id="{1D5C127C-79CE-408F-B566-7FF99AC94476}"/>
               </a:ext>
             </a:extLst>
           </p:cNvPr>
@@ -3127,7 +3127,7 @@
           <p:cNvPr id="24" name="s2-n2-label">
             <a:extLst xmlns:a="http://schemas.openxmlformats.org/drawingml/2006/main">
               <a:ext uri="{FF2B5EF4-FFF2-40B4-BE49-F238E27FC236}">
-                <a16:creationId xmlns:a16="http://schemas.microsoft.com/office/drawing/2014/main" id="{758B1B5C-4A3A-4E43-9223-B0F64104B272}"/>
+                <a16:creationId xmlns:a16="http://schemas.microsoft.com/office/drawing/2014/main" id="{8EF3DFF5-43D6-4951-A2FB-FB5480C72702}"/>
               </a:ext>
             </a:extLst>
           </p:cNvPr>
@@ -3172,7 +3172,7 @@
           <p:cNvPr id="25" name="s2-p2">
             <a:extLst xmlns:a="http://schemas.openxmlformats.org/drawingml/2006/main">
               <a:ext uri="{FF2B5EF4-FFF2-40B4-BE49-F238E27FC236}">
-                <a16:creationId xmlns:a16="http://schemas.microsoft.com/office/drawing/2014/main" id="{216F0699-0303-427C-A104-396B5BFAEB4D}"/>
+                <a16:creationId xmlns:a16="http://schemas.microsoft.com/office/drawing/2014/main" id="{B0EEB293-3063-4266-9D21-B260197D1B69}"/>
               </a:ext>
             </a:extLst>
           </p:cNvPr>
@@ -3217,7 +3217,7 @@
           <p:cNvPr id="26" name="s2-n3">
             <a:extLst xmlns:a="http://schemas.openxmlformats.org/drawingml/2006/main">
               <a:ext uri="{FF2B5EF4-FFF2-40B4-BE49-F238E27FC236}">
-                <a16:creationId xmlns:a16="http://schemas.microsoft.com/office/drawing/2014/main" id="{953A21F2-A6AD-4166-9B57-9F79639EE525}"/>
+                <a16:creationId xmlns:a16="http://schemas.microsoft.com/office/drawing/2014/main" id="{8807360B-1D31-4C4D-9D60-50F655519668}"/>
               </a:ext>
             </a:extLst>
           </p:cNvPr>
@@ -3250,7 +3250,7 @@
           <p:cNvPr id="27" name="s2-n3-label">
             <a:extLst xmlns:a="http://schemas.openxmlformats.org/drawingml/2006/main">
               <a:ext uri="{FF2B5EF4-FFF2-40B4-BE49-F238E27FC236}">
-                <a16:creationId xmlns:a16="http://schemas.microsoft.com/office/drawing/2014/main" id="{67E3757C-7BC9-473D-BD3D-0A16007A14C9}"/>
+                <a16:creationId xmlns:a16="http://schemas.microsoft.com/office/drawing/2014/main" id="{ECF7D8E2-753B-4544-8C14-A25F659CFCC2}"/>
               </a:ext>
             </a:extLst>
           </p:cNvPr>
@@ -3295,7 +3295,7 @@
           <p:cNvPr id="28" name="s2-p3">
             <a:extLst xmlns:a="http://schemas.openxmlformats.org/drawingml/2006/main">
               <a:ext uri="{FF2B5EF4-FFF2-40B4-BE49-F238E27FC236}">
-                <a16:creationId xmlns:a16="http://schemas.microsoft.com/office/drawing/2014/main" id="{769800D5-994F-4BB1-AD39-635972011F2D}"/>
+                <a16:creationId xmlns:a16="http://schemas.microsoft.com/office/drawing/2014/main" id="{F53A45E9-915F-4D65-9CE0-DA52330C9231}"/>
               </a:ext>
             </a:extLst>
           </p:cNvPr>
@@ -3340,7 +3340,7 @@
           <p:cNvPr id="29" name="s2-takeaway">
             <a:extLst xmlns:a="http://schemas.openxmlformats.org/drawingml/2006/main">
               <a:ext uri="{FF2B5EF4-FFF2-40B4-BE49-F238E27FC236}">
-                <a16:creationId xmlns:a16="http://schemas.microsoft.com/office/drawing/2014/main" id="{F96DB957-1493-4D0D-8297-7670DA2B63B2}"/>
+                <a16:creationId xmlns:a16="http://schemas.microsoft.com/office/drawing/2014/main" id="{68D5A9DF-DEAC-4378-A635-97BF67A0A3F3}"/>
               </a:ext>
             </a:extLst>
           </p:cNvPr>
@@ -3407,7 +3407,7 @@
           <p:cNvPr id="31" name="footer-source-2">
             <a:extLst xmlns:a="http://schemas.openxmlformats.org/drawingml/2006/main">
               <a:ext uri="{FF2B5EF4-FFF2-40B4-BE49-F238E27FC236}">
-                <a16:creationId xmlns:a16="http://schemas.microsoft.com/office/drawing/2014/main" id="{73CFBAD0-5848-46F1-AA68-4BF1E8A140F0}"/>
+                <a16:creationId xmlns:a16="http://schemas.microsoft.com/office/drawing/2014/main" id="{B57DC3D6-4F55-4D36-B1EE-B3FD2A699B9D}"/>
               </a:ext>
             </a:extLst>
           </p:cNvPr>
@@ -3452,7 +3452,7 @@
           <p:cNvPr id="32" name="footer-number-2">
             <a:extLst xmlns:a="http://schemas.openxmlformats.org/drawingml/2006/main">
               <a:ext uri="{FF2B5EF4-FFF2-40B4-BE49-F238E27FC236}">
-                <a16:creationId xmlns:a16="http://schemas.microsoft.com/office/drawing/2014/main" id="{C40432CF-26AF-4DE0-B190-F8AE9AB03723}"/>
+                <a16:creationId xmlns:a16="http://schemas.microsoft.com/office/drawing/2014/main" id="{16D6A9C6-293C-4E0A-B71D-1A73C2AB6736}"/>
               </a:ext>
             </a:extLst>
           </p:cNvPr>
@@ -3495,7 +3495,7 @@
     </p:spTree>
     <p:extLst>
       <p:ext uri="{BB962C8B-B14F-4D97-AF65-F5344CB8AC3E}">
-        <p14:creationId xmlns:p14="http://schemas.microsoft.com/office/powerpoint/2010/main" val="1442236352"/>
+        <p14:creationId xmlns:p14="http://schemas.microsoft.com/office/powerpoint/2010/main" val="1608650757"/>
       </p:ext>
     </p:extLst>
   </p:cSld>
@@ -3523,10 +3523,10 @@
       </p:grpSpPr>
       <p:sp>
         <p:nvSpPr>
-          <p:cNvPr id="29" name="s3-title">
-            <a:extLst xmlns:a="http://schemas.openxmlformats.org/drawingml/2006/main">
-              <a:ext uri="{FF2B5EF4-FFF2-40B4-BE49-F238E27FC236}">
-                <a16:creationId xmlns:a16="http://schemas.microsoft.com/office/drawing/2014/main" id="{E27733F7-45C4-4741-BECA-AB6F8949F354}"/>
+          <p:cNvPr id="38" name="s3-title">
+            <a:extLst xmlns:a="http://schemas.openxmlformats.org/drawingml/2006/main">
+              <a:ext uri="{FF2B5EF4-FFF2-40B4-BE49-F238E27FC236}">
+                <a16:creationId xmlns:a16="http://schemas.microsoft.com/office/drawing/2014/main" id="{D1D4BB7D-6882-4D9D-8940-3BC3CE7586C1}"/>
               </a:ext>
             </a:extLst>
           </p:cNvPr>
@@ -3561,7 +3561,7 @@
               </a:defRPr>
             </a:pPr>
             <a:r>
-              <a:t>I wanted to turn a 2D repository into a 3D building.</a:t>
+              <a:t>The 3D building gives every context item an address.</a:t>
             </a:r>
           </a:p>
         </p:txBody>
@@ -3571,7 +3571,7 @@
           <p:cNvPr id="2" name="s3-subtitle">
             <a:extLst xmlns:a="http://schemas.openxmlformats.org/drawingml/2006/main">
               <a:ext uri="{FF2B5EF4-FFF2-40B4-BE49-F238E27FC236}">
-                <a16:creationId xmlns:a16="http://schemas.microsoft.com/office/drawing/2014/main" id="{D8B89513-F66C-4268-806F-44E2DF33041A}"/>
+                <a16:creationId xmlns:a16="http://schemas.microsoft.com/office/drawing/2014/main" id="{7BF1BF28-A736-4B07-9CE0-DA6C052B85EB}"/>
               </a:ext>
             </a:extLst>
           </p:cNvPr>
@@ -3606,882 +3606,21 @@
               </a:defRPr>
             </a:pPr>
             <a:r>
-              <a:t>Domains became floors. Features became rooms. Files and symbols became cabinets and drawers.</a:t>
+              <a:t>X locates the domain. Y selects the architectural floor. Z controls inspection depth.</a:t>
             </a:r>
           </a:p>
         </p:txBody>
       </p:sp>
       <p:cxnSp>
         <p:nvCxnSpPr>
-          <p:cNvPr id="31" name="s3-c1"/>
+          <p:cNvPr id="40" name="s3-rule-x"/>
           <p:cNvCxnSpPr/>
           <p:nvPr/>
         </p:nvCxnSpPr>
         <p:spPr>
           <a:xfrm xmlns:a="http://schemas.openxmlformats.org/drawingml/2006/main">
-            <a:off x="2209800" y="2933700"/>
-            <a:ext cx="762000" cy="953"/>
-          </a:xfrm>
-          <a:prstGeom xmlns:a="http://schemas.openxmlformats.org/drawingml/2006/main" prst="straightConnector1">
-            <a:avLst/>
-          </a:prstGeom>
-          <a:ln xmlns:a="http://schemas.openxmlformats.org/drawingml/2006/main" w="28575">
-            <a:solidFill>
-              <a:srgbClr val="13B7D5"/>
-            </a:solidFill>
-            <a:prstDash val="solid"/>
-          </a:ln>
-        </p:spPr>
-      </p:cxnSp>
-      <p:cxnSp>
-        <p:nvCxnSpPr>
-          <p:cNvPr id="32" name="s3-c2"/>
-          <p:cNvCxnSpPr/>
-          <p:nvPr/>
-        </p:nvCxnSpPr>
-        <p:spPr>
-          <a:xfrm xmlns:a="http://schemas.openxmlformats.org/drawingml/2006/main">
-            <a:off x="4400550" y="2933700"/>
-            <a:ext cx="762000" cy="953"/>
-          </a:xfrm>
-          <a:prstGeom xmlns:a="http://schemas.openxmlformats.org/drawingml/2006/main" prst="straightConnector1">
-            <a:avLst/>
-          </a:prstGeom>
-          <a:ln xmlns:a="http://schemas.openxmlformats.org/drawingml/2006/main" w="28575">
-            <a:solidFill>
-              <a:srgbClr val="1677FF"/>
-            </a:solidFill>
-            <a:prstDash val="solid"/>
-          </a:ln>
-        </p:spPr>
-      </p:cxnSp>
-      <p:cxnSp>
-        <p:nvCxnSpPr>
-          <p:cNvPr id="33" name="s3-c3"/>
-          <p:cNvCxnSpPr/>
-          <p:nvPr/>
-        </p:nvCxnSpPr>
-        <p:spPr>
-          <a:xfrm xmlns:a="http://schemas.openxmlformats.org/drawingml/2006/main">
-            <a:off x="6591300" y="2933700"/>
-            <a:ext cx="762000" cy="953"/>
-          </a:xfrm>
-          <a:prstGeom xmlns:a="http://schemas.openxmlformats.org/drawingml/2006/main" prst="straightConnector1">
-            <a:avLst/>
-          </a:prstGeom>
-          <a:ln xmlns:a="http://schemas.openxmlformats.org/drawingml/2006/main" w="28575">
-            <a:solidFill>
-              <a:srgbClr val="7438F5"/>
-            </a:solidFill>
-            <a:prstDash val="solid"/>
-          </a:ln>
-        </p:spPr>
-      </p:cxnSp>
-      <p:cxnSp>
-        <p:nvCxnSpPr>
-          <p:cNvPr id="34" name="s3-c4"/>
-          <p:cNvCxnSpPr/>
-          <p:nvPr/>
-        </p:nvCxnSpPr>
-        <p:spPr>
-          <a:xfrm xmlns:a="http://schemas.openxmlformats.org/drawingml/2006/main">
-            <a:off x="8782050" y="2933700"/>
-            <a:ext cx="762000" cy="953"/>
-          </a:xfrm>
-          <a:prstGeom xmlns:a="http://schemas.openxmlformats.org/drawingml/2006/main" prst="straightConnector1">
-            <a:avLst/>
-          </a:prstGeom>
-          <a:ln xmlns:a="http://schemas.openxmlformats.org/drawingml/2006/main" w="28575">
-            <a:solidFill>
-              <a:srgbClr val="15A777"/>
-            </a:solidFill>
-            <a:prstDash val="solid"/>
-          </a:ln>
-        </p:spPr>
-      </p:cxnSp>
-      <p:cxnSp>
-        <p:nvCxnSpPr>
-          <p:cNvPr id="35" name="s3-memory-link"/>
-          <p:cNvCxnSpPr/>
-          <p:nvPr/>
-        </p:nvCxnSpPr>
-        <p:spPr>
-          <a:xfrm xmlns:a="http://schemas.openxmlformats.org/drawingml/2006/main">
-            <a:off x="7848600" y="3752850"/>
-            <a:ext cx="2381250" cy="838200"/>
-          </a:xfrm>
-          <a:prstGeom xmlns:a="http://schemas.openxmlformats.org/drawingml/2006/main" prst="straightConnector1">
-            <a:avLst/>
-          </a:prstGeom>
-          <a:ln xmlns:a="http://schemas.openxmlformats.org/drawingml/2006/main" w="19050">
-            <a:solidFill>
-              <a:srgbClr val="B8BCC4"/>
-            </a:solidFill>
-            <a:prstDash val="solid"/>
-          </a:ln>
-        </p:spPr>
-      </p:cxnSp>
-      <p:sp>
-        <p:nvSpPr>
-          <p:cNvPr id="8" name="s3-repo">
-            <a:extLst xmlns:a="http://schemas.openxmlformats.org/drawingml/2006/main">
-              <a:ext uri="{FF2B5EF4-FFF2-40B4-BE49-F238E27FC236}">
-                <a16:creationId xmlns:a16="http://schemas.microsoft.com/office/drawing/2014/main" id="{F84B093C-FEA3-4914-8E41-2D9A530BAA25}"/>
-              </a:ext>
-            </a:extLst>
-          </p:cNvPr>
-          <p:cNvSpPr>
-            <a:spLocks xmlns:a="http://schemas.openxmlformats.org/drawingml/2006/main" noGrp="1"/>
-          </p:cNvSpPr>
-          <p:nvPr/>
-        </p:nvSpPr>
-        <p:spPr>
-          <a:xfrm xmlns:a="http://schemas.openxmlformats.org/drawingml/2006/main">
-            <a:off x="590550" y="2143125"/>
-            <a:ext cx="1619250" cy="1600200"/>
-          </a:xfrm>
-          <a:prstGeom xmlns:a="http://schemas.openxmlformats.org/drawingml/2006/main" prst="roundRect">
-            <a:avLst>
-              <a:gd name="adj" fmla="val 4762"/>
-            </a:avLst>
-          </a:prstGeom>
-          <a:solidFill xmlns:a="http://schemas.openxmlformats.org/drawingml/2006/main">
-            <a:srgbClr val="EDEFF3"/>
-          </a:solidFill>
-          <a:ln xmlns:a="http://schemas.openxmlformats.org/drawingml/2006/main" w="0">
-            <a:solidFill>
-              <a:srgbClr val="EDEFF3"/>
-            </a:solidFill>
-            <a:prstDash val="solid"/>
-          </a:ln>
-        </p:spPr>
-      </p:sp>
-      <p:sp>
-        <p:nvSpPr>
-          <p:cNvPr id="9" name="s3-index">
-            <a:extLst xmlns:a="http://schemas.openxmlformats.org/drawingml/2006/main">
-              <a:ext uri="{FF2B5EF4-FFF2-40B4-BE49-F238E27FC236}">
-                <a16:creationId xmlns:a16="http://schemas.microsoft.com/office/drawing/2014/main" id="{89846913-9258-41E6-A885-56F6F473227D}"/>
-              </a:ext>
-            </a:extLst>
-          </p:cNvPr>
-          <p:cNvSpPr>
-            <a:spLocks xmlns:a="http://schemas.openxmlformats.org/drawingml/2006/main" noGrp="1"/>
-          </p:cNvSpPr>
-          <p:nvPr/>
-        </p:nvSpPr>
-        <p:spPr>
-          <a:xfrm xmlns:a="http://schemas.openxmlformats.org/drawingml/2006/main">
-            <a:off x="2971800" y="2143125"/>
-            <a:ext cx="1428750" cy="1600200"/>
-          </a:xfrm>
-          <a:prstGeom xmlns:a="http://schemas.openxmlformats.org/drawingml/2006/main" prst="roundRect">
-            <a:avLst>
-              <a:gd name="adj" fmla="val 5333"/>
-            </a:avLst>
-          </a:prstGeom>
-          <a:solidFill xmlns:a="http://schemas.openxmlformats.org/drawingml/2006/main">
-            <a:srgbClr val="E8F7FB"/>
-          </a:solidFill>
-          <a:ln xmlns:a="http://schemas.openxmlformats.org/drawingml/2006/main" w="0">
-            <a:solidFill>
-              <a:srgbClr val="E8F7FB"/>
-            </a:solidFill>
-            <a:prstDash val="solid"/>
-          </a:ln>
-        </p:spPr>
-      </p:sp>
-      <p:sp>
-        <p:nvSpPr>
-          <p:cNvPr id="10" name="s3-mode">
-            <a:extLst xmlns:a="http://schemas.openxmlformats.org/drawingml/2006/main">
-              <a:ext uri="{FF2B5EF4-FFF2-40B4-BE49-F238E27FC236}">
-                <a16:creationId xmlns:a16="http://schemas.microsoft.com/office/drawing/2014/main" id="{C55F47EA-5C65-456D-B485-4D330B21B66C}"/>
-              </a:ext>
-            </a:extLst>
-          </p:cNvPr>
-          <p:cNvSpPr>
-            <a:spLocks xmlns:a="http://schemas.openxmlformats.org/drawingml/2006/main" noGrp="1"/>
-          </p:cNvSpPr>
-          <p:nvPr/>
-        </p:nvSpPr>
-        <p:spPr>
-          <a:xfrm xmlns:a="http://schemas.openxmlformats.org/drawingml/2006/main">
-            <a:off x="5162550" y="2143125"/>
-            <a:ext cx="1428750" cy="1600200"/>
-          </a:xfrm>
-          <a:prstGeom xmlns:a="http://schemas.openxmlformats.org/drawingml/2006/main" prst="roundRect">
-            <a:avLst>
-              <a:gd name="adj" fmla="val 5333"/>
-            </a:avLst>
-          </a:prstGeom>
-          <a:solidFill xmlns:a="http://schemas.openxmlformats.org/drawingml/2006/main">
-            <a:srgbClr val="EAF1FF"/>
-          </a:solidFill>
-          <a:ln xmlns:a="http://schemas.openxmlformats.org/drawingml/2006/main" w="0">
-            <a:solidFill>
-              <a:srgbClr val="EAF1FF"/>
-            </a:solidFill>
-            <a:prstDash val="solid"/>
-          </a:ln>
-        </p:spPr>
-      </p:sp>
-      <p:sp>
-        <p:nvSpPr>
-          <p:cNvPr id="11" name="s3-pack">
-            <a:extLst xmlns:a="http://schemas.openxmlformats.org/drawingml/2006/main">
-              <a:ext uri="{FF2B5EF4-FFF2-40B4-BE49-F238E27FC236}">
-                <a16:creationId xmlns:a16="http://schemas.microsoft.com/office/drawing/2014/main" id="{253B49D7-D4B8-44CF-8038-1EC8F11B9418}"/>
-              </a:ext>
-            </a:extLst>
-          </p:cNvPr>
-          <p:cNvSpPr>
-            <a:spLocks xmlns:a="http://schemas.openxmlformats.org/drawingml/2006/main" noGrp="1"/>
-          </p:cNvSpPr>
-          <p:nvPr/>
-        </p:nvSpPr>
-        <p:spPr>
-          <a:xfrm xmlns:a="http://schemas.openxmlformats.org/drawingml/2006/main">
-            <a:off x="7353300" y="2143125"/>
-            <a:ext cx="1428750" cy="1600200"/>
-          </a:xfrm>
-          <a:prstGeom xmlns:a="http://schemas.openxmlformats.org/drawingml/2006/main" prst="roundRect">
-            <a:avLst>
-              <a:gd name="adj" fmla="val 5333"/>
-            </a:avLst>
-          </a:prstGeom>
-          <a:solidFill xmlns:a="http://schemas.openxmlformats.org/drawingml/2006/main">
-            <a:srgbClr val="F1EBFF"/>
-          </a:solidFill>
-          <a:ln xmlns:a="http://schemas.openxmlformats.org/drawingml/2006/main" w="0">
-            <a:solidFill>
-              <a:srgbClr val="F1EBFF"/>
-            </a:solidFill>
-            <a:prstDash val="solid"/>
-          </a:ln>
-        </p:spPr>
-      </p:sp>
-      <p:sp>
-        <p:nvSpPr>
-          <p:cNvPr id="12" name="s3-task">
-            <a:extLst xmlns:a="http://schemas.openxmlformats.org/drawingml/2006/main">
-              <a:ext uri="{FF2B5EF4-FFF2-40B4-BE49-F238E27FC236}">
-                <a16:creationId xmlns:a16="http://schemas.microsoft.com/office/drawing/2014/main" id="{8D16ACD7-C8C3-4977-8C92-5CC73FFE564B}"/>
-              </a:ext>
-            </a:extLst>
-          </p:cNvPr>
-          <p:cNvSpPr>
-            <a:spLocks xmlns:a="http://schemas.openxmlformats.org/drawingml/2006/main" noGrp="1"/>
-          </p:cNvSpPr>
-          <p:nvPr/>
-        </p:nvSpPr>
-        <p:spPr>
-          <a:xfrm xmlns:a="http://schemas.openxmlformats.org/drawingml/2006/main">
-            <a:off x="9544050" y="2143125"/>
-            <a:ext cx="1809750" cy="1600200"/>
-          </a:xfrm>
-          <a:prstGeom xmlns:a="http://schemas.openxmlformats.org/drawingml/2006/main" prst="roundRect">
-            <a:avLst>
-              <a:gd name="adj" fmla="val 4762"/>
-            </a:avLst>
-          </a:prstGeom>
-          <a:solidFill xmlns:a="http://schemas.openxmlformats.org/drawingml/2006/main">
-            <a:srgbClr val="E9F7F2"/>
-          </a:solidFill>
-          <a:ln xmlns:a="http://schemas.openxmlformats.org/drawingml/2006/main" w="0">
-            <a:solidFill>
-              <a:srgbClr val="E9F7F2"/>
-            </a:solidFill>
-            <a:prstDash val="solid"/>
-          </a:ln>
-        </p:spPr>
-      </p:sp>
-      <p:sp>
-        <p:nvSpPr>
-          <p:cNvPr id="13" name="s3-repo-label">
-            <a:extLst xmlns:a="http://schemas.openxmlformats.org/drawingml/2006/main">
-              <a:ext uri="{FF2B5EF4-FFF2-40B4-BE49-F238E27FC236}">
-                <a16:creationId xmlns:a16="http://schemas.microsoft.com/office/drawing/2014/main" id="{DE66DED8-C4E0-495F-9EA6-E16BAEC49390}"/>
-              </a:ext>
-            </a:extLst>
-          </p:cNvPr>
-          <p:cNvSpPr>
-            <a:spLocks xmlns:a="http://schemas.openxmlformats.org/drawingml/2006/main" noGrp="1"/>
-          </p:cNvSpPr>
-          <p:nvPr/>
-        </p:nvSpPr>
-        <p:spPr>
-          <a:xfrm xmlns:a="http://schemas.openxmlformats.org/drawingml/2006/main">
-            <a:off x="666750" y="2447925"/>
-            <a:ext cx="1466850" cy="285750"/>
-          </a:xfrm>
-          <a:prstGeom xmlns:a="http://schemas.openxmlformats.org/drawingml/2006/main" prst="rect">
-            <a:avLst/>
-          </a:prstGeom>
-        </p:spPr>
-        <p:txBody>
-          <a:bodyPr xmlns:a="http://schemas.openxmlformats.org/drawingml/2006/main" wrap="square" lIns="0" tIns="0" rIns="0" bIns="0" anchor="t">
-            <a:noAutofit/>
-          </a:bodyPr>
-          <a:lstStyle xmlns:a="http://schemas.openxmlformats.org/drawingml/2006/main"/>
-          <a:p xmlns:a="http://schemas.openxmlformats.org/drawingml/2006/main">
-            <a:pPr algn="ctr">
-              <a:defRPr sz="1200" b="1">
-                <a:solidFill>
-                  <a:srgbClr val="526071"/>
-                </a:solidFill>
-                <a:latin typeface="Arial"/>
-                <a:ea typeface="Arial"/>
-                <a:cs typeface="Arial"/>
-              </a:defRPr>
-            </a:pPr>
-            <a:r>
-              <a:t>2D REPOSITORY</a:t>
-            </a:r>
-          </a:p>
-        </p:txBody>
-      </p:sp>
-      <p:sp>
-        <p:nvSpPr>
-          <p:cNvPr id="14" name="s3-repo-main">
-            <a:extLst xmlns:a="http://schemas.openxmlformats.org/drawingml/2006/main">
-              <a:ext uri="{FF2B5EF4-FFF2-40B4-BE49-F238E27FC236}">
-                <a16:creationId xmlns:a16="http://schemas.microsoft.com/office/drawing/2014/main" id="{68158F59-AA4A-4B63-BB04-EEB6328FF700}"/>
-              </a:ext>
-            </a:extLst>
-          </p:cNvPr>
-          <p:cNvSpPr>
-            <a:spLocks xmlns:a="http://schemas.openxmlformats.org/drawingml/2006/main" noGrp="1"/>
-          </p:cNvSpPr>
-          <p:nvPr/>
-        </p:nvSpPr>
-        <p:spPr>
-          <a:xfrm xmlns:a="http://schemas.openxmlformats.org/drawingml/2006/main">
-            <a:off x="723900" y="2943225"/>
-            <a:ext cx="1352550" cy="457200"/>
-          </a:xfrm>
-          <a:prstGeom xmlns:a="http://schemas.openxmlformats.org/drawingml/2006/main" prst="rect">
-            <a:avLst/>
-          </a:prstGeom>
-        </p:spPr>
-        <p:txBody>
-          <a:bodyPr xmlns:a="http://schemas.openxmlformats.org/drawingml/2006/main" wrap="square" lIns="0" tIns="0" rIns="0" bIns="0" anchor="t">
-            <a:noAutofit/>
-          </a:bodyPr>
-          <a:lstStyle xmlns:a="http://schemas.openxmlformats.org/drawingml/2006/main"/>
-          <a:p xmlns:a="http://schemas.openxmlformats.org/drawingml/2006/main">
-            <a:pPr algn="ctr">
-              <a:defRPr sz="1725" b="1">
-                <a:solidFill>
-                  <a:srgbClr val="0A1224"/>
-                </a:solidFill>
-                <a:latin typeface="Arial"/>
-                <a:ea typeface="Arial"/>
-                <a:cs typeface="Arial"/>
-              </a:defRPr>
-            </a:pPr>
-            <a:r>
-              <a:t>Files + symbols</a:t>
-            </a:r>
-          </a:p>
-        </p:txBody>
-      </p:sp>
-      <p:sp>
-        <p:nvSpPr>
-          <p:cNvPr id="15" name="s3-index-label">
-            <a:extLst xmlns:a="http://schemas.openxmlformats.org/drawingml/2006/main">
-              <a:ext uri="{FF2B5EF4-FFF2-40B4-BE49-F238E27FC236}">
-                <a16:creationId xmlns:a16="http://schemas.microsoft.com/office/drawing/2014/main" id="{61C61F4D-AB50-4C8A-A245-D365FFB10584}"/>
-              </a:ext>
-            </a:extLst>
-          </p:cNvPr>
-          <p:cNvSpPr>
-            <a:spLocks xmlns:a="http://schemas.openxmlformats.org/drawingml/2006/main" noGrp="1"/>
-          </p:cNvSpPr>
-          <p:nvPr/>
-        </p:nvSpPr>
-        <p:spPr>
-          <a:xfrm xmlns:a="http://schemas.openxmlformats.org/drawingml/2006/main">
-            <a:off x="3143250" y="2447925"/>
-            <a:ext cx="1085850" cy="285750"/>
-          </a:xfrm>
-          <a:prstGeom xmlns:a="http://schemas.openxmlformats.org/drawingml/2006/main" prst="rect">
-            <a:avLst/>
-          </a:prstGeom>
-        </p:spPr>
-        <p:txBody>
-          <a:bodyPr xmlns:a="http://schemas.openxmlformats.org/drawingml/2006/main" wrap="square" lIns="0" tIns="0" rIns="0" bIns="0" anchor="t">
-            <a:noAutofit/>
-          </a:bodyPr>
-          <a:lstStyle xmlns:a="http://schemas.openxmlformats.org/drawingml/2006/main"/>
-          <a:p xmlns:a="http://schemas.openxmlformats.org/drawingml/2006/main">
-            <a:pPr algn="ctr">
-              <a:defRPr sz="1275" b="1">
-                <a:solidFill>
-                  <a:srgbClr val="13B7D5"/>
-                </a:solidFill>
-                <a:latin typeface="Arial"/>
-                <a:ea typeface="Arial"/>
-                <a:cs typeface="Arial"/>
-              </a:defRPr>
-            </a:pPr>
-            <a:r>
-              <a:t>3D MAP</a:t>
-            </a:r>
-          </a:p>
-        </p:txBody>
-      </p:sp>
-      <p:sp>
-        <p:nvSpPr>
-          <p:cNvPr id="16" name="s3-index-main">
-            <a:extLst xmlns:a="http://schemas.openxmlformats.org/drawingml/2006/main">
-              <a:ext uri="{FF2B5EF4-FFF2-40B4-BE49-F238E27FC236}">
-                <a16:creationId xmlns:a16="http://schemas.microsoft.com/office/drawing/2014/main" id="{80ED80A2-8106-4FBE-B141-772AB77F4A5D}"/>
-              </a:ext>
-            </a:extLst>
-          </p:cNvPr>
-          <p:cNvSpPr>
-            <a:spLocks xmlns:a="http://schemas.openxmlformats.org/drawingml/2006/main" noGrp="1"/>
-          </p:cNvSpPr>
-          <p:nvPr/>
-        </p:nvSpPr>
-        <p:spPr>
-          <a:xfrm xmlns:a="http://schemas.openxmlformats.org/drawingml/2006/main">
-            <a:off x="3105150" y="2943225"/>
-            <a:ext cx="1162050" cy="457200"/>
-          </a:xfrm>
-          <a:prstGeom xmlns:a="http://schemas.openxmlformats.org/drawingml/2006/main" prst="rect">
-            <a:avLst/>
-          </a:prstGeom>
-        </p:spPr>
-        <p:txBody>
-          <a:bodyPr xmlns:a="http://schemas.openxmlformats.org/drawingml/2006/main" wrap="square" lIns="0" tIns="0" rIns="0" bIns="0" anchor="t">
-            <a:noAutofit/>
-          </a:bodyPr>
-          <a:lstStyle xmlns:a="http://schemas.openxmlformats.org/drawingml/2006/main"/>
-          <a:p xmlns:a="http://schemas.openxmlformats.org/drawingml/2006/main">
-            <a:pPr algn="ctr">
-              <a:defRPr sz="1725" b="1">
-                <a:solidFill>
-                  <a:srgbClr val="0A1224"/>
-                </a:solidFill>
-                <a:latin typeface="Arial"/>
-                <a:ea typeface="Arial"/>
-                <a:cs typeface="Arial"/>
-              </a:defRPr>
-            </a:pPr>
-            <a:r>
-              <a:t>Floors + rooms</a:t>
-            </a:r>
-          </a:p>
-        </p:txBody>
-      </p:sp>
-      <p:sp>
-        <p:nvSpPr>
-          <p:cNvPr id="17" name="s3-mode-label">
-            <a:extLst xmlns:a="http://schemas.openxmlformats.org/drawingml/2006/main">
-              <a:ext uri="{FF2B5EF4-FFF2-40B4-BE49-F238E27FC236}">
-                <a16:creationId xmlns:a16="http://schemas.microsoft.com/office/drawing/2014/main" id="{50EC9758-2A1F-4CCC-AFCC-3FE14473EB71}"/>
-              </a:ext>
-            </a:extLst>
-          </p:cNvPr>
-          <p:cNvSpPr>
-            <a:spLocks xmlns:a="http://schemas.openxmlformats.org/drawingml/2006/main" noGrp="1"/>
-          </p:cNvSpPr>
-          <p:nvPr/>
-        </p:nvSpPr>
-        <p:spPr>
-          <a:xfrm xmlns:a="http://schemas.openxmlformats.org/drawingml/2006/main">
-            <a:off x="5334000" y="2447925"/>
-            <a:ext cx="1085850" cy="285750"/>
-          </a:xfrm>
-          <a:prstGeom xmlns:a="http://schemas.openxmlformats.org/drawingml/2006/main" prst="rect">
-            <a:avLst/>
-          </a:prstGeom>
-        </p:spPr>
-        <p:txBody>
-          <a:bodyPr xmlns:a="http://schemas.openxmlformats.org/drawingml/2006/main" wrap="square" lIns="0" tIns="0" rIns="0" bIns="0" anchor="t">
-            <a:noAutofit/>
-          </a:bodyPr>
-          <a:lstStyle xmlns:a="http://schemas.openxmlformats.org/drawingml/2006/main"/>
-          <a:p xmlns:a="http://schemas.openxmlformats.org/drawingml/2006/main">
-            <a:pPr algn="ctr">
-              <a:defRPr sz="1275" b="1">
-                <a:solidFill>
-                  <a:srgbClr val="1677FF"/>
-                </a:solidFill>
-                <a:latin typeface="Arial"/>
-                <a:ea typeface="Arial"/>
-                <a:cs typeface="Arial"/>
-              </a:defRPr>
-            </a:pPr>
-            <a:r>
-              <a:t>ADAPT</a:t>
-            </a:r>
-          </a:p>
-        </p:txBody>
-      </p:sp>
-      <p:sp>
-        <p:nvSpPr>
-          <p:cNvPr id="18" name="s3-mode-main">
-            <a:extLst xmlns:a="http://schemas.openxmlformats.org/drawingml/2006/main">
-              <a:ext uri="{FF2B5EF4-FFF2-40B4-BE49-F238E27FC236}">
-                <a16:creationId xmlns:a16="http://schemas.microsoft.com/office/drawing/2014/main" id="{1141A154-71D2-4D75-BBBC-811FF386FA02}"/>
-              </a:ext>
-            </a:extLst>
-          </p:cNvPr>
-          <p:cNvSpPr>
-            <a:spLocks xmlns:a="http://schemas.openxmlformats.org/drawingml/2006/main" noGrp="1"/>
-          </p:cNvSpPr>
-          <p:nvPr/>
-        </p:nvSpPr>
-        <p:spPr>
-          <a:xfrm xmlns:a="http://schemas.openxmlformats.org/drawingml/2006/main">
-            <a:off x="5295900" y="2943225"/>
-            <a:ext cx="1162050" cy="457200"/>
-          </a:xfrm>
-          <a:prstGeom xmlns:a="http://schemas.openxmlformats.org/drawingml/2006/main" prst="rect">
-            <a:avLst/>
-          </a:prstGeom>
-        </p:spPr>
-        <p:txBody>
-          <a:bodyPr xmlns:a="http://schemas.openxmlformats.org/drawingml/2006/main" wrap="square" lIns="0" tIns="0" rIns="0" bIns="0" anchor="t">
-            <a:noAutofit/>
-          </a:bodyPr>
-          <a:lstStyle xmlns:a="http://schemas.openxmlformats.org/drawingml/2006/main"/>
-          <a:p xmlns:a="http://schemas.openxmlformats.org/drawingml/2006/main">
-            <a:pPr algn="ctr">
-              <a:defRPr sz="1725" b="1">
-                <a:solidFill>
-                  <a:srgbClr val="0A1224"/>
-                </a:solidFill>
-                <a:latin typeface="Arial"/>
-                <a:ea typeface="Arial"/>
-                <a:cs typeface="Arial"/>
-              </a:defRPr>
-            </a:pPr>
-            <a:r>
-              <a:t>Choose mode</a:t>
-            </a:r>
-          </a:p>
-        </p:txBody>
-      </p:sp>
-      <p:sp>
-        <p:nvSpPr>
-          <p:cNvPr id="19" name="s3-pack-label">
-            <a:extLst xmlns:a="http://schemas.openxmlformats.org/drawingml/2006/main">
-              <a:ext uri="{FF2B5EF4-FFF2-40B4-BE49-F238E27FC236}">
-                <a16:creationId xmlns:a16="http://schemas.microsoft.com/office/drawing/2014/main" id="{CC3A3F32-7EEA-4FEA-ABB0-35FC9A1F0B23}"/>
-              </a:ext>
-            </a:extLst>
-          </p:cNvPr>
-          <p:cNvSpPr>
-            <a:spLocks xmlns:a="http://schemas.openxmlformats.org/drawingml/2006/main" noGrp="1"/>
-          </p:cNvSpPr>
-          <p:nvPr/>
-        </p:nvSpPr>
-        <p:spPr>
-          <a:xfrm xmlns:a="http://schemas.openxmlformats.org/drawingml/2006/main">
-            <a:off x="7524750" y="2447925"/>
-            <a:ext cx="1085850" cy="285750"/>
-          </a:xfrm>
-          <a:prstGeom xmlns:a="http://schemas.openxmlformats.org/drawingml/2006/main" prst="rect">
-            <a:avLst/>
-          </a:prstGeom>
-        </p:spPr>
-        <p:txBody>
-          <a:bodyPr xmlns:a="http://schemas.openxmlformats.org/drawingml/2006/main" wrap="square" lIns="0" tIns="0" rIns="0" bIns="0" anchor="t">
-            <a:noAutofit/>
-          </a:bodyPr>
-          <a:lstStyle xmlns:a="http://schemas.openxmlformats.org/drawingml/2006/main"/>
-          <a:p xmlns:a="http://schemas.openxmlformats.org/drawingml/2006/main">
-            <a:pPr algn="ctr">
-              <a:defRPr sz="1275" b="1">
-                <a:solidFill>
-                  <a:srgbClr val="7438F5"/>
-                </a:solidFill>
-                <a:latin typeface="Arial"/>
-                <a:ea typeface="Arial"/>
-                <a:cs typeface="Arial"/>
-              </a:defRPr>
-            </a:pPr>
-            <a:r>
-              <a:t>PACK</a:t>
-            </a:r>
-          </a:p>
-        </p:txBody>
-      </p:sp>
-      <p:sp>
-        <p:nvSpPr>
-          <p:cNvPr id="20" name="s3-pack-main">
-            <a:extLst xmlns:a="http://schemas.openxmlformats.org/drawingml/2006/main">
-              <a:ext uri="{FF2B5EF4-FFF2-40B4-BE49-F238E27FC236}">
-                <a16:creationId xmlns:a16="http://schemas.microsoft.com/office/drawing/2014/main" id="{514BDFEB-EBD4-4270-A5E1-9EC8CDB44BAB}"/>
-              </a:ext>
-            </a:extLst>
-          </p:cNvPr>
-          <p:cNvSpPr>
-            <a:spLocks xmlns:a="http://schemas.openxmlformats.org/drawingml/2006/main" noGrp="1"/>
-          </p:cNvSpPr>
-          <p:nvPr/>
-        </p:nvSpPr>
-        <p:spPr>
-          <a:xfrm xmlns:a="http://schemas.openxmlformats.org/drawingml/2006/main">
-            <a:off x="7477125" y="2857500"/>
-            <a:ext cx="1181100" cy="628650"/>
-          </a:xfrm>
-          <a:prstGeom xmlns:a="http://schemas.openxmlformats.org/drawingml/2006/main" prst="rect">
-            <a:avLst/>
-          </a:prstGeom>
-        </p:spPr>
-        <p:txBody>
-          <a:bodyPr xmlns:a="http://schemas.openxmlformats.org/drawingml/2006/main" wrap="square" lIns="0" tIns="0" rIns="0" bIns="0" anchor="t">
-            <a:noAutofit/>
-          </a:bodyPr>
-          <a:lstStyle xmlns:a="http://schemas.openxmlformats.org/drawingml/2006/main"/>
-          <a:p xmlns:a="http://schemas.openxmlformats.org/drawingml/2006/main">
-            <a:pPr algn="ctr">
-              <a:defRPr sz="1650" b="1">
-                <a:solidFill>
-                  <a:srgbClr val="0A1224"/>
-                </a:solidFill>
-                <a:latin typeface="Arial"/>
-                <a:ea typeface="Arial"/>
-                <a:cs typeface="Arial"/>
-              </a:defRPr>
-            </a:pPr>
-            <a:r>
-              <a:t>Primary + support</a:t>
-            </a:r>
-          </a:p>
-        </p:txBody>
-      </p:sp>
-      <p:sp>
-        <p:nvSpPr>
-          <p:cNvPr id="21" name="s3-task-label">
-            <a:extLst xmlns:a="http://schemas.openxmlformats.org/drawingml/2006/main">
-              <a:ext uri="{FF2B5EF4-FFF2-40B4-BE49-F238E27FC236}">
-                <a16:creationId xmlns:a16="http://schemas.microsoft.com/office/drawing/2014/main" id="{9BA4AB6D-90C4-4A8D-B33E-DF0776097333}"/>
-              </a:ext>
-            </a:extLst>
-          </p:cNvPr>
-          <p:cNvSpPr>
-            <a:spLocks xmlns:a="http://schemas.openxmlformats.org/drawingml/2006/main" noGrp="1"/>
-          </p:cNvSpPr>
-          <p:nvPr/>
-        </p:nvSpPr>
-        <p:spPr>
-          <a:xfrm xmlns:a="http://schemas.openxmlformats.org/drawingml/2006/main">
-            <a:off x="9725025" y="2447925"/>
-            <a:ext cx="1447800" cy="285750"/>
-          </a:xfrm>
-          <a:prstGeom xmlns:a="http://schemas.openxmlformats.org/drawingml/2006/main" prst="rect">
-            <a:avLst/>
-          </a:prstGeom>
-        </p:spPr>
-        <p:txBody>
-          <a:bodyPr xmlns:a="http://schemas.openxmlformats.org/drawingml/2006/main" wrap="square" lIns="0" tIns="0" rIns="0" bIns="0" anchor="t">
-            <a:noAutofit/>
-          </a:bodyPr>
-          <a:lstStyle xmlns:a="http://schemas.openxmlformats.org/drawingml/2006/main"/>
-          <a:p xmlns:a="http://schemas.openxmlformats.org/drawingml/2006/main">
-            <a:pPr algn="ctr">
-              <a:defRPr sz="1275" b="1">
-                <a:solidFill>
-                  <a:srgbClr val="15A777"/>
-                </a:solidFill>
-                <a:latin typeface="Arial"/>
-                <a:ea typeface="Arial"/>
-                <a:cs typeface="Arial"/>
-              </a:defRPr>
-            </a:pPr>
-            <a:r>
-              <a:t>EXECUTE</a:t>
-            </a:r>
-          </a:p>
-        </p:txBody>
-      </p:sp>
-      <p:sp>
-        <p:nvSpPr>
-          <p:cNvPr id="22" name="s3-task-main">
-            <a:extLst xmlns:a="http://schemas.openxmlformats.org/drawingml/2006/main">
-              <a:ext uri="{FF2B5EF4-FFF2-40B4-BE49-F238E27FC236}">
-                <a16:creationId xmlns:a16="http://schemas.microsoft.com/office/drawing/2014/main" id="{ACB93DFB-A28F-45E4-A94B-BAB1B6B6DD2E}"/>
-              </a:ext>
-            </a:extLst>
-          </p:cNvPr>
-          <p:cNvSpPr>
-            <a:spLocks xmlns:a="http://schemas.openxmlformats.org/drawingml/2006/main" noGrp="1"/>
-          </p:cNvSpPr>
-          <p:nvPr/>
-        </p:nvSpPr>
-        <p:spPr>
-          <a:xfrm xmlns:a="http://schemas.openxmlformats.org/drawingml/2006/main">
-            <a:off x="9725025" y="2943225"/>
-            <a:ext cx="1447800" cy="457200"/>
-          </a:xfrm>
-          <a:prstGeom xmlns:a="http://schemas.openxmlformats.org/drawingml/2006/main" prst="rect">
-            <a:avLst/>
-          </a:prstGeom>
-        </p:spPr>
-        <p:txBody>
-          <a:bodyPr xmlns:a="http://schemas.openxmlformats.org/drawingml/2006/main" wrap="square" lIns="0" tIns="0" rIns="0" bIns="0" anchor="t">
-            <a:noAutofit/>
-          </a:bodyPr>
-          <a:lstStyle xmlns:a="http://schemas.openxmlformats.org/drawingml/2006/main"/>
-          <a:p xmlns:a="http://schemas.openxmlformats.org/drawingml/2006/main">
-            <a:pPr algn="ctr">
-              <a:defRPr sz="1725" b="1">
-                <a:solidFill>
-                  <a:srgbClr val="0A1224"/>
-                </a:solidFill>
-                <a:latin typeface="Arial"/>
-                <a:ea typeface="Arial"/>
-                <a:cs typeface="Arial"/>
-              </a:defRPr>
-            </a:pPr>
-            <a:r>
-              <a:t>Focused task</a:t>
-            </a:r>
-          </a:p>
-        </p:txBody>
-      </p:sp>
-      <p:sp>
-        <p:nvSpPr>
-          <p:cNvPr id="23" name="s3-memory">
-            <a:extLst xmlns:a="http://schemas.openxmlformats.org/drawingml/2006/main">
-              <a:ext uri="{FF2B5EF4-FFF2-40B4-BE49-F238E27FC236}">
-                <a16:creationId xmlns:a16="http://schemas.microsoft.com/office/drawing/2014/main" id="{22661A92-B252-4608-BE68-42477823B58A}"/>
-              </a:ext>
-            </a:extLst>
-          </p:cNvPr>
-          <p:cNvSpPr>
-            <a:spLocks xmlns:a="http://schemas.openxmlformats.org/drawingml/2006/main" noGrp="1"/>
-          </p:cNvSpPr>
-          <p:nvPr/>
-        </p:nvSpPr>
-        <p:spPr>
-          <a:xfrm xmlns:a="http://schemas.openxmlformats.org/drawingml/2006/main">
-            <a:off x="6019800" y="4591050"/>
-            <a:ext cx="3714750" cy="1143000"/>
-          </a:xfrm>
-          <a:prstGeom xmlns:a="http://schemas.openxmlformats.org/drawingml/2006/main" prst="roundRect">
-            <a:avLst>
-              <a:gd name="adj" fmla="val 6667"/>
-            </a:avLst>
-          </a:prstGeom>
-          <a:solidFill xmlns:a="http://schemas.openxmlformats.org/drawingml/2006/main">
-            <a:srgbClr val="061B3D"/>
-          </a:solidFill>
-          <a:ln xmlns:a="http://schemas.openxmlformats.org/drawingml/2006/main" w="0">
-            <a:solidFill>
-              <a:srgbClr val="061B3D"/>
-            </a:solidFill>
-            <a:prstDash val="solid"/>
-          </a:ln>
-        </p:spPr>
-      </p:sp>
-      <p:sp>
-        <p:nvSpPr>
-          <p:cNvPr id="24" name="s3-memory-label">
-            <a:extLst xmlns:a="http://schemas.openxmlformats.org/drawingml/2006/main">
-              <a:ext uri="{FF2B5EF4-FFF2-40B4-BE49-F238E27FC236}">
-                <a16:creationId xmlns:a16="http://schemas.microsoft.com/office/drawing/2014/main" id="{38A2F781-4E22-45E9-A836-99B70AAF960C}"/>
-              </a:ext>
-            </a:extLst>
-          </p:cNvPr>
-          <p:cNvSpPr>
-            <a:spLocks xmlns:a="http://schemas.openxmlformats.org/drawingml/2006/main" noGrp="1"/>
-          </p:cNvSpPr>
-          <p:nvPr/>
-        </p:nvSpPr>
-        <p:spPr>
-          <a:xfrm xmlns:a="http://schemas.openxmlformats.org/drawingml/2006/main">
-            <a:off x="6267450" y="4762500"/>
-            <a:ext cx="3219450" cy="247650"/>
-          </a:xfrm>
-          <a:prstGeom xmlns:a="http://schemas.openxmlformats.org/drawingml/2006/main" prst="rect">
-            <a:avLst/>
-          </a:prstGeom>
-        </p:spPr>
-        <p:txBody>
-          <a:bodyPr xmlns:a="http://schemas.openxmlformats.org/drawingml/2006/main" wrap="square" lIns="0" tIns="0" rIns="0" bIns="0" anchor="t">
-            <a:noAutofit/>
-          </a:bodyPr>
-          <a:lstStyle xmlns:a="http://schemas.openxmlformats.org/drawingml/2006/main"/>
-          <a:p xmlns:a="http://schemas.openxmlformats.org/drawingml/2006/main">
-            <a:pPr algn="ctr">
-              <a:defRPr sz="1200" b="1">
-                <a:solidFill>
-                  <a:srgbClr val="13B7D5"/>
-                </a:solidFill>
-                <a:latin typeface="Arial"/>
-                <a:ea typeface="Arial"/>
-                <a:cs typeface="Arial"/>
-              </a:defRPr>
-            </a:pPr>
-            <a:r>
-              <a:t>PITFALL BOARD</a:t>
-            </a:r>
-          </a:p>
-        </p:txBody>
-      </p:sp>
-      <p:sp>
-        <p:nvSpPr>
-          <p:cNvPr id="25" name="s3-memory-main">
-            <a:extLst xmlns:a="http://schemas.openxmlformats.org/drawingml/2006/main">
-              <a:ext uri="{FF2B5EF4-FFF2-40B4-BE49-F238E27FC236}">
-                <a16:creationId xmlns:a16="http://schemas.microsoft.com/office/drawing/2014/main" id="{9176910D-FF8F-47BD-9D19-D6FF55856235}"/>
-              </a:ext>
-            </a:extLst>
-          </p:cNvPr>
-          <p:cNvSpPr>
-            <a:spLocks xmlns:a="http://schemas.openxmlformats.org/drawingml/2006/main" noGrp="1"/>
-          </p:cNvSpPr>
-          <p:nvPr/>
-        </p:nvSpPr>
-        <p:spPr>
-          <a:xfrm xmlns:a="http://schemas.openxmlformats.org/drawingml/2006/main">
-            <a:off x="6267450" y="5143500"/>
-            <a:ext cx="3219450" cy="495300"/>
-          </a:xfrm>
-          <a:prstGeom xmlns:a="http://schemas.openxmlformats.org/drawingml/2006/main" prst="rect">
-            <a:avLst/>
-          </a:prstGeom>
-        </p:spPr>
-        <p:txBody>
-          <a:bodyPr xmlns:a="http://schemas.openxmlformats.org/drawingml/2006/main" wrap="square" lIns="0" tIns="0" rIns="0" bIns="0" anchor="t">
-            <a:noAutofit/>
-          </a:bodyPr>
-          <a:lstStyle xmlns:a="http://schemas.openxmlformats.org/drawingml/2006/main"/>
-          <a:p xmlns:a="http://schemas.openxmlformats.org/drawingml/2006/main">
-            <a:pPr algn="ctr">
-              <a:defRPr sz="1425" b="0">
-                <a:solidFill>
-                  <a:srgbClr val="FFFFFF"/>
-                </a:solidFill>
-                <a:latin typeface="Arial"/>
-                <a:ea typeface="Arial"/>
-                <a:cs typeface="Arial"/>
-              </a:defRPr>
-            </a:pPr>
-            <a:r>
-              <a:t>Relevant mistakes appear at the
-entrance next time.</a:t>
-            </a:r>
-          </a:p>
-        </p:txBody>
-      </p:sp>
-      <p:cxnSp>
-        <p:nvCxnSpPr>
-          <p:cNvPr id="54" name="footer-rule-3"/>
-          <p:cNvCxnSpPr/>
-          <p:nvPr/>
-        </p:nvCxnSpPr>
-        <p:spPr>
-          <a:xfrm xmlns:a="http://schemas.openxmlformats.org/drawingml/2006/main">
-            <a:off x="400050" y="6162675"/>
-            <a:ext cx="11391900" cy="953"/>
+            <a:off x="1428750" y="2886075"/>
+            <a:ext cx="4762500" cy="953"/>
           </a:xfrm>
           <a:prstGeom xmlns:a="http://schemas.openxmlformats.org/drawingml/2006/main" prst="straightConnector1">
             <a:avLst/>
@@ -4494,39 +3633,173 @@
           </a:ln>
         </p:spPr>
       </p:cxnSp>
-      <p:sp>
-        <p:nvSpPr>
-          <p:cNvPr id="27" name="footer-source-3">
-            <a:extLst xmlns:a="http://schemas.openxmlformats.org/drawingml/2006/main">
-              <a:ext uri="{FF2B5EF4-FFF2-40B4-BE49-F238E27FC236}">
-                <a16:creationId xmlns:a16="http://schemas.microsoft.com/office/drawing/2014/main" id="{D36EEE0C-5739-45FB-998D-4F61E564678D}"/>
-              </a:ext>
-            </a:extLst>
-          </p:cNvPr>
-          <p:cNvSpPr>
-            <a:spLocks xmlns:a="http://schemas.openxmlformats.org/drawingml/2006/main" noGrp="1"/>
-          </p:cNvSpPr>
-          <p:nvPr/>
-        </p:nvSpPr>
-        <p:spPr>
-          <a:xfrm xmlns:a="http://schemas.openxmlformats.org/drawingml/2006/main">
-            <a:off x="400050" y="6238875"/>
-            <a:ext cx="10001250" cy="228600"/>
-          </a:xfrm>
-          <a:prstGeom xmlns:a="http://schemas.openxmlformats.org/drawingml/2006/main" prst="rect">
-            <a:avLst/>
-          </a:prstGeom>
-        </p:spPr>
-        <p:txBody>
-          <a:bodyPr xmlns:a="http://schemas.openxmlformats.org/drawingml/2006/main" wrap="square" lIns="0" tIns="0" rIns="0" bIns="0" anchor="t">
-            <a:noAutofit/>
-          </a:bodyPr>
-          <a:lstStyle xmlns:a="http://schemas.openxmlformats.org/drawingml/2006/main"/>
-          <a:p xmlns:a="http://schemas.openxmlformats.org/drawingml/2006/main">
-            <a:pPr algn="l">
-              <a:defRPr sz="863" b="0">
-                <a:solidFill>
-                  <a:srgbClr val="526071"/>
+      <p:cxnSp>
+        <p:nvCxnSpPr>
+          <p:cNvPr id="41" name="s3-rule-y"/>
+          <p:cNvCxnSpPr/>
+          <p:nvPr/>
+        </p:nvCxnSpPr>
+        <p:spPr>
+          <a:xfrm xmlns:a="http://schemas.openxmlformats.org/drawingml/2006/main">
+            <a:off x="1428750" y="4076700"/>
+            <a:ext cx="4762500" cy="953"/>
+          </a:xfrm>
+          <a:prstGeom xmlns:a="http://schemas.openxmlformats.org/drawingml/2006/main" prst="straightConnector1">
+            <a:avLst/>
+          </a:prstGeom>
+          <a:ln xmlns:a="http://schemas.openxmlformats.org/drawingml/2006/main" w="9525">
+            <a:solidFill>
+              <a:srgbClr val="B8BCC4"/>
+            </a:solidFill>
+            <a:prstDash val="solid"/>
+          </a:ln>
+        </p:spPr>
+      </p:cxnSp>
+      <p:sp>
+        <p:nvSpPr>
+          <p:cNvPr id="5" name="s3-address-panel">
+            <a:extLst xmlns:a="http://schemas.openxmlformats.org/drawingml/2006/main">
+              <a:ext uri="{FF2B5EF4-FFF2-40B4-BE49-F238E27FC236}">
+                <a16:creationId xmlns:a16="http://schemas.microsoft.com/office/drawing/2014/main" id="{05A16BC2-9449-4688-BBB9-EA4E3E286293}"/>
+              </a:ext>
+            </a:extLst>
+          </p:cNvPr>
+          <p:cNvSpPr>
+            <a:spLocks xmlns:a="http://schemas.openxmlformats.org/drawingml/2006/main" noGrp="1"/>
+          </p:cNvSpPr>
+          <p:nvPr/>
+        </p:nvSpPr>
+        <p:spPr>
+          <a:xfrm xmlns:a="http://schemas.openxmlformats.org/drawingml/2006/main">
+            <a:off x="6858000" y="1809750"/>
+            <a:ext cx="4762500" cy="3238500"/>
+          </a:xfrm>
+          <a:prstGeom xmlns:a="http://schemas.openxmlformats.org/drawingml/2006/main" prst="roundRect">
+            <a:avLst>
+              <a:gd name="adj" fmla="val 2353"/>
+            </a:avLst>
+          </a:prstGeom>
+          <a:solidFill xmlns:a="http://schemas.openxmlformats.org/drawingml/2006/main">
+            <a:srgbClr val="061B3D"/>
+          </a:solidFill>
+          <a:ln xmlns:a="http://schemas.openxmlformats.org/drawingml/2006/main" w="9525">
+            <a:solidFill>
+              <a:srgbClr val="0B2B56"/>
+            </a:solidFill>
+            <a:prstDash val="solid"/>
+          </a:ln>
+        </p:spPr>
+      </p:sp>
+      <p:cxnSp>
+        <p:nvCxnSpPr>
+          <p:cNvPr id="43" name="s3-address-rule-1"/>
+          <p:cNvCxnSpPr/>
+          <p:nvPr/>
+        </p:nvCxnSpPr>
+        <p:spPr>
+          <a:xfrm xmlns:a="http://schemas.openxmlformats.org/drawingml/2006/main">
+            <a:off x="7219950" y="2476500"/>
+            <a:ext cx="4038600" cy="953"/>
+          </a:xfrm>
+          <a:prstGeom xmlns:a="http://schemas.openxmlformats.org/drawingml/2006/main" prst="straightConnector1">
+            <a:avLst/>
+          </a:prstGeom>
+          <a:ln xmlns:a="http://schemas.openxmlformats.org/drawingml/2006/main" w="9525">
+            <a:solidFill>
+              <a:srgbClr val="24466F"/>
+            </a:solidFill>
+            <a:prstDash val="solid"/>
+          </a:ln>
+        </p:spPr>
+      </p:cxnSp>
+      <p:cxnSp>
+        <p:nvCxnSpPr>
+          <p:cNvPr id="44" name="s3-address-rule-2"/>
+          <p:cNvCxnSpPr/>
+          <p:nvPr/>
+        </p:nvCxnSpPr>
+        <p:spPr>
+          <a:xfrm xmlns:a="http://schemas.openxmlformats.org/drawingml/2006/main">
+            <a:off x="7219950" y="4267200"/>
+            <a:ext cx="4038600" cy="953"/>
+          </a:xfrm>
+          <a:prstGeom xmlns:a="http://schemas.openxmlformats.org/drawingml/2006/main" prst="straightConnector1">
+            <a:avLst/>
+          </a:prstGeom>
+          <a:ln xmlns:a="http://schemas.openxmlformats.org/drawingml/2006/main" w="9525">
+            <a:solidFill>
+              <a:srgbClr val="24466F"/>
+            </a:solidFill>
+            <a:prstDash val="solid"/>
+          </a:ln>
+        </p:spPr>
+      </p:cxnSp>
+      <p:sp>
+        <p:nvSpPr>
+          <p:cNvPr id="8" name="s3-x">
+            <a:extLst xmlns:a="http://schemas.openxmlformats.org/drawingml/2006/main">
+              <a:ext uri="{FF2B5EF4-FFF2-40B4-BE49-F238E27FC236}">
+                <a16:creationId xmlns:a16="http://schemas.microsoft.com/office/drawing/2014/main" id="{CDB9D831-FEBE-4300-A416-5EE874F0BFA9}"/>
+              </a:ext>
+            </a:extLst>
+          </p:cNvPr>
+          <p:cNvSpPr>
+            <a:spLocks xmlns:a="http://schemas.openxmlformats.org/drawingml/2006/main" noGrp="1"/>
+          </p:cNvSpPr>
+          <p:nvPr/>
+        </p:nvSpPr>
+        <p:spPr>
+          <a:xfrm xmlns:a="http://schemas.openxmlformats.org/drawingml/2006/main">
+            <a:off x="666750" y="2000250"/>
+            <a:ext cx="533400" cy="533400"/>
+          </a:xfrm>
+          <a:prstGeom xmlns:a="http://schemas.openxmlformats.org/drawingml/2006/main" prst="ellipse">
+            <a:avLst/>
+          </a:prstGeom>
+          <a:solidFill xmlns:a="http://schemas.openxmlformats.org/drawingml/2006/main">
+            <a:srgbClr val="13B7D5"/>
+          </a:solidFill>
+          <a:ln xmlns:a="http://schemas.openxmlformats.org/drawingml/2006/main" w="0">
+            <a:solidFill>
+              <a:srgbClr val="13B7D5"/>
+            </a:solidFill>
+            <a:prstDash val="solid"/>
+          </a:ln>
+        </p:spPr>
+      </p:sp>
+      <p:sp>
+        <p:nvSpPr>
+          <p:cNvPr id="9" name="s3-x-letter">
+            <a:extLst xmlns:a="http://schemas.openxmlformats.org/drawingml/2006/main">
+              <a:ext uri="{FF2B5EF4-FFF2-40B4-BE49-F238E27FC236}">
+                <a16:creationId xmlns:a16="http://schemas.microsoft.com/office/drawing/2014/main" id="{FA717173-24A2-4E68-97D0-609C23492D67}"/>
+              </a:ext>
+            </a:extLst>
+          </p:cNvPr>
+          <p:cNvSpPr>
+            <a:spLocks xmlns:a="http://schemas.openxmlformats.org/drawingml/2006/main" noGrp="1"/>
+          </p:cNvSpPr>
+          <p:nvPr/>
+        </p:nvSpPr>
+        <p:spPr>
+          <a:xfrm xmlns:a="http://schemas.openxmlformats.org/drawingml/2006/main">
+            <a:off x="666750" y="2114550"/>
+            <a:ext cx="533400" cy="304800"/>
+          </a:xfrm>
+          <a:prstGeom xmlns:a="http://schemas.openxmlformats.org/drawingml/2006/main" prst="rect">
+            <a:avLst/>
+          </a:prstGeom>
+        </p:spPr>
+        <p:txBody>
+          <a:bodyPr xmlns:a="http://schemas.openxmlformats.org/drawingml/2006/main" wrap="square" lIns="0" tIns="0" rIns="0" bIns="0" anchor="t">
+            <a:noAutofit/>
+          </a:bodyPr>
+          <a:lstStyle xmlns:a="http://schemas.openxmlformats.org/drawingml/2006/main"/>
+          <a:p xmlns:a="http://schemas.openxmlformats.org/drawingml/2006/main">
+            <a:pPr algn="ctr">
+              <a:defRPr sz="1875" b="1">
+                <a:solidFill>
+                  <a:srgbClr val="FFFFFF"/>
                 </a:solidFill>
                 <a:latin typeface="Arial"/>
                 <a:ea typeface="Arial"/>
@@ -4534,44 +3807,44 @@
               </a:defRPr>
             </a:pPr>
             <a:r>
-              <a:t/>
-            </a:r>
-          </a:p>
-        </p:txBody>
-      </p:sp>
-      <p:sp>
-        <p:nvSpPr>
-          <p:cNvPr id="28" name="footer-number-3">
-            <a:extLst xmlns:a="http://schemas.openxmlformats.org/drawingml/2006/main">
-              <a:ext uri="{FF2B5EF4-FFF2-40B4-BE49-F238E27FC236}">
-                <a16:creationId xmlns:a16="http://schemas.microsoft.com/office/drawing/2014/main" id="{FF2E9AEF-FEBB-42E0-B537-B71C9B502CB6}"/>
-              </a:ext>
-            </a:extLst>
-          </p:cNvPr>
-          <p:cNvSpPr>
-            <a:spLocks xmlns:a="http://schemas.openxmlformats.org/drawingml/2006/main" noGrp="1"/>
-          </p:cNvSpPr>
-          <p:nvPr/>
-        </p:nvSpPr>
-        <p:spPr>
-          <a:xfrm xmlns:a="http://schemas.openxmlformats.org/drawingml/2006/main">
-            <a:off x="11258550" y="6238875"/>
-            <a:ext cx="533400" cy="228600"/>
-          </a:xfrm>
-          <a:prstGeom xmlns:a="http://schemas.openxmlformats.org/drawingml/2006/main" prst="rect">
-            <a:avLst/>
-          </a:prstGeom>
-        </p:spPr>
-        <p:txBody>
-          <a:bodyPr xmlns:a="http://schemas.openxmlformats.org/drawingml/2006/main" wrap="square" lIns="0" tIns="0" rIns="0" bIns="0" anchor="t">
-            <a:noAutofit/>
-          </a:bodyPr>
-          <a:lstStyle xmlns:a="http://schemas.openxmlformats.org/drawingml/2006/main"/>
-          <a:p xmlns:a="http://schemas.openxmlformats.org/drawingml/2006/main">
-            <a:pPr algn="r">
-              <a:defRPr sz="900" b="0">
-                <a:solidFill>
-                  <a:srgbClr val="526071"/>
+              <a:t>X</a:t>
+            </a:r>
+          </a:p>
+        </p:txBody>
+      </p:sp>
+      <p:sp>
+        <p:nvSpPr>
+          <p:cNvPr id="10" name="s3-x-label">
+            <a:extLst xmlns:a="http://schemas.openxmlformats.org/drawingml/2006/main">
+              <a:ext uri="{FF2B5EF4-FFF2-40B4-BE49-F238E27FC236}">
+                <a16:creationId xmlns:a16="http://schemas.microsoft.com/office/drawing/2014/main" id="{E9B76430-4E2E-473E-AE4B-EB7DBF0BAF07}"/>
+              </a:ext>
+            </a:extLst>
+          </p:cNvPr>
+          <p:cNvSpPr>
+            <a:spLocks xmlns:a="http://schemas.openxmlformats.org/drawingml/2006/main" noGrp="1"/>
+          </p:cNvSpPr>
+          <p:nvPr/>
+        </p:nvSpPr>
+        <p:spPr>
+          <a:xfrm xmlns:a="http://schemas.openxmlformats.org/drawingml/2006/main">
+            <a:off x="1428750" y="1933575"/>
+            <a:ext cx="4762500" cy="247650"/>
+          </a:xfrm>
+          <a:prstGeom xmlns:a="http://schemas.openxmlformats.org/drawingml/2006/main" prst="rect">
+            <a:avLst/>
+          </a:prstGeom>
+        </p:spPr>
+        <p:txBody>
+          <a:bodyPr xmlns:a="http://schemas.openxmlformats.org/drawingml/2006/main" wrap="square" lIns="0" tIns="0" rIns="0" bIns="0" anchor="t">
+            <a:noAutofit/>
+          </a:bodyPr>
+          <a:lstStyle xmlns:a="http://schemas.openxmlformats.org/drawingml/2006/main"/>
+          <a:p xmlns:a="http://schemas.openxmlformats.org/drawingml/2006/main">
+            <a:pPr algn="l">
+              <a:defRPr sz="1275" b="1">
+                <a:solidFill>
+                  <a:srgbClr val="13B7D5"/>
                 </a:solidFill>
                 <a:latin typeface="Arial"/>
                 <a:ea typeface="Arial"/>
@@ -4579,6 +3852,1174 @@
               </a:defRPr>
             </a:pPr>
             <a:r>
+              <a:t>X / DOMAIN OR MODULE</a:t>
+            </a:r>
+          </a:p>
+        </p:txBody>
+      </p:sp>
+      <p:sp>
+        <p:nvSpPr>
+          <p:cNvPr id="11" name="s3-x-main">
+            <a:extLst xmlns:a="http://schemas.openxmlformats.org/drawingml/2006/main">
+              <a:ext uri="{FF2B5EF4-FFF2-40B4-BE49-F238E27FC236}">
+                <a16:creationId xmlns:a16="http://schemas.microsoft.com/office/drawing/2014/main" id="{5DA85545-8411-46C7-8B84-19E542478B24}"/>
+              </a:ext>
+            </a:extLst>
+          </p:cNvPr>
+          <p:cNvSpPr>
+            <a:spLocks xmlns:a="http://schemas.openxmlformats.org/drawingml/2006/main" noGrp="1"/>
+          </p:cNvSpPr>
+          <p:nvPr/>
+        </p:nvSpPr>
+        <p:spPr>
+          <a:xfrm xmlns:a="http://schemas.openxmlformats.org/drawingml/2006/main">
+            <a:off x="1428750" y="2238375"/>
+            <a:ext cx="4762500" cy="342900"/>
+          </a:xfrm>
+          <a:prstGeom xmlns:a="http://schemas.openxmlformats.org/drawingml/2006/main" prst="rect">
+            <a:avLst/>
+          </a:prstGeom>
+        </p:spPr>
+        <p:txBody>
+          <a:bodyPr xmlns:a="http://schemas.openxmlformats.org/drawingml/2006/main" wrap="square" lIns="0" tIns="0" rIns="0" bIns="0" anchor="t">
+            <a:noAutofit/>
+          </a:bodyPr>
+          <a:lstStyle xmlns:a="http://schemas.openxmlformats.org/drawingml/2006/main"/>
+          <a:p xmlns:a="http://schemas.openxmlformats.org/drawingml/2006/main">
+            <a:pPr algn="l">
+              <a:defRPr sz="1875" b="1">
+                <a:solidFill>
+                  <a:srgbClr val="0A1224"/>
+                </a:solidFill>
+                <a:latin typeface="Consolas"/>
+                <a:ea typeface="Consolas"/>
+                <a:cs typeface="Consolas"/>
+              </a:defRPr>
+            </a:pPr>
+            <a:r>
+              <a:t>auth  /  checkout  /  blog</a:t>
+            </a:r>
+          </a:p>
+        </p:txBody>
+      </p:sp>
+      <p:sp>
+        <p:nvSpPr>
+          <p:cNvPr id="12" name="s3-x-question">
+            <a:extLst xmlns:a="http://schemas.openxmlformats.org/drawingml/2006/main">
+              <a:ext uri="{FF2B5EF4-FFF2-40B4-BE49-F238E27FC236}">
+                <a16:creationId xmlns:a16="http://schemas.microsoft.com/office/drawing/2014/main" id="{7F610FBC-1AA5-4D68-B967-97F444729BF2}"/>
+              </a:ext>
+            </a:extLst>
+          </p:cNvPr>
+          <p:cNvSpPr>
+            <a:spLocks xmlns:a="http://schemas.openxmlformats.org/drawingml/2006/main" noGrp="1"/>
+          </p:cNvSpPr>
+          <p:nvPr/>
+        </p:nvSpPr>
+        <p:spPr>
+          <a:xfrm xmlns:a="http://schemas.openxmlformats.org/drawingml/2006/main">
+            <a:off x="1428750" y="2609850"/>
+            <a:ext cx="4762500" cy="228600"/>
+          </a:xfrm>
+          <a:prstGeom xmlns:a="http://schemas.openxmlformats.org/drawingml/2006/main" prst="rect">
+            <a:avLst/>
+          </a:prstGeom>
+        </p:spPr>
+        <p:txBody>
+          <a:bodyPr xmlns:a="http://schemas.openxmlformats.org/drawingml/2006/main" wrap="square" lIns="0" tIns="0" rIns="0" bIns="0" anchor="t">
+            <a:noAutofit/>
+          </a:bodyPr>
+          <a:lstStyle xmlns:a="http://schemas.openxmlformats.org/drawingml/2006/main"/>
+          <a:p xmlns:a="http://schemas.openxmlformats.org/drawingml/2006/main">
+            <a:pPr algn="l">
+              <a:defRPr sz="1200" b="0">
+                <a:solidFill>
+                  <a:srgbClr val="526071"/>
+                </a:solidFill>
+                <a:latin typeface="Arial"/>
+                <a:ea typeface="Arial"/>
+                <a:cs typeface="Arial"/>
+              </a:defRPr>
+            </a:pPr>
+            <a:r>
+              <a:t>Which product area?</a:t>
+            </a:r>
+          </a:p>
+        </p:txBody>
+      </p:sp>
+      <p:sp>
+        <p:nvSpPr>
+          <p:cNvPr id="13" name="s3-y">
+            <a:extLst xmlns:a="http://schemas.openxmlformats.org/drawingml/2006/main">
+              <a:ext uri="{FF2B5EF4-FFF2-40B4-BE49-F238E27FC236}">
+                <a16:creationId xmlns:a16="http://schemas.microsoft.com/office/drawing/2014/main" id="{E26DE3E6-E5F1-45F3-A426-636174F88DF8}"/>
+              </a:ext>
+            </a:extLst>
+          </p:cNvPr>
+          <p:cNvSpPr>
+            <a:spLocks xmlns:a="http://schemas.openxmlformats.org/drawingml/2006/main" noGrp="1"/>
+          </p:cNvSpPr>
+          <p:nvPr/>
+        </p:nvSpPr>
+        <p:spPr>
+          <a:xfrm xmlns:a="http://schemas.openxmlformats.org/drawingml/2006/main">
+            <a:off x="666750" y="3190875"/>
+            <a:ext cx="533400" cy="533400"/>
+          </a:xfrm>
+          <a:prstGeom xmlns:a="http://schemas.openxmlformats.org/drawingml/2006/main" prst="ellipse">
+            <a:avLst/>
+          </a:prstGeom>
+          <a:solidFill xmlns:a="http://schemas.openxmlformats.org/drawingml/2006/main">
+            <a:srgbClr val="1677FF"/>
+          </a:solidFill>
+          <a:ln xmlns:a="http://schemas.openxmlformats.org/drawingml/2006/main" w="0">
+            <a:solidFill>
+              <a:srgbClr val="1677FF"/>
+            </a:solidFill>
+            <a:prstDash val="solid"/>
+          </a:ln>
+        </p:spPr>
+      </p:sp>
+      <p:sp>
+        <p:nvSpPr>
+          <p:cNvPr id="14" name="s3-y-letter">
+            <a:extLst xmlns:a="http://schemas.openxmlformats.org/drawingml/2006/main">
+              <a:ext uri="{FF2B5EF4-FFF2-40B4-BE49-F238E27FC236}">
+                <a16:creationId xmlns:a16="http://schemas.microsoft.com/office/drawing/2014/main" id="{C70A5603-7E90-49F2-BAB3-AF67E7613771}"/>
+              </a:ext>
+            </a:extLst>
+          </p:cNvPr>
+          <p:cNvSpPr>
+            <a:spLocks xmlns:a="http://schemas.openxmlformats.org/drawingml/2006/main" noGrp="1"/>
+          </p:cNvSpPr>
+          <p:nvPr/>
+        </p:nvSpPr>
+        <p:spPr>
+          <a:xfrm xmlns:a="http://schemas.openxmlformats.org/drawingml/2006/main">
+            <a:off x="666750" y="3305175"/>
+            <a:ext cx="533400" cy="304800"/>
+          </a:xfrm>
+          <a:prstGeom xmlns:a="http://schemas.openxmlformats.org/drawingml/2006/main" prst="rect">
+            <a:avLst/>
+          </a:prstGeom>
+        </p:spPr>
+        <p:txBody>
+          <a:bodyPr xmlns:a="http://schemas.openxmlformats.org/drawingml/2006/main" wrap="square" lIns="0" tIns="0" rIns="0" bIns="0" anchor="t">
+            <a:noAutofit/>
+          </a:bodyPr>
+          <a:lstStyle xmlns:a="http://schemas.openxmlformats.org/drawingml/2006/main"/>
+          <a:p xmlns:a="http://schemas.openxmlformats.org/drawingml/2006/main">
+            <a:pPr algn="ctr">
+              <a:defRPr sz="1875" b="1">
+                <a:solidFill>
+                  <a:srgbClr val="FFFFFF"/>
+                </a:solidFill>
+                <a:latin typeface="Arial"/>
+                <a:ea typeface="Arial"/>
+                <a:cs typeface="Arial"/>
+              </a:defRPr>
+            </a:pPr>
+            <a:r>
+              <a:t>Y</a:t>
+            </a:r>
+          </a:p>
+        </p:txBody>
+      </p:sp>
+      <p:sp>
+        <p:nvSpPr>
+          <p:cNvPr id="15" name="s3-y-label">
+            <a:extLst xmlns:a="http://schemas.openxmlformats.org/drawingml/2006/main">
+              <a:ext uri="{FF2B5EF4-FFF2-40B4-BE49-F238E27FC236}">
+                <a16:creationId xmlns:a16="http://schemas.microsoft.com/office/drawing/2014/main" id="{00C3F9E7-92D9-42F7-BA11-E8DE82838A76}"/>
+              </a:ext>
+            </a:extLst>
+          </p:cNvPr>
+          <p:cNvSpPr>
+            <a:spLocks xmlns:a="http://schemas.openxmlformats.org/drawingml/2006/main" noGrp="1"/>
+          </p:cNvSpPr>
+          <p:nvPr/>
+        </p:nvSpPr>
+        <p:spPr>
+          <a:xfrm xmlns:a="http://schemas.openxmlformats.org/drawingml/2006/main">
+            <a:off x="1428750" y="3124200"/>
+            <a:ext cx="4762500" cy="247650"/>
+          </a:xfrm>
+          <a:prstGeom xmlns:a="http://schemas.openxmlformats.org/drawingml/2006/main" prst="rect">
+            <a:avLst/>
+          </a:prstGeom>
+        </p:spPr>
+        <p:txBody>
+          <a:bodyPr xmlns:a="http://schemas.openxmlformats.org/drawingml/2006/main" wrap="square" lIns="0" tIns="0" rIns="0" bIns="0" anchor="t">
+            <a:noAutofit/>
+          </a:bodyPr>
+          <a:lstStyle xmlns:a="http://schemas.openxmlformats.org/drawingml/2006/main"/>
+          <a:p xmlns:a="http://schemas.openxmlformats.org/drawingml/2006/main">
+            <a:pPr algn="l">
+              <a:defRPr sz="1275" b="1">
+                <a:solidFill>
+                  <a:srgbClr val="1677FF"/>
+                </a:solidFill>
+                <a:latin typeface="Arial"/>
+                <a:ea typeface="Arial"/>
+                <a:cs typeface="Arial"/>
+              </a:defRPr>
+            </a:pPr>
+            <a:r>
+              <a:t>Y / ARCHITECTURE FLOOR</a:t>
+            </a:r>
+          </a:p>
+        </p:txBody>
+      </p:sp>
+      <p:sp>
+        <p:nvSpPr>
+          <p:cNvPr id="16" name="s3-y-main">
+            <a:extLst xmlns:a="http://schemas.openxmlformats.org/drawingml/2006/main">
+              <a:ext uri="{FF2B5EF4-FFF2-40B4-BE49-F238E27FC236}">
+                <a16:creationId xmlns:a16="http://schemas.microsoft.com/office/drawing/2014/main" id="{59B3D219-1F76-45B8-94EB-83CB2DDE2744}"/>
+              </a:ext>
+            </a:extLst>
+          </p:cNvPr>
+          <p:cNvSpPr>
+            <a:spLocks xmlns:a="http://schemas.openxmlformats.org/drawingml/2006/main" noGrp="1"/>
+          </p:cNvSpPr>
+          <p:nvPr/>
+        </p:nvSpPr>
+        <p:spPr>
+          <a:xfrm xmlns:a="http://schemas.openxmlformats.org/drawingml/2006/main">
+            <a:off x="1428750" y="3429000"/>
+            <a:ext cx="4762500" cy="323850"/>
+          </a:xfrm>
+          <a:prstGeom xmlns:a="http://schemas.openxmlformats.org/drawingml/2006/main" prst="rect">
+            <a:avLst/>
+          </a:prstGeom>
+        </p:spPr>
+        <p:txBody>
+          <a:bodyPr xmlns:a="http://schemas.openxmlformats.org/drawingml/2006/main" wrap="square" lIns="0" tIns="0" rIns="0" bIns="0" anchor="t">
+            <a:noAutofit/>
+          </a:bodyPr>
+          <a:lstStyle xmlns:a="http://schemas.openxmlformats.org/drawingml/2006/main"/>
+          <a:p xmlns:a="http://schemas.openxmlformats.org/drawingml/2006/main">
+            <a:pPr algn="l">
+              <a:defRPr sz="1575" b="1">
+                <a:solidFill>
+                  <a:srgbClr val="0A1224"/>
+                </a:solidFill>
+                <a:latin typeface="Consolas"/>
+                <a:ea typeface="Consolas"/>
+                <a:cs typeface="Consolas"/>
+              </a:defRPr>
+            </a:pPr>
+            <a:r>
+              <a:t>interface  /  implementation  /  data</a:t>
+            </a:r>
+          </a:p>
+        </p:txBody>
+      </p:sp>
+      <p:sp>
+        <p:nvSpPr>
+          <p:cNvPr id="17" name="s3-y-question">
+            <a:extLst xmlns:a="http://schemas.openxmlformats.org/drawingml/2006/main">
+              <a:ext uri="{FF2B5EF4-FFF2-40B4-BE49-F238E27FC236}">
+                <a16:creationId xmlns:a16="http://schemas.microsoft.com/office/drawing/2014/main" id="{206957FA-86D2-491C-B7E3-0B8C16307D59}"/>
+              </a:ext>
+            </a:extLst>
+          </p:cNvPr>
+          <p:cNvSpPr>
+            <a:spLocks xmlns:a="http://schemas.openxmlformats.org/drawingml/2006/main" noGrp="1"/>
+          </p:cNvSpPr>
+          <p:nvPr/>
+        </p:nvSpPr>
+        <p:spPr>
+          <a:xfrm xmlns:a="http://schemas.openxmlformats.org/drawingml/2006/main">
+            <a:off x="1428750" y="3800475"/>
+            <a:ext cx="4762500" cy="228600"/>
+          </a:xfrm>
+          <a:prstGeom xmlns:a="http://schemas.openxmlformats.org/drawingml/2006/main" prst="rect">
+            <a:avLst/>
+          </a:prstGeom>
+        </p:spPr>
+        <p:txBody>
+          <a:bodyPr xmlns:a="http://schemas.openxmlformats.org/drawingml/2006/main" wrap="square" lIns="0" tIns="0" rIns="0" bIns="0" anchor="t">
+            <a:noAutofit/>
+          </a:bodyPr>
+          <a:lstStyle xmlns:a="http://schemas.openxmlformats.org/drawingml/2006/main"/>
+          <a:p xmlns:a="http://schemas.openxmlformats.org/drawingml/2006/main">
+            <a:pPr algn="l">
+              <a:defRPr sz="1200" b="0">
+                <a:solidFill>
+                  <a:srgbClr val="526071"/>
+                </a:solidFill>
+                <a:latin typeface="Arial"/>
+                <a:ea typeface="Arial"/>
+                <a:cs typeface="Arial"/>
+              </a:defRPr>
+            </a:pPr>
+            <a:r>
+              <a:t>Which responsibility layer?</a:t>
+            </a:r>
+          </a:p>
+        </p:txBody>
+      </p:sp>
+      <p:sp>
+        <p:nvSpPr>
+          <p:cNvPr id="18" name="s3-z">
+            <a:extLst xmlns:a="http://schemas.openxmlformats.org/drawingml/2006/main">
+              <a:ext uri="{FF2B5EF4-FFF2-40B4-BE49-F238E27FC236}">
+                <a16:creationId xmlns:a16="http://schemas.microsoft.com/office/drawing/2014/main" id="{9AAF1B90-6BE1-4582-8168-A31444E516F0}"/>
+              </a:ext>
+            </a:extLst>
+          </p:cNvPr>
+          <p:cNvSpPr>
+            <a:spLocks xmlns:a="http://schemas.openxmlformats.org/drawingml/2006/main" noGrp="1"/>
+          </p:cNvSpPr>
+          <p:nvPr/>
+        </p:nvSpPr>
+        <p:spPr>
+          <a:xfrm xmlns:a="http://schemas.openxmlformats.org/drawingml/2006/main">
+            <a:off x="666750" y="4381500"/>
+            <a:ext cx="533400" cy="533400"/>
+          </a:xfrm>
+          <a:prstGeom xmlns:a="http://schemas.openxmlformats.org/drawingml/2006/main" prst="ellipse">
+            <a:avLst/>
+          </a:prstGeom>
+          <a:solidFill xmlns:a="http://schemas.openxmlformats.org/drawingml/2006/main">
+            <a:srgbClr val="7438F5"/>
+          </a:solidFill>
+          <a:ln xmlns:a="http://schemas.openxmlformats.org/drawingml/2006/main" w="0">
+            <a:solidFill>
+              <a:srgbClr val="7438F5"/>
+            </a:solidFill>
+            <a:prstDash val="solid"/>
+          </a:ln>
+        </p:spPr>
+      </p:sp>
+      <p:sp>
+        <p:nvSpPr>
+          <p:cNvPr id="19" name="s3-z-letter">
+            <a:extLst xmlns:a="http://schemas.openxmlformats.org/drawingml/2006/main">
+              <a:ext uri="{FF2B5EF4-FFF2-40B4-BE49-F238E27FC236}">
+                <a16:creationId xmlns:a16="http://schemas.microsoft.com/office/drawing/2014/main" id="{C9AF575A-471D-4091-8622-1767B8A1B51E}"/>
+              </a:ext>
+            </a:extLst>
+          </p:cNvPr>
+          <p:cNvSpPr>
+            <a:spLocks xmlns:a="http://schemas.openxmlformats.org/drawingml/2006/main" noGrp="1"/>
+          </p:cNvSpPr>
+          <p:nvPr/>
+        </p:nvSpPr>
+        <p:spPr>
+          <a:xfrm xmlns:a="http://schemas.openxmlformats.org/drawingml/2006/main">
+            <a:off x="666750" y="4495800"/>
+            <a:ext cx="533400" cy="304800"/>
+          </a:xfrm>
+          <a:prstGeom xmlns:a="http://schemas.openxmlformats.org/drawingml/2006/main" prst="rect">
+            <a:avLst/>
+          </a:prstGeom>
+        </p:spPr>
+        <p:txBody>
+          <a:bodyPr xmlns:a="http://schemas.openxmlformats.org/drawingml/2006/main" wrap="square" lIns="0" tIns="0" rIns="0" bIns="0" anchor="t">
+            <a:noAutofit/>
+          </a:bodyPr>
+          <a:lstStyle xmlns:a="http://schemas.openxmlformats.org/drawingml/2006/main"/>
+          <a:p xmlns:a="http://schemas.openxmlformats.org/drawingml/2006/main">
+            <a:pPr algn="ctr">
+              <a:defRPr sz="1875" b="1">
+                <a:solidFill>
+                  <a:srgbClr val="FFFFFF"/>
+                </a:solidFill>
+                <a:latin typeface="Arial"/>
+                <a:ea typeface="Arial"/>
+                <a:cs typeface="Arial"/>
+              </a:defRPr>
+            </a:pPr>
+            <a:r>
+              <a:t>Z</a:t>
+            </a:r>
+          </a:p>
+        </p:txBody>
+      </p:sp>
+      <p:sp>
+        <p:nvSpPr>
+          <p:cNvPr id="20" name="s3-z-label">
+            <a:extLst xmlns:a="http://schemas.openxmlformats.org/drawingml/2006/main">
+              <a:ext uri="{FF2B5EF4-FFF2-40B4-BE49-F238E27FC236}">
+                <a16:creationId xmlns:a16="http://schemas.microsoft.com/office/drawing/2014/main" id="{37C1AF48-C7AA-4752-AE7D-66D80FA4C792}"/>
+              </a:ext>
+            </a:extLst>
+          </p:cNvPr>
+          <p:cNvSpPr>
+            <a:spLocks xmlns:a="http://schemas.openxmlformats.org/drawingml/2006/main" noGrp="1"/>
+          </p:cNvSpPr>
+          <p:nvPr/>
+        </p:nvSpPr>
+        <p:spPr>
+          <a:xfrm xmlns:a="http://schemas.openxmlformats.org/drawingml/2006/main">
+            <a:off x="1428750" y="4314825"/>
+            <a:ext cx="4762500" cy="247650"/>
+          </a:xfrm>
+          <a:prstGeom xmlns:a="http://schemas.openxmlformats.org/drawingml/2006/main" prst="rect">
+            <a:avLst/>
+          </a:prstGeom>
+        </p:spPr>
+        <p:txBody>
+          <a:bodyPr xmlns:a="http://schemas.openxmlformats.org/drawingml/2006/main" wrap="square" lIns="0" tIns="0" rIns="0" bIns="0" anchor="t">
+            <a:noAutofit/>
+          </a:bodyPr>
+          <a:lstStyle xmlns:a="http://schemas.openxmlformats.org/drawingml/2006/main"/>
+          <a:p xmlns:a="http://schemas.openxmlformats.org/drawingml/2006/main">
+            <a:pPr algn="l">
+              <a:defRPr sz="1275" b="1">
+                <a:solidFill>
+                  <a:srgbClr val="7438F5"/>
+                </a:solidFill>
+                <a:latin typeface="Arial"/>
+                <a:ea typeface="Arial"/>
+                <a:cs typeface="Arial"/>
+              </a:defRPr>
+            </a:pPr>
+            <a:r>
+              <a:t>Z / INSPECTION DEPTH</a:t>
+            </a:r>
+          </a:p>
+        </p:txBody>
+      </p:sp>
+      <p:sp>
+        <p:nvSpPr>
+          <p:cNvPr id="21" name="s3-z-main">
+            <a:extLst xmlns:a="http://schemas.openxmlformats.org/drawingml/2006/main">
+              <a:ext uri="{FF2B5EF4-FFF2-40B4-BE49-F238E27FC236}">
+                <a16:creationId xmlns:a16="http://schemas.microsoft.com/office/drawing/2014/main" id="{50EDBA67-BA95-4261-B2F8-BB667D4C96D4}"/>
+              </a:ext>
+            </a:extLst>
+          </p:cNvPr>
+          <p:cNvSpPr>
+            <a:spLocks xmlns:a="http://schemas.openxmlformats.org/drawingml/2006/main" noGrp="1"/>
+          </p:cNvSpPr>
+          <p:nvPr/>
+        </p:nvSpPr>
+        <p:spPr>
+          <a:xfrm xmlns:a="http://schemas.openxmlformats.org/drawingml/2006/main">
+            <a:off x="1428750" y="4619625"/>
+            <a:ext cx="4762500" cy="323850"/>
+          </a:xfrm>
+          <a:prstGeom xmlns:a="http://schemas.openxmlformats.org/drawingml/2006/main" prst="rect">
+            <a:avLst/>
+          </a:prstGeom>
+        </p:spPr>
+        <p:txBody>
+          <a:bodyPr xmlns:a="http://schemas.openxmlformats.org/drawingml/2006/main" wrap="square" lIns="0" tIns="0" rIns="0" bIns="0" anchor="t">
+            <a:noAutofit/>
+          </a:bodyPr>
+          <a:lstStyle xmlns:a="http://schemas.openxmlformats.org/drawingml/2006/main"/>
+          <a:p xmlns:a="http://schemas.openxmlformats.org/drawingml/2006/main">
+            <a:pPr algn="l">
+              <a:defRPr sz="1575" b="1">
+                <a:solidFill>
+                  <a:srgbClr val="0A1224"/>
+                </a:solidFill>
+                <a:latin typeface="Consolas"/>
+                <a:ea typeface="Consolas"/>
+                <a:cs typeface="Consolas"/>
+              </a:defRPr>
+            </a:pPr>
+            <a:r>
+              <a:t>room  -&gt;  file  -&gt;  symbol  -&gt;  snippet</a:t>
+            </a:r>
+          </a:p>
+        </p:txBody>
+      </p:sp>
+      <p:sp>
+        <p:nvSpPr>
+          <p:cNvPr id="22" name="s3-z-question">
+            <a:extLst xmlns:a="http://schemas.openxmlformats.org/drawingml/2006/main">
+              <a:ext uri="{FF2B5EF4-FFF2-40B4-BE49-F238E27FC236}">
+                <a16:creationId xmlns:a16="http://schemas.microsoft.com/office/drawing/2014/main" id="{68AF6718-973A-49F5-8400-6B306BE536AA}"/>
+              </a:ext>
+            </a:extLst>
+          </p:cNvPr>
+          <p:cNvSpPr>
+            <a:spLocks xmlns:a="http://schemas.openxmlformats.org/drawingml/2006/main" noGrp="1"/>
+          </p:cNvSpPr>
+          <p:nvPr/>
+        </p:nvSpPr>
+        <p:spPr>
+          <a:xfrm xmlns:a="http://schemas.openxmlformats.org/drawingml/2006/main">
+            <a:off x="1428750" y="4991100"/>
+            <a:ext cx="4762500" cy="228600"/>
+          </a:xfrm>
+          <a:prstGeom xmlns:a="http://schemas.openxmlformats.org/drawingml/2006/main" prst="rect">
+            <a:avLst/>
+          </a:prstGeom>
+        </p:spPr>
+        <p:txBody>
+          <a:bodyPr xmlns:a="http://schemas.openxmlformats.org/drawingml/2006/main" wrap="square" lIns="0" tIns="0" rIns="0" bIns="0" anchor="t">
+            <a:noAutofit/>
+          </a:bodyPr>
+          <a:lstStyle xmlns:a="http://schemas.openxmlformats.org/drawingml/2006/main"/>
+          <a:p xmlns:a="http://schemas.openxmlformats.org/drawingml/2006/main">
+            <a:pPr algn="l">
+              <a:defRPr sz="1200" b="0">
+                <a:solidFill>
+                  <a:srgbClr val="526071"/>
+                </a:solidFill>
+                <a:latin typeface="Arial"/>
+                <a:ea typeface="Arial"/>
+                <a:cs typeface="Arial"/>
+              </a:defRPr>
+            </a:pPr>
+            <a:r>
+              <a:t>How much context is needed?</a:t>
+            </a:r>
+          </a:p>
+        </p:txBody>
+      </p:sp>
+      <p:sp>
+        <p:nvSpPr>
+          <p:cNvPr id="23" name="s3-address-label">
+            <a:extLst xmlns:a="http://schemas.openxmlformats.org/drawingml/2006/main">
+              <a:ext uri="{FF2B5EF4-FFF2-40B4-BE49-F238E27FC236}">
+                <a16:creationId xmlns:a16="http://schemas.microsoft.com/office/drawing/2014/main" id="{56C49C60-F960-4024-B649-BBECCB4D8BAE}"/>
+              </a:ext>
+            </a:extLst>
+          </p:cNvPr>
+          <p:cNvSpPr>
+            <a:spLocks xmlns:a="http://schemas.openxmlformats.org/drawingml/2006/main" noGrp="1"/>
+          </p:cNvSpPr>
+          <p:nvPr/>
+        </p:nvSpPr>
+        <p:spPr>
+          <a:xfrm xmlns:a="http://schemas.openxmlformats.org/drawingml/2006/main">
+            <a:off x="7219950" y="2095500"/>
+            <a:ext cx="4038600" cy="228600"/>
+          </a:xfrm>
+          <a:prstGeom xmlns:a="http://schemas.openxmlformats.org/drawingml/2006/main" prst="rect">
+            <a:avLst/>
+          </a:prstGeom>
+        </p:spPr>
+        <p:txBody>
+          <a:bodyPr xmlns:a="http://schemas.openxmlformats.org/drawingml/2006/main" wrap="square" lIns="0" tIns="0" rIns="0" bIns="0" anchor="t">
+            <a:noAutofit/>
+          </a:bodyPr>
+          <a:lstStyle xmlns:a="http://schemas.openxmlformats.org/drawingml/2006/main"/>
+          <a:p xmlns:a="http://schemas.openxmlformats.org/drawingml/2006/main">
+            <a:pPr algn="l">
+              <a:defRPr sz="1200" b="1">
+                <a:solidFill>
+                  <a:srgbClr val="13B7D5"/>
+                </a:solidFill>
+                <a:latin typeface="Arial"/>
+                <a:ea typeface="Arial"/>
+                <a:cs typeface="Arial"/>
+              </a:defRPr>
+            </a:pPr>
+            <a:r>
+              <a:t>ONE ADDRESS</a:t>
+            </a:r>
+          </a:p>
+        </p:txBody>
+      </p:sp>
+      <p:sp>
+        <p:nvSpPr>
+          <p:cNvPr id="24" name="s3-address-x">
+            <a:extLst xmlns:a="http://schemas.openxmlformats.org/drawingml/2006/main">
+              <a:ext uri="{FF2B5EF4-FFF2-40B4-BE49-F238E27FC236}">
+                <a16:creationId xmlns:a16="http://schemas.microsoft.com/office/drawing/2014/main" id="{5D4E6A4E-4672-48D8-A777-D4732DE0CB03}"/>
+              </a:ext>
+            </a:extLst>
+          </p:cNvPr>
+          <p:cNvSpPr>
+            <a:spLocks xmlns:a="http://schemas.openxmlformats.org/drawingml/2006/main" noGrp="1"/>
+          </p:cNvSpPr>
+          <p:nvPr/>
+        </p:nvSpPr>
+        <p:spPr>
+          <a:xfrm xmlns:a="http://schemas.openxmlformats.org/drawingml/2006/main">
+            <a:off x="7219950" y="2724150"/>
+            <a:ext cx="323850" cy="285750"/>
+          </a:xfrm>
+          <a:prstGeom xmlns:a="http://schemas.openxmlformats.org/drawingml/2006/main" prst="rect">
+            <a:avLst/>
+          </a:prstGeom>
+        </p:spPr>
+        <p:txBody>
+          <a:bodyPr xmlns:a="http://schemas.openxmlformats.org/drawingml/2006/main" wrap="square" lIns="0" tIns="0" rIns="0" bIns="0" anchor="t">
+            <a:noAutofit/>
+          </a:bodyPr>
+          <a:lstStyle xmlns:a="http://schemas.openxmlformats.org/drawingml/2006/main"/>
+          <a:p xmlns:a="http://schemas.openxmlformats.org/drawingml/2006/main">
+            <a:pPr algn="l">
+              <a:defRPr sz="1575" b="1">
+                <a:solidFill>
+                  <a:srgbClr val="13B7D5"/>
+                </a:solidFill>
+                <a:latin typeface="Arial"/>
+                <a:ea typeface="Arial"/>
+                <a:cs typeface="Arial"/>
+              </a:defRPr>
+            </a:pPr>
+            <a:r>
+              <a:t>X</a:t>
+            </a:r>
+          </a:p>
+        </p:txBody>
+      </p:sp>
+      <p:sp>
+        <p:nvSpPr>
+          <p:cNvPr id="25" name="s3-address-x-value">
+            <a:extLst xmlns:a="http://schemas.openxmlformats.org/drawingml/2006/main">
+              <a:ext uri="{FF2B5EF4-FFF2-40B4-BE49-F238E27FC236}">
+                <a16:creationId xmlns:a16="http://schemas.microsoft.com/office/drawing/2014/main" id="{FA1A2287-AF2D-4062-B309-4E7B6A0CF5A3}"/>
+              </a:ext>
+            </a:extLst>
+          </p:cNvPr>
+          <p:cNvSpPr>
+            <a:spLocks xmlns:a="http://schemas.openxmlformats.org/drawingml/2006/main" noGrp="1"/>
+          </p:cNvSpPr>
+          <p:nvPr/>
+        </p:nvSpPr>
+        <p:spPr>
+          <a:xfrm xmlns:a="http://schemas.openxmlformats.org/drawingml/2006/main">
+            <a:off x="7734300" y="2705100"/>
+            <a:ext cx="3333750" cy="304800"/>
+          </a:xfrm>
+          <a:prstGeom xmlns:a="http://schemas.openxmlformats.org/drawingml/2006/main" prst="rect">
+            <a:avLst/>
+          </a:prstGeom>
+        </p:spPr>
+        <p:txBody>
+          <a:bodyPr xmlns:a="http://schemas.openxmlformats.org/drawingml/2006/main" wrap="square" lIns="0" tIns="0" rIns="0" bIns="0" anchor="t">
+            <a:noAutofit/>
+          </a:bodyPr>
+          <a:lstStyle xmlns:a="http://schemas.openxmlformats.org/drawingml/2006/main"/>
+          <a:p xmlns:a="http://schemas.openxmlformats.org/drawingml/2006/main">
+            <a:pPr algn="l">
+              <a:defRPr sz="1800" b="1">
+                <a:solidFill>
+                  <a:srgbClr val="FFFFFF"/>
+                </a:solidFill>
+                <a:latin typeface="Consolas"/>
+                <a:ea typeface="Consolas"/>
+                <a:cs typeface="Consolas"/>
+              </a:defRPr>
+            </a:pPr>
+            <a:r>
+              <a:t>checkout</a:t>
+            </a:r>
+          </a:p>
+        </p:txBody>
+      </p:sp>
+      <p:sp>
+        <p:nvSpPr>
+          <p:cNvPr id="26" name="s3-address-y">
+            <a:extLst xmlns:a="http://schemas.openxmlformats.org/drawingml/2006/main">
+              <a:ext uri="{FF2B5EF4-FFF2-40B4-BE49-F238E27FC236}">
+                <a16:creationId xmlns:a16="http://schemas.microsoft.com/office/drawing/2014/main" id="{1C64F50B-ABC3-4A7D-916E-655145729645}"/>
+              </a:ext>
+            </a:extLst>
+          </p:cNvPr>
+          <p:cNvSpPr>
+            <a:spLocks xmlns:a="http://schemas.openxmlformats.org/drawingml/2006/main" noGrp="1"/>
+          </p:cNvSpPr>
+          <p:nvPr/>
+        </p:nvSpPr>
+        <p:spPr>
+          <a:xfrm xmlns:a="http://schemas.openxmlformats.org/drawingml/2006/main">
+            <a:off x="7219950" y="3257550"/>
+            <a:ext cx="323850" cy="285750"/>
+          </a:xfrm>
+          <a:prstGeom xmlns:a="http://schemas.openxmlformats.org/drawingml/2006/main" prst="rect">
+            <a:avLst/>
+          </a:prstGeom>
+        </p:spPr>
+        <p:txBody>
+          <a:bodyPr xmlns:a="http://schemas.openxmlformats.org/drawingml/2006/main" wrap="square" lIns="0" tIns="0" rIns="0" bIns="0" anchor="t">
+            <a:noAutofit/>
+          </a:bodyPr>
+          <a:lstStyle xmlns:a="http://schemas.openxmlformats.org/drawingml/2006/main"/>
+          <a:p xmlns:a="http://schemas.openxmlformats.org/drawingml/2006/main">
+            <a:pPr algn="l">
+              <a:defRPr sz="1575" b="1">
+                <a:solidFill>
+                  <a:srgbClr val="1677FF"/>
+                </a:solidFill>
+                <a:latin typeface="Arial"/>
+                <a:ea typeface="Arial"/>
+                <a:cs typeface="Arial"/>
+              </a:defRPr>
+            </a:pPr>
+            <a:r>
+              <a:t>Y</a:t>
+            </a:r>
+          </a:p>
+        </p:txBody>
+      </p:sp>
+      <p:sp>
+        <p:nvSpPr>
+          <p:cNvPr id="27" name="s3-address-y-value">
+            <a:extLst xmlns:a="http://schemas.openxmlformats.org/drawingml/2006/main">
+              <a:ext uri="{FF2B5EF4-FFF2-40B4-BE49-F238E27FC236}">
+                <a16:creationId xmlns:a16="http://schemas.microsoft.com/office/drawing/2014/main" id="{00430B53-3183-484D-A26F-8D1D790939B4}"/>
+              </a:ext>
+            </a:extLst>
+          </p:cNvPr>
+          <p:cNvSpPr>
+            <a:spLocks xmlns:a="http://schemas.openxmlformats.org/drawingml/2006/main" noGrp="1"/>
+          </p:cNvSpPr>
+          <p:nvPr/>
+        </p:nvSpPr>
+        <p:spPr>
+          <a:xfrm xmlns:a="http://schemas.openxmlformats.org/drawingml/2006/main">
+            <a:off x="7734300" y="3238500"/>
+            <a:ext cx="3333750" cy="304800"/>
+          </a:xfrm>
+          <a:prstGeom xmlns:a="http://schemas.openxmlformats.org/drawingml/2006/main" prst="rect">
+            <a:avLst/>
+          </a:prstGeom>
+        </p:spPr>
+        <p:txBody>
+          <a:bodyPr xmlns:a="http://schemas.openxmlformats.org/drawingml/2006/main" wrap="square" lIns="0" tIns="0" rIns="0" bIns="0" anchor="t">
+            <a:noAutofit/>
+          </a:bodyPr>
+          <a:lstStyle xmlns:a="http://schemas.openxmlformats.org/drawingml/2006/main"/>
+          <a:p xmlns:a="http://schemas.openxmlformats.org/drawingml/2006/main">
+            <a:pPr algn="l">
+              <a:defRPr sz="1800" b="1">
+                <a:solidFill>
+                  <a:srgbClr val="FFFFFF"/>
+                </a:solidFill>
+                <a:latin typeface="Consolas"/>
+                <a:ea typeface="Consolas"/>
+                <a:cs typeface="Consolas"/>
+              </a:defRPr>
+            </a:pPr>
+            <a:r>
+              <a:t>implementation</a:t>
+            </a:r>
+          </a:p>
+        </p:txBody>
+      </p:sp>
+      <p:sp>
+        <p:nvSpPr>
+          <p:cNvPr id="28" name="s3-address-z">
+            <a:extLst xmlns:a="http://schemas.openxmlformats.org/drawingml/2006/main">
+              <a:ext uri="{FF2B5EF4-FFF2-40B4-BE49-F238E27FC236}">
+                <a16:creationId xmlns:a16="http://schemas.microsoft.com/office/drawing/2014/main" id="{B9B4EA29-BD3A-4D45-ACA1-90CB0078B621}"/>
+              </a:ext>
+            </a:extLst>
+          </p:cNvPr>
+          <p:cNvSpPr>
+            <a:spLocks xmlns:a="http://schemas.openxmlformats.org/drawingml/2006/main" noGrp="1"/>
+          </p:cNvSpPr>
+          <p:nvPr/>
+        </p:nvSpPr>
+        <p:spPr>
+          <a:xfrm xmlns:a="http://schemas.openxmlformats.org/drawingml/2006/main">
+            <a:off x="7219950" y="3790950"/>
+            <a:ext cx="323850" cy="285750"/>
+          </a:xfrm>
+          <a:prstGeom xmlns:a="http://schemas.openxmlformats.org/drawingml/2006/main" prst="rect">
+            <a:avLst/>
+          </a:prstGeom>
+        </p:spPr>
+        <p:txBody>
+          <a:bodyPr xmlns:a="http://schemas.openxmlformats.org/drawingml/2006/main" wrap="square" lIns="0" tIns="0" rIns="0" bIns="0" anchor="t">
+            <a:noAutofit/>
+          </a:bodyPr>
+          <a:lstStyle xmlns:a="http://schemas.openxmlformats.org/drawingml/2006/main"/>
+          <a:p xmlns:a="http://schemas.openxmlformats.org/drawingml/2006/main">
+            <a:pPr algn="l">
+              <a:defRPr sz="1575" b="1">
+                <a:solidFill>
+                  <a:srgbClr val="7438F5"/>
+                </a:solidFill>
+                <a:latin typeface="Arial"/>
+                <a:ea typeface="Arial"/>
+                <a:cs typeface="Arial"/>
+              </a:defRPr>
+            </a:pPr>
+            <a:r>
+              <a:t>Z</a:t>
+            </a:r>
+          </a:p>
+        </p:txBody>
+      </p:sp>
+      <p:sp>
+        <p:nvSpPr>
+          <p:cNvPr id="29" name="s3-address-z-value">
+            <a:extLst xmlns:a="http://schemas.openxmlformats.org/drawingml/2006/main">
+              <a:ext uri="{FF2B5EF4-FFF2-40B4-BE49-F238E27FC236}">
+                <a16:creationId xmlns:a16="http://schemas.microsoft.com/office/drawing/2014/main" id="{7D5C5B7B-DC57-4802-97DE-FD5C0729FD15}"/>
+              </a:ext>
+            </a:extLst>
+          </p:cNvPr>
+          <p:cNvSpPr>
+            <a:spLocks xmlns:a="http://schemas.openxmlformats.org/drawingml/2006/main" noGrp="1"/>
+          </p:cNvSpPr>
+          <p:nvPr/>
+        </p:nvSpPr>
+        <p:spPr>
+          <a:xfrm xmlns:a="http://schemas.openxmlformats.org/drawingml/2006/main">
+            <a:off x="7734300" y="3771900"/>
+            <a:ext cx="3333750" cy="304800"/>
+          </a:xfrm>
+          <a:prstGeom xmlns:a="http://schemas.openxmlformats.org/drawingml/2006/main" prst="rect">
+            <a:avLst/>
+          </a:prstGeom>
+        </p:spPr>
+        <p:txBody>
+          <a:bodyPr xmlns:a="http://schemas.openxmlformats.org/drawingml/2006/main" wrap="square" lIns="0" tIns="0" rIns="0" bIns="0" anchor="t">
+            <a:noAutofit/>
+          </a:bodyPr>
+          <a:lstStyle xmlns:a="http://schemas.openxmlformats.org/drawingml/2006/main"/>
+          <a:p xmlns:a="http://schemas.openxmlformats.org/drawingml/2006/main">
+            <a:pPr algn="l">
+              <a:defRPr sz="1800" b="1">
+                <a:solidFill>
+                  <a:srgbClr val="FFFFFF"/>
+                </a:solidFill>
+                <a:latin typeface="Consolas"/>
+                <a:ea typeface="Consolas"/>
+                <a:cs typeface="Consolas"/>
+              </a:defRPr>
+            </a:pPr>
+            <a:r>
+              <a:t>shippingQuote()</a:t>
+            </a:r>
+          </a:p>
+        </p:txBody>
+      </p:sp>
+      <p:sp>
+        <p:nvSpPr>
+          <p:cNvPr id="30" name="s3-address-note">
+            <a:extLst xmlns:a="http://schemas.openxmlformats.org/drawingml/2006/main">
+              <a:ext uri="{FF2B5EF4-FFF2-40B4-BE49-F238E27FC236}">
+                <a16:creationId xmlns:a16="http://schemas.microsoft.com/office/drawing/2014/main" id="{421D33AB-5D71-4F46-A6AC-7F25D9920FC1}"/>
+              </a:ext>
+            </a:extLst>
+          </p:cNvPr>
+          <p:cNvSpPr>
+            <a:spLocks xmlns:a="http://schemas.openxmlformats.org/drawingml/2006/main" noGrp="1"/>
+          </p:cNvSpPr>
+          <p:nvPr/>
+        </p:nvSpPr>
+        <p:spPr>
+          <a:xfrm xmlns:a="http://schemas.openxmlformats.org/drawingml/2006/main">
+            <a:off x="7219950" y="4476750"/>
+            <a:ext cx="4038600" cy="323850"/>
+          </a:xfrm>
+          <a:prstGeom xmlns:a="http://schemas.openxmlformats.org/drawingml/2006/main" prst="rect">
+            <a:avLst/>
+          </a:prstGeom>
+        </p:spPr>
+        <p:txBody>
+          <a:bodyPr xmlns:a="http://schemas.openxmlformats.org/drawingml/2006/main" wrap="square" lIns="0" tIns="0" rIns="0" bIns="0" anchor="t">
+            <a:noAutofit/>
+          </a:bodyPr>
+          <a:lstStyle xmlns:a="http://schemas.openxmlformats.org/drawingml/2006/main"/>
+          <a:p xmlns:a="http://schemas.openxmlformats.org/drawingml/2006/main">
+            <a:pPr algn="l">
+              <a:defRPr sz="1500" b="0">
+                <a:solidFill>
+                  <a:srgbClr val="9CC8FF"/>
+                </a:solidFill>
+                <a:latin typeface="Arial"/>
+                <a:ea typeface="Arial"/>
+                <a:cs typeface="Arial"/>
+              </a:defRPr>
+            </a:pPr>
+            <a:r>
+              <a:t>One bounded entry point.</a:t>
+            </a:r>
+          </a:p>
+        </p:txBody>
+      </p:sp>
+      <p:sp>
+        <p:nvSpPr>
+          <p:cNvPr id="31" name="s3-route-label">
+            <a:extLst xmlns:a="http://schemas.openxmlformats.org/drawingml/2006/main">
+              <a:ext uri="{FF2B5EF4-FFF2-40B4-BE49-F238E27FC236}">
+                <a16:creationId xmlns:a16="http://schemas.microsoft.com/office/drawing/2014/main" id="{EF313E81-650E-4030-BF44-92E9BB016C9F}"/>
+              </a:ext>
+            </a:extLst>
+          </p:cNvPr>
+          <p:cNvSpPr>
+            <a:spLocks xmlns:a="http://schemas.openxmlformats.org/drawingml/2006/main" noGrp="1"/>
+          </p:cNvSpPr>
+          <p:nvPr/>
+        </p:nvSpPr>
+        <p:spPr>
+          <a:xfrm xmlns:a="http://schemas.openxmlformats.org/drawingml/2006/main">
+            <a:off x="6858000" y="5276850"/>
+            <a:ext cx="742950" cy="228600"/>
+          </a:xfrm>
+          <a:prstGeom xmlns:a="http://schemas.openxmlformats.org/drawingml/2006/main" prst="rect">
+            <a:avLst/>
+          </a:prstGeom>
+        </p:spPr>
+        <p:txBody>
+          <a:bodyPr xmlns:a="http://schemas.openxmlformats.org/drawingml/2006/main" wrap="square" lIns="0" tIns="0" rIns="0" bIns="0" anchor="t">
+            <a:noAutofit/>
+          </a:bodyPr>
+          <a:lstStyle xmlns:a="http://schemas.openxmlformats.org/drawingml/2006/main"/>
+          <a:p xmlns:a="http://schemas.openxmlformats.org/drawingml/2006/main">
+            <a:pPr algn="l">
+              <a:defRPr sz="1200" b="1">
+                <a:solidFill>
+                  <a:srgbClr val="15A777"/>
+                </a:solidFill>
+                <a:latin typeface="Arial"/>
+                <a:ea typeface="Arial"/>
+                <a:cs typeface="Arial"/>
+              </a:defRPr>
+            </a:pPr>
+            <a:r>
+              <a:t>ROUTE</a:t>
+            </a:r>
+          </a:p>
+        </p:txBody>
+      </p:sp>
+      <p:sp>
+        <p:nvSpPr>
+          <p:cNvPr id="32" name="s3-route-main">
+            <a:extLst xmlns:a="http://schemas.openxmlformats.org/drawingml/2006/main">
+              <a:ext uri="{FF2B5EF4-FFF2-40B4-BE49-F238E27FC236}">
+                <a16:creationId xmlns:a16="http://schemas.microsoft.com/office/drawing/2014/main" id="{2C909F8F-4FE0-471F-850E-769B320FA499}"/>
+              </a:ext>
+            </a:extLst>
+          </p:cNvPr>
+          <p:cNvSpPr>
+            <a:spLocks xmlns:a="http://schemas.openxmlformats.org/drawingml/2006/main" noGrp="1"/>
+          </p:cNvSpPr>
+          <p:nvPr/>
+        </p:nvSpPr>
+        <p:spPr>
+          <a:xfrm xmlns:a="http://schemas.openxmlformats.org/drawingml/2006/main">
+            <a:off x="7639050" y="5276850"/>
+            <a:ext cx="3981450" cy="228600"/>
+          </a:xfrm>
+          <a:prstGeom xmlns:a="http://schemas.openxmlformats.org/drawingml/2006/main" prst="rect">
+            <a:avLst/>
+          </a:prstGeom>
+        </p:spPr>
+        <p:txBody>
+          <a:bodyPr xmlns:a="http://schemas.openxmlformats.org/drawingml/2006/main" wrap="square" lIns="0" tIns="0" rIns="0" bIns="0" anchor="t">
+            <a:noAutofit/>
+          </a:bodyPr>
+          <a:lstStyle xmlns:a="http://schemas.openxmlformats.org/drawingml/2006/main"/>
+          <a:p xmlns:a="http://schemas.openxmlformats.org/drawingml/2006/main">
+            <a:pPr algn="l">
+              <a:defRPr sz="1200" b="0">
+                <a:solidFill>
+                  <a:srgbClr val="526071"/>
+                </a:solidFill>
+                <a:latin typeface="Arial"/>
+                <a:ea typeface="Arial"/>
+                <a:cs typeface="Arial"/>
+              </a:defRPr>
+            </a:pPr>
+            <a:r>
+              <a:t>task-specific path between addresses</a:t>
+            </a:r>
+          </a:p>
+        </p:txBody>
+      </p:sp>
+      <p:sp>
+        <p:nvSpPr>
+          <p:cNvPr id="33" name="s3-memory-label">
+            <a:extLst xmlns:a="http://schemas.openxmlformats.org/drawingml/2006/main">
+              <a:ext uri="{FF2B5EF4-FFF2-40B4-BE49-F238E27FC236}">
+                <a16:creationId xmlns:a16="http://schemas.microsoft.com/office/drawing/2014/main" id="{C0174A6C-1C5E-42CF-8B90-7FCD8A11AE0F}"/>
+              </a:ext>
+            </a:extLst>
+          </p:cNvPr>
+          <p:cNvSpPr>
+            <a:spLocks xmlns:a="http://schemas.openxmlformats.org/drawingml/2006/main" noGrp="1"/>
+          </p:cNvSpPr>
+          <p:nvPr/>
+        </p:nvSpPr>
+        <p:spPr>
+          <a:xfrm xmlns:a="http://schemas.openxmlformats.org/drawingml/2006/main">
+            <a:off x="6858000" y="5581650"/>
+            <a:ext cx="800100" cy="228600"/>
+          </a:xfrm>
+          <a:prstGeom xmlns:a="http://schemas.openxmlformats.org/drawingml/2006/main" prst="rect">
+            <a:avLst/>
+          </a:prstGeom>
+        </p:spPr>
+        <p:txBody>
+          <a:bodyPr xmlns:a="http://schemas.openxmlformats.org/drawingml/2006/main" wrap="square" lIns="0" tIns="0" rIns="0" bIns="0" anchor="t">
+            <a:noAutofit/>
+          </a:bodyPr>
+          <a:lstStyle xmlns:a="http://schemas.openxmlformats.org/drawingml/2006/main"/>
+          <a:p xmlns:a="http://schemas.openxmlformats.org/drawingml/2006/main">
+            <a:pPr algn="l">
+              <a:defRPr sz="1200" b="1">
+                <a:solidFill>
+                  <a:srgbClr val="13B7D5"/>
+                </a:solidFill>
+                <a:latin typeface="Arial"/>
+                <a:ea typeface="Arial"/>
+                <a:cs typeface="Arial"/>
+              </a:defRPr>
+            </a:pPr>
+            <a:r>
+              <a:t>MEMORY</a:t>
+            </a:r>
+          </a:p>
+        </p:txBody>
+      </p:sp>
+      <p:sp>
+        <p:nvSpPr>
+          <p:cNvPr id="34" name="s3-memory-main">
+            <a:extLst xmlns:a="http://schemas.openxmlformats.org/drawingml/2006/main">
+              <a:ext uri="{FF2B5EF4-FFF2-40B4-BE49-F238E27FC236}">
+                <a16:creationId xmlns:a16="http://schemas.microsoft.com/office/drawing/2014/main" id="{56AEA01B-111F-4829-832D-40F634B4AE52}"/>
+              </a:ext>
+            </a:extLst>
+          </p:cNvPr>
+          <p:cNvSpPr>
+            <a:spLocks xmlns:a="http://schemas.openxmlformats.org/drawingml/2006/main" noGrp="1"/>
+          </p:cNvSpPr>
+          <p:nvPr/>
+        </p:nvSpPr>
+        <p:spPr>
+          <a:xfrm xmlns:a="http://schemas.openxmlformats.org/drawingml/2006/main">
+            <a:off x="7696200" y="5581650"/>
+            <a:ext cx="3924300" cy="381000"/>
+          </a:xfrm>
+          <a:prstGeom xmlns:a="http://schemas.openxmlformats.org/drawingml/2006/main" prst="rect">
+            <a:avLst/>
+          </a:prstGeom>
+        </p:spPr>
+        <p:txBody>
+          <a:bodyPr xmlns:a="http://schemas.openxmlformats.org/drawingml/2006/main" wrap="square" lIns="0" tIns="0" rIns="0" bIns="0" anchor="t">
+            <a:noAutofit/>
+          </a:bodyPr>
+          <a:lstStyle xmlns:a="http://schemas.openxmlformats.org/drawingml/2006/main"/>
+          <a:p xmlns:a="http://schemas.openxmlformats.org/drawingml/2006/main">
+            <a:pPr algn="l">
+              <a:defRPr sz="1200" b="0">
+                <a:solidFill>
+                  <a:srgbClr val="526071"/>
+                </a:solidFill>
+                <a:latin typeface="Arial"/>
+                <a:ea typeface="Arial"/>
+                <a:cs typeface="Arial"/>
+              </a:defRPr>
+            </a:pPr>
+            <a:r>
+              <a:t>evidence + pitfalls attached to places, not another axis</a:t>
+            </a:r>
+          </a:p>
+        </p:txBody>
+      </p:sp>
+      <p:cxnSp>
+        <p:nvCxnSpPr>
+          <p:cNvPr id="72" name="footer-rule-3"/>
+          <p:cNvCxnSpPr/>
+          <p:nvPr/>
+        </p:nvCxnSpPr>
+        <p:spPr>
+          <a:xfrm xmlns:a="http://schemas.openxmlformats.org/drawingml/2006/main">
+            <a:off x="400050" y="6162675"/>
+            <a:ext cx="11391900" cy="953"/>
+          </a:xfrm>
+          <a:prstGeom xmlns:a="http://schemas.openxmlformats.org/drawingml/2006/main" prst="straightConnector1">
+            <a:avLst/>
+          </a:prstGeom>
+          <a:ln xmlns:a="http://schemas.openxmlformats.org/drawingml/2006/main" w="9525">
+            <a:solidFill>
+              <a:srgbClr val="B8BCC4"/>
+            </a:solidFill>
+            <a:prstDash val="solid"/>
+          </a:ln>
+        </p:spPr>
+      </p:cxnSp>
+      <p:sp>
+        <p:nvSpPr>
+          <p:cNvPr id="36" name="footer-source-3">
+            <a:extLst xmlns:a="http://schemas.openxmlformats.org/drawingml/2006/main">
+              <a:ext uri="{FF2B5EF4-FFF2-40B4-BE49-F238E27FC236}">
+                <a16:creationId xmlns:a16="http://schemas.microsoft.com/office/drawing/2014/main" id="{D10B03C9-48D9-4057-9B40-17585A3E129D}"/>
+              </a:ext>
+            </a:extLst>
+          </p:cNvPr>
+          <p:cNvSpPr>
+            <a:spLocks xmlns:a="http://schemas.openxmlformats.org/drawingml/2006/main" noGrp="1"/>
+          </p:cNvSpPr>
+          <p:nvPr/>
+        </p:nvSpPr>
+        <p:spPr>
+          <a:xfrm xmlns:a="http://schemas.openxmlformats.org/drawingml/2006/main">
+            <a:off x="400050" y="6238875"/>
+            <a:ext cx="10001250" cy="228600"/>
+          </a:xfrm>
+          <a:prstGeom xmlns:a="http://schemas.openxmlformats.org/drawingml/2006/main" prst="rect">
+            <a:avLst/>
+          </a:prstGeom>
+        </p:spPr>
+        <p:txBody>
+          <a:bodyPr xmlns:a="http://schemas.openxmlformats.org/drawingml/2006/main" wrap="square" lIns="0" tIns="0" rIns="0" bIns="0" anchor="t">
+            <a:noAutofit/>
+          </a:bodyPr>
+          <a:lstStyle xmlns:a="http://schemas.openxmlformats.org/drawingml/2006/main"/>
+          <a:p xmlns:a="http://schemas.openxmlformats.org/drawingml/2006/main">
+            <a:pPr algn="l">
+              <a:defRPr sz="863" b="0">
+                <a:solidFill>
+                  <a:srgbClr val="526071"/>
+                </a:solidFill>
+                <a:latin typeface="Arial"/>
+                <a:ea typeface="Arial"/>
+                <a:cs typeface="Arial"/>
+              </a:defRPr>
+            </a:pPr>
+            <a:r>
+              <a:t/>
+            </a:r>
+          </a:p>
+        </p:txBody>
+      </p:sp>
+      <p:sp>
+        <p:nvSpPr>
+          <p:cNvPr id="37" name="footer-number-3">
+            <a:extLst xmlns:a="http://schemas.openxmlformats.org/drawingml/2006/main">
+              <a:ext uri="{FF2B5EF4-FFF2-40B4-BE49-F238E27FC236}">
+                <a16:creationId xmlns:a16="http://schemas.microsoft.com/office/drawing/2014/main" id="{31774030-2F81-49CB-97FA-5B99F41CE831}"/>
+              </a:ext>
+            </a:extLst>
+          </p:cNvPr>
+          <p:cNvSpPr>
+            <a:spLocks xmlns:a="http://schemas.openxmlformats.org/drawingml/2006/main" noGrp="1"/>
+          </p:cNvSpPr>
+          <p:nvPr/>
+        </p:nvSpPr>
+        <p:spPr>
+          <a:xfrm xmlns:a="http://schemas.openxmlformats.org/drawingml/2006/main">
+            <a:off x="11258550" y="6238875"/>
+            <a:ext cx="533400" cy="228600"/>
+          </a:xfrm>
+          <a:prstGeom xmlns:a="http://schemas.openxmlformats.org/drawingml/2006/main" prst="rect">
+            <a:avLst/>
+          </a:prstGeom>
+        </p:spPr>
+        <p:txBody>
+          <a:bodyPr xmlns:a="http://schemas.openxmlformats.org/drawingml/2006/main" wrap="square" lIns="0" tIns="0" rIns="0" bIns="0" anchor="t">
+            <a:noAutofit/>
+          </a:bodyPr>
+          <a:lstStyle xmlns:a="http://schemas.openxmlformats.org/drawingml/2006/main"/>
+          <a:p xmlns:a="http://schemas.openxmlformats.org/drawingml/2006/main">
+            <a:pPr algn="r">
+              <a:defRPr sz="900" b="0">
+                <a:solidFill>
+                  <a:srgbClr val="526071"/>
+                </a:solidFill>
+                <a:latin typeface="Arial"/>
+                <a:ea typeface="Arial"/>
+                <a:cs typeface="Arial"/>
+              </a:defRPr>
+            </a:pPr>
+            <a:r>
               <a:t>3</a:t>
             </a:r>
           </a:p>
@@ -4587,7 +5028,7 @@
     </p:spTree>
     <p:extLst>
       <p:ext uri="{BB962C8B-B14F-4D97-AF65-F5344CB8AC3E}">
-        <p14:creationId xmlns:p14="http://schemas.microsoft.com/office/powerpoint/2010/main" val="1758424556"/>
+        <p14:creationId xmlns:p14="http://schemas.microsoft.com/office/powerpoint/2010/main" val="299079171"/>
       </p:ext>
     </p:extLst>
   </p:cSld>
@@ -4618,7 +5059,7 @@
           <p:cNvPr id="26" name="s4-title">
             <a:extLst xmlns:a="http://schemas.openxmlformats.org/drawingml/2006/main">
               <a:ext uri="{FF2B5EF4-FFF2-40B4-BE49-F238E27FC236}">
-                <a16:creationId xmlns:a16="http://schemas.microsoft.com/office/drawing/2014/main" id="{ECA5D961-2EE9-4A5E-B81F-8A9688892170}"/>
+                <a16:creationId xmlns:a16="http://schemas.microsoft.com/office/drawing/2014/main" id="{00A86969-2DF3-4078-B402-F7AAD8552E4E}"/>
               </a:ext>
             </a:extLst>
           </p:cNvPr>
@@ -4663,7 +5104,7 @@
           <p:cNvPr id="2" name="s4-subtitle">
             <a:extLst xmlns:a="http://schemas.openxmlformats.org/drawingml/2006/main">
               <a:ext uri="{FF2B5EF4-FFF2-40B4-BE49-F238E27FC236}">
-                <a16:creationId xmlns:a16="http://schemas.microsoft.com/office/drawing/2014/main" id="{321E7CAC-0FC2-46A7-9274-8A907B2D1403}"/>
+                <a16:creationId xmlns:a16="http://schemas.microsoft.com/office/drawing/2014/main" id="{8DE6C813-311D-4525-8230-6719017C69B7}"/>
               </a:ext>
             </a:extLst>
           </p:cNvPr>
@@ -4708,7 +5149,7 @@
           <p:cNvPr id="3" name="s4-terminal">
             <a:extLst xmlns:a="http://schemas.openxmlformats.org/drawingml/2006/main">
               <a:ext uri="{FF2B5EF4-FFF2-40B4-BE49-F238E27FC236}">
-                <a16:creationId xmlns:a16="http://schemas.microsoft.com/office/drawing/2014/main" id="{DFE91957-DDAD-4185-BD6E-A67F17BD252D}"/>
+                <a16:creationId xmlns:a16="http://schemas.microsoft.com/office/drawing/2014/main" id="{623D79A5-0CD7-49F1-89AB-E36100952572}"/>
               </a:ext>
             </a:extLst>
           </p:cNvPr>
@@ -4765,7 +5206,7 @@
           <p:cNvPr id="5" name="s4-dot1">
             <a:extLst xmlns:a="http://schemas.openxmlformats.org/drawingml/2006/main">
               <a:ext uri="{FF2B5EF4-FFF2-40B4-BE49-F238E27FC236}">
-                <a16:creationId xmlns:a16="http://schemas.microsoft.com/office/drawing/2014/main" id="{DCF94B8F-E198-417E-90D2-D57B6656DB45}"/>
+                <a16:creationId xmlns:a16="http://schemas.microsoft.com/office/drawing/2014/main" id="{144B4091-2CE7-486A-AB5D-1FC014E02C79}"/>
               </a:ext>
             </a:extLst>
           </p:cNvPr>
@@ -4798,7 +5239,7 @@
           <p:cNvPr id="6" name="s4-dot2">
             <a:extLst xmlns:a="http://schemas.openxmlformats.org/drawingml/2006/main">
               <a:ext uri="{FF2B5EF4-FFF2-40B4-BE49-F238E27FC236}">
-                <a16:creationId xmlns:a16="http://schemas.microsoft.com/office/drawing/2014/main" id="{580B3C56-7D5F-472B-BC43-74DBD9CC4587}"/>
+                <a16:creationId xmlns:a16="http://schemas.microsoft.com/office/drawing/2014/main" id="{4EA41AA9-1B9E-4B89-814C-476276CB13E5}"/>
               </a:ext>
             </a:extLst>
           </p:cNvPr>
@@ -4831,7 +5272,7 @@
           <p:cNvPr id="7" name="s4-dot3">
             <a:extLst xmlns:a="http://schemas.openxmlformats.org/drawingml/2006/main">
               <a:ext uri="{FF2B5EF4-FFF2-40B4-BE49-F238E27FC236}">
-                <a16:creationId xmlns:a16="http://schemas.microsoft.com/office/drawing/2014/main" id="{94D12B48-C7BB-495D-87D3-42E1E09F494D}"/>
+                <a16:creationId xmlns:a16="http://schemas.microsoft.com/office/drawing/2014/main" id="{D6447499-3E02-4ADC-8BA9-C1C4ED38FAF0}"/>
               </a:ext>
             </a:extLst>
           </p:cNvPr>
@@ -4864,7 +5305,7 @@
           <p:cNvPr id="8" name="s4-command-label">
             <a:extLst xmlns:a="http://schemas.openxmlformats.org/drawingml/2006/main">
               <a:ext uri="{FF2B5EF4-FFF2-40B4-BE49-F238E27FC236}">
-                <a16:creationId xmlns:a16="http://schemas.microsoft.com/office/drawing/2014/main" id="{6BFAD678-1E01-48C1-9FEB-A1066E6262DA}"/>
+                <a16:creationId xmlns:a16="http://schemas.microsoft.com/office/drawing/2014/main" id="{9820C9DA-EB71-4E0B-97A0-4A86B0E23296}"/>
               </a:ext>
             </a:extLst>
           </p:cNvPr>
@@ -4909,7 +5350,7 @@
           <p:cNvPr id="9" name="s4-command">
             <a:extLst xmlns:a="http://schemas.openxmlformats.org/drawingml/2006/main">
               <a:ext uri="{FF2B5EF4-FFF2-40B4-BE49-F238E27FC236}">
-                <a16:creationId xmlns:a16="http://schemas.microsoft.com/office/drawing/2014/main" id="{BC067BAD-F1B8-430C-A94A-24FD66FB9623}"/>
+                <a16:creationId xmlns:a16="http://schemas.microsoft.com/office/drawing/2014/main" id="{FDE44250-1019-4CB1-B959-5D7046F3E2D4}"/>
               </a:ext>
             </a:extLst>
           </p:cNvPr>
@@ -4958,7 +5399,7 @@
           <p:cNvPr id="10" name="s4-command-note">
             <a:extLst xmlns:a="http://schemas.openxmlformats.org/drawingml/2006/main">
               <a:ext uri="{FF2B5EF4-FFF2-40B4-BE49-F238E27FC236}">
-                <a16:creationId xmlns:a16="http://schemas.microsoft.com/office/drawing/2014/main" id="{B2E2F647-B92F-471E-BE3A-2804F7CE3BA4}"/>
+                <a16:creationId xmlns:a16="http://schemas.microsoft.com/office/drawing/2014/main" id="{1A5E0206-8638-49B0-81E7-631C01FD29F4}"/>
               </a:ext>
             </a:extLst>
           </p:cNvPr>
@@ -5003,7 +5444,7 @@
           <p:cNvPr id="11" name="s4-output-label">
             <a:extLst xmlns:a="http://schemas.openxmlformats.org/drawingml/2006/main">
               <a:ext uri="{FF2B5EF4-FFF2-40B4-BE49-F238E27FC236}">
-                <a16:creationId xmlns:a16="http://schemas.microsoft.com/office/drawing/2014/main" id="{B5358BA2-183D-49E8-89FC-E121568F0B55}"/>
+                <a16:creationId xmlns:a16="http://schemas.microsoft.com/office/drawing/2014/main" id="{929FF591-E607-4BCA-B7A0-76583FDABBCF}"/>
               </a:ext>
             </a:extLst>
           </p:cNvPr>
@@ -5048,7 +5489,7 @@
           <p:cNvPr id="12" name="s4-o1a">
             <a:extLst xmlns:a="http://schemas.openxmlformats.org/drawingml/2006/main">
               <a:ext uri="{FF2B5EF4-FFF2-40B4-BE49-F238E27FC236}">
-                <a16:creationId xmlns:a16="http://schemas.microsoft.com/office/drawing/2014/main" id="{3F3A315A-A832-4508-B97E-057AC5D7B79D}"/>
+                <a16:creationId xmlns:a16="http://schemas.microsoft.com/office/drawing/2014/main" id="{70073B08-FD54-47C7-842B-F62389DA8E6F}"/>
               </a:ext>
             </a:extLst>
           </p:cNvPr>
@@ -5093,7 +5534,7 @@
           <p:cNvPr id="13" name="s4-o1b">
             <a:extLst xmlns:a="http://schemas.openxmlformats.org/drawingml/2006/main">
               <a:ext uri="{FF2B5EF4-FFF2-40B4-BE49-F238E27FC236}">
-                <a16:creationId xmlns:a16="http://schemas.microsoft.com/office/drawing/2014/main" id="{415326A1-EA95-438B-A5A9-078EB0DF7A70}"/>
+                <a16:creationId xmlns:a16="http://schemas.microsoft.com/office/drawing/2014/main" id="{18522825-0F41-47AF-AB09-B27C39F28213}"/>
               </a:ext>
             </a:extLst>
           </p:cNvPr>
@@ -5138,7 +5579,7 @@
           <p:cNvPr id="14" name="s4-o2a">
             <a:extLst xmlns:a="http://schemas.openxmlformats.org/drawingml/2006/main">
               <a:ext uri="{FF2B5EF4-FFF2-40B4-BE49-F238E27FC236}">
-                <a16:creationId xmlns:a16="http://schemas.microsoft.com/office/drawing/2014/main" id="{C150D3AC-C6E0-4280-AB80-17F3590A3FA9}"/>
+                <a16:creationId xmlns:a16="http://schemas.microsoft.com/office/drawing/2014/main" id="{B0C5889C-FCCD-4937-B9E2-87397E2B0363}"/>
               </a:ext>
             </a:extLst>
           </p:cNvPr>
@@ -5183,7 +5624,7 @@
           <p:cNvPr id="15" name="s4-o2b">
             <a:extLst xmlns:a="http://schemas.openxmlformats.org/drawingml/2006/main">
               <a:ext uri="{FF2B5EF4-FFF2-40B4-BE49-F238E27FC236}">
-                <a16:creationId xmlns:a16="http://schemas.microsoft.com/office/drawing/2014/main" id="{9D684430-950D-41C8-A2D1-D44F19D82E41}"/>
+                <a16:creationId xmlns:a16="http://schemas.microsoft.com/office/drawing/2014/main" id="{F0A70C6D-30A9-474C-A86D-A1D898061B2F}"/>
               </a:ext>
             </a:extLst>
           </p:cNvPr>
@@ -5228,7 +5669,7 @@
           <p:cNvPr id="16" name="s4-o3a">
             <a:extLst xmlns:a="http://schemas.openxmlformats.org/drawingml/2006/main">
               <a:ext uri="{FF2B5EF4-FFF2-40B4-BE49-F238E27FC236}">
-                <a16:creationId xmlns:a16="http://schemas.microsoft.com/office/drawing/2014/main" id="{7C63FBB0-FD02-4013-A128-D24B97FAA85B}"/>
+                <a16:creationId xmlns:a16="http://schemas.microsoft.com/office/drawing/2014/main" id="{2799C415-561B-4770-B41F-D8C1ED384CE1}"/>
               </a:ext>
             </a:extLst>
           </p:cNvPr>
@@ -5273,7 +5714,7 @@
           <p:cNvPr id="17" name="s4-o3b">
             <a:extLst xmlns:a="http://schemas.openxmlformats.org/drawingml/2006/main">
               <a:ext uri="{FF2B5EF4-FFF2-40B4-BE49-F238E27FC236}">
-                <a16:creationId xmlns:a16="http://schemas.microsoft.com/office/drawing/2014/main" id="{174A7B0C-D948-4F71-9367-164A398FB2B9}"/>
+                <a16:creationId xmlns:a16="http://schemas.microsoft.com/office/drawing/2014/main" id="{DCBAA2D0-7B07-42B2-A370-0FD5DFDAE56E}"/>
               </a:ext>
             </a:extLst>
           </p:cNvPr>
@@ -5318,7 +5759,7 @@
           <p:cNvPr id="18" name="s4-o4a">
             <a:extLst xmlns:a="http://schemas.openxmlformats.org/drawingml/2006/main">
               <a:ext uri="{FF2B5EF4-FFF2-40B4-BE49-F238E27FC236}">
-                <a16:creationId xmlns:a16="http://schemas.microsoft.com/office/drawing/2014/main" id="{6AE3775C-738C-413E-9136-2502F8B11B51}"/>
+                <a16:creationId xmlns:a16="http://schemas.microsoft.com/office/drawing/2014/main" id="{81C07A28-0C4D-4193-A5DE-0813EC601278}"/>
               </a:ext>
             </a:extLst>
           </p:cNvPr>
@@ -5363,7 +5804,7 @@
           <p:cNvPr id="19" name="s4-o4b">
             <a:extLst xmlns:a="http://schemas.openxmlformats.org/drawingml/2006/main">
               <a:ext uri="{FF2B5EF4-FFF2-40B4-BE49-F238E27FC236}">
-                <a16:creationId xmlns:a16="http://schemas.microsoft.com/office/drawing/2014/main" id="{75695E33-5176-479E-B4B9-FE1001AA7B83}"/>
+                <a16:creationId xmlns:a16="http://schemas.microsoft.com/office/drawing/2014/main" id="{9B4755B3-D1BA-43BE-AAF7-3D4D7798A392}"/>
               </a:ext>
             </a:extLst>
           </p:cNvPr>
@@ -5409,7 +5850,7 @@
           <p:cNvPr id="20" name="s4-o5a">
             <a:extLst xmlns:a="http://schemas.openxmlformats.org/drawingml/2006/main">
               <a:ext uri="{FF2B5EF4-FFF2-40B4-BE49-F238E27FC236}">
-                <a16:creationId xmlns:a16="http://schemas.microsoft.com/office/drawing/2014/main" id="{70530514-10EB-4369-BE2E-6D6ABE0C273F}"/>
+                <a16:creationId xmlns:a16="http://schemas.microsoft.com/office/drawing/2014/main" id="{F407A083-D9A9-4F0D-B199-030688D71EDA}"/>
               </a:ext>
             </a:extLst>
           </p:cNvPr>
@@ -5454,7 +5895,7 @@
           <p:cNvPr id="21" name="s4-o5b">
             <a:extLst xmlns:a="http://schemas.openxmlformats.org/drawingml/2006/main">
               <a:ext uri="{FF2B5EF4-FFF2-40B4-BE49-F238E27FC236}">
-                <a16:creationId xmlns:a16="http://schemas.microsoft.com/office/drawing/2014/main" id="{1AB4CD06-0FF7-4127-BC5B-79E885B2C3AB}"/>
+                <a16:creationId xmlns:a16="http://schemas.microsoft.com/office/drawing/2014/main" id="{4267C68A-E521-4B98-A5F6-9FFAF762B2CB}"/>
               </a:ext>
             </a:extLst>
           </p:cNvPr>
@@ -5499,7 +5940,7 @@
           <p:cNvPr id="22" name="s4-output-note">
             <a:extLst xmlns:a="http://schemas.openxmlformats.org/drawingml/2006/main">
               <a:ext uri="{FF2B5EF4-FFF2-40B4-BE49-F238E27FC236}">
-                <a16:creationId xmlns:a16="http://schemas.microsoft.com/office/drawing/2014/main" id="{1FAC71B4-C94A-4FBA-94A6-E7E5C2E3C991}"/>
+                <a16:creationId xmlns:a16="http://schemas.microsoft.com/office/drawing/2014/main" id="{45EF5AAE-14D3-4D6F-B6FF-90DB08F6C13F}"/>
               </a:ext>
             </a:extLst>
           </p:cNvPr>
@@ -5566,7 +6007,7 @@
           <p:cNvPr id="24" name="footer-source-4">
             <a:extLst xmlns:a="http://schemas.openxmlformats.org/drawingml/2006/main">
               <a:ext uri="{FF2B5EF4-FFF2-40B4-BE49-F238E27FC236}">
-                <a16:creationId xmlns:a16="http://schemas.microsoft.com/office/drawing/2014/main" id="{F63D8B2C-3A87-4263-9A45-5C444E223E8A}"/>
+                <a16:creationId xmlns:a16="http://schemas.microsoft.com/office/drawing/2014/main" id="{7C0053B7-2ADC-41E7-8F74-7B958F8D6CE2}"/>
               </a:ext>
             </a:extLst>
           </p:cNvPr>
@@ -5611,7 +6052,7 @@
           <p:cNvPr id="25" name="footer-number-4">
             <a:extLst xmlns:a="http://schemas.openxmlformats.org/drawingml/2006/main">
               <a:ext uri="{FF2B5EF4-FFF2-40B4-BE49-F238E27FC236}">
-                <a16:creationId xmlns:a16="http://schemas.microsoft.com/office/drawing/2014/main" id="{A9B14503-75BC-4257-BC86-E0D03F6C9783}"/>
+                <a16:creationId xmlns:a16="http://schemas.microsoft.com/office/drawing/2014/main" id="{C85A1841-8AD6-4E68-AAC5-7148F54E1EC4}"/>
               </a:ext>
             </a:extLst>
           </p:cNvPr>
@@ -5654,7 +6095,7 @@
     </p:spTree>
     <p:extLst>
       <p:ext uri="{BB962C8B-B14F-4D97-AF65-F5344CB8AC3E}">
-        <p14:creationId xmlns:p14="http://schemas.microsoft.com/office/powerpoint/2010/main" val="611825970"/>
+        <p14:creationId xmlns:p14="http://schemas.microsoft.com/office/powerpoint/2010/main" val="842626295"/>
       </p:ext>
     </p:extLst>
   </p:cSld>
@@ -5685,7 +6126,7 @@
           <p:cNvPr id="17" name="s5-title">
             <a:extLst xmlns:a="http://schemas.openxmlformats.org/drawingml/2006/main">
               <a:ext uri="{FF2B5EF4-FFF2-40B4-BE49-F238E27FC236}">
-                <a16:creationId xmlns:a16="http://schemas.microsoft.com/office/drawing/2014/main" id="{9960B5BD-357D-46AC-9292-A4FEF9254D35}"/>
+                <a16:creationId xmlns:a16="http://schemas.microsoft.com/office/drawing/2014/main" id="{CE056469-356C-4CF7-A68E-9B8DE354B7A3}"/>
               </a:ext>
             </a:extLst>
           </p:cNvPr>
@@ -5730,7 +6171,7 @@
           <p:cNvPr id="2" name="s5-subtitle">
             <a:extLst xmlns:a="http://schemas.openxmlformats.org/drawingml/2006/main">
               <a:ext uri="{FF2B5EF4-FFF2-40B4-BE49-F238E27FC236}">
-                <a16:creationId xmlns:a16="http://schemas.microsoft.com/office/drawing/2014/main" id="{D4B1788C-1D9B-40A2-9F2B-5E4B3A8449E8}"/>
+                <a16:creationId xmlns:a16="http://schemas.microsoft.com/office/drawing/2014/main" id="{2E97FCA5-3759-4473-98B7-445B6E392B9A}"/>
               </a:ext>
             </a:extLst>
           </p:cNvPr>
@@ -5775,7 +6216,7 @@
           <p:cNvPr id="3" name="s5-chart-label-pack">
             <a:extLst xmlns:a="http://schemas.openxmlformats.org/drawingml/2006/main">
               <a:ext uri="{FF2B5EF4-FFF2-40B4-BE49-F238E27FC236}">
-                <a16:creationId xmlns:a16="http://schemas.microsoft.com/office/drawing/2014/main" id="{B302D2F5-7B48-496C-8A30-671D8C512E83}"/>
+                <a16:creationId xmlns:a16="http://schemas.microsoft.com/office/drawing/2014/main" id="{5EF5C323-7392-476F-9E31-37AB59A1A3B2}"/>
               </a:ext>
             </a:extLst>
           </p:cNvPr>
@@ -5820,7 +6261,7 @@
           <p:cNvPr id="4" name="s5-chart-label-repo">
             <a:extLst xmlns:a="http://schemas.openxmlformats.org/drawingml/2006/main">
               <a:ext uri="{FF2B5EF4-FFF2-40B4-BE49-F238E27FC236}">
-                <a16:creationId xmlns:a16="http://schemas.microsoft.com/office/drawing/2014/main" id="{0873D7B7-95FB-41E8-A9FF-10CD59A40501}"/>
+                <a16:creationId xmlns:a16="http://schemas.microsoft.com/office/drawing/2014/main" id="{9C50DF07-D51A-4C44-A58D-40CBC8349326}"/>
               </a:ext>
             </a:extLst>
           </p:cNvPr>
@@ -5865,7 +6306,7 @@
           <p:cNvPr id="5" name="s5-stat1">
             <a:extLst xmlns:a="http://schemas.openxmlformats.org/drawingml/2006/main">
               <a:ext uri="{FF2B5EF4-FFF2-40B4-BE49-F238E27FC236}">
-                <a16:creationId xmlns:a16="http://schemas.microsoft.com/office/drawing/2014/main" id="{CFABFDA4-1947-4A45-9087-E5CA71C23EE6}"/>
+                <a16:creationId xmlns:a16="http://schemas.microsoft.com/office/drawing/2014/main" id="{3F311FF6-116B-450D-AE8B-1442FD7F22F3}"/>
               </a:ext>
             </a:extLst>
           </p:cNvPr>
@@ -5910,7 +6351,7 @@
           <p:cNvPr id="6" name="s5-stat1-label">
             <a:extLst xmlns:a="http://schemas.openxmlformats.org/drawingml/2006/main">
               <a:ext uri="{FF2B5EF4-FFF2-40B4-BE49-F238E27FC236}">
-                <a16:creationId xmlns:a16="http://schemas.microsoft.com/office/drawing/2014/main" id="{89784536-19BF-4B39-9A6C-DB166297047B}"/>
+                <a16:creationId xmlns:a16="http://schemas.microsoft.com/office/drawing/2014/main" id="{BBF1766A-A563-4805-BB9A-0BDA99E720BC}"/>
               </a:ext>
             </a:extLst>
           </p:cNvPr>
@@ -5977,7 +6418,7 @@
           <p:cNvPr id="8" name="s5-stat2">
             <a:extLst xmlns:a="http://schemas.openxmlformats.org/drawingml/2006/main">
               <a:ext uri="{FF2B5EF4-FFF2-40B4-BE49-F238E27FC236}">
-                <a16:creationId xmlns:a16="http://schemas.microsoft.com/office/drawing/2014/main" id="{6BF0995E-B27D-412A-85ED-C7385FE383EC}"/>
+                <a16:creationId xmlns:a16="http://schemas.microsoft.com/office/drawing/2014/main" id="{41059287-E99F-4EB1-9E71-CE3976773FD7}"/>
               </a:ext>
             </a:extLst>
           </p:cNvPr>
@@ -6022,7 +6463,7 @@
           <p:cNvPr id="9" name="s5-stat2-label">
             <a:extLst xmlns:a="http://schemas.openxmlformats.org/drawingml/2006/main">
               <a:ext uri="{FF2B5EF4-FFF2-40B4-BE49-F238E27FC236}">
-                <a16:creationId xmlns:a16="http://schemas.microsoft.com/office/drawing/2014/main" id="{CDBE5ED7-B628-4456-A1F8-6E0A939C27CF}"/>
+                <a16:creationId xmlns:a16="http://schemas.microsoft.com/office/drawing/2014/main" id="{8508F888-BDF8-44F2-B2A8-BCCD387A2BB9}"/>
               </a:ext>
             </a:extLst>
           </p:cNvPr>
@@ -6067,7 +6508,7 @@
           <p:cNvPr id="10" name="s5-stat3">
             <a:extLst xmlns:a="http://schemas.openxmlformats.org/drawingml/2006/main">
               <a:ext uri="{FF2B5EF4-FFF2-40B4-BE49-F238E27FC236}">
-                <a16:creationId xmlns:a16="http://schemas.microsoft.com/office/drawing/2014/main" id="{B89465DC-908F-48F5-A652-8F0C3FF59B25}"/>
+                <a16:creationId xmlns:a16="http://schemas.microsoft.com/office/drawing/2014/main" id="{2B9CF1C5-0C4F-4E16-9A19-201C16D2F009}"/>
               </a:ext>
             </a:extLst>
           </p:cNvPr>
@@ -6112,7 +6553,7 @@
           <p:cNvPr id="11" name="s5-stat3-label">
             <a:extLst xmlns:a="http://schemas.openxmlformats.org/drawingml/2006/main">
               <a:ext uri="{FF2B5EF4-FFF2-40B4-BE49-F238E27FC236}">
-                <a16:creationId xmlns:a16="http://schemas.microsoft.com/office/drawing/2014/main" id="{D387EA68-54E2-41A5-98F2-1033EC89CDD9}"/>
+                <a16:creationId xmlns:a16="http://schemas.microsoft.com/office/drawing/2014/main" id="{904FD2F1-0013-4F73-853F-6681E0BC5C8F}"/>
               </a:ext>
             </a:extLst>
           </p:cNvPr>
@@ -6157,7 +6598,7 @@
           <p:cNvPr id="12" name="s5-explain">
             <a:extLst xmlns:a="http://schemas.openxmlformats.org/drawingml/2006/main">
               <a:ext uri="{FF2B5EF4-FFF2-40B4-BE49-F238E27FC236}">
-                <a16:creationId xmlns:a16="http://schemas.microsoft.com/office/drawing/2014/main" id="{DF8A17DB-F518-4892-B58A-892C81ACE86D}"/>
+                <a16:creationId xmlns:a16="http://schemas.microsoft.com/office/drawing/2014/main" id="{E6DEEA2D-50F5-46F8-B0A7-81431B4F850D}"/>
               </a:ext>
             </a:extLst>
           </p:cNvPr>
@@ -6224,7 +6665,7 @@
           <p:cNvPr id="14" name="footer-source-5">
             <a:extLst xmlns:a="http://schemas.openxmlformats.org/drawingml/2006/main">
               <a:ext uri="{FF2B5EF4-FFF2-40B4-BE49-F238E27FC236}">
-                <a16:creationId xmlns:a16="http://schemas.microsoft.com/office/drawing/2014/main" id="{1381C75E-9B0D-4D19-8364-9EFF93B73F6F}"/>
+                <a16:creationId xmlns:a16="http://schemas.microsoft.com/office/drawing/2014/main" id="{BC448489-CCC7-4B83-8CFD-FB9F1653C439}"/>
               </a:ext>
             </a:extLst>
           </p:cNvPr>
@@ -6269,7 +6710,7 @@
           <p:cNvPr id="15" name="footer-number-5">
             <a:extLst xmlns:a="http://schemas.openxmlformats.org/drawingml/2006/main">
               <a:ext uri="{FF2B5EF4-FFF2-40B4-BE49-F238E27FC236}">
-                <a16:creationId xmlns:a16="http://schemas.microsoft.com/office/drawing/2014/main" id="{98F320C5-9CE7-40CA-9357-4765D3222782}"/>
+                <a16:creationId xmlns:a16="http://schemas.microsoft.com/office/drawing/2014/main" id="{D7409FD4-D66E-4D45-A857-E92D5538D525}"/>
               </a:ext>
             </a:extLst>
           </p:cNvPr>
@@ -6321,14 +6762,14 @@
         </p:xfrm>
         <a:graphic xmlns:a="http://schemas.openxmlformats.org/drawingml/2006/main">
           <a:graphicData uri="http://schemas.openxmlformats.org/drawingml/2006/chart">
-            <c:chart xmlns:r="http://schemas.openxmlformats.org/officeDocument/2006/relationships" xmlns:c="http://schemas.openxmlformats.org/drawingml/2006/chart" r:id="R47ea2b50f6794f4e"/>
+            <c:chart xmlns:r="http://schemas.openxmlformats.org/officeDocument/2006/relationships" xmlns:c="http://schemas.openxmlformats.org/drawingml/2006/chart" r:id="R7723a296227f4ecc"/>
           </a:graphicData>
         </a:graphic>
       </p:graphicFrame>
     </p:spTree>
     <p:extLst>
       <p:ext uri="{BB962C8B-B14F-4D97-AF65-F5344CB8AC3E}">
-        <p14:creationId xmlns:p14="http://schemas.microsoft.com/office/powerpoint/2010/main" val="1800457806"/>
+        <p14:creationId xmlns:p14="http://schemas.microsoft.com/office/powerpoint/2010/main" val="1909060003"/>
       </p:ext>
     </p:extLst>
   </p:cSld>
@@ -6359,7 +6800,7 @@
           <p:cNvPr id="16" name="s6-title">
             <a:extLst xmlns:a="http://schemas.openxmlformats.org/drawingml/2006/main">
               <a:ext uri="{FF2B5EF4-FFF2-40B4-BE49-F238E27FC236}">
-                <a16:creationId xmlns:a16="http://schemas.microsoft.com/office/drawing/2014/main" id="{0C2D433A-0A5F-4750-A545-B4BBADD062D5}"/>
+                <a16:creationId xmlns:a16="http://schemas.microsoft.com/office/drawing/2014/main" id="{487359B8-978F-4A12-9574-E8F4BADF5823}"/>
               </a:ext>
             </a:extLst>
           </p:cNvPr>
@@ -6404,7 +6845,7 @@
           <p:cNvPr id="2" name="s6-subtitle">
             <a:extLst xmlns:a="http://schemas.openxmlformats.org/drawingml/2006/main">
               <a:ext uri="{FF2B5EF4-FFF2-40B4-BE49-F238E27FC236}">
-                <a16:creationId xmlns:a16="http://schemas.microsoft.com/office/drawing/2014/main" id="{EE4BFD3C-F413-4E75-8CA7-AEE80452EA2C}"/>
+                <a16:creationId xmlns:a16="http://schemas.microsoft.com/office/drawing/2014/main" id="{2318C7CF-539D-4275-BE7D-CF5E8AC9DFA4}"/>
               </a:ext>
             </a:extLst>
           </p:cNvPr>
@@ -6449,7 +6890,7 @@
           <p:cNvPr id="3" name="s6-chart-label-control">
             <a:extLst xmlns:a="http://schemas.openxmlformats.org/drawingml/2006/main">
               <a:ext uri="{FF2B5EF4-FFF2-40B4-BE49-F238E27FC236}">
-                <a16:creationId xmlns:a16="http://schemas.microsoft.com/office/drawing/2014/main" id="{5466175F-C1E1-40DE-ACAC-C3FCC407F2AD}"/>
+                <a16:creationId xmlns:a16="http://schemas.microsoft.com/office/drawing/2014/main" id="{50356403-4DA9-4582-B4CF-22F5D3B5E281}"/>
               </a:ext>
             </a:extLst>
           </p:cNvPr>
@@ -6494,7 +6935,7 @@
           <p:cNvPr id="4" name="s6-chart-label-full">
             <a:extLst xmlns:a="http://schemas.openxmlformats.org/drawingml/2006/main">
               <a:ext uri="{FF2B5EF4-FFF2-40B4-BE49-F238E27FC236}">
-                <a16:creationId xmlns:a16="http://schemas.microsoft.com/office/drawing/2014/main" id="{DED135FB-2FD2-4960-98DF-81D70C0B7343}"/>
+                <a16:creationId xmlns:a16="http://schemas.microsoft.com/office/drawing/2014/main" id="{EFA8917E-B0A2-436D-B3F8-30221B03FD8D}"/>
               </a:ext>
             </a:extLst>
           </p:cNvPr>
@@ -6539,7 +6980,7 @@
           <p:cNvPr id="5" name="s6-stat">
             <a:extLst xmlns:a="http://schemas.openxmlformats.org/drawingml/2006/main">
               <a:ext uri="{FF2B5EF4-FFF2-40B4-BE49-F238E27FC236}">
-                <a16:creationId xmlns:a16="http://schemas.microsoft.com/office/drawing/2014/main" id="{768D07AB-4D1A-474B-95EF-569164FA9146}"/>
+                <a16:creationId xmlns:a16="http://schemas.microsoft.com/office/drawing/2014/main" id="{4C0C8A57-3B85-4380-88E5-5E7927A79B79}"/>
               </a:ext>
             </a:extLst>
           </p:cNvPr>
@@ -6584,7 +7025,7 @@
           <p:cNvPr id="6" name="s6-stat-label">
             <a:extLst xmlns:a="http://schemas.openxmlformats.org/drawingml/2006/main">
               <a:ext uri="{FF2B5EF4-FFF2-40B4-BE49-F238E27FC236}">
-                <a16:creationId xmlns:a16="http://schemas.microsoft.com/office/drawing/2014/main" id="{CA80A2BD-C7B1-4FC9-ACE0-97F54DB43668}"/>
+                <a16:creationId xmlns:a16="http://schemas.microsoft.com/office/drawing/2014/main" id="{DF62B7DA-CD60-48C6-8047-C2C9DD5A2DA0}"/>
               </a:ext>
             </a:extLst>
           </p:cNvPr>
@@ -6652,7 +7093,7 @@
           <p:cNvPr id="8" name="s6-supported">
             <a:extLst xmlns:a="http://schemas.openxmlformats.org/drawingml/2006/main">
               <a:ext uri="{FF2B5EF4-FFF2-40B4-BE49-F238E27FC236}">
-                <a16:creationId xmlns:a16="http://schemas.microsoft.com/office/drawing/2014/main" id="{D0A0DAFF-993E-4627-AFDA-3E7F1ED72EBE}"/>
+                <a16:creationId xmlns:a16="http://schemas.microsoft.com/office/drawing/2014/main" id="{E803D258-5E49-40A9-B842-D07D91C702B4}"/>
               </a:ext>
             </a:extLst>
           </p:cNvPr>
@@ -6697,7 +7138,7 @@
           <p:cNvPr id="9" name="s6-supported-body">
             <a:extLst xmlns:a="http://schemas.openxmlformats.org/drawingml/2006/main">
               <a:ext uri="{FF2B5EF4-FFF2-40B4-BE49-F238E27FC236}">
-                <a16:creationId xmlns:a16="http://schemas.microsoft.com/office/drawing/2014/main" id="{70FABB36-C603-47F5-B3B7-CC579B84336D}"/>
+                <a16:creationId xmlns:a16="http://schemas.microsoft.com/office/drawing/2014/main" id="{022D91F2-7BEA-4D51-847D-F56BDD78BD3B}"/>
               </a:ext>
             </a:extLst>
           </p:cNvPr>
@@ -6742,7 +7183,7 @@
           <p:cNvPr id="10" name="s6-unsupported">
             <a:extLst xmlns:a="http://schemas.openxmlformats.org/drawingml/2006/main">
               <a:ext uri="{FF2B5EF4-FFF2-40B4-BE49-F238E27FC236}">
-                <a16:creationId xmlns:a16="http://schemas.microsoft.com/office/drawing/2014/main" id="{657E45F9-7E83-44B6-8BB0-27AE799FE80E}"/>
+                <a16:creationId xmlns:a16="http://schemas.microsoft.com/office/drawing/2014/main" id="{BA3B2723-CB93-48CD-B8E5-DA584A12F095}"/>
               </a:ext>
             </a:extLst>
           </p:cNvPr>
@@ -6787,7 +7228,7 @@
           <p:cNvPr id="11" name="s6-unsupported-body">
             <a:extLst xmlns:a="http://schemas.openxmlformats.org/drawingml/2006/main">
               <a:ext uri="{FF2B5EF4-FFF2-40B4-BE49-F238E27FC236}">
-                <a16:creationId xmlns:a16="http://schemas.microsoft.com/office/drawing/2014/main" id="{3197535D-34AD-4118-A1DC-E0D9BB3954A3}"/>
+                <a16:creationId xmlns:a16="http://schemas.microsoft.com/office/drawing/2014/main" id="{9AB02B32-5353-4EAC-8FFD-1A004B207A2D}"/>
               </a:ext>
             </a:extLst>
           </p:cNvPr>
@@ -6854,7 +7295,7 @@
           <p:cNvPr id="13" name="footer-source-6">
             <a:extLst xmlns:a="http://schemas.openxmlformats.org/drawingml/2006/main">
               <a:ext uri="{FF2B5EF4-FFF2-40B4-BE49-F238E27FC236}">
-                <a16:creationId xmlns:a16="http://schemas.microsoft.com/office/drawing/2014/main" id="{73332EA1-1677-4881-8B67-C3684940470E}"/>
+                <a16:creationId xmlns:a16="http://schemas.microsoft.com/office/drawing/2014/main" id="{F7978778-3991-4DE3-A088-A93CE651A785}"/>
               </a:ext>
             </a:extLst>
           </p:cNvPr>
@@ -6899,7 +7340,7 @@
           <p:cNvPr id="14" name="footer-number-6">
             <a:extLst xmlns:a="http://schemas.openxmlformats.org/drawingml/2006/main">
               <a:ext uri="{FF2B5EF4-FFF2-40B4-BE49-F238E27FC236}">
-                <a16:creationId xmlns:a16="http://schemas.microsoft.com/office/drawing/2014/main" id="{6F2BDA4C-3ED2-43E4-8C63-9F21706169EE}"/>
+                <a16:creationId xmlns:a16="http://schemas.microsoft.com/office/drawing/2014/main" id="{15881A3C-A8DD-4EEA-BD29-DB167674AB80}"/>
               </a:ext>
             </a:extLst>
           </p:cNvPr>
@@ -6951,14 +7392,14 @@
         </p:xfrm>
         <a:graphic xmlns:a="http://schemas.openxmlformats.org/drawingml/2006/main">
           <a:graphicData uri="http://schemas.openxmlformats.org/drawingml/2006/chart">
-            <c:chart xmlns:r="http://schemas.openxmlformats.org/officeDocument/2006/relationships" xmlns:c="http://schemas.openxmlformats.org/drawingml/2006/chart" r:id="R15084b7a54204e72"/>
+            <c:chart xmlns:r="http://schemas.openxmlformats.org/officeDocument/2006/relationships" xmlns:c="http://schemas.openxmlformats.org/drawingml/2006/chart" r:id="R441623c8d6f14263"/>
           </a:graphicData>
         </a:graphic>
       </p:graphicFrame>
     </p:spTree>
     <p:extLst>
       <p:ext uri="{BB962C8B-B14F-4D97-AF65-F5344CB8AC3E}">
-        <p14:creationId xmlns:p14="http://schemas.microsoft.com/office/powerpoint/2010/main" val="2035459435"/>
+        <p14:creationId xmlns:p14="http://schemas.microsoft.com/office/powerpoint/2010/main" val="681927638"/>
       </p:ext>
     </p:extLst>
   </p:cSld>
@@ -6989,7 +7430,7 @@
           <p:cNvPr id="26" name="s7-title">
             <a:extLst xmlns:a="http://schemas.openxmlformats.org/drawingml/2006/main">
               <a:ext uri="{FF2B5EF4-FFF2-40B4-BE49-F238E27FC236}">
-                <a16:creationId xmlns:a16="http://schemas.microsoft.com/office/drawing/2014/main" id="{62307740-79C4-45E5-B354-B214B79B46E9}"/>
+                <a16:creationId xmlns:a16="http://schemas.microsoft.com/office/drawing/2014/main" id="{929197BB-C9E3-41FC-BD9B-343A5925640F}"/>
               </a:ext>
             </a:extLst>
           </p:cNvPr>
@@ -7034,7 +7475,7 @@
           <p:cNvPr id="2" name="s7-subtitle">
             <a:extLst xmlns:a="http://schemas.openxmlformats.org/drawingml/2006/main">
               <a:ext uri="{FF2B5EF4-FFF2-40B4-BE49-F238E27FC236}">
-                <a16:creationId xmlns:a16="http://schemas.microsoft.com/office/drawing/2014/main" id="{6BC49522-2AF5-485D-A1E4-5D5DC0DB3369}"/>
+                <a16:creationId xmlns:a16="http://schemas.microsoft.com/office/drawing/2014/main" id="{95FD0001-4D7E-48CE-965C-6145AAEC86D1}"/>
               </a:ext>
             </a:extLst>
           </p:cNvPr>
@@ -7167,7 +7608,7 @@
           <p:cNvPr id="7" name="s7-card1">
             <a:extLst xmlns:a="http://schemas.openxmlformats.org/drawingml/2006/main">
               <a:ext uri="{FF2B5EF4-FFF2-40B4-BE49-F238E27FC236}">
-                <a16:creationId xmlns:a16="http://schemas.microsoft.com/office/drawing/2014/main" id="{7D7C20F4-85BD-450E-B486-4D4FF9169430}"/>
+                <a16:creationId xmlns:a16="http://schemas.microsoft.com/office/drawing/2014/main" id="{747762F8-4186-4728-9DA0-B979B2064A24}"/>
               </a:ext>
             </a:extLst>
           </p:cNvPr>
@@ -7202,7 +7643,7 @@
           <p:cNvPr id="8" name="s7-card2">
             <a:extLst xmlns:a="http://schemas.openxmlformats.org/drawingml/2006/main">
               <a:ext uri="{FF2B5EF4-FFF2-40B4-BE49-F238E27FC236}">
-                <a16:creationId xmlns:a16="http://schemas.microsoft.com/office/drawing/2014/main" id="{1CF1ADA0-1C81-4FFC-8E1D-A5B7BFE53FBA}"/>
+                <a16:creationId xmlns:a16="http://schemas.microsoft.com/office/drawing/2014/main" id="{76164CE1-4552-4E6C-B2A2-9DDEFAF930BB}"/>
               </a:ext>
             </a:extLst>
           </p:cNvPr>
@@ -7237,7 +7678,7 @@
           <p:cNvPr id="9" name="s7-card3">
             <a:extLst xmlns:a="http://schemas.openxmlformats.org/drawingml/2006/main">
               <a:ext uri="{FF2B5EF4-FFF2-40B4-BE49-F238E27FC236}">
-                <a16:creationId xmlns:a16="http://schemas.microsoft.com/office/drawing/2014/main" id="{EC2E9828-528B-4CC5-ABDA-345FCA599887}"/>
+                <a16:creationId xmlns:a16="http://schemas.microsoft.com/office/drawing/2014/main" id="{2AED20BD-33BE-4EED-8286-5A0E73709D23}"/>
               </a:ext>
             </a:extLst>
           </p:cNvPr>
@@ -7272,7 +7713,7 @@
           <p:cNvPr id="10" name="s7-dot1">
             <a:extLst xmlns:a="http://schemas.openxmlformats.org/drawingml/2006/main">
               <a:ext uri="{FF2B5EF4-FFF2-40B4-BE49-F238E27FC236}">
-                <a16:creationId xmlns:a16="http://schemas.microsoft.com/office/drawing/2014/main" id="{DB69A42A-1C50-434E-8916-B18955905E3E}"/>
+                <a16:creationId xmlns:a16="http://schemas.microsoft.com/office/drawing/2014/main" id="{25E8F013-CFC7-449B-AE69-3762175092D9}"/>
               </a:ext>
             </a:extLst>
           </p:cNvPr>
@@ -7305,7 +7746,7 @@
           <p:cNvPr id="11" name="s7-dot2">
             <a:extLst xmlns:a="http://schemas.openxmlformats.org/drawingml/2006/main">
               <a:ext uri="{FF2B5EF4-FFF2-40B4-BE49-F238E27FC236}">
-                <a16:creationId xmlns:a16="http://schemas.microsoft.com/office/drawing/2014/main" id="{099A993C-DB73-478B-8AA3-5359D13359B6}"/>
+                <a16:creationId xmlns:a16="http://schemas.microsoft.com/office/drawing/2014/main" id="{526E9602-9EF4-45AA-8CCD-520BA5E05638}"/>
               </a:ext>
             </a:extLst>
           </p:cNvPr>
@@ -7338,7 +7779,7 @@
           <p:cNvPr id="12" name="s7-dot3">
             <a:extLst xmlns:a="http://schemas.openxmlformats.org/drawingml/2006/main">
               <a:ext uri="{FF2B5EF4-FFF2-40B4-BE49-F238E27FC236}">
-                <a16:creationId xmlns:a16="http://schemas.microsoft.com/office/drawing/2014/main" id="{0FF17C76-E67E-40BD-8193-C19D1F53174F}"/>
+                <a16:creationId xmlns:a16="http://schemas.microsoft.com/office/drawing/2014/main" id="{4C148250-AA68-49CC-BD40-03473359EE98}"/>
               </a:ext>
             </a:extLst>
           </p:cNvPr>
@@ -7371,7 +7812,7 @@
           <p:cNvPr id="13" name="s7-k1">
             <a:extLst xmlns:a="http://schemas.openxmlformats.org/drawingml/2006/main">
               <a:ext uri="{FF2B5EF4-FFF2-40B4-BE49-F238E27FC236}">
-                <a16:creationId xmlns:a16="http://schemas.microsoft.com/office/drawing/2014/main" id="{E003B36B-D895-4A69-AF86-E865C0F65527}"/>
+                <a16:creationId xmlns:a16="http://schemas.microsoft.com/office/drawing/2014/main" id="{0734BDBD-EA2E-4C0C-8978-61BDC9AC1F4A}"/>
               </a:ext>
             </a:extLst>
           </p:cNvPr>
@@ -7416,7 +7857,7 @@
           <p:cNvPr id="14" name="s7-b1">
             <a:extLst xmlns:a="http://schemas.openxmlformats.org/drawingml/2006/main">
               <a:ext uri="{FF2B5EF4-FFF2-40B4-BE49-F238E27FC236}">
-                <a16:creationId xmlns:a16="http://schemas.microsoft.com/office/drawing/2014/main" id="{1F0365B3-BFDD-4DC1-BCFC-1F3FB89260A1}"/>
+                <a16:creationId xmlns:a16="http://schemas.microsoft.com/office/drawing/2014/main" id="{DA24AC9C-38E1-4BA4-AF5A-0784E1126829}"/>
               </a:ext>
             </a:extLst>
           </p:cNvPr>
@@ -7461,7 +7902,7 @@
           <p:cNvPr id="15" name="s7-v1">
             <a:extLst xmlns:a="http://schemas.openxmlformats.org/drawingml/2006/main">
               <a:ext uri="{FF2B5EF4-FFF2-40B4-BE49-F238E27FC236}">
-                <a16:creationId xmlns:a16="http://schemas.microsoft.com/office/drawing/2014/main" id="{FBE9EF65-4136-486E-BE12-E0468B1EF79D}"/>
+                <a16:creationId xmlns:a16="http://schemas.microsoft.com/office/drawing/2014/main" id="{F95EDEE1-DF4F-4239-A1E9-03AC6DE3BA10}"/>
               </a:ext>
             </a:extLst>
           </p:cNvPr>
@@ -7506,7 +7947,7 @@
           <p:cNvPr id="16" name="s7-k2">
             <a:extLst xmlns:a="http://schemas.openxmlformats.org/drawingml/2006/main">
               <a:ext uri="{FF2B5EF4-FFF2-40B4-BE49-F238E27FC236}">
-                <a16:creationId xmlns:a16="http://schemas.microsoft.com/office/drawing/2014/main" id="{20E20B9E-D1DD-4ECD-AE19-C63C11984AD3}"/>
+                <a16:creationId xmlns:a16="http://schemas.microsoft.com/office/drawing/2014/main" id="{804655D3-B186-40D9-9F32-67596F0498D3}"/>
               </a:ext>
             </a:extLst>
           </p:cNvPr>
@@ -7551,7 +7992,7 @@
           <p:cNvPr id="17" name="s7-b2">
             <a:extLst xmlns:a="http://schemas.openxmlformats.org/drawingml/2006/main">
               <a:ext uri="{FF2B5EF4-FFF2-40B4-BE49-F238E27FC236}">
-                <a16:creationId xmlns:a16="http://schemas.microsoft.com/office/drawing/2014/main" id="{576DBC82-DCA6-4348-9207-B83374DA9CAB}"/>
+                <a16:creationId xmlns:a16="http://schemas.microsoft.com/office/drawing/2014/main" id="{C0874439-16BF-4EAC-96A6-C54EC030D658}"/>
               </a:ext>
             </a:extLst>
           </p:cNvPr>
@@ -7596,7 +8037,7 @@
           <p:cNvPr id="18" name="s7-v2">
             <a:extLst xmlns:a="http://schemas.openxmlformats.org/drawingml/2006/main">
               <a:ext uri="{FF2B5EF4-FFF2-40B4-BE49-F238E27FC236}">
-                <a16:creationId xmlns:a16="http://schemas.microsoft.com/office/drawing/2014/main" id="{66E86001-6B3D-40E3-9828-1C9CF27D291F}"/>
+                <a16:creationId xmlns:a16="http://schemas.microsoft.com/office/drawing/2014/main" id="{937D3E81-0C02-4F1E-B186-D85220CC2E25}"/>
               </a:ext>
             </a:extLst>
           </p:cNvPr>
@@ -7641,7 +8082,7 @@
           <p:cNvPr id="19" name="s7-k3">
             <a:extLst xmlns:a="http://schemas.openxmlformats.org/drawingml/2006/main">
               <a:ext uri="{FF2B5EF4-FFF2-40B4-BE49-F238E27FC236}">
-                <a16:creationId xmlns:a16="http://schemas.microsoft.com/office/drawing/2014/main" id="{8F05AB0E-788D-4EED-9BAB-B94073A87D10}"/>
+                <a16:creationId xmlns:a16="http://schemas.microsoft.com/office/drawing/2014/main" id="{0741E171-8028-433E-9C96-DEBBBECD28FB}"/>
               </a:ext>
             </a:extLst>
           </p:cNvPr>
@@ -7686,7 +8127,7 @@
           <p:cNvPr id="20" name="s7-b3">
             <a:extLst xmlns:a="http://schemas.openxmlformats.org/drawingml/2006/main">
               <a:ext uri="{FF2B5EF4-FFF2-40B4-BE49-F238E27FC236}">
-                <a16:creationId xmlns:a16="http://schemas.microsoft.com/office/drawing/2014/main" id="{605B9B9E-C4D1-4650-AFB3-77F2F043CF61}"/>
+                <a16:creationId xmlns:a16="http://schemas.microsoft.com/office/drawing/2014/main" id="{DA0FF87D-9C3B-475C-A287-A5C637B178B0}"/>
               </a:ext>
             </a:extLst>
           </p:cNvPr>
@@ -7731,7 +8172,7 @@
           <p:cNvPr id="21" name="s7-v3">
             <a:extLst xmlns:a="http://schemas.openxmlformats.org/drawingml/2006/main">
               <a:ext uri="{FF2B5EF4-FFF2-40B4-BE49-F238E27FC236}">
-                <a16:creationId xmlns:a16="http://schemas.microsoft.com/office/drawing/2014/main" id="{D63B3F2D-1A06-4909-9C0E-B0D6FFAAFEE5}"/>
+                <a16:creationId xmlns:a16="http://schemas.microsoft.com/office/drawing/2014/main" id="{2FE82206-12A8-4445-9107-63AE87F93460}"/>
               </a:ext>
             </a:extLst>
           </p:cNvPr>
@@ -7776,7 +8217,7 @@
           <p:cNvPr id="22" name="s7-human">
             <a:extLst xmlns:a="http://schemas.openxmlformats.org/drawingml/2006/main">
               <a:ext uri="{FF2B5EF4-FFF2-40B4-BE49-F238E27FC236}">
-                <a16:creationId xmlns:a16="http://schemas.microsoft.com/office/drawing/2014/main" id="{F3EC9779-C014-4A0D-8FD0-E6E2FABEBCA6}"/>
+                <a16:creationId xmlns:a16="http://schemas.microsoft.com/office/drawing/2014/main" id="{A2445D32-5A4A-455B-B496-BE0978E9931F}"/>
               </a:ext>
             </a:extLst>
           </p:cNvPr>
@@ -7843,7 +8284,7 @@
           <p:cNvPr id="24" name="footer-source-7">
             <a:extLst xmlns:a="http://schemas.openxmlformats.org/drawingml/2006/main">
               <a:ext uri="{FF2B5EF4-FFF2-40B4-BE49-F238E27FC236}">
-                <a16:creationId xmlns:a16="http://schemas.microsoft.com/office/drawing/2014/main" id="{DB55EB28-2BFD-4C16-8A1D-162669AB4496}"/>
+                <a16:creationId xmlns:a16="http://schemas.microsoft.com/office/drawing/2014/main" id="{58F0A127-F807-46BA-A562-C15960D1D54E}"/>
               </a:ext>
             </a:extLst>
           </p:cNvPr>
@@ -7888,7 +8329,7 @@
           <p:cNvPr id="25" name="footer-number-7">
             <a:extLst xmlns:a="http://schemas.openxmlformats.org/drawingml/2006/main">
               <a:ext uri="{FF2B5EF4-FFF2-40B4-BE49-F238E27FC236}">
-                <a16:creationId xmlns:a16="http://schemas.microsoft.com/office/drawing/2014/main" id="{FEC4E551-9CD6-4DCF-A25E-83D7096000EB}"/>
+                <a16:creationId xmlns:a16="http://schemas.microsoft.com/office/drawing/2014/main" id="{CFCE8DB4-3B60-44BA-822B-0AC6063C7019}"/>
               </a:ext>
             </a:extLst>
           </p:cNvPr>
@@ -7931,7 +8372,7 @@
     </p:spTree>
     <p:extLst>
       <p:ext uri="{BB962C8B-B14F-4D97-AF65-F5344CB8AC3E}">
-        <p14:creationId xmlns:p14="http://schemas.microsoft.com/office/powerpoint/2010/main" val="2144432346"/>
+        <p14:creationId xmlns:p14="http://schemas.microsoft.com/office/powerpoint/2010/main" val="878683353"/>
       </p:ext>
     </p:extLst>
   </p:cSld>
@@ -7962,7 +8403,7 @@
           <p:cNvPr id="19" name="s8-eyebrow">
             <a:extLst xmlns:a="http://schemas.openxmlformats.org/drawingml/2006/main">
               <a:ext uri="{FF2B5EF4-FFF2-40B4-BE49-F238E27FC236}">
-                <a16:creationId xmlns:a16="http://schemas.microsoft.com/office/drawing/2014/main" id="{D7A16CD0-B306-4ACB-AE6E-0629C612EE67}"/>
+                <a16:creationId xmlns:a16="http://schemas.microsoft.com/office/drawing/2014/main" id="{350716B8-D243-4CC7-8A2E-CCD72D7D968C}"/>
               </a:ext>
             </a:extLst>
           </p:cNvPr>
@@ -8007,7 +8448,7 @@
           <p:cNvPr id="2" name="s8-title">
             <a:extLst xmlns:a="http://schemas.openxmlformats.org/drawingml/2006/main">
               <a:ext uri="{FF2B5EF4-FFF2-40B4-BE49-F238E27FC236}">
-                <a16:creationId xmlns:a16="http://schemas.microsoft.com/office/drawing/2014/main" id="{ABBA4495-E05B-46A6-B02F-D61846528968}"/>
+                <a16:creationId xmlns:a16="http://schemas.microsoft.com/office/drawing/2014/main" id="{F8808116-DD7E-4AE9-9EB6-B4A12D869F13}"/>
               </a:ext>
             </a:extLst>
           </p:cNvPr>
@@ -8076,7 +8517,7 @@
           <p:cNvPr id="4" name="s8-close">
             <a:extLst xmlns:a="http://schemas.openxmlformats.org/drawingml/2006/main">
               <a:ext uri="{FF2B5EF4-FFF2-40B4-BE49-F238E27FC236}">
-                <a16:creationId xmlns:a16="http://schemas.microsoft.com/office/drawing/2014/main" id="{74B32A34-E346-4563-8FB7-E78BCEB67710}"/>
+                <a16:creationId xmlns:a16="http://schemas.microsoft.com/office/drawing/2014/main" id="{21E7F17E-D3DA-4C1B-8129-C08F1C119B22}"/>
               </a:ext>
             </a:extLst>
           </p:cNvPr>
@@ -8121,7 +8562,7 @@
           <p:cNvPr id="5" name="s8-command-box">
             <a:extLst xmlns:a="http://schemas.openxmlformats.org/drawingml/2006/main">
               <a:ext uri="{FF2B5EF4-FFF2-40B4-BE49-F238E27FC236}">
-                <a16:creationId xmlns:a16="http://schemas.microsoft.com/office/drawing/2014/main" id="{8939BC3B-C64F-4496-8C4E-469BA1F49407}"/>
+                <a16:creationId xmlns:a16="http://schemas.microsoft.com/office/drawing/2014/main" id="{10C70A31-BAAC-41A0-93C7-BC206762DFAF}"/>
               </a:ext>
             </a:extLst>
           </p:cNvPr>
@@ -8156,7 +8597,7 @@
           <p:cNvPr id="6" name="s8-command">
             <a:extLst xmlns:a="http://schemas.openxmlformats.org/drawingml/2006/main">
               <a:ext uri="{FF2B5EF4-FFF2-40B4-BE49-F238E27FC236}">
-                <a16:creationId xmlns:a16="http://schemas.microsoft.com/office/drawing/2014/main" id="{2741DBFD-99D2-4EEA-867E-7CC67701E272}"/>
+                <a16:creationId xmlns:a16="http://schemas.microsoft.com/office/drawing/2014/main" id="{91CC4267-8446-4469-A4C9-6F3FF7A158DA}"/>
               </a:ext>
             </a:extLst>
           </p:cNvPr>
@@ -8202,7 +8643,7 @@
           <p:cNvPr id="7" name="s8-github">
             <a:extLst xmlns:a="http://schemas.openxmlformats.org/drawingml/2006/main">
               <a:ext uri="{FF2B5EF4-FFF2-40B4-BE49-F238E27FC236}">
-                <a16:creationId xmlns:a16="http://schemas.microsoft.com/office/drawing/2014/main" id="{BFE149C0-BDB7-4F64-AD11-15F053E4D2CF}"/>
+                <a16:creationId xmlns:a16="http://schemas.microsoft.com/office/drawing/2014/main" id="{AF8896AC-44C9-4763-A6B1-A5C90CA10E39}"/>
               </a:ext>
             </a:extLst>
           </p:cNvPr>
@@ -8247,7 +8688,7 @@
           <p:cNvPr id="8" name="s8-npm">
             <a:extLst xmlns:a="http://schemas.openxmlformats.org/drawingml/2006/main">
               <a:ext uri="{FF2B5EF4-FFF2-40B4-BE49-F238E27FC236}">
-                <a16:creationId xmlns:a16="http://schemas.microsoft.com/office/drawing/2014/main" id="{F7F6D1C7-5851-4975-90C6-4D666912BA74}"/>
+                <a16:creationId xmlns:a16="http://schemas.microsoft.com/office/drawing/2014/main" id="{09E5B382-4510-455B-BFF9-5F0EB8EBC3A4}"/>
               </a:ext>
             </a:extLst>
           </p:cNvPr>
@@ -8292,7 +8733,7 @@
           <p:cNvPr id="9" name="s8-d1">
             <a:extLst xmlns:a="http://schemas.openxmlformats.org/drawingml/2006/main">
               <a:ext uri="{FF2B5EF4-FFF2-40B4-BE49-F238E27FC236}">
-                <a16:creationId xmlns:a16="http://schemas.microsoft.com/office/drawing/2014/main" id="{91DDB8B8-A07A-4FC4-8CAD-37D30C3B7F67}"/>
+                <a16:creationId xmlns:a16="http://schemas.microsoft.com/office/drawing/2014/main" id="{169F9059-2B1A-4A97-83D1-39D9E1EEB772}"/>
               </a:ext>
             </a:extLst>
           </p:cNvPr>
@@ -8325,7 +8766,7 @@
           <p:cNvPr id="10" name="s8-l1">
             <a:extLst xmlns:a="http://schemas.openxmlformats.org/drawingml/2006/main">
               <a:ext uri="{FF2B5EF4-FFF2-40B4-BE49-F238E27FC236}">
-                <a16:creationId xmlns:a16="http://schemas.microsoft.com/office/drawing/2014/main" id="{C4805384-80DD-439A-9F3B-748EBDBA746A}"/>
+                <a16:creationId xmlns:a16="http://schemas.microsoft.com/office/drawing/2014/main" id="{0E80CB7C-4061-48DD-B7F1-F534F5E9B2D3}"/>
               </a:ext>
             </a:extLst>
           </p:cNvPr>
@@ -8370,7 +8811,7 @@
           <p:cNvPr id="11" name="s8-d2">
             <a:extLst xmlns:a="http://schemas.openxmlformats.org/drawingml/2006/main">
               <a:ext uri="{FF2B5EF4-FFF2-40B4-BE49-F238E27FC236}">
-                <a16:creationId xmlns:a16="http://schemas.microsoft.com/office/drawing/2014/main" id="{7A57D747-4406-4A9B-899E-213958211E91}"/>
+                <a16:creationId xmlns:a16="http://schemas.microsoft.com/office/drawing/2014/main" id="{2F1535AE-FC9B-4E9E-8E45-EC5E4A97799F}"/>
               </a:ext>
             </a:extLst>
           </p:cNvPr>
@@ -8403,7 +8844,7 @@
           <p:cNvPr id="12" name="s8-l2">
             <a:extLst xmlns:a="http://schemas.openxmlformats.org/drawingml/2006/main">
               <a:ext uri="{FF2B5EF4-FFF2-40B4-BE49-F238E27FC236}">
-                <a16:creationId xmlns:a16="http://schemas.microsoft.com/office/drawing/2014/main" id="{6C2106C5-A204-4920-8066-806344907E14}"/>
+                <a16:creationId xmlns:a16="http://schemas.microsoft.com/office/drawing/2014/main" id="{7B7A5867-8B20-46E2-95CF-05E12176F1E8}"/>
               </a:ext>
             </a:extLst>
           </p:cNvPr>
@@ -8448,7 +8889,7 @@
           <p:cNvPr id="13" name="s8-d3">
             <a:extLst xmlns:a="http://schemas.openxmlformats.org/drawingml/2006/main">
               <a:ext uri="{FF2B5EF4-FFF2-40B4-BE49-F238E27FC236}">
-                <a16:creationId xmlns:a16="http://schemas.microsoft.com/office/drawing/2014/main" id="{EA0B3F80-C9A0-4924-A30A-361F11D6AEDE}"/>
+                <a16:creationId xmlns:a16="http://schemas.microsoft.com/office/drawing/2014/main" id="{4DCD492D-97B7-4F51-91CC-6F534E64CD1C}"/>
               </a:ext>
             </a:extLst>
           </p:cNvPr>
@@ -8481,7 +8922,7 @@
           <p:cNvPr id="14" name="s8-l3">
             <a:extLst xmlns:a="http://schemas.openxmlformats.org/drawingml/2006/main">
               <a:ext uri="{FF2B5EF4-FFF2-40B4-BE49-F238E27FC236}">
-                <a16:creationId xmlns:a16="http://schemas.microsoft.com/office/drawing/2014/main" id="{7EEF8C95-F7D6-4C9C-A2C6-AAD268664D3C}"/>
+                <a16:creationId xmlns:a16="http://schemas.microsoft.com/office/drawing/2014/main" id="{6F88E6FF-50BD-4DC3-AD40-8982CFF6D71C}"/>
               </a:ext>
             </a:extLst>
           </p:cNvPr>
@@ -8526,7 +8967,7 @@
           <p:cNvPr id="15" name="s8-platforms">
             <a:extLst xmlns:a="http://schemas.openxmlformats.org/drawingml/2006/main">
               <a:ext uri="{FF2B5EF4-FFF2-40B4-BE49-F238E27FC236}">
-                <a16:creationId xmlns:a16="http://schemas.microsoft.com/office/drawing/2014/main" id="{7DAD2529-C304-4C68-A7AE-81A7C31E709B}"/>
+                <a16:creationId xmlns:a16="http://schemas.microsoft.com/office/drawing/2014/main" id="{E0C0EB5A-1288-488C-8ED3-B7491E97A0C4}"/>
               </a:ext>
             </a:extLst>
           </p:cNvPr>
@@ -8593,7 +9034,7 @@
           <p:cNvPr id="17" name="footer-source-8">
             <a:extLst xmlns:a="http://schemas.openxmlformats.org/drawingml/2006/main">
               <a:ext uri="{FF2B5EF4-FFF2-40B4-BE49-F238E27FC236}">
-                <a16:creationId xmlns:a16="http://schemas.microsoft.com/office/drawing/2014/main" id="{7B79A44B-BBE1-49AD-98B9-18B5D3499FCF}"/>
+                <a16:creationId xmlns:a16="http://schemas.microsoft.com/office/drawing/2014/main" id="{A2830800-C494-4C98-B0BC-4B419D500DC6}"/>
               </a:ext>
             </a:extLst>
           </p:cNvPr>
@@ -8638,7 +9079,7 @@
           <p:cNvPr id="18" name="footer-number-8">
             <a:extLst xmlns:a="http://schemas.openxmlformats.org/drawingml/2006/main">
               <a:ext uri="{FF2B5EF4-FFF2-40B4-BE49-F238E27FC236}">
-                <a16:creationId xmlns:a16="http://schemas.microsoft.com/office/drawing/2014/main" id="{06D2C7E8-428D-49E7-BE60-DD3EECA2C140}"/>
+                <a16:creationId xmlns:a16="http://schemas.microsoft.com/office/drawing/2014/main" id="{3692B7C0-C78E-46EC-8470-7D7A4D12425F}"/>
               </a:ext>
             </a:extLst>
           </p:cNvPr>
@@ -8681,7 +9122,7 @@
     </p:spTree>
     <p:extLst>
       <p:ext uri="{BB962C8B-B14F-4D97-AF65-F5344CB8AC3E}">
-        <p14:creationId xmlns:p14="http://schemas.microsoft.com/office/powerpoint/2010/main" val="1784538584"/>
+        <p14:creationId xmlns:p14="http://schemas.microsoft.com/office/powerpoint/2010/main" val="1171177393"/>
       </p:ext>
     </p:extLst>
   </p:cSld>

</xml_diff>

<commit_message>
docs: make Codex baseline explicit in benchmark
</commit_message>
<xml_diff>
--- a/outputs/vertex-palace-build-week-demo.pptx
+++ b/outputs/vertex-palace-build-week-demo.pptx
@@ -2,24 +2,24 @@
 <file path=ppt/presentation.xml><?xml version="1.0" encoding="utf-8"?>
 <p:presentation xmlns:p="http://schemas.openxmlformats.org/presentationml/2006/main">
   <p:sldMasterIdLst>
-    <p:sldMasterId xmlns:r="http://schemas.openxmlformats.org/officeDocument/2006/relationships" id="2147483648" r:id="Rfa7efd61061c429f"/>
+    <p:sldMasterId xmlns:r="http://schemas.openxmlformats.org/officeDocument/2006/relationships" id="2147483648" r:id="R9a1527e3f664493a"/>
   </p:sldMasterIdLst>
   <p:notesMasterIdLst>
-    <p:notesMasterId xmlns:r="http://schemas.openxmlformats.org/officeDocument/2006/relationships" r:id="Rdc5b3f1b06fa4e75"/>
+    <p:notesMasterId xmlns:r="http://schemas.openxmlformats.org/officeDocument/2006/relationships" r:id="R26b3130091ff41e9"/>
   </p:notesMasterIdLst>
   <p:sldIdLst>
-    <p:sldId xmlns:r="http://schemas.openxmlformats.org/officeDocument/2006/relationships" id="256" r:id="R8f8f2530d2df4f6c"/>
-    <p:sldId xmlns:r="http://schemas.openxmlformats.org/officeDocument/2006/relationships" id="257" r:id="Ra553d0c38f834a20"/>
-    <p:sldId xmlns:r="http://schemas.openxmlformats.org/officeDocument/2006/relationships" id="258" r:id="R88478c72c5244abf"/>
-    <p:sldId xmlns:r="http://schemas.openxmlformats.org/officeDocument/2006/relationships" id="259" r:id="Rfa3e39caf32949f1"/>
-    <p:sldId xmlns:r="http://schemas.openxmlformats.org/officeDocument/2006/relationships" id="260" r:id="R0a4c72b3dcb444a0"/>
-    <p:sldId xmlns:r="http://schemas.openxmlformats.org/officeDocument/2006/relationships" id="261" r:id="Raa743e28550944a7"/>
-    <p:sldId xmlns:r="http://schemas.openxmlformats.org/officeDocument/2006/relationships" id="262" r:id="R305d7fe5ea074677"/>
-    <p:sldId xmlns:r="http://schemas.openxmlformats.org/officeDocument/2006/relationships" id="263" r:id="R4c741d9685b2475d"/>
-    <p:sldId xmlns:r="http://schemas.openxmlformats.org/officeDocument/2006/relationships" id="264" r:id="Reac28eb7789c4297"/>
-    <p:sldId xmlns:r="http://schemas.openxmlformats.org/officeDocument/2006/relationships" id="265" r:id="R7ceae9fe556b4351"/>
-    <p:sldId xmlns:r="http://schemas.openxmlformats.org/officeDocument/2006/relationships" id="266" r:id="Rcf74c570646a4b09"/>
-    <p:sldId xmlns:r="http://schemas.openxmlformats.org/officeDocument/2006/relationships" id="267" r:id="Rd3ef8fe7668c4a6c"/>
+    <p:sldId xmlns:r="http://schemas.openxmlformats.org/officeDocument/2006/relationships" id="256" r:id="R046a9563a86f4f7d"/>
+    <p:sldId xmlns:r="http://schemas.openxmlformats.org/officeDocument/2006/relationships" id="257" r:id="R925c9c8d69e8439a"/>
+    <p:sldId xmlns:r="http://schemas.openxmlformats.org/officeDocument/2006/relationships" id="258" r:id="R3f4f772aa47c40e5"/>
+    <p:sldId xmlns:r="http://schemas.openxmlformats.org/officeDocument/2006/relationships" id="259" r:id="Rd609fa70d57943d2"/>
+    <p:sldId xmlns:r="http://schemas.openxmlformats.org/officeDocument/2006/relationships" id="260" r:id="Re6cc03ad701b47dd"/>
+    <p:sldId xmlns:r="http://schemas.openxmlformats.org/officeDocument/2006/relationships" id="261" r:id="Rfc802f44aafa4d18"/>
+    <p:sldId xmlns:r="http://schemas.openxmlformats.org/officeDocument/2006/relationships" id="262" r:id="R45c047a3952c4090"/>
+    <p:sldId xmlns:r="http://schemas.openxmlformats.org/officeDocument/2006/relationships" id="263" r:id="R78ce1b5f112d4c5a"/>
+    <p:sldId xmlns:r="http://schemas.openxmlformats.org/officeDocument/2006/relationships" id="264" r:id="Rcd339ced721a44f2"/>
+    <p:sldId xmlns:r="http://schemas.openxmlformats.org/officeDocument/2006/relationships" id="265" r:id="R3ef1b87c345c4d33"/>
+    <p:sldId xmlns:r="http://schemas.openxmlformats.org/officeDocument/2006/relationships" id="266" r:id="R846745ac91574482"/>
+    <p:sldId xmlns:r="http://schemas.openxmlformats.org/officeDocument/2006/relationships" id="267" r:id="Rcc99a644f15b426c"/>
   </p:sldIdLst>
   <p:sldSz cx="12192000" cy="6858000"/>
   <p:notesSz cx="6858000" cy="9144000"/>
@@ -1173,7 +1173,7 @@
           <a:lstStyle xmlns:a="http://schemas.openxmlformats.org/drawingml/2006/main"/>
           <a:p xmlns:a="http://schemas.openxmlformats.org/drawingml/2006/main">
             <a:r>
-              <a:t>Start with experimental control. Sixteen tasks were each run four ways: no Palace, route metadata only, always-on Full Palace, and Adaptive mode selection.</a:t>
+              <a:t>Start by defining the baseline. Codex alone is the no-Palace Control: the same Codex searches the repository directly. Sixteen tasks were each run four ways: Codex alone, route metadata only, always-on Full Palace, and Adaptive mode selection.</a:t>
             </a:r>
           </a:p>
           <a:p xmlns:a="http://schemas.openxmlformats.org/drawingml/2006/main">
@@ -1246,6 +1246,11 @@
         <p:txBody>
           <a:bodyPr xmlns:a="http://schemas.openxmlformats.org/drawingml/2006/main"/>
           <a:lstStyle xmlns:a="http://schemas.openxmlformats.org/drawingml/2006/main"/>
+          <a:p xmlns:a="http://schemas.openxmlformats.org/drawingml/2006/main">
+            <a:r>
+              <a:t>Define the comparison before reading the result: Codex alone is the no-Palace Control, not another model or agent. Everything else was held fixed. The displayed numbers are paired Adaptive-minus-Codex-alone differences.</a:t>
+            </a:r>
+          </a:p>
           <a:p xmlns:a="http://schemas.openxmlformats.org/drawingml/2006/main">
             <a:r>
               <a:t>Say the uncomfortable result plainly: if Vertex Palace were forced on for every task, this benchmark would argue that it was unnecessary for these deterministic synthetic fixtures. Adaptive added 4.5 tool calls, while reported Token and time central estimates were higher but inconclusive.</a:t>
@@ -1476,7 +1481,7 @@
   </p:cSld>
   <p:clrMap bg1="lt1" tx1="dk1" bg2="lt2" tx2="dk2" accent1="accent1" accent2="accent2" accent3="accent3" accent4="accent4" accent5="accent5" accent6="accent6" hlink="hlink" folHlink="folHlink"/>
   <p:sldLayoutIdLst>
-    <p:sldLayoutId xmlns:r="http://schemas.openxmlformats.org/officeDocument/2006/relationships" id="2147483649" r:id="R850c1df3decc421f"/>
+    <p:sldLayoutId xmlns:r="http://schemas.openxmlformats.org/officeDocument/2006/relationships" id="2147483649" r:id="Rd3091bcf134c4561"/>
   </p:sldLayoutIdLst>
   <p:txStyles>
     <p:titleStyle>
@@ -2197,7 +2202,7 @@
           <p:cNvPr id="7" name="s1-eyebrow">
             <a:extLst xmlns:a="http://schemas.openxmlformats.org/drawingml/2006/main">
               <a:ext uri="{FF2B5EF4-FFF2-40B4-BE49-F238E27FC236}">
-                <a16:creationId xmlns:a16="http://schemas.microsoft.com/office/drawing/2014/main" id="{41C192AE-BED5-4A4F-943E-64B34B26425D}"/>
+                <a16:creationId xmlns:a16="http://schemas.microsoft.com/office/drawing/2014/main" id="{201B327C-6A4A-4221-90C4-CCFD0914DE4A}"/>
               </a:ext>
             </a:extLst>
           </p:cNvPr>
@@ -2242,7 +2247,7 @@
           <p:cNvPr id="2" name="s1-title">
             <a:extLst xmlns:a="http://schemas.openxmlformats.org/drawingml/2006/main">
               <a:ext uri="{FF2B5EF4-FFF2-40B4-BE49-F238E27FC236}">
-                <a16:creationId xmlns:a16="http://schemas.microsoft.com/office/drawing/2014/main" id="{E8116F1E-3E9F-4042-8978-8FAFFD912EE8}"/>
+                <a16:creationId xmlns:a16="http://schemas.microsoft.com/office/drawing/2014/main" id="{BE248E8D-F991-4EA1-930E-63226690D67B}"/>
               </a:ext>
             </a:extLst>
           </p:cNvPr>
@@ -2310,7 +2315,7 @@
           <p:cNvPr id="4" name="s1-subtitle">
             <a:extLst xmlns:a="http://schemas.openxmlformats.org/drawingml/2006/main">
               <a:ext uri="{FF2B5EF4-FFF2-40B4-BE49-F238E27FC236}">
-                <a16:creationId xmlns:a16="http://schemas.microsoft.com/office/drawing/2014/main" id="{574F8BF2-2299-40E0-BE13-7D0B6EAF6549}"/>
+                <a16:creationId xmlns:a16="http://schemas.microsoft.com/office/drawing/2014/main" id="{2B0FA419-93BB-44C6-B18E-97BE047A40B4}"/>
               </a:ext>
             </a:extLst>
           </p:cNvPr>
@@ -2355,7 +2360,7 @@
           <p:cNvPr id="5" name="s1-version">
             <a:extLst xmlns:a="http://schemas.openxmlformats.org/drawingml/2006/main">
               <a:ext uri="{FF2B5EF4-FFF2-40B4-BE49-F238E27FC236}">
-                <a16:creationId xmlns:a16="http://schemas.microsoft.com/office/drawing/2014/main" id="{A8EB010A-B1A3-4B88-BE4E-F08BBAE27F7B}"/>
+                <a16:creationId xmlns:a16="http://schemas.microsoft.com/office/drawing/2014/main" id="{1C24CAB5-4138-48F1-BC59-A5EC31151FF4}"/>
               </a:ext>
             </a:extLst>
           </p:cNvPr>
@@ -2404,7 +2409,7 @@
           <p:nvPr/>
         </p:nvPicPr>
         <p:blipFill>
-          <a:blip xmlns:r="http://schemas.openxmlformats.org/officeDocument/2006/relationships" xmlns:a="http://schemas.openxmlformats.org/drawingml/2006/main" r:embed="R09ce5c00e97644fc"/>
+          <a:blip xmlns:r="http://schemas.openxmlformats.org/officeDocument/2006/relationships" xmlns:a="http://schemas.openxmlformats.org/drawingml/2006/main" r:embed="Rd8095c8b1b5e44a2"/>
           <a:stretch xmlns:a="http://schemas.openxmlformats.org/drawingml/2006/main"/>
         </p:blipFill>
         <p:spPr>
@@ -2420,7 +2425,7 @@
     </p:spTree>
     <p:extLst>
       <p:ext uri="{BB962C8B-B14F-4D97-AF65-F5344CB8AC3E}">
-        <p14:creationId xmlns:p14="http://schemas.microsoft.com/office/powerpoint/2010/main" val="1017580000"/>
+        <p14:creationId xmlns:p14="http://schemas.microsoft.com/office/powerpoint/2010/main" val="337108345"/>
       </p:ext>
     </p:extLst>
   </p:cSld>
@@ -2451,7 +2456,7 @@
           <p:cNvPr id="39" name="s10-title">
             <a:extLst xmlns:a="http://schemas.openxmlformats.org/drawingml/2006/main">
               <a:ext uri="{FF2B5EF4-FFF2-40B4-BE49-F238E27FC236}">
-                <a16:creationId xmlns:a16="http://schemas.microsoft.com/office/drawing/2014/main" id="{F27BC063-6326-45FC-8EAC-A4A8127E509F}"/>
+                <a16:creationId xmlns:a16="http://schemas.microsoft.com/office/drawing/2014/main" id="{809D7507-4C0D-4EF4-9B14-B15B29DD0189}"/>
               </a:ext>
             </a:extLst>
           </p:cNvPr>
@@ -2496,7 +2501,7 @@
           <p:cNvPr id="2" name="s10-subtitle">
             <a:extLst xmlns:a="http://schemas.openxmlformats.org/drawingml/2006/main">
               <a:ext uri="{FF2B5EF4-FFF2-40B4-BE49-F238E27FC236}">
-                <a16:creationId xmlns:a16="http://schemas.microsoft.com/office/drawing/2014/main" id="{261E399F-678D-49F0-BD84-ABD438374628}"/>
+                <a16:creationId xmlns:a16="http://schemas.microsoft.com/office/drawing/2014/main" id="{46D1C3E3-02A4-4023-994C-2E032FCD08C3}"/>
               </a:ext>
             </a:extLst>
           </p:cNvPr>
@@ -2541,7 +2546,7 @@
           <p:cNvPr id="3" name="s10-tests">
             <a:extLst xmlns:a="http://schemas.openxmlformats.org/drawingml/2006/main">
               <a:ext uri="{FF2B5EF4-FFF2-40B4-BE49-F238E27FC236}">
-                <a16:creationId xmlns:a16="http://schemas.microsoft.com/office/drawing/2014/main" id="{3D87FFCD-113C-48BA-9D84-BC8A1202D7F4}"/>
+                <a16:creationId xmlns:a16="http://schemas.microsoft.com/office/drawing/2014/main" id="{C4E4B177-1A5B-4AA4-A9C7-20ECB3706466}"/>
               </a:ext>
             </a:extLst>
           </p:cNvPr>
@@ -2576,7 +2581,7 @@
           <p:cNvPr id="4" name="s10-tests-k">
             <a:extLst xmlns:a="http://schemas.openxmlformats.org/drawingml/2006/main">
               <a:ext uri="{FF2B5EF4-FFF2-40B4-BE49-F238E27FC236}">
-                <a16:creationId xmlns:a16="http://schemas.microsoft.com/office/drawing/2014/main" id="{0F410417-F4FA-45EB-BCBA-3C31897B56B3}"/>
+                <a16:creationId xmlns:a16="http://schemas.microsoft.com/office/drawing/2014/main" id="{DEA62B3B-325A-419D-9CEA-1E2BFDFCC43A}"/>
               </a:ext>
             </a:extLst>
           </p:cNvPr>
@@ -2621,7 +2626,7 @@
           <p:cNvPr id="5" name="s10-tests-stat">
             <a:extLst xmlns:a="http://schemas.openxmlformats.org/drawingml/2006/main">
               <a:ext uri="{FF2B5EF4-FFF2-40B4-BE49-F238E27FC236}">
-                <a16:creationId xmlns:a16="http://schemas.microsoft.com/office/drawing/2014/main" id="{4613D372-ABD3-4D0E-906B-D5937B93F5DA}"/>
+                <a16:creationId xmlns:a16="http://schemas.microsoft.com/office/drawing/2014/main" id="{ED7F1BD6-A103-42DF-A19E-C373FB6E3597}"/>
               </a:ext>
             </a:extLst>
           </p:cNvPr>
@@ -2666,7 +2671,7 @@
           <p:cNvPr id="6" name="s10-tests-label">
             <a:extLst xmlns:a="http://schemas.openxmlformats.org/drawingml/2006/main">
               <a:ext uri="{FF2B5EF4-FFF2-40B4-BE49-F238E27FC236}">
-                <a16:creationId xmlns:a16="http://schemas.microsoft.com/office/drawing/2014/main" id="{CE65B99E-2D66-4A16-A5A3-B55E1863E4A0}"/>
+                <a16:creationId xmlns:a16="http://schemas.microsoft.com/office/drawing/2014/main" id="{8E7C6F6F-8F37-4C9E-B1A4-CF7119750EEA}"/>
               </a:ext>
             </a:extLst>
           </p:cNvPr>
@@ -2733,7 +2738,7 @@
           <p:cNvPr id="8" name="s10-tests-body">
             <a:extLst xmlns:a="http://schemas.openxmlformats.org/drawingml/2006/main">
               <a:ext uri="{FF2B5EF4-FFF2-40B4-BE49-F238E27FC236}">
-                <a16:creationId xmlns:a16="http://schemas.microsoft.com/office/drawing/2014/main" id="{9FAF8158-1E05-4353-9CEB-7D9C322D4258}"/>
+                <a16:creationId xmlns:a16="http://schemas.microsoft.com/office/drawing/2014/main" id="{81814738-AB05-4AD0-BE69-6F3895C69BF2}"/>
               </a:ext>
             </a:extLst>
           </p:cNvPr>
@@ -2780,7 +2785,7 @@
           <p:cNvPr id="9" name="s10-test-d1">
             <a:extLst xmlns:a="http://schemas.openxmlformats.org/drawingml/2006/main">
               <a:ext uri="{FF2B5EF4-FFF2-40B4-BE49-F238E27FC236}">
-                <a16:creationId xmlns:a16="http://schemas.microsoft.com/office/drawing/2014/main" id="{CE83ECAA-A54B-4E6A-893B-60F056E2BE44}"/>
+                <a16:creationId xmlns:a16="http://schemas.microsoft.com/office/drawing/2014/main" id="{FEB28929-6F93-4532-8A1A-F29BA5AC54D6}"/>
               </a:ext>
             </a:extLst>
           </p:cNvPr>
@@ -2813,7 +2818,7 @@
           <p:cNvPr id="10" name="s10-test-d2">
             <a:extLst xmlns:a="http://schemas.openxmlformats.org/drawingml/2006/main">
               <a:ext uri="{FF2B5EF4-FFF2-40B4-BE49-F238E27FC236}">
-                <a16:creationId xmlns:a16="http://schemas.microsoft.com/office/drawing/2014/main" id="{510DF344-BD2D-4BAD-91C4-6FC19945F0B5}"/>
+                <a16:creationId xmlns:a16="http://schemas.microsoft.com/office/drawing/2014/main" id="{4E6C1326-3B44-43A6-B03B-115D4CDE0DEF}"/>
               </a:ext>
             </a:extLst>
           </p:cNvPr>
@@ -2846,7 +2851,7 @@
           <p:cNvPr id="11" name="s10-test-d3">
             <a:extLst xmlns:a="http://schemas.openxmlformats.org/drawingml/2006/main">
               <a:ext uri="{FF2B5EF4-FFF2-40B4-BE49-F238E27FC236}">
-                <a16:creationId xmlns:a16="http://schemas.microsoft.com/office/drawing/2014/main" id="{B896DA41-F61A-454E-86A9-9523EFE7205C}"/>
+                <a16:creationId xmlns:a16="http://schemas.microsoft.com/office/drawing/2014/main" id="{F5D5D915-C0EE-4EEE-B72F-503161137258}"/>
               </a:ext>
             </a:extLst>
           </p:cNvPr>
@@ -2879,7 +2884,7 @@
           <p:cNvPr id="12" name="s10-test-g1">
             <a:extLst xmlns:a="http://schemas.openxmlformats.org/drawingml/2006/main">
               <a:ext uri="{FF2B5EF4-FFF2-40B4-BE49-F238E27FC236}">
-                <a16:creationId xmlns:a16="http://schemas.microsoft.com/office/drawing/2014/main" id="{153024CE-DECD-4ED6-A625-3B34D78E77CB}"/>
+                <a16:creationId xmlns:a16="http://schemas.microsoft.com/office/drawing/2014/main" id="{E9160AD9-08A3-496F-91A0-6652CF5C6D2D}"/>
               </a:ext>
             </a:extLst>
           </p:cNvPr>
@@ -2924,7 +2929,7 @@
           <p:cNvPr id="13" name="s10-test-g2">
             <a:extLst xmlns:a="http://schemas.openxmlformats.org/drawingml/2006/main">
               <a:ext uri="{FF2B5EF4-FFF2-40B4-BE49-F238E27FC236}">
-                <a16:creationId xmlns:a16="http://schemas.microsoft.com/office/drawing/2014/main" id="{B30B41DB-C769-41E2-A1D5-B049C3F4FFB0}"/>
+                <a16:creationId xmlns:a16="http://schemas.microsoft.com/office/drawing/2014/main" id="{1BAC6A13-C2C6-435D-B924-80F4A565298E}"/>
               </a:ext>
             </a:extLst>
           </p:cNvPr>
@@ -2969,7 +2974,7 @@
           <p:cNvPr id="14" name="s10-test-g3">
             <a:extLst xmlns:a="http://schemas.openxmlformats.org/drawingml/2006/main">
               <a:ext uri="{FF2B5EF4-FFF2-40B4-BE49-F238E27FC236}">
-                <a16:creationId xmlns:a16="http://schemas.microsoft.com/office/drawing/2014/main" id="{00614CD4-2195-46E2-9306-663231605B7D}"/>
+                <a16:creationId xmlns:a16="http://schemas.microsoft.com/office/drawing/2014/main" id="{D5DCAE87-CE77-4CEC-B380-71EDC548152B}"/>
               </a:ext>
             </a:extLst>
           </p:cNvPr>
@@ -3014,7 +3019,7 @@
           <p:cNvPr id="15" name="s10-tests-foot">
             <a:extLst xmlns:a="http://schemas.openxmlformats.org/drawingml/2006/main">
               <a:ext uri="{FF2B5EF4-FFF2-40B4-BE49-F238E27FC236}">
-                <a16:creationId xmlns:a16="http://schemas.microsoft.com/office/drawing/2014/main" id="{97839723-FD15-43E3-80C1-6BCFB83C93A9}"/>
+                <a16:creationId xmlns:a16="http://schemas.microsoft.com/office/drawing/2014/main" id="{B9835101-6EA7-4CE5-AB16-4CDBA10337EB}"/>
               </a:ext>
             </a:extLst>
           </p:cNvPr>
@@ -3059,7 +3064,7 @@
           <p:cNvPr id="16" name="s10-ci">
             <a:extLst xmlns:a="http://schemas.openxmlformats.org/drawingml/2006/main">
               <a:ext uri="{FF2B5EF4-FFF2-40B4-BE49-F238E27FC236}">
-                <a16:creationId xmlns:a16="http://schemas.microsoft.com/office/drawing/2014/main" id="{CED290D0-6EA4-4D5B-B8BE-4FBC33965613}"/>
+                <a16:creationId xmlns:a16="http://schemas.microsoft.com/office/drawing/2014/main" id="{8147F822-471D-495A-A84D-09159181CB41}"/>
               </a:ext>
             </a:extLst>
           </p:cNvPr>
@@ -3094,7 +3099,7 @@
           <p:cNvPr id="17" name="s10-ci-k">
             <a:extLst xmlns:a="http://schemas.openxmlformats.org/drawingml/2006/main">
               <a:ext uri="{FF2B5EF4-FFF2-40B4-BE49-F238E27FC236}">
-                <a16:creationId xmlns:a16="http://schemas.microsoft.com/office/drawing/2014/main" id="{EAC8066A-455A-48A2-9F5A-2A46062960FC}"/>
+                <a16:creationId xmlns:a16="http://schemas.microsoft.com/office/drawing/2014/main" id="{C4A1BB3E-3D5E-445F-AF1B-A5ACF18B4B3E}"/>
               </a:ext>
             </a:extLst>
           </p:cNvPr>
@@ -3139,7 +3144,7 @@
           <p:cNvPr id="18" name="s10-ci-stat">
             <a:extLst xmlns:a="http://schemas.openxmlformats.org/drawingml/2006/main">
               <a:ext uri="{FF2B5EF4-FFF2-40B4-BE49-F238E27FC236}">
-                <a16:creationId xmlns:a16="http://schemas.microsoft.com/office/drawing/2014/main" id="{35B74422-4ACD-4FBB-B8EB-B9FC9097A648}"/>
+                <a16:creationId xmlns:a16="http://schemas.microsoft.com/office/drawing/2014/main" id="{A3F0902E-57B7-4FC4-9AEC-0B456A446916}"/>
               </a:ext>
             </a:extLst>
           </p:cNvPr>
@@ -3184,7 +3189,7 @@
           <p:cNvPr id="19" name="s10-ci-label">
             <a:extLst xmlns:a="http://schemas.openxmlformats.org/drawingml/2006/main">
               <a:ext uri="{FF2B5EF4-FFF2-40B4-BE49-F238E27FC236}">
-                <a16:creationId xmlns:a16="http://schemas.microsoft.com/office/drawing/2014/main" id="{19F1228C-8E16-460F-B51E-70D35365E519}"/>
+                <a16:creationId xmlns:a16="http://schemas.microsoft.com/office/drawing/2014/main" id="{9B906DF6-B103-460F-9116-102650862C63}"/>
               </a:ext>
             </a:extLst>
           </p:cNvPr>
@@ -3251,7 +3256,7 @@
           <p:cNvPr id="21" name="s10-ci-d1">
             <a:extLst xmlns:a="http://schemas.openxmlformats.org/drawingml/2006/main">
               <a:ext uri="{FF2B5EF4-FFF2-40B4-BE49-F238E27FC236}">
-                <a16:creationId xmlns:a16="http://schemas.microsoft.com/office/drawing/2014/main" id="{191EB898-FCB0-430B-A272-838CC0B43B56}"/>
+                <a16:creationId xmlns:a16="http://schemas.microsoft.com/office/drawing/2014/main" id="{13DF9BB2-6ACD-4A72-8672-8F2546224523}"/>
               </a:ext>
             </a:extLst>
           </p:cNvPr>
@@ -3284,7 +3289,7 @@
           <p:cNvPr id="22" name="s10-ci-d2">
             <a:extLst xmlns:a="http://schemas.openxmlformats.org/drawingml/2006/main">
               <a:ext uri="{FF2B5EF4-FFF2-40B4-BE49-F238E27FC236}">
-                <a16:creationId xmlns:a16="http://schemas.microsoft.com/office/drawing/2014/main" id="{C5A7C34F-A155-4400-B87B-B9DB89012FFC}"/>
+                <a16:creationId xmlns:a16="http://schemas.microsoft.com/office/drawing/2014/main" id="{B0FEDDA0-C908-4E68-84D6-AA747E1D1BE1}"/>
               </a:ext>
             </a:extLst>
           </p:cNvPr>
@@ -3317,7 +3322,7 @@
           <p:cNvPr id="23" name="s10-ci-d3">
             <a:extLst xmlns:a="http://schemas.openxmlformats.org/drawingml/2006/main">
               <a:ext uri="{FF2B5EF4-FFF2-40B4-BE49-F238E27FC236}">
-                <a16:creationId xmlns:a16="http://schemas.microsoft.com/office/drawing/2014/main" id="{984C8550-C944-4978-ABAF-FEB461089B71}"/>
+                <a16:creationId xmlns:a16="http://schemas.microsoft.com/office/drawing/2014/main" id="{5556716E-156B-4E0F-85BE-4708A214C155}"/>
               </a:ext>
             </a:extLst>
           </p:cNvPr>
@@ -3350,7 +3355,7 @@
           <p:cNvPr id="24" name="s10-ci-d4">
             <a:extLst xmlns:a="http://schemas.openxmlformats.org/drawingml/2006/main">
               <a:ext uri="{FF2B5EF4-FFF2-40B4-BE49-F238E27FC236}">
-                <a16:creationId xmlns:a16="http://schemas.microsoft.com/office/drawing/2014/main" id="{721DF192-FAB8-4658-8C67-C32437BF43AC}"/>
+                <a16:creationId xmlns:a16="http://schemas.microsoft.com/office/drawing/2014/main" id="{498B89AB-F8A2-461B-8157-FB2724180765}"/>
               </a:ext>
             </a:extLst>
           </p:cNvPr>
@@ -3383,7 +3388,7 @@
           <p:cNvPr id="25" name="s10-ci-d5">
             <a:extLst xmlns:a="http://schemas.openxmlformats.org/drawingml/2006/main">
               <a:ext uri="{FF2B5EF4-FFF2-40B4-BE49-F238E27FC236}">
-                <a16:creationId xmlns:a16="http://schemas.microsoft.com/office/drawing/2014/main" id="{B5707517-A80D-41ED-94E1-D0DFBF2FD7B9}"/>
+                <a16:creationId xmlns:a16="http://schemas.microsoft.com/office/drawing/2014/main" id="{4478B55B-9F5C-4F6C-B788-8E3CE032A4CD}"/>
               </a:ext>
             </a:extLst>
           </p:cNvPr>
@@ -3416,7 +3421,7 @@
           <p:cNvPr id="26" name="s10-ci-r1">
             <a:extLst xmlns:a="http://schemas.openxmlformats.org/drawingml/2006/main">
               <a:ext uri="{FF2B5EF4-FFF2-40B4-BE49-F238E27FC236}">
-                <a16:creationId xmlns:a16="http://schemas.microsoft.com/office/drawing/2014/main" id="{998C2722-49B7-471F-BC2C-BC940225F0D5}"/>
+                <a16:creationId xmlns:a16="http://schemas.microsoft.com/office/drawing/2014/main" id="{43D6478E-DC7F-4579-B154-5DDEAED5C4EB}"/>
               </a:ext>
             </a:extLst>
           </p:cNvPr>
@@ -3461,7 +3466,7 @@
           <p:cNvPr id="27" name="s10-ci-r2">
             <a:extLst xmlns:a="http://schemas.openxmlformats.org/drawingml/2006/main">
               <a:ext uri="{FF2B5EF4-FFF2-40B4-BE49-F238E27FC236}">
-                <a16:creationId xmlns:a16="http://schemas.microsoft.com/office/drawing/2014/main" id="{9FFA5A5E-2615-4B2F-8E19-2BFDA40822B8}"/>
+                <a16:creationId xmlns:a16="http://schemas.microsoft.com/office/drawing/2014/main" id="{84CC1E37-0CED-4F08-B683-2BF9144CD734}"/>
               </a:ext>
             </a:extLst>
           </p:cNvPr>
@@ -3506,7 +3511,7 @@
           <p:cNvPr id="28" name="s10-ci-r3">
             <a:extLst xmlns:a="http://schemas.openxmlformats.org/drawingml/2006/main">
               <a:ext uri="{FF2B5EF4-FFF2-40B4-BE49-F238E27FC236}">
-                <a16:creationId xmlns:a16="http://schemas.microsoft.com/office/drawing/2014/main" id="{3A030282-3494-4B98-9E15-C1CB6525A3F4}"/>
+                <a16:creationId xmlns:a16="http://schemas.microsoft.com/office/drawing/2014/main" id="{6D786245-A39F-446C-9547-73474E71729F}"/>
               </a:ext>
             </a:extLst>
           </p:cNvPr>
@@ -3551,7 +3556,7 @@
           <p:cNvPr id="29" name="s10-ci-r4">
             <a:extLst xmlns:a="http://schemas.openxmlformats.org/drawingml/2006/main">
               <a:ext uri="{FF2B5EF4-FFF2-40B4-BE49-F238E27FC236}">
-                <a16:creationId xmlns:a16="http://schemas.microsoft.com/office/drawing/2014/main" id="{35A11E4D-D72B-4195-BF69-316E2881C14C}"/>
+                <a16:creationId xmlns:a16="http://schemas.microsoft.com/office/drawing/2014/main" id="{341426AF-9D33-45ED-8BBC-03DC9B29941E}"/>
               </a:ext>
             </a:extLst>
           </p:cNvPr>
@@ -3596,7 +3601,7 @@
           <p:cNvPr id="30" name="s10-ci-r5">
             <a:extLst xmlns:a="http://schemas.openxmlformats.org/drawingml/2006/main">
               <a:ext uri="{FF2B5EF4-FFF2-40B4-BE49-F238E27FC236}">
-                <a16:creationId xmlns:a16="http://schemas.microsoft.com/office/drawing/2014/main" id="{C5AD33EC-4700-4393-9570-372451C3951F}"/>
+                <a16:creationId xmlns:a16="http://schemas.microsoft.com/office/drawing/2014/main" id="{316DDD90-D6F3-4095-B1C1-F40DEA085A8E}"/>
               </a:ext>
             </a:extLst>
           </p:cNvPr>
@@ -3641,7 +3646,7 @@
           <p:cNvPr id="31" name="s10-release">
             <a:extLst xmlns:a="http://schemas.openxmlformats.org/drawingml/2006/main">
               <a:ext uri="{FF2B5EF4-FFF2-40B4-BE49-F238E27FC236}">
-                <a16:creationId xmlns:a16="http://schemas.microsoft.com/office/drawing/2014/main" id="{60FB1B5A-304F-42B3-A2EE-B16843F7A189}"/>
+                <a16:creationId xmlns:a16="http://schemas.microsoft.com/office/drawing/2014/main" id="{1635ADD2-F230-45ED-B19D-F652F6C99292}"/>
               </a:ext>
             </a:extLst>
           </p:cNvPr>
@@ -3676,7 +3681,7 @@
           <p:cNvPr id="32" name="s10-release-k">
             <a:extLst xmlns:a="http://schemas.openxmlformats.org/drawingml/2006/main">
               <a:ext uri="{FF2B5EF4-FFF2-40B4-BE49-F238E27FC236}">
-                <a16:creationId xmlns:a16="http://schemas.microsoft.com/office/drawing/2014/main" id="{74AEE07C-788D-43E7-A8CC-A1C2A73F29A4}"/>
+                <a16:creationId xmlns:a16="http://schemas.microsoft.com/office/drawing/2014/main" id="{F64F7C70-E63D-40C9-B3C1-78FEC0AB0253}"/>
               </a:ext>
             </a:extLst>
           </p:cNvPr>
@@ -3721,7 +3726,7 @@
           <p:cNvPr id="33" name="s10-release-stat">
             <a:extLst xmlns:a="http://schemas.openxmlformats.org/drawingml/2006/main">
               <a:ext uri="{FF2B5EF4-FFF2-40B4-BE49-F238E27FC236}">
-                <a16:creationId xmlns:a16="http://schemas.microsoft.com/office/drawing/2014/main" id="{D0326E64-05E0-4617-B8A6-BA3344F6805C}"/>
+                <a16:creationId xmlns:a16="http://schemas.microsoft.com/office/drawing/2014/main" id="{AB915AE8-C297-44DF-86B2-2A5BD87D3EC0}"/>
               </a:ext>
             </a:extLst>
           </p:cNvPr>
@@ -3766,7 +3771,7 @@
           <p:cNvPr id="34" name="s10-release-list">
             <a:extLst xmlns:a="http://schemas.openxmlformats.org/drawingml/2006/main">
               <a:ext uri="{FF2B5EF4-FFF2-40B4-BE49-F238E27FC236}">
-                <a16:creationId xmlns:a16="http://schemas.microsoft.com/office/drawing/2014/main" id="{6BBE62F5-0485-4189-8CFD-009908C2EDA4}"/>
+                <a16:creationId xmlns:a16="http://schemas.microsoft.com/office/drawing/2014/main" id="{BF621953-A50D-4D25-9CAB-C0B38080C59B}"/>
               </a:ext>
             </a:extLst>
           </p:cNvPr>
@@ -3816,7 +3821,7 @@
           <p:cNvPr id="35" name="s10-release-platforms">
             <a:extLst xmlns:a="http://schemas.openxmlformats.org/drawingml/2006/main">
               <a:ext uri="{FF2B5EF4-FFF2-40B4-BE49-F238E27FC236}">
-                <a16:creationId xmlns:a16="http://schemas.microsoft.com/office/drawing/2014/main" id="{C72D513A-07BF-4880-BB2A-6AB81F731928}"/>
+                <a16:creationId xmlns:a16="http://schemas.microsoft.com/office/drawing/2014/main" id="{2AF913EE-C00A-4517-A7C8-A29419C54D45}"/>
               </a:ext>
             </a:extLst>
           </p:cNvPr>
@@ -3883,7 +3888,7 @@
           <p:cNvPr id="37" name="footer-source-10">
             <a:extLst xmlns:a="http://schemas.openxmlformats.org/drawingml/2006/main">
               <a:ext uri="{FF2B5EF4-FFF2-40B4-BE49-F238E27FC236}">
-                <a16:creationId xmlns:a16="http://schemas.microsoft.com/office/drawing/2014/main" id="{7E1C986C-192E-4A03-BC4A-AD2F48BB5ECC}"/>
+                <a16:creationId xmlns:a16="http://schemas.microsoft.com/office/drawing/2014/main" id="{3E94C869-94AA-437B-8D28-8FF90D4DA72D}"/>
               </a:ext>
             </a:extLst>
           </p:cNvPr>
@@ -3928,7 +3933,7 @@
           <p:cNvPr id="38" name="footer-number-10">
             <a:extLst xmlns:a="http://schemas.openxmlformats.org/drawingml/2006/main">
               <a:ext uri="{FF2B5EF4-FFF2-40B4-BE49-F238E27FC236}">
-                <a16:creationId xmlns:a16="http://schemas.microsoft.com/office/drawing/2014/main" id="{2265554B-04D8-44EE-850E-ADF252825A0E}"/>
+                <a16:creationId xmlns:a16="http://schemas.microsoft.com/office/drawing/2014/main" id="{8127F37C-3956-404A-930D-0AEB325AE4D7}"/>
               </a:ext>
             </a:extLst>
           </p:cNvPr>
@@ -3971,7 +3976,7 @@
     </p:spTree>
     <p:extLst>
       <p:ext uri="{BB962C8B-B14F-4D97-AF65-F5344CB8AC3E}">
-        <p14:creationId xmlns:p14="http://schemas.microsoft.com/office/powerpoint/2010/main" val="1542810664"/>
+        <p14:creationId xmlns:p14="http://schemas.microsoft.com/office/powerpoint/2010/main" val="754048349"/>
       </p:ext>
     </p:extLst>
   </p:cSld>
@@ -4002,7 +4007,7 @@
           <p:cNvPr id="27" name="s11-title">
             <a:extLst xmlns:a="http://schemas.openxmlformats.org/drawingml/2006/main">
               <a:ext uri="{FF2B5EF4-FFF2-40B4-BE49-F238E27FC236}">
-                <a16:creationId xmlns:a16="http://schemas.microsoft.com/office/drawing/2014/main" id="{B88885FA-C7F9-4D22-AC38-9759BB0CB7DC}"/>
+                <a16:creationId xmlns:a16="http://schemas.microsoft.com/office/drawing/2014/main" id="{310B7194-FCE1-419C-8774-F97B54EF8CD7}"/>
               </a:ext>
             </a:extLst>
           </p:cNvPr>
@@ -4047,7 +4052,7 @@
           <p:cNvPr id="2" name="s11-subtitle">
             <a:extLst xmlns:a="http://schemas.openxmlformats.org/drawingml/2006/main">
               <a:ext uri="{FF2B5EF4-FFF2-40B4-BE49-F238E27FC236}">
-                <a16:creationId xmlns:a16="http://schemas.microsoft.com/office/drawing/2014/main" id="{56DF3C25-5C1E-40EF-9ABD-0DE0A17C4FAE}"/>
+                <a16:creationId xmlns:a16="http://schemas.microsoft.com/office/drawing/2014/main" id="{5AAD7392-9B4B-4476-A323-56EFBE02EC83}"/>
               </a:ext>
             </a:extLst>
           </p:cNvPr>
@@ -4136,7 +4141,7 @@
           <p:cNvPr id="5" name="s11-arrow1">
             <a:extLst xmlns:a="http://schemas.openxmlformats.org/drawingml/2006/main">
               <a:ext uri="{FF2B5EF4-FFF2-40B4-BE49-F238E27FC236}">
-                <a16:creationId xmlns:a16="http://schemas.microsoft.com/office/drawing/2014/main" id="{2AFE2DBA-7DCA-49A4-B355-2BCD972A0475}"/>
+                <a16:creationId xmlns:a16="http://schemas.microsoft.com/office/drawing/2014/main" id="{827DF129-7BC3-4F2B-9DE9-8B9AB1BCCD26}"/>
               </a:ext>
             </a:extLst>
           </p:cNvPr>
@@ -4181,7 +4186,7 @@
           <p:cNvPr id="6" name="s11-arrow2">
             <a:extLst xmlns:a="http://schemas.openxmlformats.org/drawingml/2006/main">
               <a:ext uri="{FF2B5EF4-FFF2-40B4-BE49-F238E27FC236}">
-                <a16:creationId xmlns:a16="http://schemas.microsoft.com/office/drawing/2014/main" id="{FFFE4074-3AEB-4937-8C6F-56E06C6B47E5}"/>
+                <a16:creationId xmlns:a16="http://schemas.microsoft.com/office/drawing/2014/main" id="{A2FCA3CE-91BD-4588-8A1B-02B26034A07A}"/>
               </a:ext>
             </a:extLst>
           </p:cNvPr>
@@ -4226,7 +4231,7 @@
           <p:cNvPr id="7" name="s11-v021">
             <a:extLst xmlns:a="http://schemas.openxmlformats.org/drawingml/2006/main">
               <a:ext uri="{FF2B5EF4-FFF2-40B4-BE49-F238E27FC236}">
-                <a16:creationId xmlns:a16="http://schemas.microsoft.com/office/drawing/2014/main" id="{D7339D09-7816-4C05-BF73-C8A28B56E259}"/>
+                <a16:creationId xmlns:a16="http://schemas.microsoft.com/office/drawing/2014/main" id="{3AF62F2C-DF75-4BBD-8EA4-A62749D485C8}"/>
               </a:ext>
             </a:extLst>
           </p:cNvPr>
@@ -4261,7 +4266,7 @@
           <p:cNvPr id="8" name="s11-v021-version">
             <a:extLst xmlns:a="http://schemas.openxmlformats.org/drawingml/2006/main">
               <a:ext uri="{FF2B5EF4-FFF2-40B4-BE49-F238E27FC236}">
-                <a16:creationId xmlns:a16="http://schemas.microsoft.com/office/drawing/2014/main" id="{C0645A0E-766F-4F7B-9C7B-B76F55B72F86}"/>
+                <a16:creationId xmlns:a16="http://schemas.microsoft.com/office/drawing/2014/main" id="{07942954-31FA-4003-B660-9CA2C1AC2CF2}"/>
               </a:ext>
             </a:extLst>
           </p:cNvPr>
@@ -4306,7 +4311,7 @@
           <p:cNvPr id="9" name="s11-v021-k">
             <a:extLst xmlns:a="http://schemas.openxmlformats.org/drawingml/2006/main">
               <a:ext uri="{FF2B5EF4-FFF2-40B4-BE49-F238E27FC236}">
-                <a16:creationId xmlns:a16="http://schemas.microsoft.com/office/drawing/2014/main" id="{C88E47FD-BEC9-4EC0-A087-0268A53F8E69}"/>
+                <a16:creationId xmlns:a16="http://schemas.microsoft.com/office/drawing/2014/main" id="{D275748F-2E68-434B-B45A-F2645A306910}"/>
               </a:ext>
             </a:extLst>
           </p:cNvPr>
@@ -4351,7 +4356,7 @@
           <p:cNvPr id="10" name="s11-v021-v">
             <a:extLst xmlns:a="http://schemas.openxmlformats.org/drawingml/2006/main">
               <a:ext uri="{FF2B5EF4-FFF2-40B4-BE49-F238E27FC236}">
-                <a16:creationId xmlns:a16="http://schemas.microsoft.com/office/drawing/2014/main" id="{87FBFD28-1BF7-42C5-852D-E305681A9C1F}"/>
+                <a16:creationId xmlns:a16="http://schemas.microsoft.com/office/drawing/2014/main" id="{D55CADB7-3FB3-4907-980F-4C2D8461365E}"/>
               </a:ext>
             </a:extLst>
           </p:cNvPr>
@@ -4396,7 +4401,7 @@
           <p:cNvPr id="11" name="s11-v021-foot">
             <a:extLst xmlns:a="http://schemas.openxmlformats.org/drawingml/2006/main">
               <a:ext uri="{FF2B5EF4-FFF2-40B4-BE49-F238E27FC236}">
-                <a16:creationId xmlns:a16="http://schemas.microsoft.com/office/drawing/2014/main" id="{C3046B0D-96DC-4DB8-8447-33896CFC01B5}"/>
+                <a16:creationId xmlns:a16="http://schemas.microsoft.com/office/drawing/2014/main" id="{8CC8917F-9835-46DB-A59E-F4F60AF6CE95}"/>
               </a:ext>
             </a:extLst>
           </p:cNvPr>
@@ -4441,7 +4446,7 @@
           <p:cNvPr id="12" name="s11-v022">
             <a:extLst xmlns:a="http://schemas.openxmlformats.org/drawingml/2006/main">
               <a:ext uri="{FF2B5EF4-FFF2-40B4-BE49-F238E27FC236}">
-                <a16:creationId xmlns:a16="http://schemas.microsoft.com/office/drawing/2014/main" id="{224B769D-C6A6-4DFB-ACED-3D9EED9BC135}"/>
+                <a16:creationId xmlns:a16="http://schemas.microsoft.com/office/drawing/2014/main" id="{BD891712-FADA-4C5D-8474-6AE7001834A1}"/>
               </a:ext>
             </a:extLst>
           </p:cNvPr>
@@ -4476,7 +4481,7 @@
           <p:cNvPr id="13" name="s11-v022-version">
             <a:extLst xmlns:a="http://schemas.openxmlformats.org/drawingml/2006/main">
               <a:ext uri="{FF2B5EF4-FFF2-40B4-BE49-F238E27FC236}">
-                <a16:creationId xmlns:a16="http://schemas.microsoft.com/office/drawing/2014/main" id="{736EF2A3-093D-46EF-A766-746A30ADE831}"/>
+                <a16:creationId xmlns:a16="http://schemas.microsoft.com/office/drawing/2014/main" id="{854545AE-BFB3-4C3B-A2AE-0C066C0C9055}"/>
               </a:ext>
             </a:extLst>
           </p:cNvPr>
@@ -4521,7 +4526,7 @@
           <p:cNvPr id="14" name="s11-v022-k">
             <a:extLst xmlns:a="http://schemas.openxmlformats.org/drawingml/2006/main">
               <a:ext uri="{FF2B5EF4-FFF2-40B4-BE49-F238E27FC236}">
-                <a16:creationId xmlns:a16="http://schemas.microsoft.com/office/drawing/2014/main" id="{516D3DEE-650D-4FD5-9D8F-654B8BABE00B}"/>
+                <a16:creationId xmlns:a16="http://schemas.microsoft.com/office/drawing/2014/main" id="{EFC4EF56-AA0A-4A2D-8B6D-3D9A1BD7B0F8}"/>
               </a:ext>
             </a:extLst>
           </p:cNvPr>
@@ -4566,7 +4571,7 @@
           <p:cNvPr id="15" name="s11-v022-v">
             <a:extLst xmlns:a="http://schemas.openxmlformats.org/drawingml/2006/main">
               <a:ext uri="{FF2B5EF4-FFF2-40B4-BE49-F238E27FC236}">
-                <a16:creationId xmlns:a16="http://schemas.microsoft.com/office/drawing/2014/main" id="{7A83E86C-0BCF-48B8-8639-CC7E3B479C0E}"/>
+                <a16:creationId xmlns:a16="http://schemas.microsoft.com/office/drawing/2014/main" id="{6DA7722A-6A95-4A31-BFA7-1AE4201D4622}"/>
               </a:ext>
             </a:extLst>
           </p:cNvPr>
@@ -4611,7 +4616,7 @@
           <p:cNvPr id="16" name="s11-v022-foot">
             <a:extLst xmlns:a="http://schemas.openxmlformats.org/drawingml/2006/main">
               <a:ext uri="{FF2B5EF4-FFF2-40B4-BE49-F238E27FC236}">
-                <a16:creationId xmlns:a16="http://schemas.microsoft.com/office/drawing/2014/main" id="{EBA0B7DA-BFB7-4A7C-892E-F12005CF07CD}"/>
+                <a16:creationId xmlns:a16="http://schemas.microsoft.com/office/drawing/2014/main" id="{CBBD98ED-4E39-44B8-9580-E2D5D62AB45E}"/>
               </a:ext>
             </a:extLst>
           </p:cNvPr>
@@ -4656,7 +4661,7 @@
           <p:cNvPr id="17" name="s11-v023">
             <a:extLst xmlns:a="http://schemas.openxmlformats.org/drawingml/2006/main">
               <a:ext uri="{FF2B5EF4-FFF2-40B4-BE49-F238E27FC236}">
-                <a16:creationId xmlns:a16="http://schemas.microsoft.com/office/drawing/2014/main" id="{93676E56-517B-4813-A342-1D44DB1D4A64}"/>
+                <a16:creationId xmlns:a16="http://schemas.microsoft.com/office/drawing/2014/main" id="{BAA8A162-DAFC-4847-B914-A671CD51A820}"/>
               </a:ext>
             </a:extLst>
           </p:cNvPr>
@@ -4691,7 +4696,7 @@
           <p:cNvPr id="18" name="s11-v023-version">
             <a:extLst xmlns:a="http://schemas.openxmlformats.org/drawingml/2006/main">
               <a:ext uri="{FF2B5EF4-FFF2-40B4-BE49-F238E27FC236}">
-                <a16:creationId xmlns:a16="http://schemas.microsoft.com/office/drawing/2014/main" id="{7EFCAD78-A838-4E79-9088-839052DB4ABD}"/>
+                <a16:creationId xmlns:a16="http://schemas.microsoft.com/office/drawing/2014/main" id="{D9D28751-C303-4A53-AFB2-4D18C5DEF83B}"/>
               </a:ext>
             </a:extLst>
           </p:cNvPr>
@@ -4736,7 +4741,7 @@
           <p:cNvPr id="19" name="s11-v023-k">
             <a:extLst xmlns:a="http://schemas.openxmlformats.org/drawingml/2006/main">
               <a:ext uri="{FF2B5EF4-FFF2-40B4-BE49-F238E27FC236}">
-                <a16:creationId xmlns:a16="http://schemas.microsoft.com/office/drawing/2014/main" id="{417C79D9-8885-4864-A7B3-D50F7E0D53E2}"/>
+                <a16:creationId xmlns:a16="http://schemas.microsoft.com/office/drawing/2014/main" id="{7E6CA211-8C29-484E-A06A-FB2CFD1EAF5D}"/>
               </a:ext>
             </a:extLst>
           </p:cNvPr>
@@ -4781,7 +4786,7 @@
           <p:cNvPr id="20" name="s11-v023-v">
             <a:extLst xmlns:a="http://schemas.openxmlformats.org/drawingml/2006/main">
               <a:ext uri="{FF2B5EF4-FFF2-40B4-BE49-F238E27FC236}">
-                <a16:creationId xmlns:a16="http://schemas.microsoft.com/office/drawing/2014/main" id="{F9D95D13-85ED-49FC-9955-5EE9C23D90ED}"/>
+                <a16:creationId xmlns:a16="http://schemas.microsoft.com/office/drawing/2014/main" id="{1C02CB7D-FEA6-4A37-9FC4-DEB7C3015ABC}"/>
               </a:ext>
             </a:extLst>
           </p:cNvPr>
@@ -4826,7 +4831,7 @@
           <p:cNvPr id="21" name="s11-v023-foot">
             <a:extLst xmlns:a="http://schemas.openxmlformats.org/drawingml/2006/main">
               <a:ext uri="{FF2B5EF4-FFF2-40B4-BE49-F238E27FC236}">
-                <a16:creationId xmlns:a16="http://schemas.microsoft.com/office/drawing/2014/main" id="{07E36275-9B69-413F-93AF-7F0266699BA4}"/>
+                <a16:creationId xmlns:a16="http://schemas.microsoft.com/office/drawing/2014/main" id="{356BBA22-3227-4892-850F-F153B3A1DD7D}"/>
               </a:ext>
             </a:extLst>
           </p:cNvPr>
@@ -4871,7 +4876,7 @@
           <p:cNvPr id="22" name="s11-takeaway">
             <a:extLst xmlns:a="http://schemas.openxmlformats.org/drawingml/2006/main">
               <a:ext uri="{FF2B5EF4-FFF2-40B4-BE49-F238E27FC236}">
-                <a16:creationId xmlns:a16="http://schemas.microsoft.com/office/drawing/2014/main" id="{77D522C4-7CA9-41A9-B18C-9C9E98523823}"/>
+                <a16:creationId xmlns:a16="http://schemas.microsoft.com/office/drawing/2014/main" id="{A8F3C9EF-9909-45F0-9B03-D14A517E57B3}"/>
               </a:ext>
             </a:extLst>
           </p:cNvPr>
@@ -4906,7 +4911,7 @@
           <p:cNvPr id="23" name="s11-takeaway-v">
             <a:extLst xmlns:a="http://schemas.openxmlformats.org/drawingml/2006/main">
               <a:ext uri="{FF2B5EF4-FFF2-40B4-BE49-F238E27FC236}">
-                <a16:creationId xmlns:a16="http://schemas.microsoft.com/office/drawing/2014/main" id="{0800FE5A-59EF-4389-896D-70A56166D526}"/>
+                <a16:creationId xmlns:a16="http://schemas.microsoft.com/office/drawing/2014/main" id="{72A8C497-CBB8-4C03-B137-9FB700DB12E5}"/>
               </a:ext>
             </a:extLst>
           </p:cNvPr>
@@ -4973,7 +4978,7 @@
           <p:cNvPr id="25" name="footer-source-11">
             <a:extLst xmlns:a="http://schemas.openxmlformats.org/drawingml/2006/main">
               <a:ext uri="{FF2B5EF4-FFF2-40B4-BE49-F238E27FC236}">
-                <a16:creationId xmlns:a16="http://schemas.microsoft.com/office/drawing/2014/main" id="{72E33532-B7A3-4670-8627-62D9BCC99CDF}"/>
+                <a16:creationId xmlns:a16="http://schemas.microsoft.com/office/drawing/2014/main" id="{0BA49C22-7D16-4CED-9FDF-37AB6A64B157}"/>
               </a:ext>
             </a:extLst>
           </p:cNvPr>
@@ -5018,7 +5023,7 @@
           <p:cNvPr id="26" name="footer-number-11">
             <a:extLst xmlns:a="http://schemas.openxmlformats.org/drawingml/2006/main">
               <a:ext uri="{FF2B5EF4-FFF2-40B4-BE49-F238E27FC236}">
-                <a16:creationId xmlns:a16="http://schemas.microsoft.com/office/drawing/2014/main" id="{4FB2D785-5BDA-4FE7-BF3E-8A206A21E83D}"/>
+                <a16:creationId xmlns:a16="http://schemas.microsoft.com/office/drawing/2014/main" id="{2D05B543-400A-436B-894D-8069FF257A38}"/>
               </a:ext>
             </a:extLst>
           </p:cNvPr>
@@ -5061,7 +5066,7 @@
     </p:spTree>
     <p:extLst>
       <p:ext uri="{BB962C8B-B14F-4D97-AF65-F5344CB8AC3E}">
-        <p14:creationId xmlns:p14="http://schemas.microsoft.com/office/powerpoint/2010/main" val="1507675935"/>
+        <p14:creationId xmlns:p14="http://schemas.microsoft.com/office/powerpoint/2010/main" val="930949057"/>
       </p:ext>
     </p:extLst>
   </p:cSld>
@@ -5092,7 +5097,7 @@
           <p:cNvPr id="19" name="s12-eyebrow">
             <a:extLst xmlns:a="http://schemas.openxmlformats.org/drawingml/2006/main">
               <a:ext uri="{FF2B5EF4-FFF2-40B4-BE49-F238E27FC236}">
-                <a16:creationId xmlns:a16="http://schemas.microsoft.com/office/drawing/2014/main" id="{B26EE5D9-331C-46B9-8A17-70B8B29581BE}"/>
+                <a16:creationId xmlns:a16="http://schemas.microsoft.com/office/drawing/2014/main" id="{05AFF4B1-03E1-4F7F-9851-A3756D7676EC}"/>
               </a:ext>
             </a:extLst>
           </p:cNvPr>
@@ -5137,7 +5142,7 @@
           <p:cNvPr id="2" name="s12-title">
             <a:extLst xmlns:a="http://schemas.openxmlformats.org/drawingml/2006/main">
               <a:ext uri="{FF2B5EF4-FFF2-40B4-BE49-F238E27FC236}">
-                <a16:creationId xmlns:a16="http://schemas.microsoft.com/office/drawing/2014/main" id="{FC0598FE-5934-4156-9111-EADA524C3B38}"/>
+                <a16:creationId xmlns:a16="http://schemas.microsoft.com/office/drawing/2014/main" id="{D1534BCD-88FB-45A5-904E-BB27EF0D778E}"/>
               </a:ext>
             </a:extLst>
           </p:cNvPr>
@@ -5206,7 +5211,7 @@
           <p:cNvPr id="4" name="s12-close">
             <a:extLst xmlns:a="http://schemas.openxmlformats.org/drawingml/2006/main">
               <a:ext uri="{FF2B5EF4-FFF2-40B4-BE49-F238E27FC236}">
-                <a16:creationId xmlns:a16="http://schemas.microsoft.com/office/drawing/2014/main" id="{4C4DCF78-D1CB-4A22-825F-9FCBA090C768}"/>
+                <a16:creationId xmlns:a16="http://schemas.microsoft.com/office/drawing/2014/main" id="{82BDF553-CC3A-4D95-8A65-5279F868CDEA}"/>
               </a:ext>
             </a:extLst>
           </p:cNvPr>
@@ -5251,7 +5256,7 @@
           <p:cNvPr id="5" name="s12-command-box">
             <a:extLst xmlns:a="http://schemas.openxmlformats.org/drawingml/2006/main">
               <a:ext uri="{FF2B5EF4-FFF2-40B4-BE49-F238E27FC236}">
-                <a16:creationId xmlns:a16="http://schemas.microsoft.com/office/drawing/2014/main" id="{D4B06752-48F6-476C-8EC7-DF4AEDDC0EBE}"/>
+                <a16:creationId xmlns:a16="http://schemas.microsoft.com/office/drawing/2014/main" id="{78279851-2975-4C3D-8786-D34607CB580D}"/>
               </a:ext>
             </a:extLst>
           </p:cNvPr>
@@ -5286,7 +5291,7 @@
           <p:cNvPr id="6" name="s12-command">
             <a:extLst xmlns:a="http://schemas.openxmlformats.org/drawingml/2006/main">
               <a:ext uri="{FF2B5EF4-FFF2-40B4-BE49-F238E27FC236}">
-                <a16:creationId xmlns:a16="http://schemas.microsoft.com/office/drawing/2014/main" id="{069802BD-E1D7-4C26-9DAF-BC9F3769CE17}"/>
+                <a16:creationId xmlns:a16="http://schemas.microsoft.com/office/drawing/2014/main" id="{889DE4A9-01F0-4EFF-919D-98E62167DA65}"/>
               </a:ext>
             </a:extLst>
           </p:cNvPr>
@@ -5332,7 +5337,7 @@
           <p:cNvPr id="7" name="s12-github">
             <a:extLst xmlns:a="http://schemas.openxmlformats.org/drawingml/2006/main">
               <a:ext uri="{FF2B5EF4-FFF2-40B4-BE49-F238E27FC236}">
-                <a16:creationId xmlns:a16="http://schemas.microsoft.com/office/drawing/2014/main" id="{B216AC18-2B33-46B2-9B5A-657C425E7978}"/>
+                <a16:creationId xmlns:a16="http://schemas.microsoft.com/office/drawing/2014/main" id="{CE91FD8C-9291-450A-9432-30443031B623}"/>
               </a:ext>
             </a:extLst>
           </p:cNvPr>
@@ -5377,7 +5382,7 @@
           <p:cNvPr id="8" name="s12-npm">
             <a:extLst xmlns:a="http://schemas.openxmlformats.org/drawingml/2006/main">
               <a:ext uri="{FF2B5EF4-FFF2-40B4-BE49-F238E27FC236}">
-                <a16:creationId xmlns:a16="http://schemas.microsoft.com/office/drawing/2014/main" id="{4BBF6B50-3F2B-49CE-AFEA-1D85265BD334}"/>
+                <a16:creationId xmlns:a16="http://schemas.microsoft.com/office/drawing/2014/main" id="{8D97ECC4-4CB1-4FE0-839A-54974A11B900}"/>
               </a:ext>
             </a:extLst>
           </p:cNvPr>
@@ -5422,7 +5427,7 @@
           <p:cNvPr id="9" name="s12-d1">
             <a:extLst xmlns:a="http://schemas.openxmlformats.org/drawingml/2006/main">
               <a:ext uri="{FF2B5EF4-FFF2-40B4-BE49-F238E27FC236}">
-                <a16:creationId xmlns:a16="http://schemas.microsoft.com/office/drawing/2014/main" id="{B3B25E61-6DDF-4879-8965-97C53775D3A9}"/>
+                <a16:creationId xmlns:a16="http://schemas.microsoft.com/office/drawing/2014/main" id="{B485CE4F-E36F-489F-BA11-4E85B84F896F}"/>
               </a:ext>
             </a:extLst>
           </p:cNvPr>
@@ -5455,7 +5460,7 @@
           <p:cNvPr id="10" name="s12-l1">
             <a:extLst xmlns:a="http://schemas.openxmlformats.org/drawingml/2006/main">
               <a:ext uri="{FF2B5EF4-FFF2-40B4-BE49-F238E27FC236}">
-                <a16:creationId xmlns:a16="http://schemas.microsoft.com/office/drawing/2014/main" id="{B656556F-3903-4E84-B2EE-CA7166FCCF6D}"/>
+                <a16:creationId xmlns:a16="http://schemas.microsoft.com/office/drawing/2014/main" id="{BB2E4B60-6CB6-4991-9C1B-2E55E008E0C4}"/>
               </a:ext>
             </a:extLst>
           </p:cNvPr>
@@ -5500,7 +5505,7 @@
           <p:cNvPr id="11" name="s12-d2">
             <a:extLst xmlns:a="http://schemas.openxmlformats.org/drawingml/2006/main">
               <a:ext uri="{FF2B5EF4-FFF2-40B4-BE49-F238E27FC236}">
-                <a16:creationId xmlns:a16="http://schemas.microsoft.com/office/drawing/2014/main" id="{1AF05E55-D24C-4CFC-9139-2F6C7B99A11F}"/>
+                <a16:creationId xmlns:a16="http://schemas.microsoft.com/office/drawing/2014/main" id="{88B504A8-08F4-4031-A147-ACE37173D53F}"/>
               </a:ext>
             </a:extLst>
           </p:cNvPr>
@@ -5533,7 +5538,7 @@
           <p:cNvPr id="12" name="s12-l2">
             <a:extLst xmlns:a="http://schemas.openxmlformats.org/drawingml/2006/main">
               <a:ext uri="{FF2B5EF4-FFF2-40B4-BE49-F238E27FC236}">
-                <a16:creationId xmlns:a16="http://schemas.microsoft.com/office/drawing/2014/main" id="{0B033A61-2C37-41E1-8953-89C2700EAB04}"/>
+                <a16:creationId xmlns:a16="http://schemas.microsoft.com/office/drawing/2014/main" id="{4927472C-2628-40A6-9679-B4A8553B7E60}"/>
               </a:ext>
             </a:extLst>
           </p:cNvPr>
@@ -5578,7 +5583,7 @@
           <p:cNvPr id="13" name="s12-d3">
             <a:extLst xmlns:a="http://schemas.openxmlformats.org/drawingml/2006/main">
               <a:ext uri="{FF2B5EF4-FFF2-40B4-BE49-F238E27FC236}">
-                <a16:creationId xmlns:a16="http://schemas.microsoft.com/office/drawing/2014/main" id="{9CDC4976-A93B-47F9-930C-AF0C4432AE6E}"/>
+                <a16:creationId xmlns:a16="http://schemas.microsoft.com/office/drawing/2014/main" id="{136B6EE9-39AF-4328-AE90-D501D56A10D8}"/>
               </a:ext>
             </a:extLst>
           </p:cNvPr>
@@ -5611,7 +5616,7 @@
           <p:cNvPr id="14" name="s12-l3">
             <a:extLst xmlns:a="http://schemas.openxmlformats.org/drawingml/2006/main">
               <a:ext uri="{FF2B5EF4-FFF2-40B4-BE49-F238E27FC236}">
-                <a16:creationId xmlns:a16="http://schemas.microsoft.com/office/drawing/2014/main" id="{8D41EC01-ABF0-4549-8D41-703F592AB321}"/>
+                <a16:creationId xmlns:a16="http://schemas.microsoft.com/office/drawing/2014/main" id="{1396DC50-2D5D-457E-9961-C0095F095BE7}"/>
               </a:ext>
             </a:extLst>
           </p:cNvPr>
@@ -5656,7 +5661,7 @@
           <p:cNvPr id="15" name="s12-platforms">
             <a:extLst xmlns:a="http://schemas.openxmlformats.org/drawingml/2006/main">
               <a:ext uri="{FF2B5EF4-FFF2-40B4-BE49-F238E27FC236}">
-                <a16:creationId xmlns:a16="http://schemas.microsoft.com/office/drawing/2014/main" id="{FFE4BC4A-4106-45CF-83F2-3E422BC8DC2A}"/>
+                <a16:creationId xmlns:a16="http://schemas.microsoft.com/office/drawing/2014/main" id="{110E9BD2-9594-4F7B-81E6-419AD915A2C3}"/>
               </a:ext>
             </a:extLst>
           </p:cNvPr>
@@ -5723,7 +5728,7 @@
           <p:cNvPr id="17" name="footer-source-12">
             <a:extLst xmlns:a="http://schemas.openxmlformats.org/drawingml/2006/main">
               <a:ext uri="{FF2B5EF4-FFF2-40B4-BE49-F238E27FC236}">
-                <a16:creationId xmlns:a16="http://schemas.microsoft.com/office/drawing/2014/main" id="{C069F0C0-645C-4BF6-B273-34B4A2F3AD9A}"/>
+                <a16:creationId xmlns:a16="http://schemas.microsoft.com/office/drawing/2014/main" id="{FD429DF0-28AE-4844-9E80-C1F0BE7C180D}"/>
               </a:ext>
             </a:extLst>
           </p:cNvPr>
@@ -5768,7 +5773,7 @@
           <p:cNvPr id="18" name="footer-number-12">
             <a:extLst xmlns:a="http://schemas.openxmlformats.org/drawingml/2006/main">
               <a:ext uri="{FF2B5EF4-FFF2-40B4-BE49-F238E27FC236}">
-                <a16:creationId xmlns:a16="http://schemas.microsoft.com/office/drawing/2014/main" id="{5DD12322-F830-4A90-9054-AB33254C8704}"/>
+                <a16:creationId xmlns:a16="http://schemas.microsoft.com/office/drawing/2014/main" id="{C14C4B1E-DC96-4CC1-B275-EEF5744B0849}"/>
               </a:ext>
             </a:extLst>
           </p:cNvPr>
@@ -5811,7 +5816,7 @@
     </p:spTree>
     <p:extLst>
       <p:ext uri="{BB962C8B-B14F-4D97-AF65-F5344CB8AC3E}">
-        <p14:creationId xmlns:p14="http://schemas.microsoft.com/office/powerpoint/2010/main" val="916940136"/>
+        <p14:creationId xmlns:p14="http://schemas.microsoft.com/office/powerpoint/2010/main" val="548470902"/>
       </p:ext>
     </p:extLst>
   </p:cSld>
@@ -5842,7 +5847,7 @@
           <p:cNvPr id="33" name="s2-title">
             <a:extLst xmlns:a="http://schemas.openxmlformats.org/drawingml/2006/main">
               <a:ext uri="{FF2B5EF4-FFF2-40B4-BE49-F238E27FC236}">
-                <a16:creationId xmlns:a16="http://schemas.microsoft.com/office/drawing/2014/main" id="{D4217F34-942D-44AC-B9F5-3CBB5861F309}"/>
+                <a16:creationId xmlns:a16="http://schemas.microsoft.com/office/drawing/2014/main" id="{0D579AC8-5583-4984-8E94-3754ED7C7944}"/>
               </a:ext>
             </a:extLst>
           </p:cNvPr>
@@ -5887,7 +5892,7 @@
           <p:cNvPr id="2" name="s2-subtitle">
             <a:extLst xmlns:a="http://schemas.openxmlformats.org/drawingml/2006/main">
               <a:ext uri="{FF2B5EF4-FFF2-40B4-BE49-F238E27FC236}">
-                <a16:creationId xmlns:a16="http://schemas.microsoft.com/office/drawing/2014/main" id="{A3C65415-11E0-42D3-B208-7F06D07B409B}"/>
+                <a16:creationId xmlns:a16="http://schemas.microsoft.com/office/drawing/2014/main" id="{665CBE63-4DA3-434A-8B6C-0FDB5DF7E2E9}"/>
               </a:ext>
             </a:extLst>
           </p:cNvPr>
@@ -6042,7 +6047,7 @@
           <p:cNvPr id="8" name="s2-agent">
             <a:extLst xmlns:a="http://schemas.openxmlformats.org/drawingml/2006/main">
               <a:ext uri="{FF2B5EF4-FFF2-40B4-BE49-F238E27FC236}">
-                <a16:creationId xmlns:a16="http://schemas.microsoft.com/office/drawing/2014/main" id="{4A66E9DF-E3D7-4C60-A342-770FDC1548E1}"/>
+                <a16:creationId xmlns:a16="http://schemas.microsoft.com/office/drawing/2014/main" id="{2D81A6FB-D4A8-478C-A701-7A2628B07088}"/>
               </a:ext>
             </a:extLst>
           </p:cNvPr>
@@ -6075,7 +6080,7 @@
           <p:cNvPr id="9" name="s2-agent-label">
             <a:extLst xmlns:a="http://schemas.openxmlformats.org/drawingml/2006/main">
               <a:ext uri="{FF2B5EF4-FFF2-40B4-BE49-F238E27FC236}">
-                <a16:creationId xmlns:a16="http://schemas.microsoft.com/office/drawing/2014/main" id="{C9435926-405F-4235-A003-F4847ABBC510}"/>
+                <a16:creationId xmlns:a16="http://schemas.microsoft.com/office/drawing/2014/main" id="{3B443F16-D913-4BC1-A78B-BB449299C1E2}"/>
               </a:ext>
             </a:extLst>
           </p:cNvPr>
@@ -6120,7 +6125,7 @@
           <p:cNvPr id="10" name="s2-file-a">
             <a:extLst xmlns:a="http://schemas.openxmlformats.org/drawingml/2006/main">
               <a:ext uri="{FF2B5EF4-FFF2-40B4-BE49-F238E27FC236}">
-                <a16:creationId xmlns:a16="http://schemas.microsoft.com/office/drawing/2014/main" id="{D24AF75A-FFE9-4933-9BB2-C0D45480D322}"/>
+                <a16:creationId xmlns:a16="http://schemas.microsoft.com/office/drawing/2014/main" id="{D75ECA4C-35A7-4F99-8F92-E892302B79AB}"/>
               </a:ext>
             </a:extLst>
           </p:cNvPr>
@@ -6153,7 +6158,7 @@
           <p:cNvPr id="11" name="s2-file-b">
             <a:extLst xmlns:a="http://schemas.openxmlformats.org/drawingml/2006/main">
               <a:ext uri="{FF2B5EF4-FFF2-40B4-BE49-F238E27FC236}">
-                <a16:creationId xmlns:a16="http://schemas.microsoft.com/office/drawing/2014/main" id="{A4B71D6A-4D1C-4B81-812C-9EE6A1CD41E6}"/>
+                <a16:creationId xmlns:a16="http://schemas.microsoft.com/office/drawing/2014/main" id="{76676E01-8050-4B3A-AC64-0D322E3BA22D}"/>
               </a:ext>
             </a:extLst>
           </p:cNvPr>
@@ -6186,7 +6191,7 @@
           <p:cNvPr id="12" name="s2-file-c">
             <a:extLst xmlns:a="http://schemas.openxmlformats.org/drawingml/2006/main">
               <a:ext uri="{FF2B5EF4-FFF2-40B4-BE49-F238E27FC236}">
-                <a16:creationId xmlns:a16="http://schemas.microsoft.com/office/drawing/2014/main" id="{C4894B43-A2D4-43CD-A175-6EC33B022700}"/>
+                <a16:creationId xmlns:a16="http://schemas.microsoft.com/office/drawing/2014/main" id="{CEC73809-9FF0-40CB-B57B-E0EA13925669}"/>
               </a:ext>
             </a:extLst>
           </p:cNvPr>
@@ -6219,7 +6224,7 @@
           <p:cNvPr id="13" name="s2-file-d">
             <a:extLst xmlns:a="http://schemas.openxmlformats.org/drawingml/2006/main">
               <a:ext uri="{FF2B5EF4-FFF2-40B4-BE49-F238E27FC236}">
-                <a16:creationId xmlns:a16="http://schemas.microsoft.com/office/drawing/2014/main" id="{344C97E6-4F03-4BDA-965D-970786B50785}"/>
+                <a16:creationId xmlns:a16="http://schemas.microsoft.com/office/drawing/2014/main" id="{735042F7-FA80-4EF7-8051-B0E4DA443577}"/>
               </a:ext>
             </a:extLst>
           </p:cNvPr>
@@ -6252,7 +6257,7 @@
           <p:cNvPr id="14" name="s2-file-e">
             <a:extLst xmlns:a="http://schemas.openxmlformats.org/drawingml/2006/main">
               <a:ext uri="{FF2B5EF4-FFF2-40B4-BE49-F238E27FC236}">
-                <a16:creationId xmlns:a16="http://schemas.microsoft.com/office/drawing/2014/main" id="{7AA431F2-B0BE-46BF-847C-BF44F95F8FC1}"/>
+                <a16:creationId xmlns:a16="http://schemas.microsoft.com/office/drawing/2014/main" id="{DD8C8351-EA5B-4BA8-A2C8-EF24F2C0B1D6}"/>
               </a:ext>
             </a:extLst>
           </p:cNvPr>
@@ -6285,7 +6290,7 @@
           <p:cNvPr id="15" name="s2-file-a-label">
             <a:extLst xmlns:a="http://schemas.openxmlformats.org/drawingml/2006/main">
               <a:ext uri="{FF2B5EF4-FFF2-40B4-BE49-F238E27FC236}">
-                <a16:creationId xmlns:a16="http://schemas.microsoft.com/office/drawing/2014/main" id="{5034AA7B-A186-4426-A322-B7352398D8FC}"/>
+                <a16:creationId xmlns:a16="http://schemas.microsoft.com/office/drawing/2014/main" id="{937604E1-2EC4-4C35-9D0B-2690E0B04209}"/>
               </a:ext>
             </a:extLst>
           </p:cNvPr>
@@ -6330,7 +6335,7 @@
           <p:cNvPr id="16" name="s2-file-b-label">
             <a:extLst xmlns:a="http://schemas.openxmlformats.org/drawingml/2006/main">
               <a:ext uri="{FF2B5EF4-FFF2-40B4-BE49-F238E27FC236}">
-                <a16:creationId xmlns:a16="http://schemas.microsoft.com/office/drawing/2014/main" id="{6AB0B5BE-18B4-402C-BDEF-1F999CF10361}"/>
+                <a16:creationId xmlns:a16="http://schemas.microsoft.com/office/drawing/2014/main" id="{78CFE8E6-4A7C-46ED-9875-CF2AC0D3EF81}"/>
               </a:ext>
             </a:extLst>
           </p:cNvPr>
@@ -6375,7 +6380,7 @@
           <p:cNvPr id="17" name="s2-file-c-label">
             <a:extLst xmlns:a="http://schemas.openxmlformats.org/drawingml/2006/main">
               <a:ext uri="{FF2B5EF4-FFF2-40B4-BE49-F238E27FC236}">
-                <a16:creationId xmlns:a16="http://schemas.microsoft.com/office/drawing/2014/main" id="{47204CF0-30D5-4D4C-998E-AF8E604F2398}"/>
+                <a16:creationId xmlns:a16="http://schemas.microsoft.com/office/drawing/2014/main" id="{A2D1D843-BDAE-4187-B47D-1E55D27D8747}"/>
               </a:ext>
             </a:extLst>
           </p:cNvPr>
@@ -6420,7 +6425,7 @@
           <p:cNvPr id="18" name="s2-file-d-label">
             <a:extLst xmlns:a="http://schemas.openxmlformats.org/drawingml/2006/main">
               <a:ext uri="{FF2B5EF4-FFF2-40B4-BE49-F238E27FC236}">
-                <a16:creationId xmlns:a16="http://schemas.microsoft.com/office/drawing/2014/main" id="{7D121530-0933-4A3B-A533-86E54302F464}"/>
+                <a16:creationId xmlns:a16="http://schemas.microsoft.com/office/drawing/2014/main" id="{9CA23953-9B88-4574-9986-3D9DB659128B}"/>
               </a:ext>
             </a:extLst>
           </p:cNvPr>
@@ -6465,7 +6470,7 @@
           <p:cNvPr id="19" name="s2-file-e-label">
             <a:extLst xmlns:a="http://schemas.openxmlformats.org/drawingml/2006/main">
               <a:ext uri="{FF2B5EF4-FFF2-40B4-BE49-F238E27FC236}">
-                <a16:creationId xmlns:a16="http://schemas.microsoft.com/office/drawing/2014/main" id="{B31332A7-AA25-4AF2-ABCC-3F00BC66EF77}"/>
+                <a16:creationId xmlns:a16="http://schemas.microsoft.com/office/drawing/2014/main" id="{44AB05B2-0C5A-49F9-B789-21587EC76FB1}"/>
               </a:ext>
             </a:extLst>
           </p:cNvPr>
@@ -6510,7 +6515,7 @@
           <p:cNvPr id="20" name="s2-n1">
             <a:extLst xmlns:a="http://schemas.openxmlformats.org/drawingml/2006/main">
               <a:ext uri="{FF2B5EF4-FFF2-40B4-BE49-F238E27FC236}">
-                <a16:creationId xmlns:a16="http://schemas.microsoft.com/office/drawing/2014/main" id="{FB0AF871-16EE-45D8-8B1B-A548953ACF9E}"/>
+                <a16:creationId xmlns:a16="http://schemas.microsoft.com/office/drawing/2014/main" id="{37CC9AC9-FA90-495A-AC41-3AC10A146441}"/>
               </a:ext>
             </a:extLst>
           </p:cNvPr>
@@ -6543,7 +6548,7 @@
           <p:cNvPr id="21" name="s2-n1-label">
             <a:extLst xmlns:a="http://schemas.openxmlformats.org/drawingml/2006/main">
               <a:ext uri="{FF2B5EF4-FFF2-40B4-BE49-F238E27FC236}">
-                <a16:creationId xmlns:a16="http://schemas.microsoft.com/office/drawing/2014/main" id="{57869D4F-53EB-4C23-99EA-88763AEFCD21}"/>
+                <a16:creationId xmlns:a16="http://schemas.microsoft.com/office/drawing/2014/main" id="{190823B6-5663-4373-8629-15A20D8291BA}"/>
               </a:ext>
             </a:extLst>
           </p:cNvPr>
@@ -6588,7 +6593,7 @@
           <p:cNvPr id="22" name="s2-p1">
             <a:extLst xmlns:a="http://schemas.openxmlformats.org/drawingml/2006/main">
               <a:ext uri="{FF2B5EF4-FFF2-40B4-BE49-F238E27FC236}">
-                <a16:creationId xmlns:a16="http://schemas.microsoft.com/office/drawing/2014/main" id="{A96FAC6A-2F04-473B-9F12-CC75CD1844CB}"/>
+                <a16:creationId xmlns:a16="http://schemas.microsoft.com/office/drawing/2014/main" id="{79810E1B-924C-4ADC-9860-6B354734F743}"/>
               </a:ext>
             </a:extLst>
           </p:cNvPr>
@@ -6633,7 +6638,7 @@
           <p:cNvPr id="23" name="s2-n2">
             <a:extLst xmlns:a="http://schemas.openxmlformats.org/drawingml/2006/main">
               <a:ext uri="{FF2B5EF4-FFF2-40B4-BE49-F238E27FC236}">
-                <a16:creationId xmlns:a16="http://schemas.microsoft.com/office/drawing/2014/main" id="{B94514C9-B05A-4EFE-B07D-975C619477E8}"/>
+                <a16:creationId xmlns:a16="http://schemas.microsoft.com/office/drawing/2014/main" id="{50DC14B7-3041-4E7E-98D2-89FDE7AEB300}"/>
               </a:ext>
             </a:extLst>
           </p:cNvPr>
@@ -6666,7 +6671,7 @@
           <p:cNvPr id="24" name="s2-n2-label">
             <a:extLst xmlns:a="http://schemas.openxmlformats.org/drawingml/2006/main">
               <a:ext uri="{FF2B5EF4-FFF2-40B4-BE49-F238E27FC236}">
-                <a16:creationId xmlns:a16="http://schemas.microsoft.com/office/drawing/2014/main" id="{BFFCE878-872D-4097-B957-8F49DD999C05}"/>
+                <a16:creationId xmlns:a16="http://schemas.microsoft.com/office/drawing/2014/main" id="{A8D7F77D-4B43-4A67-AE3B-B48872879295}"/>
               </a:ext>
             </a:extLst>
           </p:cNvPr>
@@ -6711,7 +6716,7 @@
           <p:cNvPr id="25" name="s2-p2">
             <a:extLst xmlns:a="http://schemas.openxmlformats.org/drawingml/2006/main">
               <a:ext uri="{FF2B5EF4-FFF2-40B4-BE49-F238E27FC236}">
-                <a16:creationId xmlns:a16="http://schemas.microsoft.com/office/drawing/2014/main" id="{0F674F13-18FD-459B-A95E-D4BD5869322B}"/>
+                <a16:creationId xmlns:a16="http://schemas.microsoft.com/office/drawing/2014/main" id="{28B6BB48-A250-4372-8C99-D3C9B0FB56D8}"/>
               </a:ext>
             </a:extLst>
           </p:cNvPr>
@@ -6756,7 +6761,7 @@
           <p:cNvPr id="26" name="s2-n3">
             <a:extLst xmlns:a="http://schemas.openxmlformats.org/drawingml/2006/main">
               <a:ext uri="{FF2B5EF4-FFF2-40B4-BE49-F238E27FC236}">
-                <a16:creationId xmlns:a16="http://schemas.microsoft.com/office/drawing/2014/main" id="{B59033F0-4A80-4203-9F17-187664502D06}"/>
+                <a16:creationId xmlns:a16="http://schemas.microsoft.com/office/drawing/2014/main" id="{2BBABD7A-4585-444E-A9F1-6CAC5C22F736}"/>
               </a:ext>
             </a:extLst>
           </p:cNvPr>
@@ -6789,7 +6794,7 @@
           <p:cNvPr id="27" name="s2-n3-label">
             <a:extLst xmlns:a="http://schemas.openxmlformats.org/drawingml/2006/main">
               <a:ext uri="{FF2B5EF4-FFF2-40B4-BE49-F238E27FC236}">
-                <a16:creationId xmlns:a16="http://schemas.microsoft.com/office/drawing/2014/main" id="{7D736D9D-557F-4B99-A22D-D48C82A19D3C}"/>
+                <a16:creationId xmlns:a16="http://schemas.microsoft.com/office/drawing/2014/main" id="{2030DE4D-1B57-4EC4-A568-13B0BE1E45B8}"/>
               </a:ext>
             </a:extLst>
           </p:cNvPr>
@@ -6834,7 +6839,7 @@
           <p:cNvPr id="28" name="s2-p3">
             <a:extLst xmlns:a="http://schemas.openxmlformats.org/drawingml/2006/main">
               <a:ext uri="{FF2B5EF4-FFF2-40B4-BE49-F238E27FC236}">
-                <a16:creationId xmlns:a16="http://schemas.microsoft.com/office/drawing/2014/main" id="{91DE6FA7-E672-4D5C-A33E-E4C51DE231D2}"/>
+                <a16:creationId xmlns:a16="http://schemas.microsoft.com/office/drawing/2014/main" id="{93A9E5A6-C249-491F-991A-D340B2B654C4}"/>
               </a:ext>
             </a:extLst>
           </p:cNvPr>
@@ -6879,7 +6884,7 @@
           <p:cNvPr id="29" name="s2-takeaway">
             <a:extLst xmlns:a="http://schemas.openxmlformats.org/drawingml/2006/main">
               <a:ext uri="{FF2B5EF4-FFF2-40B4-BE49-F238E27FC236}">
-                <a16:creationId xmlns:a16="http://schemas.microsoft.com/office/drawing/2014/main" id="{8F5823AC-E459-4DA7-AFDD-3916BD97E5E7}"/>
+                <a16:creationId xmlns:a16="http://schemas.microsoft.com/office/drawing/2014/main" id="{096B0D61-A379-4ECD-A889-6CFFA75A7B36}"/>
               </a:ext>
             </a:extLst>
           </p:cNvPr>
@@ -6946,7 +6951,7 @@
           <p:cNvPr id="31" name="footer-source-2">
             <a:extLst xmlns:a="http://schemas.openxmlformats.org/drawingml/2006/main">
               <a:ext uri="{FF2B5EF4-FFF2-40B4-BE49-F238E27FC236}">
-                <a16:creationId xmlns:a16="http://schemas.microsoft.com/office/drawing/2014/main" id="{053667B1-D1E6-4AF0-BE2C-77B46C022AF2}"/>
+                <a16:creationId xmlns:a16="http://schemas.microsoft.com/office/drawing/2014/main" id="{04C3F60E-F37E-424C-AFF7-1743CE960E22}"/>
               </a:ext>
             </a:extLst>
           </p:cNvPr>
@@ -6991,7 +6996,7 @@
           <p:cNvPr id="32" name="footer-number-2">
             <a:extLst xmlns:a="http://schemas.openxmlformats.org/drawingml/2006/main">
               <a:ext uri="{FF2B5EF4-FFF2-40B4-BE49-F238E27FC236}">
-                <a16:creationId xmlns:a16="http://schemas.microsoft.com/office/drawing/2014/main" id="{FD03E0DA-8C35-4FE6-B15B-A45DA2327FF7}"/>
+                <a16:creationId xmlns:a16="http://schemas.microsoft.com/office/drawing/2014/main" id="{424B1FE4-777A-43BD-9F78-B10A63DCFAB4}"/>
               </a:ext>
             </a:extLst>
           </p:cNvPr>
@@ -7034,7 +7039,7 @@
     </p:spTree>
     <p:extLst>
       <p:ext uri="{BB962C8B-B14F-4D97-AF65-F5344CB8AC3E}">
-        <p14:creationId xmlns:p14="http://schemas.microsoft.com/office/powerpoint/2010/main" val="1347448899"/>
+        <p14:creationId xmlns:p14="http://schemas.microsoft.com/office/powerpoint/2010/main" val="1110572424"/>
       </p:ext>
     </p:extLst>
   </p:cSld>
@@ -7065,7 +7070,7 @@
           <p:cNvPr id="38" name="s3-title">
             <a:extLst xmlns:a="http://schemas.openxmlformats.org/drawingml/2006/main">
               <a:ext uri="{FF2B5EF4-FFF2-40B4-BE49-F238E27FC236}">
-                <a16:creationId xmlns:a16="http://schemas.microsoft.com/office/drawing/2014/main" id="{1AA5167D-8585-4D61-80DF-1055F52DF77E}"/>
+                <a16:creationId xmlns:a16="http://schemas.microsoft.com/office/drawing/2014/main" id="{16A130AA-73ED-4004-9524-EECB5261FFDF}"/>
               </a:ext>
             </a:extLst>
           </p:cNvPr>
@@ -7110,7 +7115,7 @@
           <p:cNvPr id="2" name="s3-subtitle">
             <a:extLst xmlns:a="http://schemas.openxmlformats.org/drawingml/2006/main">
               <a:ext uri="{FF2B5EF4-FFF2-40B4-BE49-F238E27FC236}">
-                <a16:creationId xmlns:a16="http://schemas.microsoft.com/office/drawing/2014/main" id="{5B692289-CD0A-42CB-9B3E-DE3CFDA25683}"/>
+                <a16:creationId xmlns:a16="http://schemas.microsoft.com/office/drawing/2014/main" id="{37AA996A-D7BF-4998-BEE4-E31AAB0E23C5}"/>
               </a:ext>
             </a:extLst>
           </p:cNvPr>
@@ -7199,7 +7204,7 @@
           <p:cNvPr id="5" name="s3-address-panel">
             <a:extLst xmlns:a="http://schemas.openxmlformats.org/drawingml/2006/main">
               <a:ext uri="{FF2B5EF4-FFF2-40B4-BE49-F238E27FC236}">
-                <a16:creationId xmlns:a16="http://schemas.microsoft.com/office/drawing/2014/main" id="{B86D3D54-FE14-4903-98D9-CA9D154914CE}"/>
+                <a16:creationId xmlns:a16="http://schemas.microsoft.com/office/drawing/2014/main" id="{B6450E92-C9CB-4D51-B901-6C2EADD3C05F}"/>
               </a:ext>
             </a:extLst>
           </p:cNvPr>
@@ -7278,7 +7283,7 @@
           <p:cNvPr id="8" name="s3-x">
             <a:extLst xmlns:a="http://schemas.openxmlformats.org/drawingml/2006/main">
               <a:ext uri="{FF2B5EF4-FFF2-40B4-BE49-F238E27FC236}">
-                <a16:creationId xmlns:a16="http://schemas.microsoft.com/office/drawing/2014/main" id="{A30D06ED-94BF-4994-82EB-74729C949082}"/>
+                <a16:creationId xmlns:a16="http://schemas.microsoft.com/office/drawing/2014/main" id="{6FE8210D-2547-4832-861E-9D0C5BA6B789}"/>
               </a:ext>
             </a:extLst>
           </p:cNvPr>
@@ -7311,7 +7316,7 @@
           <p:cNvPr id="9" name="s3-x-letter">
             <a:extLst xmlns:a="http://schemas.openxmlformats.org/drawingml/2006/main">
               <a:ext uri="{FF2B5EF4-FFF2-40B4-BE49-F238E27FC236}">
-                <a16:creationId xmlns:a16="http://schemas.microsoft.com/office/drawing/2014/main" id="{F0D697D9-DEE0-420A-96C9-566ECE493345}"/>
+                <a16:creationId xmlns:a16="http://schemas.microsoft.com/office/drawing/2014/main" id="{10FF87E8-620F-4A5F-96D7-E39BBC345435}"/>
               </a:ext>
             </a:extLst>
           </p:cNvPr>
@@ -7356,7 +7361,7 @@
           <p:cNvPr id="10" name="s3-x-label">
             <a:extLst xmlns:a="http://schemas.openxmlformats.org/drawingml/2006/main">
               <a:ext uri="{FF2B5EF4-FFF2-40B4-BE49-F238E27FC236}">
-                <a16:creationId xmlns:a16="http://schemas.microsoft.com/office/drawing/2014/main" id="{8BE6172B-40FB-4186-8601-D5F9960BD064}"/>
+                <a16:creationId xmlns:a16="http://schemas.microsoft.com/office/drawing/2014/main" id="{2DB67C25-EA75-40A8-AB42-7929F8D217CB}"/>
               </a:ext>
             </a:extLst>
           </p:cNvPr>
@@ -7401,7 +7406,7 @@
           <p:cNvPr id="11" name="s3-x-main">
             <a:extLst xmlns:a="http://schemas.openxmlformats.org/drawingml/2006/main">
               <a:ext uri="{FF2B5EF4-FFF2-40B4-BE49-F238E27FC236}">
-                <a16:creationId xmlns:a16="http://schemas.microsoft.com/office/drawing/2014/main" id="{77F53F81-98F0-40EF-B92C-4756ED8DD125}"/>
+                <a16:creationId xmlns:a16="http://schemas.microsoft.com/office/drawing/2014/main" id="{E731AB05-0E1E-44DE-8025-9CBC433A1D41}"/>
               </a:ext>
             </a:extLst>
           </p:cNvPr>
@@ -7446,7 +7451,7 @@
           <p:cNvPr id="12" name="s3-x-question">
             <a:extLst xmlns:a="http://schemas.openxmlformats.org/drawingml/2006/main">
               <a:ext uri="{FF2B5EF4-FFF2-40B4-BE49-F238E27FC236}">
-                <a16:creationId xmlns:a16="http://schemas.microsoft.com/office/drawing/2014/main" id="{5DC9BAA3-0B1A-45FB-A8D5-8EB8CEEB9FF8}"/>
+                <a16:creationId xmlns:a16="http://schemas.microsoft.com/office/drawing/2014/main" id="{BF12E5A1-25E6-4741-A41F-03A993864B09}"/>
               </a:ext>
             </a:extLst>
           </p:cNvPr>
@@ -7491,7 +7496,7 @@
           <p:cNvPr id="13" name="s3-y">
             <a:extLst xmlns:a="http://schemas.openxmlformats.org/drawingml/2006/main">
               <a:ext uri="{FF2B5EF4-FFF2-40B4-BE49-F238E27FC236}">
-                <a16:creationId xmlns:a16="http://schemas.microsoft.com/office/drawing/2014/main" id="{26E50144-EA2E-4B4A-9977-1BAEEE60CEF3}"/>
+                <a16:creationId xmlns:a16="http://schemas.microsoft.com/office/drawing/2014/main" id="{3B429CDA-AFD9-467B-83CB-5725ED91AB9F}"/>
               </a:ext>
             </a:extLst>
           </p:cNvPr>
@@ -7524,7 +7529,7 @@
           <p:cNvPr id="14" name="s3-y-letter">
             <a:extLst xmlns:a="http://schemas.openxmlformats.org/drawingml/2006/main">
               <a:ext uri="{FF2B5EF4-FFF2-40B4-BE49-F238E27FC236}">
-                <a16:creationId xmlns:a16="http://schemas.microsoft.com/office/drawing/2014/main" id="{6C9F8289-FB14-46FB-B69F-36CCA350268F}"/>
+                <a16:creationId xmlns:a16="http://schemas.microsoft.com/office/drawing/2014/main" id="{F7FBDA51-D19E-4812-BF2F-47181F016D89}"/>
               </a:ext>
             </a:extLst>
           </p:cNvPr>
@@ -7569,7 +7574,7 @@
           <p:cNvPr id="15" name="s3-y-label">
             <a:extLst xmlns:a="http://schemas.openxmlformats.org/drawingml/2006/main">
               <a:ext uri="{FF2B5EF4-FFF2-40B4-BE49-F238E27FC236}">
-                <a16:creationId xmlns:a16="http://schemas.microsoft.com/office/drawing/2014/main" id="{84B69546-30FC-4C3A-B0AF-38DCA6ED8727}"/>
+                <a16:creationId xmlns:a16="http://schemas.microsoft.com/office/drawing/2014/main" id="{CB4AF1EC-F97D-4303-82FE-E5F77AE40180}"/>
               </a:ext>
             </a:extLst>
           </p:cNvPr>
@@ -7614,7 +7619,7 @@
           <p:cNvPr id="16" name="s3-y-main">
             <a:extLst xmlns:a="http://schemas.openxmlformats.org/drawingml/2006/main">
               <a:ext uri="{FF2B5EF4-FFF2-40B4-BE49-F238E27FC236}">
-                <a16:creationId xmlns:a16="http://schemas.microsoft.com/office/drawing/2014/main" id="{9B414944-4228-4BFA-9CED-C0A1F4556A8C}"/>
+                <a16:creationId xmlns:a16="http://schemas.microsoft.com/office/drawing/2014/main" id="{176C8DC6-4CA0-449A-8560-147634EB36AA}"/>
               </a:ext>
             </a:extLst>
           </p:cNvPr>
@@ -7659,7 +7664,7 @@
           <p:cNvPr id="17" name="s3-y-question">
             <a:extLst xmlns:a="http://schemas.openxmlformats.org/drawingml/2006/main">
               <a:ext uri="{FF2B5EF4-FFF2-40B4-BE49-F238E27FC236}">
-                <a16:creationId xmlns:a16="http://schemas.microsoft.com/office/drawing/2014/main" id="{EFE28FA1-750E-47B5-8787-D62D17B0BFDB}"/>
+                <a16:creationId xmlns:a16="http://schemas.microsoft.com/office/drawing/2014/main" id="{C16A447D-36EC-473E-9652-EDCB5AA1BFB1}"/>
               </a:ext>
             </a:extLst>
           </p:cNvPr>
@@ -7704,7 +7709,7 @@
           <p:cNvPr id="18" name="s3-z">
             <a:extLst xmlns:a="http://schemas.openxmlformats.org/drawingml/2006/main">
               <a:ext uri="{FF2B5EF4-FFF2-40B4-BE49-F238E27FC236}">
-                <a16:creationId xmlns:a16="http://schemas.microsoft.com/office/drawing/2014/main" id="{65920A7D-09ED-4038-846A-97A5D870DC28}"/>
+                <a16:creationId xmlns:a16="http://schemas.microsoft.com/office/drawing/2014/main" id="{C4B6AB9A-5D13-436A-87B9-2A268EFAE405}"/>
               </a:ext>
             </a:extLst>
           </p:cNvPr>
@@ -7737,7 +7742,7 @@
           <p:cNvPr id="19" name="s3-z-letter">
             <a:extLst xmlns:a="http://schemas.openxmlformats.org/drawingml/2006/main">
               <a:ext uri="{FF2B5EF4-FFF2-40B4-BE49-F238E27FC236}">
-                <a16:creationId xmlns:a16="http://schemas.microsoft.com/office/drawing/2014/main" id="{5FE4107F-3322-415A-9588-40AFCECF606E}"/>
+                <a16:creationId xmlns:a16="http://schemas.microsoft.com/office/drawing/2014/main" id="{993907FD-BF41-4B1B-A249-9FD554D692EC}"/>
               </a:ext>
             </a:extLst>
           </p:cNvPr>
@@ -7782,7 +7787,7 @@
           <p:cNvPr id="20" name="s3-z-label">
             <a:extLst xmlns:a="http://schemas.openxmlformats.org/drawingml/2006/main">
               <a:ext uri="{FF2B5EF4-FFF2-40B4-BE49-F238E27FC236}">
-                <a16:creationId xmlns:a16="http://schemas.microsoft.com/office/drawing/2014/main" id="{E0555D1A-7FDE-4F44-A3DD-A99592BC8707}"/>
+                <a16:creationId xmlns:a16="http://schemas.microsoft.com/office/drawing/2014/main" id="{068A9C8C-5791-41F9-AAC2-8532A1C32756}"/>
               </a:ext>
             </a:extLst>
           </p:cNvPr>
@@ -7827,7 +7832,7 @@
           <p:cNvPr id="21" name="s3-z-main">
             <a:extLst xmlns:a="http://schemas.openxmlformats.org/drawingml/2006/main">
               <a:ext uri="{FF2B5EF4-FFF2-40B4-BE49-F238E27FC236}">
-                <a16:creationId xmlns:a16="http://schemas.microsoft.com/office/drawing/2014/main" id="{16D70E96-1884-438E-8F9E-35033947F7AF}"/>
+                <a16:creationId xmlns:a16="http://schemas.microsoft.com/office/drawing/2014/main" id="{D90311D5-105A-4280-B1A9-380B2A63DECD}"/>
               </a:ext>
             </a:extLst>
           </p:cNvPr>
@@ -7872,7 +7877,7 @@
           <p:cNvPr id="22" name="s3-z-question">
             <a:extLst xmlns:a="http://schemas.openxmlformats.org/drawingml/2006/main">
               <a:ext uri="{FF2B5EF4-FFF2-40B4-BE49-F238E27FC236}">
-                <a16:creationId xmlns:a16="http://schemas.microsoft.com/office/drawing/2014/main" id="{BAB8A95C-37D3-45C6-B307-11841E2C7FDD}"/>
+                <a16:creationId xmlns:a16="http://schemas.microsoft.com/office/drawing/2014/main" id="{5D1F97C1-4B3C-4179-8B90-8742AA82571B}"/>
               </a:ext>
             </a:extLst>
           </p:cNvPr>
@@ -7917,7 +7922,7 @@
           <p:cNvPr id="23" name="s3-address-label">
             <a:extLst xmlns:a="http://schemas.openxmlformats.org/drawingml/2006/main">
               <a:ext uri="{FF2B5EF4-FFF2-40B4-BE49-F238E27FC236}">
-                <a16:creationId xmlns:a16="http://schemas.microsoft.com/office/drawing/2014/main" id="{8CE274BD-7C85-45EF-9B02-FCCB694E022F}"/>
+                <a16:creationId xmlns:a16="http://schemas.microsoft.com/office/drawing/2014/main" id="{822B52BE-1741-4B81-ACB8-878C3829AFCF}"/>
               </a:ext>
             </a:extLst>
           </p:cNvPr>
@@ -7962,7 +7967,7 @@
           <p:cNvPr id="24" name="s3-address-x">
             <a:extLst xmlns:a="http://schemas.openxmlformats.org/drawingml/2006/main">
               <a:ext uri="{FF2B5EF4-FFF2-40B4-BE49-F238E27FC236}">
-                <a16:creationId xmlns:a16="http://schemas.microsoft.com/office/drawing/2014/main" id="{66FAE4F1-A16E-47FD-9C75-6A4CD95FAB2E}"/>
+                <a16:creationId xmlns:a16="http://schemas.microsoft.com/office/drawing/2014/main" id="{A5E57E08-6FDF-4E58-BAD0-9A5195DD6AF9}"/>
               </a:ext>
             </a:extLst>
           </p:cNvPr>
@@ -8007,7 +8012,7 @@
           <p:cNvPr id="25" name="s3-address-x-value">
             <a:extLst xmlns:a="http://schemas.openxmlformats.org/drawingml/2006/main">
               <a:ext uri="{FF2B5EF4-FFF2-40B4-BE49-F238E27FC236}">
-                <a16:creationId xmlns:a16="http://schemas.microsoft.com/office/drawing/2014/main" id="{24D254DE-2F72-4B88-AEB9-E369A5E1D239}"/>
+                <a16:creationId xmlns:a16="http://schemas.microsoft.com/office/drawing/2014/main" id="{F1D6EFE7-B115-4D9E-A7B2-DBD576B93E22}"/>
               </a:ext>
             </a:extLst>
           </p:cNvPr>
@@ -8052,7 +8057,7 @@
           <p:cNvPr id="26" name="s3-address-y">
             <a:extLst xmlns:a="http://schemas.openxmlformats.org/drawingml/2006/main">
               <a:ext uri="{FF2B5EF4-FFF2-40B4-BE49-F238E27FC236}">
-                <a16:creationId xmlns:a16="http://schemas.microsoft.com/office/drawing/2014/main" id="{663B16E4-999C-4D78-8D27-59CB7E0A504A}"/>
+                <a16:creationId xmlns:a16="http://schemas.microsoft.com/office/drawing/2014/main" id="{C665195B-BC42-4252-8BA8-D27C74B0EDA7}"/>
               </a:ext>
             </a:extLst>
           </p:cNvPr>
@@ -8097,7 +8102,7 @@
           <p:cNvPr id="27" name="s3-address-y-value">
             <a:extLst xmlns:a="http://schemas.openxmlformats.org/drawingml/2006/main">
               <a:ext uri="{FF2B5EF4-FFF2-40B4-BE49-F238E27FC236}">
-                <a16:creationId xmlns:a16="http://schemas.microsoft.com/office/drawing/2014/main" id="{093CE907-53D1-4441-B27C-319C5A2DD6AE}"/>
+                <a16:creationId xmlns:a16="http://schemas.microsoft.com/office/drawing/2014/main" id="{534FAAFA-DE95-4DD0-878F-68CFB910D88C}"/>
               </a:ext>
             </a:extLst>
           </p:cNvPr>
@@ -8142,7 +8147,7 @@
           <p:cNvPr id="28" name="s3-address-z">
             <a:extLst xmlns:a="http://schemas.openxmlformats.org/drawingml/2006/main">
               <a:ext uri="{FF2B5EF4-FFF2-40B4-BE49-F238E27FC236}">
-                <a16:creationId xmlns:a16="http://schemas.microsoft.com/office/drawing/2014/main" id="{69387AC3-10C5-474D-8A54-A95C5036C855}"/>
+                <a16:creationId xmlns:a16="http://schemas.microsoft.com/office/drawing/2014/main" id="{60379254-984D-466A-B2E4-02500A2CC546}"/>
               </a:ext>
             </a:extLst>
           </p:cNvPr>
@@ -8187,7 +8192,7 @@
           <p:cNvPr id="29" name="s3-address-z-value">
             <a:extLst xmlns:a="http://schemas.openxmlformats.org/drawingml/2006/main">
               <a:ext uri="{FF2B5EF4-FFF2-40B4-BE49-F238E27FC236}">
-                <a16:creationId xmlns:a16="http://schemas.microsoft.com/office/drawing/2014/main" id="{3C45EDE7-8AA7-435B-96EB-45120B09832B}"/>
+                <a16:creationId xmlns:a16="http://schemas.microsoft.com/office/drawing/2014/main" id="{2F940990-8BC6-4375-A308-4FACC826AF95}"/>
               </a:ext>
             </a:extLst>
           </p:cNvPr>
@@ -8232,7 +8237,7 @@
           <p:cNvPr id="30" name="s3-address-note">
             <a:extLst xmlns:a="http://schemas.openxmlformats.org/drawingml/2006/main">
               <a:ext uri="{FF2B5EF4-FFF2-40B4-BE49-F238E27FC236}">
-                <a16:creationId xmlns:a16="http://schemas.microsoft.com/office/drawing/2014/main" id="{88BEF165-F0C9-47AC-85ED-5A0BE9F1F040}"/>
+                <a16:creationId xmlns:a16="http://schemas.microsoft.com/office/drawing/2014/main" id="{42969237-F0BE-4636-A645-EBBC250FAE48}"/>
               </a:ext>
             </a:extLst>
           </p:cNvPr>
@@ -8277,7 +8282,7 @@
           <p:cNvPr id="31" name="s3-route-label">
             <a:extLst xmlns:a="http://schemas.openxmlformats.org/drawingml/2006/main">
               <a:ext uri="{FF2B5EF4-FFF2-40B4-BE49-F238E27FC236}">
-                <a16:creationId xmlns:a16="http://schemas.microsoft.com/office/drawing/2014/main" id="{F66DE204-DCED-4365-99E9-131D1817EF89}"/>
+                <a16:creationId xmlns:a16="http://schemas.microsoft.com/office/drawing/2014/main" id="{96F48788-BE8F-40AB-85EE-06147F3519E7}"/>
               </a:ext>
             </a:extLst>
           </p:cNvPr>
@@ -8322,7 +8327,7 @@
           <p:cNvPr id="32" name="s3-route-main">
             <a:extLst xmlns:a="http://schemas.openxmlformats.org/drawingml/2006/main">
               <a:ext uri="{FF2B5EF4-FFF2-40B4-BE49-F238E27FC236}">
-                <a16:creationId xmlns:a16="http://schemas.microsoft.com/office/drawing/2014/main" id="{4EA3DD46-43BE-452B-9961-205C5485D58A}"/>
+                <a16:creationId xmlns:a16="http://schemas.microsoft.com/office/drawing/2014/main" id="{8393FD55-7617-4A7A-B052-C2FB65644731}"/>
               </a:ext>
             </a:extLst>
           </p:cNvPr>
@@ -8367,7 +8372,7 @@
           <p:cNvPr id="33" name="s3-memory-label">
             <a:extLst xmlns:a="http://schemas.openxmlformats.org/drawingml/2006/main">
               <a:ext uri="{FF2B5EF4-FFF2-40B4-BE49-F238E27FC236}">
-                <a16:creationId xmlns:a16="http://schemas.microsoft.com/office/drawing/2014/main" id="{62A5391B-43A8-4B53-B7A3-29773BAF062D}"/>
+                <a16:creationId xmlns:a16="http://schemas.microsoft.com/office/drawing/2014/main" id="{792231F3-D6FC-49BA-8EBA-90C356A71304}"/>
               </a:ext>
             </a:extLst>
           </p:cNvPr>
@@ -8412,7 +8417,7 @@
           <p:cNvPr id="34" name="s3-memory-main">
             <a:extLst xmlns:a="http://schemas.openxmlformats.org/drawingml/2006/main">
               <a:ext uri="{FF2B5EF4-FFF2-40B4-BE49-F238E27FC236}">
-                <a16:creationId xmlns:a16="http://schemas.microsoft.com/office/drawing/2014/main" id="{1B78DEA4-B5BD-4C61-8797-71054E068288}"/>
+                <a16:creationId xmlns:a16="http://schemas.microsoft.com/office/drawing/2014/main" id="{72E36173-92CC-4BBE-B7AE-8008F1FD9E79}"/>
               </a:ext>
             </a:extLst>
           </p:cNvPr>
@@ -8479,7 +8484,7 @@
           <p:cNvPr id="36" name="footer-source-3">
             <a:extLst xmlns:a="http://schemas.openxmlformats.org/drawingml/2006/main">
               <a:ext uri="{FF2B5EF4-FFF2-40B4-BE49-F238E27FC236}">
-                <a16:creationId xmlns:a16="http://schemas.microsoft.com/office/drawing/2014/main" id="{2204F213-185C-4C85-A88E-E62E73AFCA97}"/>
+                <a16:creationId xmlns:a16="http://schemas.microsoft.com/office/drawing/2014/main" id="{300163E3-EAF0-47E1-AA25-3126C4B7C631}"/>
               </a:ext>
             </a:extLst>
           </p:cNvPr>
@@ -8524,7 +8529,7 @@
           <p:cNvPr id="37" name="footer-number-3">
             <a:extLst xmlns:a="http://schemas.openxmlformats.org/drawingml/2006/main">
               <a:ext uri="{FF2B5EF4-FFF2-40B4-BE49-F238E27FC236}">
-                <a16:creationId xmlns:a16="http://schemas.microsoft.com/office/drawing/2014/main" id="{AE267F97-2FB0-45B8-9662-73BE554017CC}"/>
+                <a16:creationId xmlns:a16="http://schemas.microsoft.com/office/drawing/2014/main" id="{DA386582-6D24-43A0-B1F8-8A236CD4B448}"/>
               </a:ext>
             </a:extLst>
           </p:cNvPr>
@@ -8567,7 +8572,7 @@
     </p:spTree>
     <p:extLst>
       <p:ext uri="{BB962C8B-B14F-4D97-AF65-F5344CB8AC3E}">
-        <p14:creationId xmlns:p14="http://schemas.microsoft.com/office/powerpoint/2010/main" val="258359751"/>
+        <p14:creationId xmlns:p14="http://schemas.microsoft.com/office/powerpoint/2010/main" val="1511769111"/>
       </p:ext>
     </p:extLst>
   </p:cSld>
@@ -8598,7 +8603,7 @@
           <p:cNvPr id="26" name="s4-title">
             <a:extLst xmlns:a="http://schemas.openxmlformats.org/drawingml/2006/main">
               <a:ext uri="{FF2B5EF4-FFF2-40B4-BE49-F238E27FC236}">
-                <a16:creationId xmlns:a16="http://schemas.microsoft.com/office/drawing/2014/main" id="{B8534018-2C61-45E0-9079-62251C560226}"/>
+                <a16:creationId xmlns:a16="http://schemas.microsoft.com/office/drawing/2014/main" id="{395B62F6-87F0-46A3-A5DD-9B169F249AA3}"/>
               </a:ext>
             </a:extLst>
           </p:cNvPr>
@@ -8643,7 +8648,7 @@
           <p:cNvPr id="2" name="s4-subtitle">
             <a:extLst xmlns:a="http://schemas.openxmlformats.org/drawingml/2006/main">
               <a:ext uri="{FF2B5EF4-FFF2-40B4-BE49-F238E27FC236}">
-                <a16:creationId xmlns:a16="http://schemas.microsoft.com/office/drawing/2014/main" id="{A7964411-9CAC-44DB-BB39-CB0F2B0DCB15}"/>
+                <a16:creationId xmlns:a16="http://schemas.microsoft.com/office/drawing/2014/main" id="{41FA8DB0-9DD1-4B6B-8D16-66D56FA39DE4}"/>
               </a:ext>
             </a:extLst>
           </p:cNvPr>
@@ -8688,7 +8693,7 @@
           <p:cNvPr id="3" name="s4-terminal">
             <a:extLst xmlns:a="http://schemas.openxmlformats.org/drawingml/2006/main">
               <a:ext uri="{FF2B5EF4-FFF2-40B4-BE49-F238E27FC236}">
-                <a16:creationId xmlns:a16="http://schemas.microsoft.com/office/drawing/2014/main" id="{374592C3-ABE8-41C9-91DC-5A3399C15983}"/>
+                <a16:creationId xmlns:a16="http://schemas.microsoft.com/office/drawing/2014/main" id="{6E565CD7-1029-4A6F-94A2-3A5D982E466B}"/>
               </a:ext>
             </a:extLst>
           </p:cNvPr>
@@ -8745,7 +8750,7 @@
           <p:cNvPr id="5" name="s4-dot1">
             <a:extLst xmlns:a="http://schemas.openxmlformats.org/drawingml/2006/main">
               <a:ext uri="{FF2B5EF4-FFF2-40B4-BE49-F238E27FC236}">
-                <a16:creationId xmlns:a16="http://schemas.microsoft.com/office/drawing/2014/main" id="{B6465859-204C-4A4A-A8B6-C101101C9256}"/>
+                <a16:creationId xmlns:a16="http://schemas.microsoft.com/office/drawing/2014/main" id="{F5212518-CCF5-460D-98CC-D35A78BA8CD2}"/>
               </a:ext>
             </a:extLst>
           </p:cNvPr>
@@ -8778,7 +8783,7 @@
           <p:cNvPr id="6" name="s4-dot2">
             <a:extLst xmlns:a="http://schemas.openxmlformats.org/drawingml/2006/main">
               <a:ext uri="{FF2B5EF4-FFF2-40B4-BE49-F238E27FC236}">
-                <a16:creationId xmlns:a16="http://schemas.microsoft.com/office/drawing/2014/main" id="{C42EDEFC-549A-4381-BC95-8C6BEF2CB020}"/>
+                <a16:creationId xmlns:a16="http://schemas.microsoft.com/office/drawing/2014/main" id="{51697863-1408-4107-B2F6-C516AA5A820A}"/>
               </a:ext>
             </a:extLst>
           </p:cNvPr>
@@ -8811,7 +8816,7 @@
           <p:cNvPr id="7" name="s4-dot3">
             <a:extLst xmlns:a="http://schemas.openxmlformats.org/drawingml/2006/main">
               <a:ext uri="{FF2B5EF4-FFF2-40B4-BE49-F238E27FC236}">
-                <a16:creationId xmlns:a16="http://schemas.microsoft.com/office/drawing/2014/main" id="{F6215524-12D9-4B09-B615-2CB72FD8652B}"/>
+                <a16:creationId xmlns:a16="http://schemas.microsoft.com/office/drawing/2014/main" id="{375D56F5-C1EE-4CCC-87B2-79C7D6EE64F5}"/>
               </a:ext>
             </a:extLst>
           </p:cNvPr>
@@ -8844,7 +8849,7 @@
           <p:cNvPr id="8" name="s4-command-label">
             <a:extLst xmlns:a="http://schemas.openxmlformats.org/drawingml/2006/main">
               <a:ext uri="{FF2B5EF4-FFF2-40B4-BE49-F238E27FC236}">
-                <a16:creationId xmlns:a16="http://schemas.microsoft.com/office/drawing/2014/main" id="{6B5621D3-E86B-4C89-8F21-6C10A9187453}"/>
+                <a16:creationId xmlns:a16="http://schemas.microsoft.com/office/drawing/2014/main" id="{E09B3ABB-79BB-434B-BA74-9B273901CB5C}"/>
               </a:ext>
             </a:extLst>
           </p:cNvPr>
@@ -8889,7 +8894,7 @@
           <p:cNvPr id="9" name="s4-command">
             <a:extLst xmlns:a="http://schemas.openxmlformats.org/drawingml/2006/main">
               <a:ext uri="{FF2B5EF4-FFF2-40B4-BE49-F238E27FC236}">
-                <a16:creationId xmlns:a16="http://schemas.microsoft.com/office/drawing/2014/main" id="{96E25078-C8BD-4041-9B59-5BBDAF6B45C6}"/>
+                <a16:creationId xmlns:a16="http://schemas.microsoft.com/office/drawing/2014/main" id="{43A85C94-FFDF-4F75-8BEA-9A236B1FDBFC}"/>
               </a:ext>
             </a:extLst>
           </p:cNvPr>
@@ -8938,7 +8943,7 @@
           <p:cNvPr id="10" name="s4-command-note">
             <a:extLst xmlns:a="http://schemas.openxmlformats.org/drawingml/2006/main">
               <a:ext uri="{FF2B5EF4-FFF2-40B4-BE49-F238E27FC236}">
-                <a16:creationId xmlns:a16="http://schemas.microsoft.com/office/drawing/2014/main" id="{F1E1ADCA-16E6-4D75-8E6B-34372BA70BFE}"/>
+                <a16:creationId xmlns:a16="http://schemas.microsoft.com/office/drawing/2014/main" id="{46C1BF6E-06BC-4845-9AFC-249BE5CD3C5A}"/>
               </a:ext>
             </a:extLst>
           </p:cNvPr>
@@ -8983,7 +8988,7 @@
           <p:cNvPr id="11" name="s4-output-label">
             <a:extLst xmlns:a="http://schemas.openxmlformats.org/drawingml/2006/main">
               <a:ext uri="{FF2B5EF4-FFF2-40B4-BE49-F238E27FC236}">
-                <a16:creationId xmlns:a16="http://schemas.microsoft.com/office/drawing/2014/main" id="{6DE21CE4-3262-41EC-B8EE-B9D169795E63}"/>
+                <a16:creationId xmlns:a16="http://schemas.microsoft.com/office/drawing/2014/main" id="{EE87986A-94A4-43E8-9291-487DBACF8939}"/>
               </a:ext>
             </a:extLst>
           </p:cNvPr>
@@ -9028,7 +9033,7 @@
           <p:cNvPr id="12" name="s4-o1a">
             <a:extLst xmlns:a="http://schemas.openxmlformats.org/drawingml/2006/main">
               <a:ext uri="{FF2B5EF4-FFF2-40B4-BE49-F238E27FC236}">
-                <a16:creationId xmlns:a16="http://schemas.microsoft.com/office/drawing/2014/main" id="{55CBCF61-0045-432B-9560-CBB9B4F96D48}"/>
+                <a16:creationId xmlns:a16="http://schemas.microsoft.com/office/drawing/2014/main" id="{294E832D-A940-4B2E-B2F5-4FED573B4994}"/>
               </a:ext>
             </a:extLst>
           </p:cNvPr>
@@ -9073,7 +9078,7 @@
           <p:cNvPr id="13" name="s4-o1b">
             <a:extLst xmlns:a="http://schemas.openxmlformats.org/drawingml/2006/main">
               <a:ext uri="{FF2B5EF4-FFF2-40B4-BE49-F238E27FC236}">
-                <a16:creationId xmlns:a16="http://schemas.microsoft.com/office/drawing/2014/main" id="{263401F0-FC22-4C0C-A1A8-73B123EA56AF}"/>
+                <a16:creationId xmlns:a16="http://schemas.microsoft.com/office/drawing/2014/main" id="{C9F4F732-5B6C-48F8-ACEA-D4CDF4BFFD6E}"/>
               </a:ext>
             </a:extLst>
           </p:cNvPr>
@@ -9118,7 +9123,7 @@
           <p:cNvPr id="14" name="s4-o2a">
             <a:extLst xmlns:a="http://schemas.openxmlformats.org/drawingml/2006/main">
               <a:ext uri="{FF2B5EF4-FFF2-40B4-BE49-F238E27FC236}">
-                <a16:creationId xmlns:a16="http://schemas.microsoft.com/office/drawing/2014/main" id="{04EF874B-2E71-4C72-A1E2-738DA8DFA539}"/>
+                <a16:creationId xmlns:a16="http://schemas.microsoft.com/office/drawing/2014/main" id="{5E52D382-437D-45E3-8CD1-289C08634954}"/>
               </a:ext>
             </a:extLst>
           </p:cNvPr>
@@ -9163,7 +9168,7 @@
           <p:cNvPr id="15" name="s4-o2b">
             <a:extLst xmlns:a="http://schemas.openxmlformats.org/drawingml/2006/main">
               <a:ext uri="{FF2B5EF4-FFF2-40B4-BE49-F238E27FC236}">
-                <a16:creationId xmlns:a16="http://schemas.microsoft.com/office/drawing/2014/main" id="{AD2C15D4-77D7-4592-8261-D59DC9487869}"/>
+                <a16:creationId xmlns:a16="http://schemas.microsoft.com/office/drawing/2014/main" id="{BA3A926D-1290-4FE7-93E2-5F4988F7B82F}"/>
               </a:ext>
             </a:extLst>
           </p:cNvPr>
@@ -9208,7 +9213,7 @@
           <p:cNvPr id="16" name="s4-o3a">
             <a:extLst xmlns:a="http://schemas.openxmlformats.org/drawingml/2006/main">
               <a:ext uri="{FF2B5EF4-FFF2-40B4-BE49-F238E27FC236}">
-                <a16:creationId xmlns:a16="http://schemas.microsoft.com/office/drawing/2014/main" id="{94B56EFC-0A4A-4A4F-8BBF-733AECDB1E80}"/>
+                <a16:creationId xmlns:a16="http://schemas.microsoft.com/office/drawing/2014/main" id="{7C1CD88E-2C92-48ED-B55E-2C809295BE93}"/>
               </a:ext>
             </a:extLst>
           </p:cNvPr>
@@ -9253,7 +9258,7 @@
           <p:cNvPr id="17" name="s4-o3b">
             <a:extLst xmlns:a="http://schemas.openxmlformats.org/drawingml/2006/main">
               <a:ext uri="{FF2B5EF4-FFF2-40B4-BE49-F238E27FC236}">
-                <a16:creationId xmlns:a16="http://schemas.microsoft.com/office/drawing/2014/main" id="{310DF74A-6BCC-41D7-AD43-74F5FD5AB3A5}"/>
+                <a16:creationId xmlns:a16="http://schemas.microsoft.com/office/drawing/2014/main" id="{4C7959DE-A01D-4920-AD3D-7D2BE6F55F96}"/>
               </a:ext>
             </a:extLst>
           </p:cNvPr>
@@ -9298,7 +9303,7 @@
           <p:cNvPr id="18" name="s4-o4a">
             <a:extLst xmlns:a="http://schemas.openxmlformats.org/drawingml/2006/main">
               <a:ext uri="{FF2B5EF4-FFF2-40B4-BE49-F238E27FC236}">
-                <a16:creationId xmlns:a16="http://schemas.microsoft.com/office/drawing/2014/main" id="{8FFABE4F-ACA9-407D-834F-F375E79F37E6}"/>
+                <a16:creationId xmlns:a16="http://schemas.microsoft.com/office/drawing/2014/main" id="{FA71EB5F-E91E-4805-AF96-F57C25D30670}"/>
               </a:ext>
             </a:extLst>
           </p:cNvPr>
@@ -9343,7 +9348,7 @@
           <p:cNvPr id="19" name="s4-o4b">
             <a:extLst xmlns:a="http://schemas.openxmlformats.org/drawingml/2006/main">
               <a:ext uri="{FF2B5EF4-FFF2-40B4-BE49-F238E27FC236}">
-                <a16:creationId xmlns:a16="http://schemas.microsoft.com/office/drawing/2014/main" id="{16CF5A6B-3D7F-4333-BBCE-69A32093F17D}"/>
+                <a16:creationId xmlns:a16="http://schemas.microsoft.com/office/drawing/2014/main" id="{4454F99C-8A41-4A23-A576-BEDE598253AA}"/>
               </a:ext>
             </a:extLst>
           </p:cNvPr>
@@ -9389,7 +9394,7 @@
           <p:cNvPr id="20" name="s4-o5a">
             <a:extLst xmlns:a="http://schemas.openxmlformats.org/drawingml/2006/main">
               <a:ext uri="{FF2B5EF4-FFF2-40B4-BE49-F238E27FC236}">
-                <a16:creationId xmlns:a16="http://schemas.microsoft.com/office/drawing/2014/main" id="{C366C86B-0CEB-4537-9050-D6522D98E795}"/>
+                <a16:creationId xmlns:a16="http://schemas.microsoft.com/office/drawing/2014/main" id="{FDED4233-DD0F-474E-9E45-5BB3F13264B9}"/>
               </a:ext>
             </a:extLst>
           </p:cNvPr>
@@ -9434,7 +9439,7 @@
           <p:cNvPr id="21" name="s4-o5b">
             <a:extLst xmlns:a="http://schemas.openxmlformats.org/drawingml/2006/main">
               <a:ext uri="{FF2B5EF4-FFF2-40B4-BE49-F238E27FC236}">
-                <a16:creationId xmlns:a16="http://schemas.microsoft.com/office/drawing/2014/main" id="{A68220AC-DB30-4F38-8B07-2A8A8CE7A703}"/>
+                <a16:creationId xmlns:a16="http://schemas.microsoft.com/office/drawing/2014/main" id="{BEAB23FF-DFE8-42E9-9967-F5B3DF527814}"/>
               </a:ext>
             </a:extLst>
           </p:cNvPr>
@@ -9479,7 +9484,7 @@
           <p:cNvPr id="22" name="s4-output-note">
             <a:extLst xmlns:a="http://schemas.openxmlformats.org/drawingml/2006/main">
               <a:ext uri="{FF2B5EF4-FFF2-40B4-BE49-F238E27FC236}">
-                <a16:creationId xmlns:a16="http://schemas.microsoft.com/office/drawing/2014/main" id="{CA7DA214-33EE-467E-862C-265C0BD54042}"/>
+                <a16:creationId xmlns:a16="http://schemas.microsoft.com/office/drawing/2014/main" id="{AC8D8B44-AA1F-4093-88F3-C26C5EAB7EB2}"/>
               </a:ext>
             </a:extLst>
           </p:cNvPr>
@@ -9546,7 +9551,7 @@
           <p:cNvPr id="24" name="footer-source-4">
             <a:extLst xmlns:a="http://schemas.openxmlformats.org/drawingml/2006/main">
               <a:ext uri="{FF2B5EF4-FFF2-40B4-BE49-F238E27FC236}">
-                <a16:creationId xmlns:a16="http://schemas.microsoft.com/office/drawing/2014/main" id="{25F69B25-3CA0-4FC0-B547-AF351C0CC33A}"/>
+                <a16:creationId xmlns:a16="http://schemas.microsoft.com/office/drawing/2014/main" id="{8B59E73F-BA18-4D56-9638-BF07C0201803}"/>
               </a:ext>
             </a:extLst>
           </p:cNvPr>
@@ -9591,7 +9596,7 @@
           <p:cNvPr id="25" name="footer-number-4">
             <a:extLst xmlns:a="http://schemas.openxmlformats.org/drawingml/2006/main">
               <a:ext uri="{FF2B5EF4-FFF2-40B4-BE49-F238E27FC236}">
-                <a16:creationId xmlns:a16="http://schemas.microsoft.com/office/drawing/2014/main" id="{B41098A5-02E2-4250-AB80-DF673F6B8D5B}"/>
+                <a16:creationId xmlns:a16="http://schemas.microsoft.com/office/drawing/2014/main" id="{F4D6C54C-B3B7-46BB-B8A7-19D0702ECC8E}"/>
               </a:ext>
             </a:extLst>
           </p:cNvPr>
@@ -9634,7 +9639,7 @@
     </p:spTree>
     <p:extLst>
       <p:ext uri="{BB962C8B-B14F-4D97-AF65-F5344CB8AC3E}">
-        <p14:creationId xmlns:p14="http://schemas.microsoft.com/office/powerpoint/2010/main" val="1364054556"/>
+        <p14:creationId xmlns:p14="http://schemas.microsoft.com/office/powerpoint/2010/main" val="956120385"/>
       </p:ext>
     </p:extLst>
   </p:cSld>
@@ -9665,7 +9670,7 @@
           <p:cNvPr id="17" name="s5-title">
             <a:extLst xmlns:a="http://schemas.openxmlformats.org/drawingml/2006/main">
               <a:ext uri="{FF2B5EF4-FFF2-40B4-BE49-F238E27FC236}">
-                <a16:creationId xmlns:a16="http://schemas.microsoft.com/office/drawing/2014/main" id="{74DA6ED6-06FE-4224-85E7-0A91E7CFEE25}"/>
+                <a16:creationId xmlns:a16="http://schemas.microsoft.com/office/drawing/2014/main" id="{151BCC53-444B-4AD9-93DC-E01378DDFB8A}"/>
               </a:ext>
             </a:extLst>
           </p:cNvPr>
@@ -9710,7 +9715,7 @@
           <p:cNvPr id="2" name="s5-subtitle">
             <a:extLst xmlns:a="http://schemas.openxmlformats.org/drawingml/2006/main">
               <a:ext uri="{FF2B5EF4-FFF2-40B4-BE49-F238E27FC236}">
-                <a16:creationId xmlns:a16="http://schemas.microsoft.com/office/drawing/2014/main" id="{568803E9-E27E-48B5-BBFE-C5A43901D13E}"/>
+                <a16:creationId xmlns:a16="http://schemas.microsoft.com/office/drawing/2014/main" id="{5CB0B55D-89B9-4ABB-ABF6-744EA93C350E}"/>
               </a:ext>
             </a:extLst>
           </p:cNvPr>
@@ -9755,7 +9760,7 @@
           <p:cNvPr id="3" name="s5-chart-label-pack">
             <a:extLst xmlns:a="http://schemas.openxmlformats.org/drawingml/2006/main">
               <a:ext uri="{FF2B5EF4-FFF2-40B4-BE49-F238E27FC236}">
-                <a16:creationId xmlns:a16="http://schemas.microsoft.com/office/drawing/2014/main" id="{A7CEEAB7-7DB4-410E-81DD-966190CC8685}"/>
+                <a16:creationId xmlns:a16="http://schemas.microsoft.com/office/drawing/2014/main" id="{BE9AB966-5935-4470-8C8F-7019CCD93C44}"/>
               </a:ext>
             </a:extLst>
           </p:cNvPr>
@@ -9800,7 +9805,7 @@
           <p:cNvPr id="4" name="s5-chart-label-repo">
             <a:extLst xmlns:a="http://schemas.openxmlformats.org/drawingml/2006/main">
               <a:ext uri="{FF2B5EF4-FFF2-40B4-BE49-F238E27FC236}">
-                <a16:creationId xmlns:a16="http://schemas.microsoft.com/office/drawing/2014/main" id="{EF9F52B7-0006-4D85-89A7-A5D976FE12EA}"/>
+                <a16:creationId xmlns:a16="http://schemas.microsoft.com/office/drawing/2014/main" id="{3E90DBA6-E632-4D04-8F76-73A303E51C56}"/>
               </a:ext>
             </a:extLst>
           </p:cNvPr>
@@ -9845,7 +9850,7 @@
           <p:cNvPr id="5" name="s5-stat1">
             <a:extLst xmlns:a="http://schemas.openxmlformats.org/drawingml/2006/main">
               <a:ext uri="{FF2B5EF4-FFF2-40B4-BE49-F238E27FC236}">
-                <a16:creationId xmlns:a16="http://schemas.microsoft.com/office/drawing/2014/main" id="{46FCD730-E35F-4463-8F14-0165DCA2CD57}"/>
+                <a16:creationId xmlns:a16="http://schemas.microsoft.com/office/drawing/2014/main" id="{A48C06BD-0D03-4134-AC6E-E728F2C9E626}"/>
               </a:ext>
             </a:extLst>
           </p:cNvPr>
@@ -9890,7 +9895,7 @@
           <p:cNvPr id="6" name="s5-stat1-label">
             <a:extLst xmlns:a="http://schemas.openxmlformats.org/drawingml/2006/main">
               <a:ext uri="{FF2B5EF4-FFF2-40B4-BE49-F238E27FC236}">
-                <a16:creationId xmlns:a16="http://schemas.microsoft.com/office/drawing/2014/main" id="{A309F327-8DD3-4DC5-BFFA-A2DCCFC34C74}"/>
+                <a16:creationId xmlns:a16="http://schemas.microsoft.com/office/drawing/2014/main" id="{2E2E4893-3740-466A-BD9C-5FF5108BD483}"/>
               </a:ext>
             </a:extLst>
           </p:cNvPr>
@@ -9957,7 +9962,7 @@
           <p:cNvPr id="8" name="s5-stat2">
             <a:extLst xmlns:a="http://schemas.openxmlformats.org/drawingml/2006/main">
               <a:ext uri="{FF2B5EF4-FFF2-40B4-BE49-F238E27FC236}">
-                <a16:creationId xmlns:a16="http://schemas.microsoft.com/office/drawing/2014/main" id="{FCD22507-BDC5-4D38-B57C-9C4D22171D53}"/>
+                <a16:creationId xmlns:a16="http://schemas.microsoft.com/office/drawing/2014/main" id="{AB5EF88B-5DBF-44D4-AC6A-B78614E58002}"/>
               </a:ext>
             </a:extLst>
           </p:cNvPr>
@@ -10002,7 +10007,7 @@
           <p:cNvPr id="9" name="s5-stat2-label">
             <a:extLst xmlns:a="http://schemas.openxmlformats.org/drawingml/2006/main">
               <a:ext uri="{FF2B5EF4-FFF2-40B4-BE49-F238E27FC236}">
-                <a16:creationId xmlns:a16="http://schemas.microsoft.com/office/drawing/2014/main" id="{ACE7F8FC-D809-4277-818A-59B403ABD74F}"/>
+                <a16:creationId xmlns:a16="http://schemas.microsoft.com/office/drawing/2014/main" id="{27D555A5-D334-4697-81FD-354E07E3CE85}"/>
               </a:ext>
             </a:extLst>
           </p:cNvPr>
@@ -10047,7 +10052,7 @@
           <p:cNvPr id="10" name="s5-stat3">
             <a:extLst xmlns:a="http://schemas.openxmlformats.org/drawingml/2006/main">
               <a:ext uri="{FF2B5EF4-FFF2-40B4-BE49-F238E27FC236}">
-                <a16:creationId xmlns:a16="http://schemas.microsoft.com/office/drawing/2014/main" id="{8207CA7A-8A6A-4056-9E54-A69ACECB7A63}"/>
+                <a16:creationId xmlns:a16="http://schemas.microsoft.com/office/drawing/2014/main" id="{73FACFF0-BF36-422F-862E-8848539E8BA3}"/>
               </a:ext>
             </a:extLst>
           </p:cNvPr>
@@ -10092,7 +10097,7 @@
           <p:cNvPr id="11" name="s5-stat3-label">
             <a:extLst xmlns:a="http://schemas.openxmlformats.org/drawingml/2006/main">
               <a:ext uri="{FF2B5EF4-FFF2-40B4-BE49-F238E27FC236}">
-                <a16:creationId xmlns:a16="http://schemas.microsoft.com/office/drawing/2014/main" id="{66BBAA00-A630-4E58-BF85-D44F5ED01336}"/>
+                <a16:creationId xmlns:a16="http://schemas.microsoft.com/office/drawing/2014/main" id="{6CE8A7A7-A0A4-4B52-A254-0283ADA847A5}"/>
               </a:ext>
             </a:extLst>
           </p:cNvPr>
@@ -10137,7 +10142,7 @@
           <p:cNvPr id="12" name="s5-explain">
             <a:extLst xmlns:a="http://schemas.openxmlformats.org/drawingml/2006/main">
               <a:ext uri="{FF2B5EF4-FFF2-40B4-BE49-F238E27FC236}">
-                <a16:creationId xmlns:a16="http://schemas.microsoft.com/office/drawing/2014/main" id="{FD580B01-E853-44F2-867E-A4F0A1C8A795}"/>
+                <a16:creationId xmlns:a16="http://schemas.microsoft.com/office/drawing/2014/main" id="{22580F89-8C4C-46C0-B438-B853F2EB92AB}"/>
               </a:ext>
             </a:extLst>
           </p:cNvPr>
@@ -10204,7 +10209,7 @@
           <p:cNvPr id="14" name="footer-source-5">
             <a:extLst xmlns:a="http://schemas.openxmlformats.org/drawingml/2006/main">
               <a:ext uri="{FF2B5EF4-FFF2-40B4-BE49-F238E27FC236}">
-                <a16:creationId xmlns:a16="http://schemas.microsoft.com/office/drawing/2014/main" id="{B535BF3A-4BDE-4B29-B465-FD233ADA2A9E}"/>
+                <a16:creationId xmlns:a16="http://schemas.microsoft.com/office/drawing/2014/main" id="{3D094CC5-A687-4F44-8A33-99688D02D1C8}"/>
               </a:ext>
             </a:extLst>
           </p:cNvPr>
@@ -10249,7 +10254,7 @@
           <p:cNvPr id="15" name="footer-number-5">
             <a:extLst xmlns:a="http://schemas.openxmlformats.org/drawingml/2006/main">
               <a:ext uri="{FF2B5EF4-FFF2-40B4-BE49-F238E27FC236}">
-                <a16:creationId xmlns:a16="http://schemas.microsoft.com/office/drawing/2014/main" id="{58166096-9D5D-4CC5-AC8A-3B2A5DA10F2E}"/>
+                <a16:creationId xmlns:a16="http://schemas.microsoft.com/office/drawing/2014/main" id="{019D4336-2E0D-457C-B08F-E20C2E2B26BA}"/>
               </a:ext>
             </a:extLst>
           </p:cNvPr>
@@ -10301,14 +10306,14 @@
         </p:xfrm>
         <a:graphic xmlns:a="http://schemas.openxmlformats.org/drawingml/2006/main">
           <a:graphicData uri="http://schemas.openxmlformats.org/drawingml/2006/chart">
-            <c:chart xmlns:r="http://schemas.openxmlformats.org/officeDocument/2006/relationships" xmlns:c="http://schemas.openxmlformats.org/drawingml/2006/chart" r:id="R9776da1c92664094"/>
+            <c:chart xmlns:r="http://schemas.openxmlformats.org/officeDocument/2006/relationships" xmlns:c="http://schemas.openxmlformats.org/drawingml/2006/chart" r:id="R28d14ee657bf4634"/>
           </a:graphicData>
         </a:graphic>
       </p:graphicFrame>
     </p:spTree>
     <p:extLst>
       <p:ext uri="{BB962C8B-B14F-4D97-AF65-F5344CB8AC3E}">
-        <p14:creationId xmlns:p14="http://schemas.microsoft.com/office/powerpoint/2010/main" val="1555059204"/>
+        <p14:creationId xmlns:p14="http://schemas.microsoft.com/office/powerpoint/2010/main" val="694190486"/>
       </p:ext>
     </p:extLst>
   </p:cSld>
@@ -10339,7 +10344,7 @@
           <p:cNvPr id="40" name="s6-title-new">
             <a:extLst xmlns:a="http://schemas.openxmlformats.org/drawingml/2006/main">
               <a:ext uri="{FF2B5EF4-FFF2-40B4-BE49-F238E27FC236}">
-                <a16:creationId xmlns:a16="http://schemas.microsoft.com/office/drawing/2014/main" id="{0B9BBC54-A7AB-4B90-A4D8-6234D4802806}"/>
+                <a16:creationId xmlns:a16="http://schemas.microsoft.com/office/drawing/2014/main" id="{7421BD81-0679-47DE-A055-72178DD13CF3}"/>
               </a:ext>
             </a:extLst>
           </p:cNvPr>
@@ -10384,7 +10389,7 @@
           <p:cNvPr id="2" name="s6-subtitle-new">
             <a:extLst xmlns:a="http://schemas.openxmlformats.org/drawingml/2006/main">
               <a:ext uri="{FF2B5EF4-FFF2-40B4-BE49-F238E27FC236}">
-                <a16:creationId xmlns:a16="http://schemas.microsoft.com/office/drawing/2014/main" id="{70D56032-7548-4B98-B0FA-67D3FFD8C400}"/>
+                <a16:creationId xmlns:a16="http://schemas.microsoft.com/office/drawing/2014/main" id="{FFAC6B6D-D2EB-43EA-BE96-2686ED993E53}"/>
               </a:ext>
             </a:extLst>
           </p:cNvPr>
@@ -10419,7 +10424,7 @@
               </a:defRPr>
             </a:pPr>
             <a:r>
-              <a:t>The fixture, model, prompt, tests, and hidden oracle stayed fixed; only context delivery changed.</a:t>
+              <a:t>Same Codex, model, task, fixture, prompt, tests, and hidden oracle; only Palace context changed.</a:t>
             </a:r>
           </a:p>
         </p:txBody>
@@ -10429,7 +10434,7 @@
           <p:cNvPr id="3" name="s6-task-new">
             <a:extLst xmlns:a="http://schemas.openxmlformats.org/drawingml/2006/main">
               <a:ext uri="{FF2B5EF4-FFF2-40B4-BE49-F238E27FC236}">
-                <a16:creationId xmlns:a16="http://schemas.microsoft.com/office/drawing/2014/main" id="{8441CCA0-6B81-45EE-BB83-6D4181FC3202}"/>
+                <a16:creationId xmlns:a16="http://schemas.microsoft.com/office/drawing/2014/main" id="{F3B205F8-D4AA-49EE-A3F5-2A747DC14A26}"/>
               </a:ext>
             </a:extLst>
           </p:cNvPr>
@@ -10464,7 +10469,7 @@
           <p:cNvPr id="4" name="s6-task-k-new">
             <a:extLst xmlns:a="http://schemas.openxmlformats.org/drawingml/2006/main">
               <a:ext uri="{FF2B5EF4-FFF2-40B4-BE49-F238E27FC236}">
-                <a16:creationId xmlns:a16="http://schemas.microsoft.com/office/drawing/2014/main" id="{3FE37912-8D90-4D2E-9271-BF6BFF432EF9}"/>
+                <a16:creationId xmlns:a16="http://schemas.microsoft.com/office/drawing/2014/main" id="{F4B6CB0B-8D32-42E3-A0CA-108CC2032F8E}"/>
               </a:ext>
             </a:extLst>
           </p:cNvPr>
@@ -10499,7 +10504,7 @@
               </a:defRPr>
             </a:pPr>
             <a:r>
-              <a:t>SAME TASK</a:t>
+              <a:t>SAME CODEX + TASK</a:t>
             </a:r>
           </a:p>
         </p:txBody>
@@ -10509,7 +10514,7 @@
           <p:cNvPr id="5" name="s6-task-v-new">
             <a:extLst xmlns:a="http://schemas.openxmlformats.org/drawingml/2006/main">
               <a:ext uri="{FF2B5EF4-FFF2-40B4-BE49-F238E27FC236}">
-                <a16:creationId xmlns:a16="http://schemas.microsoft.com/office/drawing/2014/main" id="{7EFE2C06-CE23-4F5D-8448-4C0D3185605B}"/>
+                <a16:creationId xmlns:a16="http://schemas.microsoft.com/office/drawing/2014/main" id="{D0870969-2D92-421A-B8EF-9E50A8CBB214}"/>
               </a:ext>
             </a:extLst>
           </p:cNvPr>
@@ -10686,7 +10691,7 @@
           <p:cNvPr id="12" name="s6-control-new">
             <a:extLst xmlns:a="http://schemas.openxmlformats.org/drawingml/2006/main">
               <a:ext uri="{FF2B5EF4-FFF2-40B4-BE49-F238E27FC236}">
-                <a16:creationId xmlns:a16="http://schemas.microsoft.com/office/drawing/2014/main" id="{894D8701-6AF8-4E7C-8169-D97600CB7C7E}"/>
+                <a16:creationId xmlns:a16="http://schemas.microsoft.com/office/drawing/2014/main" id="{CF8914D1-2CD2-49E5-8F61-248EE6D448B1}"/>
               </a:ext>
             </a:extLst>
           </p:cNvPr>
@@ -10721,7 +10726,7 @@
           <p:cNvPr id="13" name="s6-route-new">
             <a:extLst xmlns:a="http://schemas.openxmlformats.org/drawingml/2006/main">
               <a:ext uri="{FF2B5EF4-FFF2-40B4-BE49-F238E27FC236}">
-                <a16:creationId xmlns:a16="http://schemas.microsoft.com/office/drawing/2014/main" id="{0277C880-7391-43B7-9908-E53C81436B26}"/>
+                <a16:creationId xmlns:a16="http://schemas.microsoft.com/office/drawing/2014/main" id="{A1770D38-1ED1-4BE8-8717-527E91C13605}"/>
               </a:ext>
             </a:extLst>
           </p:cNvPr>
@@ -10756,7 +10761,7 @@
           <p:cNvPr id="14" name="s6-full-new">
             <a:extLst xmlns:a="http://schemas.openxmlformats.org/drawingml/2006/main">
               <a:ext uri="{FF2B5EF4-FFF2-40B4-BE49-F238E27FC236}">
-                <a16:creationId xmlns:a16="http://schemas.microsoft.com/office/drawing/2014/main" id="{4F6E2568-19E8-414D-AAEE-B31C15BA3ECC}"/>
+                <a16:creationId xmlns:a16="http://schemas.microsoft.com/office/drawing/2014/main" id="{9F3E73CD-614B-41D3-AE74-4D07FA893A17}"/>
               </a:ext>
             </a:extLst>
           </p:cNvPr>
@@ -10791,7 +10796,7 @@
           <p:cNvPr id="15" name="s6-adaptive-new">
             <a:extLst xmlns:a="http://schemas.openxmlformats.org/drawingml/2006/main">
               <a:ext uri="{FF2B5EF4-FFF2-40B4-BE49-F238E27FC236}">
-                <a16:creationId xmlns:a16="http://schemas.microsoft.com/office/drawing/2014/main" id="{44DC2282-3244-4427-A43C-C48F89D888FE}"/>
+                <a16:creationId xmlns:a16="http://schemas.microsoft.com/office/drawing/2014/main" id="{F71505AB-AAFC-4FE3-A404-392A9DF5039F}"/>
               </a:ext>
             </a:extLst>
           </p:cNvPr>
@@ -10826,7 +10831,7 @@
           <p:cNvPr id="16" name="s6-control-k-new">
             <a:extLst xmlns:a="http://schemas.openxmlformats.org/drawingml/2006/main">
               <a:ext uri="{FF2B5EF4-FFF2-40B4-BE49-F238E27FC236}">
-                <a16:creationId xmlns:a16="http://schemas.microsoft.com/office/drawing/2014/main" id="{5749294E-9621-40C8-97E2-C4BA940EE341}"/>
+                <a16:creationId xmlns:a16="http://schemas.microsoft.com/office/drawing/2014/main" id="{8E6F35FB-1F2C-4925-B0A5-AAAEAC086060}"/>
               </a:ext>
             </a:extLst>
           </p:cNvPr>
@@ -10861,7 +10866,7 @@
               </a:defRPr>
             </a:pPr>
             <a:r>
-              <a:t>CONTROL</a:t>
+              <a:t>CODEX ALONE</a:t>
             </a:r>
           </a:p>
         </p:txBody>
@@ -10871,7 +10876,7 @@
           <p:cNvPr id="17" name="s6-control-v-new">
             <a:extLst xmlns:a="http://schemas.openxmlformats.org/drawingml/2006/main">
               <a:ext uri="{FF2B5EF4-FFF2-40B4-BE49-F238E27FC236}">
-                <a16:creationId xmlns:a16="http://schemas.microsoft.com/office/drawing/2014/main" id="{334ED904-0E3A-4E8E-BE0E-FC7F7E444DA0}"/>
+                <a16:creationId xmlns:a16="http://schemas.microsoft.com/office/drawing/2014/main" id="{B6C2A541-3582-4162-B865-7CCE0359561A}"/>
               </a:ext>
             </a:extLst>
           </p:cNvPr>
@@ -10916,7 +10921,7 @@
           <p:cNvPr id="18" name="s6-control-d-new">
             <a:extLst xmlns:a="http://schemas.openxmlformats.org/drawingml/2006/main">
               <a:ext uri="{FF2B5EF4-FFF2-40B4-BE49-F238E27FC236}">
-                <a16:creationId xmlns:a16="http://schemas.microsoft.com/office/drawing/2014/main" id="{3122B578-937F-455D-9503-52B57124F0A6}"/>
+                <a16:creationId xmlns:a16="http://schemas.microsoft.com/office/drawing/2014/main" id="{ED3C1272-1D4E-4076-9FE3-D9A23733300F}"/>
               </a:ext>
             </a:extLst>
           </p:cNvPr>
@@ -10951,7 +10956,7 @@
               </a:defRPr>
             </a:pPr>
             <a:r>
-              <a:t>Direct repository search</a:t>
+              <a:t>Codex searches the repo directly</a:t>
             </a:r>
           </a:p>
         </p:txBody>
@@ -10961,7 +10966,7 @@
           <p:cNvPr id="19" name="s6-route-k-new">
             <a:extLst xmlns:a="http://schemas.openxmlformats.org/drawingml/2006/main">
               <a:ext uri="{FF2B5EF4-FFF2-40B4-BE49-F238E27FC236}">
-                <a16:creationId xmlns:a16="http://schemas.microsoft.com/office/drawing/2014/main" id="{F7601BAD-5315-4DAE-AFA8-FB6BD18573B2}"/>
+                <a16:creationId xmlns:a16="http://schemas.microsoft.com/office/drawing/2014/main" id="{8770BE74-E915-4493-ABB7-0AD6A29C185F}"/>
               </a:ext>
             </a:extLst>
           </p:cNvPr>
@@ -11006,7 +11011,7 @@
           <p:cNvPr id="20" name="s6-route-v-new">
             <a:extLst xmlns:a="http://schemas.openxmlformats.org/drawingml/2006/main">
               <a:ext uri="{FF2B5EF4-FFF2-40B4-BE49-F238E27FC236}">
-                <a16:creationId xmlns:a16="http://schemas.microsoft.com/office/drawing/2014/main" id="{20BAE44E-9119-4980-9B5F-1E5E9571F841}"/>
+                <a16:creationId xmlns:a16="http://schemas.microsoft.com/office/drawing/2014/main" id="{7B911E7C-5A23-4D80-A118-A19832AF527E}"/>
               </a:ext>
             </a:extLst>
           </p:cNvPr>
@@ -11051,7 +11056,7 @@
           <p:cNvPr id="21" name="s6-route-d-new">
             <a:extLst xmlns:a="http://schemas.openxmlformats.org/drawingml/2006/main">
               <a:ext uri="{FF2B5EF4-FFF2-40B4-BE49-F238E27FC236}">
-                <a16:creationId xmlns:a16="http://schemas.microsoft.com/office/drawing/2014/main" id="{7152C733-766A-41CE-AFF6-DB743BBC0C26}"/>
+                <a16:creationId xmlns:a16="http://schemas.microsoft.com/office/drawing/2014/main" id="{88E4B44D-734B-436C-B680-0D3DC7119FDF}"/>
               </a:ext>
             </a:extLst>
           </p:cNvPr>
@@ -11096,7 +11101,7 @@
           <p:cNvPr id="22" name="s6-full-k-new">
             <a:extLst xmlns:a="http://schemas.openxmlformats.org/drawingml/2006/main">
               <a:ext uri="{FF2B5EF4-FFF2-40B4-BE49-F238E27FC236}">
-                <a16:creationId xmlns:a16="http://schemas.microsoft.com/office/drawing/2014/main" id="{09055A7B-3E1B-4AEE-BF7B-3E3E90467E37}"/>
+                <a16:creationId xmlns:a16="http://schemas.microsoft.com/office/drawing/2014/main" id="{481DD6AE-6CC7-41B8-B80C-7D518F382761}"/>
               </a:ext>
             </a:extLst>
           </p:cNvPr>
@@ -11141,7 +11146,7 @@
           <p:cNvPr id="23" name="s6-full-v-new">
             <a:extLst xmlns:a="http://schemas.openxmlformats.org/drawingml/2006/main">
               <a:ext uri="{FF2B5EF4-FFF2-40B4-BE49-F238E27FC236}">
-                <a16:creationId xmlns:a16="http://schemas.microsoft.com/office/drawing/2014/main" id="{CC9E5698-0BC1-4F14-B691-9209696D0C61}"/>
+                <a16:creationId xmlns:a16="http://schemas.microsoft.com/office/drawing/2014/main" id="{A2A01136-BA3A-44F7-B32D-F21B2399FEBA}"/>
               </a:ext>
             </a:extLst>
           </p:cNvPr>
@@ -11186,7 +11191,7 @@
           <p:cNvPr id="24" name="s6-full-d-new">
             <a:extLst xmlns:a="http://schemas.openxmlformats.org/drawingml/2006/main">
               <a:ext uri="{FF2B5EF4-FFF2-40B4-BE49-F238E27FC236}">
-                <a16:creationId xmlns:a16="http://schemas.microsoft.com/office/drawing/2014/main" id="{48626841-C427-4953-A03A-6AA7924D1B49}"/>
+                <a16:creationId xmlns:a16="http://schemas.microsoft.com/office/drawing/2014/main" id="{2D4EA5D1-38C9-4EF2-AD15-0EDF15AC9B7A}"/>
               </a:ext>
             </a:extLst>
           </p:cNvPr>
@@ -11231,7 +11236,7 @@
           <p:cNvPr id="25" name="s6-adaptive-k-new">
             <a:extLst xmlns:a="http://schemas.openxmlformats.org/drawingml/2006/main">
               <a:ext uri="{FF2B5EF4-FFF2-40B4-BE49-F238E27FC236}">
-                <a16:creationId xmlns:a16="http://schemas.microsoft.com/office/drawing/2014/main" id="{1AD2B7C2-59B5-4EAD-B962-CDB47D1DF9B1}"/>
+                <a16:creationId xmlns:a16="http://schemas.microsoft.com/office/drawing/2014/main" id="{108DC580-F130-4AC5-8A7E-28E756BBA098}"/>
               </a:ext>
             </a:extLst>
           </p:cNvPr>
@@ -11276,7 +11281,7 @@
           <p:cNvPr id="26" name="s6-adaptive-v-new">
             <a:extLst xmlns:a="http://schemas.openxmlformats.org/drawingml/2006/main">
               <a:ext uri="{FF2B5EF4-FFF2-40B4-BE49-F238E27FC236}">
-                <a16:creationId xmlns:a16="http://schemas.microsoft.com/office/drawing/2014/main" id="{1AB7BD95-8CCD-4EA3-8E7C-D4527ECFA417}"/>
+                <a16:creationId xmlns:a16="http://schemas.microsoft.com/office/drawing/2014/main" id="{A764D575-ED26-4F8E-9E8E-EAC848C43698}"/>
               </a:ext>
             </a:extLst>
           </p:cNvPr>
@@ -11321,7 +11326,7 @@
           <p:cNvPr id="27" name="s6-adaptive-d-new">
             <a:extLst xmlns:a="http://schemas.openxmlformats.org/drawingml/2006/main">
               <a:ext uri="{FF2B5EF4-FFF2-40B4-BE49-F238E27FC236}">
-                <a16:creationId xmlns:a16="http://schemas.microsoft.com/office/drawing/2014/main" id="{AC558179-DE3A-45E2-930D-6FA0B104A911}"/>
+                <a16:creationId xmlns:a16="http://schemas.microsoft.com/office/drawing/2014/main" id="{75DCA3EE-46AB-4B58-AAA6-4D788742742D}"/>
               </a:ext>
             </a:extLst>
           </p:cNvPr>
@@ -11366,7 +11371,7 @@
           <p:cNvPr id="28" name="s6-summary-new">
             <a:extLst xmlns:a="http://schemas.openxmlformats.org/drawingml/2006/main">
               <a:ext uri="{FF2B5EF4-FFF2-40B4-BE49-F238E27FC236}">
-                <a16:creationId xmlns:a16="http://schemas.microsoft.com/office/drawing/2014/main" id="{9B63C733-90F3-4E4F-8177-22F4DA6485D9}"/>
+                <a16:creationId xmlns:a16="http://schemas.microsoft.com/office/drawing/2014/main" id="{B824361F-C238-4AEA-9318-BD62C18DFE26}"/>
               </a:ext>
             </a:extLst>
           </p:cNvPr>
@@ -11401,7 +11406,7 @@
           <p:cNvPr id="29" name="s6-n-trials-new">
             <a:extLst xmlns:a="http://schemas.openxmlformats.org/drawingml/2006/main">
               <a:ext uri="{FF2B5EF4-FFF2-40B4-BE49-F238E27FC236}">
-                <a16:creationId xmlns:a16="http://schemas.microsoft.com/office/drawing/2014/main" id="{961D1829-7ACB-44CE-B8F7-395BC4F7C274}"/>
+                <a16:creationId xmlns:a16="http://schemas.microsoft.com/office/drawing/2014/main" id="{39B96ADD-4FE5-4561-B461-593E576CE3FE}"/>
               </a:ext>
             </a:extLst>
           </p:cNvPr>
@@ -11446,7 +11451,7 @@
           <p:cNvPr id="30" name="s6-l-trials-new">
             <a:extLst xmlns:a="http://schemas.openxmlformats.org/drawingml/2006/main">
               <a:ext uri="{FF2B5EF4-FFF2-40B4-BE49-F238E27FC236}">
-                <a16:creationId xmlns:a16="http://schemas.microsoft.com/office/drawing/2014/main" id="{D9F9403A-3AAE-44F1-8D88-4631E3F1A5F8}"/>
+                <a16:creationId xmlns:a16="http://schemas.microsoft.com/office/drawing/2014/main" id="{21565D55-AA93-4183-AB5B-25C689ECDADF}"/>
               </a:ext>
             </a:extLst>
           </p:cNvPr>
@@ -11491,7 +11496,7 @@
           <p:cNvPr id="31" name="s6-n-arms-new">
             <a:extLst xmlns:a="http://schemas.openxmlformats.org/drawingml/2006/main">
               <a:ext uri="{FF2B5EF4-FFF2-40B4-BE49-F238E27FC236}">
-                <a16:creationId xmlns:a16="http://schemas.microsoft.com/office/drawing/2014/main" id="{9580CB2C-71AD-434F-9A4F-F6FEC8CD4FC8}"/>
+                <a16:creationId xmlns:a16="http://schemas.microsoft.com/office/drawing/2014/main" id="{2B67E337-092E-42B9-B054-8D8B4E9D9EA9}"/>
               </a:ext>
             </a:extLst>
           </p:cNvPr>
@@ -11536,7 +11541,7 @@
           <p:cNvPr id="32" name="s6-l-arms-new">
             <a:extLst xmlns:a="http://schemas.openxmlformats.org/drawingml/2006/main">
               <a:ext uri="{FF2B5EF4-FFF2-40B4-BE49-F238E27FC236}">
-                <a16:creationId xmlns:a16="http://schemas.microsoft.com/office/drawing/2014/main" id="{C922E93C-EB09-429F-998D-03E04BE75E6A}"/>
+                <a16:creationId xmlns:a16="http://schemas.microsoft.com/office/drawing/2014/main" id="{6B393E9D-600F-44A7-B7EA-20107FAB0616}"/>
               </a:ext>
             </a:extLst>
           </p:cNvPr>
@@ -11581,7 +11586,7 @@
           <p:cNvPr id="33" name="s6-n-fixed-new">
             <a:extLst xmlns:a="http://schemas.openxmlformats.org/drawingml/2006/main">
               <a:ext uri="{FF2B5EF4-FFF2-40B4-BE49-F238E27FC236}">
-                <a16:creationId xmlns:a16="http://schemas.microsoft.com/office/drawing/2014/main" id="{19B1CEA3-0773-4161-B65E-7EDC43569515}"/>
+                <a16:creationId xmlns:a16="http://schemas.microsoft.com/office/drawing/2014/main" id="{27ECF008-9261-4E45-8598-4DB6788EF5B0}"/>
               </a:ext>
             </a:extLst>
           </p:cNvPr>
@@ -11626,7 +11631,7 @@
           <p:cNvPr id="34" name="s6-l-fixed-new">
             <a:extLst xmlns:a="http://schemas.openxmlformats.org/drawingml/2006/main">
               <a:ext uri="{FF2B5EF4-FFF2-40B4-BE49-F238E27FC236}">
-                <a16:creationId xmlns:a16="http://schemas.microsoft.com/office/drawing/2014/main" id="{CA181A73-8185-4EF0-AD72-997F785EB5DC}"/>
+                <a16:creationId xmlns:a16="http://schemas.microsoft.com/office/drawing/2014/main" id="{75CE1991-A3D5-4D5B-BE61-0D363C78F4B4}"/>
               </a:ext>
             </a:extLst>
           </p:cNvPr>
@@ -11638,20 +11643,20 @@
         <p:spPr>
           <a:xfrm xmlns:a="http://schemas.openxmlformats.org/drawingml/2006/main">
             <a:off x="4762500" y="5562600"/>
-            <a:ext cx="2857500" cy="209550"/>
-          </a:xfrm>
-          <a:prstGeom xmlns:a="http://schemas.openxmlformats.org/drawingml/2006/main" prst="rect">
-            <a:avLst/>
-          </a:prstGeom>
-        </p:spPr>
-        <p:txBody>
-          <a:bodyPr xmlns:a="http://schemas.openxmlformats.org/drawingml/2006/main" wrap="square" lIns="0" tIns="0" rIns="0" bIns="0" anchor="t">
-            <a:noAutofit/>
-          </a:bodyPr>
-          <a:lstStyle xmlns:a="http://schemas.openxmlformats.org/drawingml/2006/main"/>
-          <a:p xmlns:a="http://schemas.openxmlformats.org/drawingml/2006/main">
-            <a:pPr algn="l">
-              <a:defRPr sz="1125" b="0">
+            <a:ext cx="3143250" cy="209550"/>
+          </a:xfrm>
+          <a:prstGeom xmlns:a="http://schemas.openxmlformats.org/drawingml/2006/main" prst="rect">
+            <a:avLst/>
+          </a:prstGeom>
+        </p:spPr>
+        <p:txBody>
+          <a:bodyPr xmlns:a="http://schemas.openxmlformats.org/drawingml/2006/main" wrap="square" lIns="0" tIns="0" rIns="0" bIns="0" anchor="t">
+            <a:noAutofit/>
+          </a:bodyPr>
+          <a:lstStyle xmlns:a="http://schemas.openxmlformats.org/drawingml/2006/main"/>
+          <a:p xmlns:a="http://schemas.openxmlformats.org/drawingml/2006/main">
+            <a:pPr algn="l">
+              <a:defRPr sz="1050" b="0">
                 <a:solidFill>
                   <a:srgbClr val="FFFFFF"/>
                 </a:solidFill>
@@ -11661,7 +11666,7 @@
               </a:defRPr>
             </a:pPr>
             <a:r>
-              <a:t>task | fixture | model | tests</a:t>
+              <a:t>Codex | task | fixture | model | tests</a:t>
             </a:r>
           </a:p>
         </p:txBody>
@@ -11671,7 +11676,7 @@
           <p:cNvPr id="35" name="s6-n-variable-new">
             <a:extLst xmlns:a="http://schemas.openxmlformats.org/drawingml/2006/main">
               <a:ext uri="{FF2B5EF4-FFF2-40B4-BE49-F238E27FC236}">
-                <a16:creationId xmlns:a16="http://schemas.microsoft.com/office/drawing/2014/main" id="{765B2D8E-36E8-48FF-B693-273BD5E7256F}"/>
+                <a16:creationId xmlns:a16="http://schemas.microsoft.com/office/drawing/2014/main" id="{08F66936-C4F8-44BD-A454-F90C7A89C043}"/>
               </a:ext>
             </a:extLst>
           </p:cNvPr>
@@ -11716,7 +11721,7 @@
           <p:cNvPr id="36" name="s6-l-variable-new">
             <a:extLst xmlns:a="http://schemas.openxmlformats.org/drawingml/2006/main">
               <a:ext uri="{FF2B5EF4-FFF2-40B4-BE49-F238E27FC236}">
-                <a16:creationId xmlns:a16="http://schemas.microsoft.com/office/drawing/2014/main" id="{7ADB15E6-FDB9-403D-9747-42B5B37CF00E}"/>
+                <a16:creationId xmlns:a16="http://schemas.microsoft.com/office/drawing/2014/main" id="{60934233-58B9-4C53-8FBA-36E4C23E1ECE}"/>
               </a:ext>
             </a:extLst>
           </p:cNvPr>
@@ -11783,7 +11788,7 @@
           <p:cNvPr id="38" name="footer-source-6">
             <a:extLst xmlns:a="http://schemas.openxmlformats.org/drawingml/2006/main">
               <a:ext uri="{FF2B5EF4-FFF2-40B4-BE49-F238E27FC236}">
-                <a16:creationId xmlns:a16="http://schemas.microsoft.com/office/drawing/2014/main" id="{CE369D1D-1E0A-4FBC-BD7E-6E930E0DA0F4}"/>
+                <a16:creationId xmlns:a16="http://schemas.microsoft.com/office/drawing/2014/main" id="{FCDFC48C-75FC-4A71-9418-1FC1B5AD58C4}"/>
               </a:ext>
             </a:extLst>
           </p:cNvPr>
@@ -11828,7 +11833,7 @@
           <p:cNvPr id="39" name="footer-number-6">
             <a:extLst xmlns:a="http://schemas.openxmlformats.org/drawingml/2006/main">
               <a:ext uri="{FF2B5EF4-FFF2-40B4-BE49-F238E27FC236}">
-                <a16:creationId xmlns:a16="http://schemas.microsoft.com/office/drawing/2014/main" id="{BE2E0534-2BD3-4CE4-9789-07781AD0D9EC}"/>
+                <a16:creationId xmlns:a16="http://schemas.microsoft.com/office/drawing/2014/main" id="{75D333E8-5E0B-4DC0-913B-6BE09A02B460}"/>
               </a:ext>
             </a:extLst>
           </p:cNvPr>
@@ -11871,7 +11876,7 @@
     </p:spTree>
     <p:extLst>
       <p:ext uri="{BB962C8B-B14F-4D97-AF65-F5344CB8AC3E}">
-        <p14:creationId xmlns:p14="http://schemas.microsoft.com/office/powerpoint/2010/main" val="1067160164"/>
+        <p14:creationId xmlns:p14="http://schemas.microsoft.com/office/powerpoint/2010/main" val="1975189959"/>
       </p:ext>
     </p:extLst>
   </p:cSld>
@@ -11902,7 +11907,7 @@
           <p:cNvPr id="37" name="s7-title-new">
             <a:extLst xmlns:a="http://schemas.openxmlformats.org/drawingml/2006/main">
               <a:ext uri="{FF2B5EF4-FFF2-40B4-BE49-F238E27FC236}">
-                <a16:creationId xmlns:a16="http://schemas.microsoft.com/office/drawing/2014/main" id="{21508189-EE61-4059-B792-EA2D7757F45B}"/>
+                <a16:creationId xmlns:a16="http://schemas.microsoft.com/office/drawing/2014/main" id="{A4A4F926-B78C-4C76-A5E7-1FC3CC04CC1E}"/>
               </a:ext>
             </a:extLst>
           </p:cNvPr>
@@ -11937,7 +11942,7 @@
               </a:defRPr>
             </a:pPr>
             <a:r>
-              <a:t>The benchmark rejected an always-on Palace.</a:t>
+              <a:t>Adaptive Palace vs Codex alone</a:t>
             </a:r>
           </a:p>
         </p:txBody>
@@ -11947,32 +11952,32 @@
           <p:cNvPr id="2" name="s7-subtitle-new">
             <a:extLst xmlns:a="http://schemas.openxmlformats.org/drawingml/2006/main">
               <a:ext uri="{FF2B5EF4-FFF2-40B4-BE49-F238E27FC236}">
-                <a16:creationId xmlns:a16="http://schemas.microsoft.com/office/drawing/2014/main" id="{7E4D47A7-8282-4BD0-BCE1-1A969B5FF591}"/>
-              </a:ext>
-            </a:extLst>
-          </p:cNvPr>
-          <p:cNvSpPr>
-            <a:spLocks xmlns:a="http://schemas.openxmlformats.org/drawingml/2006/main" noGrp="1"/>
-          </p:cNvSpPr>
-          <p:nvPr/>
-        </p:nvSpPr>
-        <p:spPr>
-          <a:xfrm xmlns:a="http://schemas.openxmlformats.org/drawingml/2006/main">
-            <a:off x="400050" y="1066800"/>
-            <a:ext cx="11391900" cy="381000"/>
-          </a:xfrm>
-          <a:prstGeom xmlns:a="http://schemas.openxmlformats.org/drawingml/2006/main" prst="rect">
-            <a:avLst/>
-          </a:prstGeom>
-        </p:spPr>
-        <p:txBody>
-          <a:bodyPr xmlns:a="http://schemas.openxmlformats.org/drawingml/2006/main" wrap="square" lIns="0" tIns="0" rIns="0" bIns="0" anchor="t">
-            <a:noAutofit/>
-          </a:bodyPr>
-          <a:lstStyle xmlns:a="http://schemas.openxmlformats.org/drawingml/2006/main"/>
-          <a:p xmlns:a="http://schemas.openxmlformats.org/drawingml/2006/main">
-            <a:pPr algn="l">
-              <a:defRPr sz="1500" b="0">
+                <a16:creationId xmlns:a16="http://schemas.microsoft.com/office/drawing/2014/main" id="{990D751B-34DC-48C3-BB09-A6740E5D9630}"/>
+              </a:ext>
+            </a:extLst>
+          </p:cNvPr>
+          <p:cNvSpPr>
+            <a:spLocks xmlns:a="http://schemas.openxmlformats.org/drawingml/2006/main" noGrp="1"/>
+          </p:cNvSpPr>
+          <p:nvPr/>
+        </p:nvSpPr>
+        <p:spPr>
+          <a:xfrm xmlns:a="http://schemas.openxmlformats.org/drawingml/2006/main">
+            <a:off x="495300" y="1066800"/>
+            <a:ext cx="10953750" cy="381000"/>
+          </a:xfrm>
+          <a:prstGeom xmlns:a="http://schemas.openxmlformats.org/drawingml/2006/main" prst="rect">
+            <a:avLst/>
+          </a:prstGeom>
+        </p:spPr>
+        <p:txBody>
+          <a:bodyPr xmlns:a="http://schemas.openxmlformats.org/drawingml/2006/main" wrap="square" lIns="0" tIns="0" rIns="0" bIns="0" anchor="t">
+            <a:noAutofit/>
+          </a:bodyPr>
+          <a:lstStyle xmlns:a="http://schemas.openxmlformats.org/drawingml/2006/main"/>
+          <a:p xmlns:a="http://schemas.openxmlformats.org/drawingml/2006/main">
+            <a:pPr algn="l">
+              <a:defRPr sz="1350" b="0">
                 <a:solidFill>
                   <a:srgbClr val="526071"/>
                 </a:solidFill>
@@ -11982,7 +11987,7 @@
               </a:defRPr>
             </a:pPr>
             <a:r>
-              <a:t>On deterministic synthetic tasks, routing added calls; v0.2.3 responds with selective context modes.</a:t>
+              <a:t>Same Codex and tests; only Palace context changed. Always-on was not justified here.</a:t>
             </a:r>
           </a:p>
         </p:txBody>
@@ -11992,7 +11997,7 @@
           <p:cNvPr id="3" name="s7-result-panel">
             <a:extLst xmlns:a="http://schemas.openxmlformats.org/drawingml/2006/main">
               <a:ext uri="{FF2B5EF4-FFF2-40B4-BE49-F238E27FC236}">
-                <a16:creationId xmlns:a16="http://schemas.microsoft.com/office/drawing/2014/main" id="{413F853A-C01F-4D48-A703-A1B8B495CD55}"/>
+                <a16:creationId xmlns:a16="http://schemas.microsoft.com/office/drawing/2014/main" id="{8F68A850-2DCF-44A4-96F5-064F2121F6C3}"/>
               </a:ext>
             </a:extLst>
           </p:cNvPr>
@@ -12027,7 +12032,7 @@
           <p:cNvPr id="4" name="s7-result-k">
             <a:extLst xmlns:a="http://schemas.openxmlformats.org/drawingml/2006/main">
               <a:ext uri="{FF2B5EF4-FFF2-40B4-BE49-F238E27FC236}">
-                <a16:creationId xmlns:a16="http://schemas.microsoft.com/office/drawing/2014/main" id="{3BD0AD4F-06A9-42A3-9982-AB9684E5F117}"/>
+                <a16:creationId xmlns:a16="http://schemas.microsoft.com/office/drawing/2014/main" id="{57683290-0756-40BD-BA53-1C503A94BC65}"/>
               </a:ext>
             </a:extLst>
           </p:cNvPr>
@@ -12052,7 +12057,7 @@
           <a:lstStyle xmlns:a="http://schemas.openxmlformats.org/drawingml/2006/main"/>
           <a:p xmlns:a="http://schemas.openxmlformats.org/drawingml/2006/main">
             <a:pPr algn="l">
-              <a:defRPr sz="1125" b="1">
+              <a:defRPr sz="1050" b="1">
                 <a:solidFill>
                   <a:srgbClr val="D4515D"/>
                 </a:solidFill>
@@ -12062,7 +12067,7 @@
               </a:defRPr>
             </a:pPr>
             <a:r>
-              <a:t>FROZEN v0.2.1 RESULT</a:t>
+              <a:t>PAIRED DIFFERENCE: ADAPTIVE - CODEX ALONE</a:t>
             </a:r>
           </a:p>
         </p:txBody>
@@ -12072,7 +12077,7 @@
           <p:cNvPr id="5" name="s7-tools-stat">
             <a:extLst xmlns:a="http://schemas.openxmlformats.org/drawingml/2006/main">
               <a:ext uri="{FF2B5EF4-FFF2-40B4-BE49-F238E27FC236}">
-                <a16:creationId xmlns:a16="http://schemas.microsoft.com/office/drawing/2014/main" id="{BFD0AB1F-B840-4D99-A184-28804F0F6152}"/>
+                <a16:creationId xmlns:a16="http://schemas.microsoft.com/office/drawing/2014/main" id="{16BE07FE-4EB9-4F4B-A44C-F3C9A46EB8C1}"/>
               </a:ext>
             </a:extLst>
           </p:cNvPr>
@@ -12117,7 +12122,7 @@
           <p:cNvPr id="6" name="s7-tools-label">
             <a:extLst xmlns:a="http://schemas.openxmlformats.org/drawingml/2006/main">
               <a:ext uri="{FF2B5EF4-FFF2-40B4-BE49-F238E27FC236}">
-                <a16:creationId xmlns:a16="http://schemas.microsoft.com/office/drawing/2014/main" id="{4BA4E474-98A7-4AD2-9799-16DD3CDAF312}"/>
+                <a16:creationId xmlns:a16="http://schemas.microsoft.com/office/drawing/2014/main" id="{90E72731-2F47-415D-8BD1-5E497FBDE580}"/>
               </a:ext>
             </a:extLst>
           </p:cNvPr>
@@ -12162,7 +12167,7 @@
           <p:cNvPr id="7" name="s7-tools-ci">
             <a:extLst xmlns:a="http://schemas.openxmlformats.org/drawingml/2006/main">
               <a:ext uri="{FF2B5EF4-FFF2-40B4-BE49-F238E27FC236}">
-                <a16:creationId xmlns:a16="http://schemas.microsoft.com/office/drawing/2014/main" id="{54F65D05-45F0-42E9-97FF-D23260D7397E}"/>
+                <a16:creationId xmlns:a16="http://schemas.microsoft.com/office/drawing/2014/main" id="{68FB1825-21A8-41F4-BB82-9B3EBA1DC72A}"/>
               </a:ext>
             </a:extLst>
           </p:cNvPr>
@@ -12229,7 +12234,7 @@
           <p:cNvPr id="9" name="s7-token-stat">
             <a:extLst xmlns:a="http://schemas.openxmlformats.org/drawingml/2006/main">
               <a:ext uri="{FF2B5EF4-FFF2-40B4-BE49-F238E27FC236}">
-                <a16:creationId xmlns:a16="http://schemas.microsoft.com/office/drawing/2014/main" id="{686062B4-E426-41D6-8944-87A0CEC64E3F}"/>
+                <a16:creationId xmlns:a16="http://schemas.microsoft.com/office/drawing/2014/main" id="{3C9DC71B-9BF3-4074-AFCB-CC5A181FC205}"/>
               </a:ext>
             </a:extLst>
           </p:cNvPr>
@@ -12274,7 +12279,7 @@
           <p:cNvPr id="10" name="s7-token-label">
             <a:extLst xmlns:a="http://schemas.openxmlformats.org/drawingml/2006/main">
               <a:ext uri="{FF2B5EF4-FFF2-40B4-BE49-F238E27FC236}">
-                <a16:creationId xmlns:a16="http://schemas.microsoft.com/office/drawing/2014/main" id="{306FEAE0-3CD3-4C10-8F5F-2F4AB37A87D2}"/>
+                <a16:creationId xmlns:a16="http://schemas.microsoft.com/office/drawing/2014/main" id="{27626714-FCC5-41B9-B3FE-BCFB8D7D2528}"/>
               </a:ext>
             </a:extLst>
           </p:cNvPr>
@@ -12319,7 +12324,7 @@
           <p:cNvPr id="11" name="s7-token-note">
             <a:extLst xmlns:a="http://schemas.openxmlformats.org/drawingml/2006/main">
               <a:ext uri="{FF2B5EF4-FFF2-40B4-BE49-F238E27FC236}">
-                <a16:creationId xmlns:a16="http://schemas.microsoft.com/office/drawing/2014/main" id="{B42B31DC-9F78-41B0-A639-D3EFCAB76CC3}"/>
+                <a16:creationId xmlns:a16="http://schemas.microsoft.com/office/drawing/2014/main" id="{2343484C-8AA2-4A51-8C5C-C5ED1899E31F}"/>
               </a:ext>
             </a:extLst>
           </p:cNvPr>
@@ -12364,7 +12369,7 @@
           <p:cNvPr id="12" name="s7-time-stat">
             <a:extLst xmlns:a="http://schemas.openxmlformats.org/drawingml/2006/main">
               <a:ext uri="{FF2B5EF4-FFF2-40B4-BE49-F238E27FC236}">
-                <a16:creationId xmlns:a16="http://schemas.microsoft.com/office/drawing/2014/main" id="{5AECB523-CA05-47D3-B1DE-73ECBFB661FB}"/>
+                <a16:creationId xmlns:a16="http://schemas.microsoft.com/office/drawing/2014/main" id="{08534A30-AE99-41EF-AB76-BD01A0E77DE6}"/>
               </a:ext>
             </a:extLst>
           </p:cNvPr>
@@ -12409,7 +12414,7 @@
           <p:cNvPr id="13" name="s7-time-label">
             <a:extLst xmlns:a="http://schemas.openxmlformats.org/drawingml/2006/main">
               <a:ext uri="{FF2B5EF4-FFF2-40B4-BE49-F238E27FC236}">
-                <a16:creationId xmlns:a16="http://schemas.microsoft.com/office/drawing/2014/main" id="{1D5F6219-EF82-40BC-92D6-B05A5450E38A}"/>
+                <a16:creationId xmlns:a16="http://schemas.microsoft.com/office/drawing/2014/main" id="{FE45266C-03EE-407A-8B08-14D3C495F550}"/>
               </a:ext>
             </a:extLst>
           </p:cNvPr>
@@ -12454,7 +12459,7 @@
           <p:cNvPr id="14" name="s7-time-note">
             <a:extLst xmlns:a="http://schemas.openxmlformats.org/drawingml/2006/main">
               <a:ext uri="{FF2B5EF4-FFF2-40B4-BE49-F238E27FC236}">
-                <a16:creationId xmlns:a16="http://schemas.microsoft.com/office/drawing/2014/main" id="{73C389EF-0204-4E36-8FC4-575E2EC9993E}"/>
+                <a16:creationId xmlns:a16="http://schemas.microsoft.com/office/drawing/2014/main" id="{0DCC79DD-7D0E-4A5C-9916-6DB7453E7B4B}"/>
               </a:ext>
             </a:extLst>
           </p:cNvPr>
@@ -12499,7 +12504,7 @@
           <p:cNvPr id="15" name="s7-correct">
             <a:extLst xmlns:a="http://schemas.openxmlformats.org/drawingml/2006/main">
               <a:ext uri="{FF2B5EF4-FFF2-40B4-BE49-F238E27FC236}">
-                <a16:creationId xmlns:a16="http://schemas.microsoft.com/office/drawing/2014/main" id="{EEDE1458-9D13-4DEA-A3C5-DFF0B6B74E06}"/>
+                <a16:creationId xmlns:a16="http://schemas.microsoft.com/office/drawing/2014/main" id="{B598F663-7394-4EFB-B469-8D410790421D}"/>
               </a:ext>
             </a:extLst>
           </p:cNvPr>
@@ -12544,7 +12549,7 @@
           <p:cNvPr id="16" name="s7-policy-panel">
             <a:extLst xmlns:a="http://schemas.openxmlformats.org/drawingml/2006/main">
               <a:ext uri="{FF2B5EF4-FFF2-40B4-BE49-F238E27FC236}">
-                <a16:creationId xmlns:a16="http://schemas.microsoft.com/office/drawing/2014/main" id="{EECDA71F-36E6-43EF-A43D-6A0957BB0A0A}"/>
+                <a16:creationId xmlns:a16="http://schemas.microsoft.com/office/drawing/2014/main" id="{FA4313C7-BC75-4C60-B360-7BA91F830F39}"/>
               </a:ext>
             </a:extLst>
           </p:cNvPr>
@@ -12579,7 +12584,7 @@
           <p:cNvPr id="17" name="s7-policy-k">
             <a:extLst xmlns:a="http://schemas.openxmlformats.org/drawingml/2006/main">
               <a:ext uri="{FF2B5EF4-FFF2-40B4-BE49-F238E27FC236}">
-                <a16:creationId xmlns:a16="http://schemas.microsoft.com/office/drawing/2014/main" id="{9926438A-FA07-4755-A7DC-771024483001}"/>
+                <a16:creationId xmlns:a16="http://schemas.microsoft.com/office/drawing/2014/main" id="{A3B96636-6E59-46FB-8B42-0BB5074216B0}"/>
               </a:ext>
             </a:extLst>
           </p:cNvPr>
@@ -12624,7 +12629,7 @@
           <p:cNvPr id="18" name="s7-policy-v">
             <a:extLst xmlns:a="http://schemas.openxmlformats.org/drawingml/2006/main">
               <a:ext uri="{FF2B5EF4-FFF2-40B4-BE49-F238E27FC236}">
-                <a16:creationId xmlns:a16="http://schemas.microsoft.com/office/drawing/2014/main" id="{A70A6B99-F2C2-42A6-96D6-BB30AD398042}"/>
+                <a16:creationId xmlns:a16="http://schemas.microsoft.com/office/drawing/2014/main" id="{529A0AFB-1FAE-4F6F-8D21-EAD04C52CBF9}"/>
               </a:ext>
             </a:extLst>
           </p:cNvPr>
@@ -12669,7 +12674,7 @@
           <p:cNvPr id="19" name="s7-bypass">
             <a:extLst xmlns:a="http://schemas.openxmlformats.org/drawingml/2006/main">
               <a:ext uri="{FF2B5EF4-FFF2-40B4-BE49-F238E27FC236}">
-                <a16:creationId xmlns:a16="http://schemas.microsoft.com/office/drawing/2014/main" id="{377D3285-C9E2-49CD-8C50-518BEA500CB2}"/>
+                <a16:creationId xmlns:a16="http://schemas.microsoft.com/office/drawing/2014/main" id="{D9493279-AC4C-4F06-AB21-711444B8D06F}"/>
               </a:ext>
             </a:extLst>
           </p:cNvPr>
@@ -12704,7 +12709,7 @@
           <p:cNvPr id="20" name="s7-bypass-k">
             <a:extLst xmlns:a="http://schemas.openxmlformats.org/drawingml/2006/main">
               <a:ext uri="{FF2B5EF4-FFF2-40B4-BE49-F238E27FC236}">
-                <a16:creationId xmlns:a16="http://schemas.microsoft.com/office/drawing/2014/main" id="{1AB891D2-BF18-4B6C-8B67-940EDD451A88}"/>
+                <a16:creationId xmlns:a16="http://schemas.microsoft.com/office/drawing/2014/main" id="{345A9A35-4F4E-44AD-BA18-CAED8DCE931C}"/>
               </a:ext>
             </a:extLst>
           </p:cNvPr>
@@ -12749,7 +12754,7 @@
           <p:cNvPr id="21" name="s7-bypass-v">
             <a:extLst xmlns:a="http://schemas.openxmlformats.org/drawingml/2006/main">
               <a:ext uri="{FF2B5EF4-FFF2-40B4-BE49-F238E27FC236}">
-                <a16:creationId xmlns:a16="http://schemas.microsoft.com/office/drawing/2014/main" id="{7BACDBA1-F4BD-4D6E-8753-D50772CC550D}"/>
+                <a16:creationId xmlns:a16="http://schemas.microsoft.com/office/drawing/2014/main" id="{913815EF-D96E-4199-A540-7BEC83219DBA}"/>
               </a:ext>
             </a:extLst>
           </p:cNvPr>
@@ -12794,7 +12799,7 @@
           <p:cNvPr id="22" name="s7-bypass-d">
             <a:extLst xmlns:a="http://schemas.openxmlformats.org/drawingml/2006/main">
               <a:ext uri="{FF2B5EF4-FFF2-40B4-BE49-F238E27FC236}">
-                <a16:creationId xmlns:a16="http://schemas.microsoft.com/office/drawing/2014/main" id="{3E694FC0-CD0B-4941-8E6A-84603A512E74}"/>
+                <a16:creationId xmlns:a16="http://schemas.microsoft.com/office/drawing/2014/main" id="{FA8DAA62-F5C4-49CA-9C04-3272EB9FC765}"/>
               </a:ext>
             </a:extLst>
           </p:cNvPr>
@@ -12839,7 +12844,7 @@
           <p:cNvPr id="23" name="s7-lite">
             <a:extLst xmlns:a="http://schemas.openxmlformats.org/drawingml/2006/main">
               <a:ext uri="{FF2B5EF4-FFF2-40B4-BE49-F238E27FC236}">
-                <a16:creationId xmlns:a16="http://schemas.microsoft.com/office/drawing/2014/main" id="{D0B31634-BA94-4520-A610-8E81B222A18B}"/>
+                <a16:creationId xmlns:a16="http://schemas.microsoft.com/office/drawing/2014/main" id="{213AEA87-2DBD-402B-BB0D-37FBD6A1C7C4}"/>
               </a:ext>
             </a:extLst>
           </p:cNvPr>
@@ -12874,7 +12879,7 @@
           <p:cNvPr id="24" name="s7-lite-k">
             <a:extLst xmlns:a="http://schemas.openxmlformats.org/drawingml/2006/main">
               <a:ext uri="{FF2B5EF4-FFF2-40B4-BE49-F238E27FC236}">
-                <a16:creationId xmlns:a16="http://schemas.microsoft.com/office/drawing/2014/main" id="{25DC19EC-01D6-4BC5-8C16-4746138D7DF5}"/>
+                <a16:creationId xmlns:a16="http://schemas.microsoft.com/office/drawing/2014/main" id="{782F47AA-D0F1-46B2-9BA0-E6440F092590}"/>
               </a:ext>
             </a:extLst>
           </p:cNvPr>
@@ -12919,7 +12924,7 @@
           <p:cNvPr id="25" name="s7-lite-v">
             <a:extLst xmlns:a="http://schemas.openxmlformats.org/drawingml/2006/main">
               <a:ext uri="{FF2B5EF4-FFF2-40B4-BE49-F238E27FC236}">
-                <a16:creationId xmlns:a16="http://schemas.microsoft.com/office/drawing/2014/main" id="{034531F7-1AA4-48B3-BD6D-5CC0C4D13DB9}"/>
+                <a16:creationId xmlns:a16="http://schemas.microsoft.com/office/drawing/2014/main" id="{583F3B78-8793-4258-BDA4-91EADCAAD4FF}"/>
               </a:ext>
             </a:extLst>
           </p:cNvPr>
@@ -12964,7 +12969,7 @@
           <p:cNvPr id="26" name="s7-lite-d">
             <a:extLst xmlns:a="http://schemas.openxmlformats.org/drawingml/2006/main">
               <a:ext uri="{FF2B5EF4-FFF2-40B4-BE49-F238E27FC236}">
-                <a16:creationId xmlns:a16="http://schemas.microsoft.com/office/drawing/2014/main" id="{94A9DA78-6F8B-46E8-9B80-F1913FCAC36F}"/>
+                <a16:creationId xmlns:a16="http://schemas.microsoft.com/office/drawing/2014/main" id="{3CA05505-EAA2-48E9-9A01-389676BE7BA0}"/>
               </a:ext>
             </a:extLst>
           </p:cNvPr>
@@ -13009,7 +13014,7 @@
           <p:cNvPr id="27" name="s7-full">
             <a:extLst xmlns:a="http://schemas.openxmlformats.org/drawingml/2006/main">
               <a:ext uri="{FF2B5EF4-FFF2-40B4-BE49-F238E27FC236}">
-                <a16:creationId xmlns:a16="http://schemas.microsoft.com/office/drawing/2014/main" id="{7E9F3C5B-D207-488E-B4F6-D228CC207DB7}"/>
+                <a16:creationId xmlns:a16="http://schemas.microsoft.com/office/drawing/2014/main" id="{2F93646B-FC6D-4A75-85E6-58CE0CA79719}"/>
               </a:ext>
             </a:extLst>
           </p:cNvPr>
@@ -13044,7 +13049,7 @@
           <p:cNvPr id="28" name="s7-full-k">
             <a:extLst xmlns:a="http://schemas.openxmlformats.org/drawingml/2006/main">
               <a:ext uri="{FF2B5EF4-FFF2-40B4-BE49-F238E27FC236}">
-                <a16:creationId xmlns:a16="http://schemas.microsoft.com/office/drawing/2014/main" id="{BED98981-BFBA-40AA-AD3C-898B704BE16F}"/>
+                <a16:creationId xmlns:a16="http://schemas.microsoft.com/office/drawing/2014/main" id="{B6E93BFA-A03F-4BA4-A7EA-44FF57CC3760}"/>
               </a:ext>
             </a:extLst>
           </p:cNvPr>
@@ -13089,7 +13094,7 @@
           <p:cNvPr id="29" name="s7-full-v">
             <a:extLst xmlns:a="http://schemas.openxmlformats.org/drawingml/2006/main">
               <a:ext uri="{FF2B5EF4-FFF2-40B4-BE49-F238E27FC236}">
-                <a16:creationId xmlns:a16="http://schemas.microsoft.com/office/drawing/2014/main" id="{BE5C2050-9879-45A7-8871-445AF12E4D03}"/>
+                <a16:creationId xmlns:a16="http://schemas.microsoft.com/office/drawing/2014/main" id="{14FED87E-185F-42CE-A692-0F77E1DE4EF5}"/>
               </a:ext>
             </a:extLst>
           </p:cNvPr>
@@ -13134,7 +13139,7 @@
           <p:cNvPr id="30" name="s7-full-d">
             <a:extLst xmlns:a="http://schemas.openxmlformats.org/drawingml/2006/main">
               <a:ext uri="{FF2B5EF4-FFF2-40B4-BE49-F238E27FC236}">
-                <a16:creationId xmlns:a16="http://schemas.microsoft.com/office/drawing/2014/main" id="{D7635D5A-5271-41CB-9BC7-9BBC5976C72F}"/>
+                <a16:creationId xmlns:a16="http://schemas.microsoft.com/office/drawing/2014/main" id="{5E0B461F-A94B-402F-84E6-E676B30B95C7}"/>
               </a:ext>
             </a:extLst>
           </p:cNvPr>
@@ -13179,7 +13184,7 @@
           <p:cNvPr id="31" name="s7-next">
             <a:extLst xmlns:a="http://schemas.openxmlformats.org/drawingml/2006/main">
               <a:ext uri="{FF2B5EF4-FFF2-40B4-BE49-F238E27FC236}">
-                <a16:creationId xmlns:a16="http://schemas.microsoft.com/office/drawing/2014/main" id="{51A3D722-6235-4A8C-8FC7-6DF7B2643FF6}"/>
+                <a16:creationId xmlns:a16="http://schemas.microsoft.com/office/drawing/2014/main" id="{64D25719-69DD-4861-94A4-E8433024FF31}"/>
               </a:ext>
             </a:extLst>
           </p:cNvPr>
@@ -13214,7 +13219,7 @@
           <p:cNvPr id="32" name="s7-next-k">
             <a:extLst xmlns:a="http://schemas.openxmlformats.org/drawingml/2006/main">
               <a:ext uri="{FF2B5EF4-FFF2-40B4-BE49-F238E27FC236}">
-                <a16:creationId xmlns:a16="http://schemas.microsoft.com/office/drawing/2014/main" id="{27774AB2-3B90-48A1-8061-3C3632A8A3CE}"/>
+                <a16:creationId xmlns:a16="http://schemas.microsoft.com/office/drawing/2014/main" id="{AC00580E-ECC8-4E60-BB82-4AC0286A9CB4}"/>
               </a:ext>
             </a:extLst>
           </p:cNvPr>
@@ -13259,7 +13264,7 @@
           <p:cNvPr id="33" name="s7-next-v">
             <a:extLst xmlns:a="http://schemas.openxmlformats.org/drawingml/2006/main">
               <a:ext uri="{FF2B5EF4-FFF2-40B4-BE49-F238E27FC236}">
-                <a16:creationId xmlns:a16="http://schemas.microsoft.com/office/drawing/2014/main" id="{F096F8B7-8A40-4CAC-9CE2-8349396438D1}"/>
+                <a16:creationId xmlns:a16="http://schemas.microsoft.com/office/drawing/2014/main" id="{FA7C2138-FEE9-4CF2-8B2A-A12EBDE03575}"/>
               </a:ext>
             </a:extLst>
           </p:cNvPr>
@@ -13326,7 +13331,7 @@
           <p:cNvPr id="35" name="footer-source-7">
             <a:extLst xmlns:a="http://schemas.openxmlformats.org/drawingml/2006/main">
               <a:ext uri="{FF2B5EF4-FFF2-40B4-BE49-F238E27FC236}">
-                <a16:creationId xmlns:a16="http://schemas.microsoft.com/office/drawing/2014/main" id="{869D515A-5D1D-454F-9335-8DD8DFFCC068}"/>
+                <a16:creationId xmlns:a16="http://schemas.microsoft.com/office/drawing/2014/main" id="{9CE9EAB9-EAFD-4315-A73C-D59E00A4A6E9}"/>
               </a:ext>
             </a:extLst>
           </p:cNvPr>
@@ -13361,7 +13366,7 @@
               </a:defRPr>
             </a:pPr>
             <a:r>
-              <a:t>Control result: supported tool-call overhead; Token and time intervals crossed zero | benchmark used synthetic repositories</a:t>
+              <a:t>Codex alone = no-Palace Control | Adaptive - Codex paired differences | synthetic repositories | Vertex Palace 0.2.1</a:t>
             </a:r>
           </a:p>
         </p:txBody>
@@ -13371,7 +13376,7 @@
           <p:cNvPr id="36" name="footer-number-7">
             <a:extLst xmlns:a="http://schemas.openxmlformats.org/drawingml/2006/main">
               <a:ext uri="{FF2B5EF4-FFF2-40B4-BE49-F238E27FC236}">
-                <a16:creationId xmlns:a16="http://schemas.microsoft.com/office/drawing/2014/main" id="{FCEC97E2-7B7B-40B5-B344-FDACF536EA16}"/>
+                <a16:creationId xmlns:a16="http://schemas.microsoft.com/office/drawing/2014/main" id="{BE54CB3A-DCFD-4F5C-8F6F-98D31C896653}"/>
               </a:ext>
             </a:extLst>
           </p:cNvPr>
@@ -13414,7 +13419,7 @@
     </p:spTree>
     <p:extLst>
       <p:ext uri="{BB962C8B-B14F-4D97-AF65-F5344CB8AC3E}">
-        <p14:creationId xmlns:p14="http://schemas.microsoft.com/office/powerpoint/2010/main" val="1643005700"/>
+        <p14:creationId xmlns:p14="http://schemas.microsoft.com/office/powerpoint/2010/main" val="475093376"/>
       </p:ext>
     </p:extLst>
   </p:cSld>
@@ -13445,7 +13450,7 @@
           <p:cNvPr id="48" name="s8-title-new">
             <a:extLst xmlns:a="http://schemas.openxmlformats.org/drawingml/2006/main">
               <a:ext uri="{FF2B5EF4-FFF2-40B4-BE49-F238E27FC236}">
-                <a16:creationId xmlns:a16="http://schemas.microsoft.com/office/drawing/2014/main" id="{3802844C-F306-4B2E-8477-1515D8611E7A}"/>
+                <a16:creationId xmlns:a16="http://schemas.microsoft.com/office/drawing/2014/main" id="{76F7BBE2-BF03-450F-A92D-4AA12DA4D892}"/>
               </a:ext>
             </a:extLst>
           </p:cNvPr>
@@ -13490,7 +13495,7 @@
           <p:cNvPr id="2" name="s8-subtitle-new">
             <a:extLst xmlns:a="http://schemas.openxmlformats.org/drawingml/2006/main">
               <a:ext uri="{FF2B5EF4-FFF2-40B4-BE49-F238E27FC236}">
-                <a16:creationId xmlns:a16="http://schemas.microsoft.com/office/drawing/2014/main" id="{44B5B586-AEA3-43E3-B3C9-24A7BD1B1C3E}"/>
+                <a16:creationId xmlns:a16="http://schemas.microsoft.com/office/drawing/2014/main" id="{F4B97F8C-A4AB-49A7-8A34-4D4EF380529E}"/>
               </a:ext>
             </a:extLst>
           </p:cNvPr>
@@ -13535,7 +13540,7 @@
           <p:cNvPr id="3" name="s8-negative-new">
             <a:extLst xmlns:a="http://schemas.openxmlformats.org/drawingml/2006/main">
               <a:ext uri="{FF2B5EF4-FFF2-40B4-BE49-F238E27FC236}">
-                <a16:creationId xmlns:a16="http://schemas.microsoft.com/office/drawing/2014/main" id="{3E5F40D5-9B41-4A69-B990-C13BA643696B}"/>
+                <a16:creationId xmlns:a16="http://schemas.microsoft.com/office/drawing/2014/main" id="{7077DC7F-D42E-453A-BF69-91B12744FA76}"/>
               </a:ext>
             </a:extLst>
           </p:cNvPr>
@@ -13580,7 +13585,7 @@
           <p:cNvPr id="4" name="s8-zero-new">
             <a:extLst xmlns:a="http://schemas.openxmlformats.org/drawingml/2006/main">
               <a:ext uri="{FF2B5EF4-FFF2-40B4-BE49-F238E27FC236}">
-                <a16:creationId xmlns:a16="http://schemas.microsoft.com/office/drawing/2014/main" id="{E0CF7841-6F7A-493E-8EF0-14CCA6651759}"/>
+                <a16:creationId xmlns:a16="http://schemas.microsoft.com/office/drawing/2014/main" id="{25A2B58F-7521-45F8-8E5B-994A3734A17C}"/>
               </a:ext>
             </a:extLst>
           </p:cNvPr>
@@ -13625,7 +13630,7 @@
           <p:cNvPr id="5" name="s8-positive-new">
             <a:extLst xmlns:a="http://schemas.openxmlformats.org/drawingml/2006/main">
               <a:ext uri="{FF2B5EF4-FFF2-40B4-BE49-F238E27FC236}">
-                <a16:creationId xmlns:a16="http://schemas.microsoft.com/office/drawing/2014/main" id="{06F1D704-DD20-483B-B7B5-468A1620942B}"/>
+                <a16:creationId xmlns:a16="http://schemas.microsoft.com/office/drawing/2014/main" id="{3599FDEA-5C27-436D-B8C2-ADD94170FFE0}"/>
               </a:ext>
             </a:extLst>
           </p:cNvPr>
@@ -13670,7 +13675,7 @@
           <p:cNvPr id="6" name="s8-bytes-new-panel">
             <a:extLst xmlns:a="http://schemas.openxmlformats.org/drawingml/2006/main">
               <a:ext uri="{FF2B5EF4-FFF2-40B4-BE49-F238E27FC236}">
-                <a16:creationId xmlns:a16="http://schemas.microsoft.com/office/drawing/2014/main" id="{DFE4ED78-7995-4E1A-9488-E8CD3E4A0585}"/>
+                <a16:creationId xmlns:a16="http://schemas.microsoft.com/office/drawing/2014/main" id="{DCC214B1-F4A1-4F45-9C1D-DFCB19EB1BB5}"/>
               </a:ext>
             </a:extLst>
           </p:cNvPr>
@@ -13705,7 +13710,7 @@
           <p:cNvPr id="7" name="s8-bytes-new-label">
             <a:extLst xmlns:a="http://schemas.openxmlformats.org/drawingml/2006/main">
               <a:ext uri="{FF2B5EF4-FFF2-40B4-BE49-F238E27FC236}">
-                <a16:creationId xmlns:a16="http://schemas.microsoft.com/office/drawing/2014/main" id="{8A76280D-E9A1-4188-9C47-36D7A6D790BD}"/>
+                <a16:creationId xmlns:a16="http://schemas.microsoft.com/office/drawing/2014/main" id="{5D40EDF8-FCE6-4741-AFA7-55755276F12F}"/>
               </a:ext>
             </a:extLst>
           </p:cNvPr>
@@ -13750,7 +13755,7 @@
           <p:cNvPr id="8" name="s8-bytes-new-value">
             <a:extLst xmlns:a="http://schemas.openxmlformats.org/drawingml/2006/main">
               <a:ext uri="{FF2B5EF4-FFF2-40B4-BE49-F238E27FC236}">
-                <a16:creationId xmlns:a16="http://schemas.microsoft.com/office/drawing/2014/main" id="{2A185273-38D1-4A25-AE14-73F7FF8866E2}"/>
+                <a16:creationId xmlns:a16="http://schemas.microsoft.com/office/drawing/2014/main" id="{60DEDFE2-4361-4EF7-917C-FE84B9F3B561}"/>
               </a:ext>
             </a:extLst>
           </p:cNvPr>
@@ -13795,7 +13800,7 @@
           <p:cNvPr id="9" name="s8-bytes-new-ci">
             <a:extLst xmlns:a="http://schemas.openxmlformats.org/drawingml/2006/main">
               <a:ext uri="{FF2B5EF4-FFF2-40B4-BE49-F238E27FC236}">
-                <a16:creationId xmlns:a16="http://schemas.microsoft.com/office/drawing/2014/main" id="{D3E6BD3C-AB0F-4E0F-B805-DEDE3FD6B379}"/>
+                <a16:creationId xmlns:a16="http://schemas.microsoft.com/office/drawing/2014/main" id="{8361C750-5844-4942-91D3-7CFE82A7EEB7}"/>
               </a:ext>
             </a:extLst>
           </p:cNvPr>
@@ -13884,7 +13889,7 @@
           <p:cNvPr id="12" name="s8-bytes-new-zero-label">
             <a:extLst xmlns:a="http://schemas.openxmlformats.org/drawingml/2006/main">
               <a:ext uri="{FF2B5EF4-FFF2-40B4-BE49-F238E27FC236}">
-                <a16:creationId xmlns:a16="http://schemas.microsoft.com/office/drawing/2014/main" id="{E0876B21-A2B7-41B3-992E-59634FAE1AB9}"/>
+                <a16:creationId xmlns:a16="http://schemas.microsoft.com/office/drawing/2014/main" id="{21318D3F-7E81-4210-ACCF-4B221D1A44F3}"/>
               </a:ext>
             </a:extLst>
           </p:cNvPr>
@@ -13995,7 +14000,7 @@
           <p:cNvPr id="16" name="s8-bytes-new-median">
             <a:extLst xmlns:a="http://schemas.openxmlformats.org/drawingml/2006/main">
               <a:ext uri="{FF2B5EF4-FFF2-40B4-BE49-F238E27FC236}">
-                <a16:creationId xmlns:a16="http://schemas.microsoft.com/office/drawing/2014/main" id="{96683643-F349-4AEC-9772-119C685E4EBD}"/>
+                <a16:creationId xmlns:a16="http://schemas.microsoft.com/office/drawing/2014/main" id="{CA9EB7AD-8C98-451B-9E8E-DA58B9CAB6ED}"/>
               </a:ext>
             </a:extLst>
           </p:cNvPr>
@@ -14028,7 +14033,7 @@
           <p:cNvPr id="17" name="s8-bytes-new-status">
             <a:extLst xmlns:a="http://schemas.openxmlformats.org/drawingml/2006/main">
               <a:ext uri="{FF2B5EF4-FFF2-40B4-BE49-F238E27FC236}">
-                <a16:creationId xmlns:a16="http://schemas.microsoft.com/office/drawing/2014/main" id="{84ED7540-95AA-4774-8356-34851149F8B6}"/>
+                <a16:creationId xmlns:a16="http://schemas.microsoft.com/office/drawing/2014/main" id="{196EB9FA-0D3D-43CA-81C0-FE9C00D47312}"/>
               </a:ext>
             </a:extLst>
           </p:cNvPr>
@@ -14073,7 +14078,7 @@
           <p:cNvPr id="18" name="s8-bytes-new-interpretation">
             <a:extLst xmlns:a="http://schemas.openxmlformats.org/drawingml/2006/main">
               <a:ext uri="{FF2B5EF4-FFF2-40B4-BE49-F238E27FC236}">
-                <a16:creationId xmlns:a16="http://schemas.microsoft.com/office/drawing/2014/main" id="{BA44842E-ACE6-4482-9CE8-3F6385FA013A}"/>
+                <a16:creationId xmlns:a16="http://schemas.microsoft.com/office/drawing/2014/main" id="{C30A3B4E-C00D-4BAB-A85A-48353A004EAA}"/>
               </a:ext>
             </a:extLst>
           </p:cNvPr>
@@ -14118,7 +14123,7 @@
           <p:cNvPr id="19" name="s8-tokens-new-panel">
             <a:extLst xmlns:a="http://schemas.openxmlformats.org/drawingml/2006/main">
               <a:ext uri="{FF2B5EF4-FFF2-40B4-BE49-F238E27FC236}">
-                <a16:creationId xmlns:a16="http://schemas.microsoft.com/office/drawing/2014/main" id="{D996115E-A2E9-4C8E-A0BD-5AE4362EA43B}"/>
+                <a16:creationId xmlns:a16="http://schemas.microsoft.com/office/drawing/2014/main" id="{2806BD2C-7707-4D48-B2FC-9173C5BB2351}"/>
               </a:ext>
             </a:extLst>
           </p:cNvPr>
@@ -14153,7 +14158,7 @@
           <p:cNvPr id="20" name="s8-tokens-new-label">
             <a:extLst xmlns:a="http://schemas.openxmlformats.org/drawingml/2006/main">
               <a:ext uri="{FF2B5EF4-FFF2-40B4-BE49-F238E27FC236}">
-                <a16:creationId xmlns:a16="http://schemas.microsoft.com/office/drawing/2014/main" id="{0EFF5D4E-E430-4AAA-9A7C-069D2A29BAC8}"/>
+                <a16:creationId xmlns:a16="http://schemas.microsoft.com/office/drawing/2014/main" id="{B2640170-0707-4E73-8E54-E8FF6BFB60F0}"/>
               </a:ext>
             </a:extLst>
           </p:cNvPr>
@@ -14198,7 +14203,7 @@
           <p:cNvPr id="21" name="s8-tokens-new-value">
             <a:extLst xmlns:a="http://schemas.openxmlformats.org/drawingml/2006/main">
               <a:ext uri="{FF2B5EF4-FFF2-40B4-BE49-F238E27FC236}">
-                <a16:creationId xmlns:a16="http://schemas.microsoft.com/office/drawing/2014/main" id="{B4CF726D-C82C-4E01-9179-5D6E0285C6D8}"/>
+                <a16:creationId xmlns:a16="http://schemas.microsoft.com/office/drawing/2014/main" id="{6DF68FEF-6AAF-4E8A-A494-0831D58387BE}"/>
               </a:ext>
             </a:extLst>
           </p:cNvPr>
@@ -14243,7 +14248,7 @@
           <p:cNvPr id="22" name="s8-tokens-new-ci">
             <a:extLst xmlns:a="http://schemas.openxmlformats.org/drawingml/2006/main">
               <a:ext uri="{FF2B5EF4-FFF2-40B4-BE49-F238E27FC236}">
-                <a16:creationId xmlns:a16="http://schemas.microsoft.com/office/drawing/2014/main" id="{5CE62B2A-6285-4AE8-AF9E-0EA15A836888}"/>
+                <a16:creationId xmlns:a16="http://schemas.microsoft.com/office/drawing/2014/main" id="{82EAF919-D40E-4C6F-9784-E89013264179}"/>
               </a:ext>
             </a:extLst>
           </p:cNvPr>
@@ -14332,7 +14337,7 @@
           <p:cNvPr id="25" name="s8-tokens-new-zero-label">
             <a:extLst xmlns:a="http://schemas.openxmlformats.org/drawingml/2006/main">
               <a:ext uri="{FF2B5EF4-FFF2-40B4-BE49-F238E27FC236}">
-                <a16:creationId xmlns:a16="http://schemas.microsoft.com/office/drawing/2014/main" id="{E0279A17-5B32-496E-B6BB-44BAA3BDFEC1}"/>
+                <a16:creationId xmlns:a16="http://schemas.microsoft.com/office/drawing/2014/main" id="{39BB2021-44EE-49D5-B884-8AAA32DD15D5}"/>
               </a:ext>
             </a:extLst>
           </p:cNvPr>
@@ -14443,7 +14448,7 @@
           <p:cNvPr id="29" name="s8-tokens-new-median">
             <a:extLst xmlns:a="http://schemas.openxmlformats.org/drawingml/2006/main">
               <a:ext uri="{FF2B5EF4-FFF2-40B4-BE49-F238E27FC236}">
-                <a16:creationId xmlns:a16="http://schemas.microsoft.com/office/drawing/2014/main" id="{3E0785BF-BBE3-4770-8912-526D0C92D35E}"/>
+                <a16:creationId xmlns:a16="http://schemas.microsoft.com/office/drawing/2014/main" id="{F58D5FC7-2399-42A8-972D-F8FA1BC3C156}"/>
               </a:ext>
             </a:extLst>
           </p:cNvPr>
@@ -14476,7 +14481,7 @@
           <p:cNvPr id="30" name="s8-tokens-new-status">
             <a:extLst xmlns:a="http://schemas.openxmlformats.org/drawingml/2006/main">
               <a:ext uri="{FF2B5EF4-FFF2-40B4-BE49-F238E27FC236}">
-                <a16:creationId xmlns:a16="http://schemas.microsoft.com/office/drawing/2014/main" id="{2E152CCD-71EF-4639-9DED-39E519847F95}"/>
+                <a16:creationId xmlns:a16="http://schemas.microsoft.com/office/drawing/2014/main" id="{C6D0C5D7-48F2-4391-A4BB-1A23C9A33EFF}"/>
               </a:ext>
             </a:extLst>
           </p:cNvPr>
@@ -14521,7 +14526,7 @@
           <p:cNvPr id="31" name="s8-tokens-new-interpretation">
             <a:extLst xmlns:a="http://schemas.openxmlformats.org/drawingml/2006/main">
               <a:ext uri="{FF2B5EF4-FFF2-40B4-BE49-F238E27FC236}">
-                <a16:creationId xmlns:a16="http://schemas.microsoft.com/office/drawing/2014/main" id="{8C7860D7-F64B-4D54-A0F4-66376472B222}"/>
+                <a16:creationId xmlns:a16="http://schemas.microsoft.com/office/drawing/2014/main" id="{4E98FFD5-9E79-499C-824C-0D1EC20F37A4}"/>
               </a:ext>
             </a:extLst>
           </p:cNvPr>
@@ -14566,7 +14571,7 @@
           <p:cNvPr id="32" name="s8-time-new-panel">
             <a:extLst xmlns:a="http://schemas.openxmlformats.org/drawingml/2006/main">
               <a:ext uri="{FF2B5EF4-FFF2-40B4-BE49-F238E27FC236}">
-                <a16:creationId xmlns:a16="http://schemas.microsoft.com/office/drawing/2014/main" id="{AC08FD9B-1DFC-433C-B804-BA1411893A89}"/>
+                <a16:creationId xmlns:a16="http://schemas.microsoft.com/office/drawing/2014/main" id="{B6B49C10-9900-45A4-9CC8-5EB3AB1C9482}"/>
               </a:ext>
             </a:extLst>
           </p:cNvPr>
@@ -14601,7 +14606,7 @@
           <p:cNvPr id="33" name="s8-time-new-label">
             <a:extLst xmlns:a="http://schemas.openxmlformats.org/drawingml/2006/main">
               <a:ext uri="{FF2B5EF4-FFF2-40B4-BE49-F238E27FC236}">
-                <a16:creationId xmlns:a16="http://schemas.microsoft.com/office/drawing/2014/main" id="{E37D0F54-0F7A-459D-9896-86A4F92D6A76}"/>
+                <a16:creationId xmlns:a16="http://schemas.microsoft.com/office/drawing/2014/main" id="{82C22E32-266D-4443-AE36-1428FE033032}"/>
               </a:ext>
             </a:extLst>
           </p:cNvPr>
@@ -14646,7 +14651,7 @@
           <p:cNvPr id="34" name="s8-time-new-value">
             <a:extLst xmlns:a="http://schemas.openxmlformats.org/drawingml/2006/main">
               <a:ext uri="{FF2B5EF4-FFF2-40B4-BE49-F238E27FC236}">
-                <a16:creationId xmlns:a16="http://schemas.microsoft.com/office/drawing/2014/main" id="{5C14187E-0B92-4A01-B033-62FAE4DD9CBF}"/>
+                <a16:creationId xmlns:a16="http://schemas.microsoft.com/office/drawing/2014/main" id="{3451CE16-CC1F-4133-B876-C7D02832AD76}"/>
               </a:ext>
             </a:extLst>
           </p:cNvPr>
@@ -14691,7 +14696,7 @@
           <p:cNvPr id="35" name="s8-time-new-ci">
             <a:extLst xmlns:a="http://schemas.openxmlformats.org/drawingml/2006/main">
               <a:ext uri="{FF2B5EF4-FFF2-40B4-BE49-F238E27FC236}">
-                <a16:creationId xmlns:a16="http://schemas.microsoft.com/office/drawing/2014/main" id="{BD97211B-3DC8-4AD0-A551-6B490A017680}"/>
+                <a16:creationId xmlns:a16="http://schemas.microsoft.com/office/drawing/2014/main" id="{AEC96845-2161-4CE3-B51F-DF7CBF8E30A8}"/>
               </a:ext>
             </a:extLst>
           </p:cNvPr>
@@ -14780,7 +14785,7 @@
           <p:cNvPr id="38" name="s8-time-new-zero-label">
             <a:extLst xmlns:a="http://schemas.openxmlformats.org/drawingml/2006/main">
               <a:ext uri="{FF2B5EF4-FFF2-40B4-BE49-F238E27FC236}">
-                <a16:creationId xmlns:a16="http://schemas.microsoft.com/office/drawing/2014/main" id="{1C4DF709-0475-47C7-BCA3-C4D1D995B25B}"/>
+                <a16:creationId xmlns:a16="http://schemas.microsoft.com/office/drawing/2014/main" id="{E39E8215-79B3-4DE5-B865-2E68746F0179}"/>
               </a:ext>
             </a:extLst>
           </p:cNvPr>
@@ -14891,7 +14896,7 @@
           <p:cNvPr id="42" name="s8-time-new-median">
             <a:extLst xmlns:a="http://schemas.openxmlformats.org/drawingml/2006/main">
               <a:ext uri="{FF2B5EF4-FFF2-40B4-BE49-F238E27FC236}">
-                <a16:creationId xmlns:a16="http://schemas.microsoft.com/office/drawing/2014/main" id="{BC239EC9-9BD1-4756-A083-C8823CCEBE4D}"/>
+                <a16:creationId xmlns:a16="http://schemas.microsoft.com/office/drawing/2014/main" id="{62F149C3-0C9A-48C2-95CB-BFF34A5C9EC8}"/>
               </a:ext>
             </a:extLst>
           </p:cNvPr>
@@ -14924,7 +14929,7 @@
           <p:cNvPr id="43" name="s8-time-new-status">
             <a:extLst xmlns:a="http://schemas.openxmlformats.org/drawingml/2006/main">
               <a:ext uri="{FF2B5EF4-FFF2-40B4-BE49-F238E27FC236}">
-                <a16:creationId xmlns:a16="http://schemas.microsoft.com/office/drawing/2014/main" id="{44467451-1748-45E2-A5C9-E0DACD96D83D}"/>
+                <a16:creationId xmlns:a16="http://schemas.microsoft.com/office/drawing/2014/main" id="{0DBEDC84-19C2-43F0-90C2-B5D39B0C0B7F}"/>
               </a:ext>
             </a:extLst>
           </p:cNvPr>
@@ -14969,7 +14974,7 @@
           <p:cNvPr id="44" name="s8-time-new-interpretation">
             <a:extLst xmlns:a="http://schemas.openxmlformats.org/drawingml/2006/main">
               <a:ext uri="{FF2B5EF4-FFF2-40B4-BE49-F238E27FC236}">
-                <a16:creationId xmlns:a16="http://schemas.microsoft.com/office/drawing/2014/main" id="{12F0BFE2-F003-4533-9B36-F3D7EC4AF8B8}"/>
+                <a16:creationId xmlns:a16="http://schemas.microsoft.com/office/drawing/2014/main" id="{32B6CC1F-A56E-4564-B668-BD48C6B1F06C}"/>
               </a:ext>
             </a:extLst>
           </p:cNvPr>
@@ -15036,7 +15041,7 @@
           <p:cNvPr id="46" name="footer-source-8">
             <a:extLst xmlns:a="http://schemas.openxmlformats.org/drawingml/2006/main">
               <a:ext uri="{FF2B5EF4-FFF2-40B4-BE49-F238E27FC236}">
-                <a16:creationId xmlns:a16="http://schemas.microsoft.com/office/drawing/2014/main" id="{285FFE47-0766-4299-9254-B39F6541F250}"/>
+                <a16:creationId xmlns:a16="http://schemas.microsoft.com/office/drawing/2014/main" id="{625A131B-2A89-45AF-B9D2-68599CE6AFC0}"/>
               </a:ext>
             </a:extLst>
           </p:cNvPr>
@@ -15081,7 +15086,7 @@
           <p:cNvPr id="47" name="footer-number-8">
             <a:extLst xmlns:a="http://schemas.openxmlformats.org/drawingml/2006/main">
               <a:ext uri="{FF2B5EF4-FFF2-40B4-BE49-F238E27FC236}">
-                <a16:creationId xmlns:a16="http://schemas.microsoft.com/office/drawing/2014/main" id="{5C550171-F99C-4908-887B-A35E541AD5AE}"/>
+                <a16:creationId xmlns:a16="http://schemas.microsoft.com/office/drawing/2014/main" id="{72054452-7012-4728-84BC-AEDFF76369F4}"/>
               </a:ext>
             </a:extLst>
           </p:cNvPr>
@@ -15124,7 +15129,7 @@
     </p:spTree>
     <p:extLst>
       <p:ext uri="{BB962C8B-B14F-4D97-AF65-F5344CB8AC3E}">
-        <p14:creationId xmlns:p14="http://schemas.microsoft.com/office/powerpoint/2010/main" val="1119215672"/>
+        <p14:creationId xmlns:p14="http://schemas.microsoft.com/office/powerpoint/2010/main" val="2035780384"/>
       </p:ext>
     </p:extLst>
   </p:cSld>
@@ -15155,7 +15160,7 @@
           <p:cNvPr id="33" name="s9-title">
             <a:extLst xmlns:a="http://schemas.openxmlformats.org/drawingml/2006/main">
               <a:ext uri="{FF2B5EF4-FFF2-40B4-BE49-F238E27FC236}">
-                <a16:creationId xmlns:a16="http://schemas.microsoft.com/office/drawing/2014/main" id="{8507B362-E400-4F53-BDFD-96469BC15E1D}"/>
+                <a16:creationId xmlns:a16="http://schemas.microsoft.com/office/drawing/2014/main" id="{A8AA6248-73FF-446E-B232-B82007E291E0}"/>
               </a:ext>
             </a:extLst>
           </p:cNvPr>
@@ -15200,7 +15205,7 @@
           <p:cNvPr id="2" name="s9-subtitle">
             <a:extLst xmlns:a="http://schemas.openxmlformats.org/drawingml/2006/main">
               <a:ext uri="{FF2B5EF4-FFF2-40B4-BE49-F238E27FC236}">
-                <a16:creationId xmlns:a16="http://schemas.microsoft.com/office/drawing/2014/main" id="{DC68917B-BCA6-4BF1-A0A0-994AFDC340DA}"/>
+                <a16:creationId xmlns:a16="http://schemas.microsoft.com/office/drawing/2014/main" id="{33B94E14-7731-4155-BC42-D83A290850B0}"/>
               </a:ext>
             </a:extLst>
           </p:cNvPr>
@@ -15245,7 +15250,7 @@
           <p:cNvPr id="3" name="s9-gate-h">
             <a:extLst xmlns:a="http://schemas.openxmlformats.org/drawingml/2006/main">
               <a:ext uri="{FF2B5EF4-FFF2-40B4-BE49-F238E27FC236}">
-                <a16:creationId xmlns:a16="http://schemas.microsoft.com/office/drawing/2014/main" id="{87EB7870-1C1E-4226-99D8-B949524662AF}"/>
+                <a16:creationId xmlns:a16="http://schemas.microsoft.com/office/drawing/2014/main" id="{6D572F37-3737-4219-86C7-42C9E6714544}"/>
               </a:ext>
             </a:extLst>
           </p:cNvPr>
@@ -15290,7 +15295,7 @@
           <p:cNvPr id="4" name="s9-result-h">
             <a:extLst xmlns:a="http://schemas.openxmlformats.org/drawingml/2006/main">
               <a:ext uri="{FF2B5EF4-FFF2-40B4-BE49-F238E27FC236}">
-                <a16:creationId xmlns:a16="http://schemas.microsoft.com/office/drawing/2014/main" id="{E7F0CC50-27A8-45C7-9FF2-C0243D0C757A}"/>
+                <a16:creationId xmlns:a16="http://schemas.microsoft.com/office/drawing/2014/main" id="{557B2A54-5B53-4E38-B19A-DC7E3F8C8D58}"/>
               </a:ext>
             </a:extLst>
           </p:cNvPr>
@@ -15335,7 +15340,7 @@
           <p:cNvPr id="5" name="s9-row1">
             <a:extLst xmlns:a="http://schemas.openxmlformats.org/drawingml/2006/main">
               <a:ext uri="{FF2B5EF4-FFF2-40B4-BE49-F238E27FC236}">
-                <a16:creationId xmlns:a16="http://schemas.microsoft.com/office/drawing/2014/main" id="{BB7CA60E-7A7D-48DA-875C-A6D3040EE74A}"/>
+                <a16:creationId xmlns:a16="http://schemas.microsoft.com/office/drawing/2014/main" id="{1DF79D29-399A-4E27-9006-5F0559684CC3}"/>
               </a:ext>
             </a:extLst>
           </p:cNvPr>
@@ -15370,7 +15375,7 @@
           <p:cNvPr id="6" name="s9-row2">
             <a:extLst xmlns:a="http://schemas.openxmlformats.org/drawingml/2006/main">
               <a:ext uri="{FF2B5EF4-FFF2-40B4-BE49-F238E27FC236}">
-                <a16:creationId xmlns:a16="http://schemas.microsoft.com/office/drawing/2014/main" id="{1A3C9F18-DFCB-44B9-B4BE-5933DC3EDB53}"/>
+                <a16:creationId xmlns:a16="http://schemas.microsoft.com/office/drawing/2014/main" id="{CD212BB6-ED32-4958-B579-2E660AB398E3}"/>
               </a:ext>
             </a:extLst>
           </p:cNvPr>
@@ -15405,7 +15410,7 @@
           <p:cNvPr id="7" name="s9-row3">
             <a:extLst xmlns:a="http://schemas.openxmlformats.org/drawingml/2006/main">
               <a:ext uri="{FF2B5EF4-FFF2-40B4-BE49-F238E27FC236}">
-                <a16:creationId xmlns:a16="http://schemas.microsoft.com/office/drawing/2014/main" id="{4D4A9B8B-87AC-41FE-94A7-3CE97C277B02}"/>
+                <a16:creationId xmlns:a16="http://schemas.microsoft.com/office/drawing/2014/main" id="{6A8184AA-F492-4017-A6CF-73F498BA1BE1}"/>
               </a:ext>
             </a:extLst>
           </p:cNvPr>
@@ -15440,7 +15445,7 @@
           <p:cNvPr id="8" name="s9-row4">
             <a:extLst xmlns:a="http://schemas.openxmlformats.org/drawingml/2006/main">
               <a:ext uri="{FF2B5EF4-FFF2-40B4-BE49-F238E27FC236}">
-                <a16:creationId xmlns:a16="http://schemas.microsoft.com/office/drawing/2014/main" id="{A8A5F3D7-9BC5-4866-8118-7E5DA63BF74B}"/>
+                <a16:creationId xmlns:a16="http://schemas.microsoft.com/office/drawing/2014/main" id="{3A79A84B-2300-4965-88A1-A987E217F9F7}"/>
               </a:ext>
             </a:extLst>
           </p:cNvPr>
@@ -15475,7 +15480,7 @@
           <p:cNvPr id="9" name="s9-row5">
             <a:extLst xmlns:a="http://schemas.openxmlformats.org/drawingml/2006/main">
               <a:ext uri="{FF2B5EF4-FFF2-40B4-BE49-F238E27FC236}">
-                <a16:creationId xmlns:a16="http://schemas.microsoft.com/office/drawing/2014/main" id="{4C4A5A5D-3B52-4BB9-AE11-73AF8F319857}"/>
+                <a16:creationId xmlns:a16="http://schemas.microsoft.com/office/drawing/2014/main" id="{DD4EBD7C-9077-41FD-A142-B7247FAC1E23}"/>
               </a:ext>
             </a:extLst>
           </p:cNvPr>
@@ -15510,7 +15515,7 @@
           <p:cNvPr id="10" name="s9-row1-k">
             <a:extLst xmlns:a="http://schemas.openxmlformats.org/drawingml/2006/main">
               <a:ext uri="{FF2B5EF4-FFF2-40B4-BE49-F238E27FC236}">
-                <a16:creationId xmlns:a16="http://schemas.microsoft.com/office/drawing/2014/main" id="{6CC3C8CD-A1F6-4FA6-8B80-48FD6B24FF19}"/>
+                <a16:creationId xmlns:a16="http://schemas.microsoft.com/office/drawing/2014/main" id="{1E57BA0E-ACBD-40A4-BB20-81D5B9016ECA}"/>
               </a:ext>
             </a:extLst>
           </p:cNvPr>
@@ -15555,7 +15560,7 @@
           <p:cNvPr id="11" name="s9-row1-v">
             <a:extLst xmlns:a="http://schemas.openxmlformats.org/drawingml/2006/main">
               <a:ext uri="{FF2B5EF4-FFF2-40B4-BE49-F238E27FC236}">
-                <a16:creationId xmlns:a16="http://schemas.microsoft.com/office/drawing/2014/main" id="{6780D2EA-25AB-4691-A31A-6B7611818B11}"/>
+                <a16:creationId xmlns:a16="http://schemas.microsoft.com/office/drawing/2014/main" id="{0262DA5B-F39A-4505-A672-147D47B17F7B}"/>
               </a:ext>
             </a:extLst>
           </p:cNvPr>
@@ -15600,7 +15605,7 @@
           <p:cNvPr id="12" name="s9-row2-k">
             <a:extLst xmlns:a="http://schemas.openxmlformats.org/drawingml/2006/main">
               <a:ext uri="{FF2B5EF4-FFF2-40B4-BE49-F238E27FC236}">
-                <a16:creationId xmlns:a16="http://schemas.microsoft.com/office/drawing/2014/main" id="{04900EFB-217D-43EA-9EDC-932B20DFFB3F}"/>
+                <a16:creationId xmlns:a16="http://schemas.microsoft.com/office/drawing/2014/main" id="{DF14AA88-147E-41D4-AD01-DA95EADE2292}"/>
               </a:ext>
             </a:extLst>
           </p:cNvPr>
@@ -15645,7 +15650,7 @@
           <p:cNvPr id="13" name="s9-row2-v">
             <a:extLst xmlns:a="http://schemas.openxmlformats.org/drawingml/2006/main">
               <a:ext uri="{FF2B5EF4-FFF2-40B4-BE49-F238E27FC236}">
-                <a16:creationId xmlns:a16="http://schemas.microsoft.com/office/drawing/2014/main" id="{63A4F8A9-E596-4D61-815F-E3DF62964E92}"/>
+                <a16:creationId xmlns:a16="http://schemas.microsoft.com/office/drawing/2014/main" id="{EB7DF7FC-3446-41EB-9E52-2732AD25E7E0}"/>
               </a:ext>
             </a:extLst>
           </p:cNvPr>
@@ -15690,7 +15695,7 @@
           <p:cNvPr id="14" name="s9-row3-k">
             <a:extLst xmlns:a="http://schemas.openxmlformats.org/drawingml/2006/main">
               <a:ext uri="{FF2B5EF4-FFF2-40B4-BE49-F238E27FC236}">
-                <a16:creationId xmlns:a16="http://schemas.microsoft.com/office/drawing/2014/main" id="{2398B0AF-BC1F-4DD9-B6F0-1C9116524A59}"/>
+                <a16:creationId xmlns:a16="http://schemas.microsoft.com/office/drawing/2014/main" id="{A86D27F8-71F8-4AF1-8427-99283B761A48}"/>
               </a:ext>
             </a:extLst>
           </p:cNvPr>
@@ -15735,7 +15740,7 @@
           <p:cNvPr id="15" name="s9-row3-v">
             <a:extLst xmlns:a="http://schemas.openxmlformats.org/drawingml/2006/main">
               <a:ext uri="{FF2B5EF4-FFF2-40B4-BE49-F238E27FC236}">
-                <a16:creationId xmlns:a16="http://schemas.microsoft.com/office/drawing/2014/main" id="{C77CA989-CEDC-4BC0-B054-0381DA8FE446}"/>
+                <a16:creationId xmlns:a16="http://schemas.microsoft.com/office/drawing/2014/main" id="{B8BC9B20-75A6-4FA5-991A-C0843074D862}"/>
               </a:ext>
             </a:extLst>
           </p:cNvPr>
@@ -15780,7 +15785,7 @@
           <p:cNvPr id="16" name="s9-row4-k">
             <a:extLst xmlns:a="http://schemas.openxmlformats.org/drawingml/2006/main">
               <a:ext uri="{FF2B5EF4-FFF2-40B4-BE49-F238E27FC236}">
-                <a16:creationId xmlns:a16="http://schemas.microsoft.com/office/drawing/2014/main" id="{B59ADD52-2BD4-48CB-98FC-CC9663C79FBE}"/>
+                <a16:creationId xmlns:a16="http://schemas.microsoft.com/office/drawing/2014/main" id="{C7F2395F-6192-4AA9-A154-6EA9381C46DA}"/>
               </a:ext>
             </a:extLst>
           </p:cNvPr>
@@ -15825,7 +15830,7 @@
           <p:cNvPr id="17" name="s9-row4-v">
             <a:extLst xmlns:a="http://schemas.openxmlformats.org/drawingml/2006/main">
               <a:ext uri="{FF2B5EF4-FFF2-40B4-BE49-F238E27FC236}">
-                <a16:creationId xmlns:a16="http://schemas.microsoft.com/office/drawing/2014/main" id="{70C2E06F-3F88-4156-837F-623A0987E780}"/>
+                <a16:creationId xmlns:a16="http://schemas.microsoft.com/office/drawing/2014/main" id="{75410D81-76EE-4741-B040-D182D6210E9F}"/>
               </a:ext>
             </a:extLst>
           </p:cNvPr>
@@ -15870,7 +15875,7 @@
           <p:cNvPr id="18" name="s9-row5-k">
             <a:extLst xmlns:a="http://schemas.openxmlformats.org/drawingml/2006/main">
               <a:ext uri="{FF2B5EF4-FFF2-40B4-BE49-F238E27FC236}">
-                <a16:creationId xmlns:a16="http://schemas.microsoft.com/office/drawing/2014/main" id="{D9C8C48B-6DEA-4B89-A45C-C2BCCA9A6F41}"/>
+                <a16:creationId xmlns:a16="http://schemas.microsoft.com/office/drawing/2014/main" id="{E2545CBC-70B9-4AAE-8C9C-77C93BFFA504}"/>
               </a:ext>
             </a:extLst>
           </p:cNvPr>
@@ -15915,7 +15920,7 @@
           <p:cNvPr id="19" name="s9-row5-v">
             <a:extLst xmlns:a="http://schemas.openxmlformats.org/drawingml/2006/main">
               <a:ext uri="{FF2B5EF4-FFF2-40B4-BE49-F238E27FC236}">
-                <a16:creationId xmlns:a16="http://schemas.microsoft.com/office/drawing/2014/main" id="{B3381B8B-A695-487C-9C73-9BCF183D7629}"/>
+                <a16:creationId xmlns:a16="http://schemas.microsoft.com/office/drawing/2014/main" id="{B012CA16-48EF-4468-BE4A-C9E2527F085A}"/>
               </a:ext>
             </a:extLst>
           </p:cNvPr>
@@ -15960,7 +15965,7 @@
           <p:cNvPr id="20" name="s9-boundary">
             <a:extLst xmlns:a="http://schemas.openxmlformats.org/drawingml/2006/main">
               <a:ext uri="{FF2B5EF4-FFF2-40B4-BE49-F238E27FC236}">
-                <a16:creationId xmlns:a16="http://schemas.microsoft.com/office/drawing/2014/main" id="{7B11D2F0-2395-48D9-8761-BE95232265BF}"/>
+                <a16:creationId xmlns:a16="http://schemas.microsoft.com/office/drawing/2014/main" id="{A212F8D6-763B-4BAE-A865-6186847DB3E2}"/>
               </a:ext>
             </a:extLst>
           </p:cNvPr>
@@ -15995,7 +16000,7 @@
           <p:cNvPr id="21" name="s9-boundary-k">
             <a:extLst xmlns:a="http://schemas.openxmlformats.org/drawingml/2006/main">
               <a:ext uri="{FF2B5EF4-FFF2-40B4-BE49-F238E27FC236}">
-                <a16:creationId xmlns:a16="http://schemas.microsoft.com/office/drawing/2014/main" id="{E8C62ADF-5456-42DB-88E8-530CAF50136F}"/>
+                <a16:creationId xmlns:a16="http://schemas.microsoft.com/office/drawing/2014/main" id="{DD56A70B-F075-4BE3-9178-044C294DB9D6}"/>
               </a:ext>
             </a:extLst>
           </p:cNvPr>
@@ -16040,7 +16045,7 @@
           <p:cNvPr id="22" name="s9-boundary-stat">
             <a:extLst xmlns:a="http://schemas.openxmlformats.org/drawingml/2006/main">
               <a:ext uri="{FF2B5EF4-FFF2-40B4-BE49-F238E27FC236}">
-                <a16:creationId xmlns:a16="http://schemas.microsoft.com/office/drawing/2014/main" id="{44E4B0CC-CCEF-4B97-A3AB-6E4C30E376C6}"/>
+                <a16:creationId xmlns:a16="http://schemas.microsoft.com/office/drawing/2014/main" id="{05FC6448-9571-4E78-BCD7-869D434BA282}"/>
               </a:ext>
             </a:extLst>
           </p:cNvPr>
@@ -16085,7 +16090,7 @@
           <p:cNvPr id="23" name="s9-boundary-label">
             <a:extLst xmlns:a="http://schemas.openxmlformats.org/drawingml/2006/main">
               <a:ext uri="{FF2B5EF4-FFF2-40B4-BE49-F238E27FC236}">
-                <a16:creationId xmlns:a16="http://schemas.microsoft.com/office/drawing/2014/main" id="{67EC59DF-C884-41AC-BD45-6A51CA96ACAA}"/>
+                <a16:creationId xmlns:a16="http://schemas.microsoft.com/office/drawing/2014/main" id="{C85F6E0A-1470-4A54-B67A-F9A102680442}"/>
               </a:ext>
             </a:extLst>
           </p:cNvPr>
@@ -16152,7 +16157,7 @@
           <p:cNvPr id="25" name="s9-supported-k">
             <a:extLst xmlns:a="http://schemas.openxmlformats.org/drawingml/2006/main">
               <a:ext uri="{FF2B5EF4-FFF2-40B4-BE49-F238E27FC236}">
-                <a16:creationId xmlns:a16="http://schemas.microsoft.com/office/drawing/2014/main" id="{AD62BDE3-91D4-4EBB-B124-581F5AA8DDFA}"/>
+                <a16:creationId xmlns:a16="http://schemas.microsoft.com/office/drawing/2014/main" id="{9EB1285A-A8E4-4339-8FF5-A99425507B16}"/>
               </a:ext>
             </a:extLst>
           </p:cNvPr>
@@ -16197,7 +16202,7 @@
           <p:cNvPr id="26" name="s9-supported-v">
             <a:extLst xmlns:a="http://schemas.openxmlformats.org/drawingml/2006/main">
               <a:ext uri="{FF2B5EF4-FFF2-40B4-BE49-F238E27FC236}">
-                <a16:creationId xmlns:a16="http://schemas.microsoft.com/office/drawing/2014/main" id="{C98DC62F-32D3-4A88-9834-AC1A3A7314C2}"/>
+                <a16:creationId xmlns:a16="http://schemas.microsoft.com/office/drawing/2014/main" id="{B566BF6A-030E-4971-8375-0D76DAC1E763}"/>
               </a:ext>
             </a:extLst>
           </p:cNvPr>
@@ -16242,7 +16247,7 @@
           <p:cNvPr id="27" name="s9-limit-k">
             <a:extLst xmlns:a="http://schemas.openxmlformats.org/drawingml/2006/main">
               <a:ext uri="{FF2B5EF4-FFF2-40B4-BE49-F238E27FC236}">
-                <a16:creationId xmlns:a16="http://schemas.microsoft.com/office/drawing/2014/main" id="{4B12E671-17F5-40E6-8C38-52C22D68B9D2}"/>
+                <a16:creationId xmlns:a16="http://schemas.microsoft.com/office/drawing/2014/main" id="{2B4003F6-3B3E-4078-A8A2-EBD98C1B5492}"/>
               </a:ext>
             </a:extLst>
           </p:cNvPr>
@@ -16287,7 +16292,7 @@
           <p:cNvPr id="28" name="s9-limit-v">
             <a:extLst xmlns:a="http://schemas.openxmlformats.org/drawingml/2006/main">
               <a:ext uri="{FF2B5EF4-FFF2-40B4-BE49-F238E27FC236}">
-                <a16:creationId xmlns:a16="http://schemas.microsoft.com/office/drawing/2014/main" id="{4D336384-66DF-48FA-91AE-9C0574501B11}"/>
+                <a16:creationId xmlns:a16="http://schemas.microsoft.com/office/drawing/2014/main" id="{C3A841A7-D4B2-4F43-90FD-F6F46D3348E8}"/>
               </a:ext>
             </a:extLst>
           </p:cNvPr>
@@ -16332,7 +16337,7 @@
           <p:cNvPr id="29" name="s9-study-note">
             <a:extLst xmlns:a="http://schemas.openxmlformats.org/drawingml/2006/main">
               <a:ext uri="{FF2B5EF4-FFF2-40B4-BE49-F238E27FC236}">
-                <a16:creationId xmlns:a16="http://schemas.microsoft.com/office/drawing/2014/main" id="{786E952B-BD57-4773-A00C-659E0D494221}"/>
+                <a16:creationId xmlns:a16="http://schemas.microsoft.com/office/drawing/2014/main" id="{A59CAEC9-CE2A-4C83-B626-8C0CB8350104}"/>
               </a:ext>
             </a:extLst>
           </p:cNvPr>
@@ -16399,7 +16404,7 @@
           <p:cNvPr id="31" name="footer-source-9">
             <a:extLst xmlns:a="http://schemas.openxmlformats.org/drawingml/2006/main">
               <a:ext uri="{FF2B5EF4-FFF2-40B4-BE49-F238E27FC236}">
-                <a16:creationId xmlns:a16="http://schemas.microsoft.com/office/drawing/2014/main" id="{66E9ACD7-278A-4D97-9420-FFF767743D50}"/>
+                <a16:creationId xmlns:a16="http://schemas.microsoft.com/office/drawing/2014/main" id="{47A8D18F-F9A7-46CC-A0BA-EF7A98A2B7F2}"/>
               </a:ext>
             </a:extLst>
           </p:cNvPr>
@@ -16444,7 +16449,7 @@
           <p:cNvPr id="32" name="footer-number-9">
             <a:extLst xmlns:a="http://schemas.openxmlformats.org/drawingml/2006/main">
               <a:ext uri="{FF2B5EF4-FFF2-40B4-BE49-F238E27FC236}">
-                <a16:creationId xmlns:a16="http://schemas.microsoft.com/office/drawing/2014/main" id="{4E0DC274-D9C9-412D-BDFB-8D9B2F1F3FFB}"/>
+                <a16:creationId xmlns:a16="http://schemas.microsoft.com/office/drawing/2014/main" id="{9C0A8D66-0293-4E46-B222-B9BFA637FDD1}"/>
               </a:ext>
             </a:extLst>
           </p:cNvPr>
@@ -16487,7 +16492,7 @@
     </p:spTree>
     <p:extLst>
       <p:ext uri="{BB962C8B-B14F-4D97-AF65-F5344CB8AC3E}">
-        <p14:creationId xmlns:p14="http://schemas.microsoft.com/office/powerpoint/2010/main" val="231114333"/>
+        <p14:creationId xmlns:p14="http://schemas.microsoft.com/office/powerpoint/2010/main" val="2058972734"/>
       </p:ext>
     </p:extLst>
   </p:cSld>

</xml_diff>